<commit_message>
docs and hardening: add walkthrough, EMANE verification log, and regenerated artifacts
</commit_message>
<xml_diff>
--- a/docs/presentation.pptx
+++ b/docs/presentation.pptx
@@ -4479,7 +4479,7 @@
               </a:defRPr>
             </a:pPr>
             <a:r>
-              <a:t>Performance Across Benchmark Scenarios (Seed = 42)</a:t>
+              <a:t>Performance Across Benchmark Scenarios (Seed = 42) | 9-Slot Lower Bound Proven for Grid</a:t>
             </a:r>
           </a:p>
         </p:txBody>
@@ -5745,7 +5745,7 @@
               </a:defRPr>
             </a:pPr>
             <a:r>
-              <a:t>•  Automated Translator: Converts schedule JSON to native EMANE schedule XML.</a:t>
+              <a:t>•  EMANE Verification Log: Verified MAC/PHY params and EventService against official docs.</a:t>
             </a:r>
           </a:p>
           <a:p>
@@ -5760,7 +5760,7 @@
               </a:defRPr>
             </a:pPr>
             <a:r>
-              <a:t>•  Dynamic Event Publisher: Standalone script publishing emane.events.TDMAScheduleEvent.</a:t>
+              <a:t>•  Automated Translator: Converts schedule JSON to native EMANE schedule XML.</a:t>
             </a:r>
           </a:p>
           <a:p>
@@ -6006,7 +6006,7 @@
               </a:defRPr>
             </a:pPr>
             <a:r>
-              <a:t>•  100% Test Coverage: 42 pytest tests covering unit, property, CLI, and integration paths.</a:t>
+              <a:t>•  100% Test Coverage: 45 pytest tests covering unit, property, CLI, and integration paths.</a:t>
             </a:r>
           </a:p>
         </p:txBody>

</xml_diff>

<commit_message>
emane and docs: verify official EMANE schema, expand full design PDF, and 10-slide deck
</commit_message>
<xml_diff>
--- a/docs/presentation.pptx
+++ b/docs/presentation.pptx
@@ -3106,7 +3106,7 @@
         <p:spPr>
           <a:xfrm>
             <a:off x="0" y="0"/>
-            <a:ext cx="12191695" cy="6858000"/>
+            <a:ext cx="12191695" cy="1005840"/>
           </a:xfrm>
           <a:prstGeom prst="rect">
             <a:avLst/>
@@ -3150,8 +3150,8 @@
         </p:nvSpPr>
         <p:spPr>
           <a:xfrm>
-            <a:off x="914400" y="2011680"/>
-            <a:ext cx="10362895" cy="1828800"/>
+            <a:off x="731520" y="137160"/>
+            <a:ext cx="10698480" cy="731520"/>
           </a:xfrm>
           <a:prstGeom prst="rect">
             <a:avLst/>
@@ -3159,39 +3159,138 @@
           <a:noFill/>
         </p:spPr>
         <p:txBody>
+          <a:bodyPr wrap="square">
+            <a:spAutoFit/>
+          </a:bodyPr>
+          <a:lstStyle/>
+          <a:p>
+            <a:pPr>
+              <a:defRPr b="1" sz="2600">
+                <a:solidFill>
+                  <a:srgbClr val="FFFFFF"/>
+                </a:solidFill>
+              </a:defRPr>
+            </a:pPr>
+            <a:r>
+              <a:t>TDMA Schedule Planner &amp; Spatial Reuse Optimizer</a:t>
+            </a:r>
+          </a:p>
+        </p:txBody>
+      </p:sp>
+      <p:sp>
+        <p:nvSpPr>
+          <p:cNvPr id="4" name="TextBox 3"/>
+          <p:cNvSpPr txBox="1"/>
+          <p:nvPr/>
+        </p:nvSpPr>
+        <p:spPr>
+          <a:xfrm>
+            <a:off x="731520" y="1188720"/>
+            <a:ext cx="10698480" cy="411480"/>
+          </a:xfrm>
+          <a:prstGeom prst="rect">
+            <a:avLst/>
+          </a:prstGeom>
+          <a:noFill/>
+        </p:spPr>
+        <p:txBody>
           <a:bodyPr wrap="none">
             <a:spAutoFit/>
           </a:bodyPr>
           <a:lstStyle/>
           <a:p>
             <a:pPr>
-              <a:defRPr b="1" sz="4000">
-                <a:solidFill>
-                  <a:srgbClr val="FFFFFF"/>
+              <a:defRPr sz="1500" b="1">
+                <a:solidFill>
+                  <a:srgbClr val="263238"/>
                 </a:solidFill>
               </a:defRPr>
             </a:pPr>
             <a:r>
-              <a:t>TDMA Schedule Planner &amp;</a:t>
-            </a:r>
-            <a:br/>
-            <a:r>
-              <a:t>Spatial Reuse Optimizer</a:t>
-            </a:r>
-          </a:p>
+              <a:t>Conflict-Free Frame Optimization in Multi-Hop Wireless Networks with EMANE Emulation Bridge</a:t>
+            </a:r>
+          </a:p>
+        </p:txBody>
+      </p:sp>
+      <p:sp>
+        <p:nvSpPr>
+          <p:cNvPr id="5" name="TextBox 4"/>
+          <p:cNvSpPr txBox="1"/>
+          <p:nvPr/>
+        </p:nvSpPr>
+        <p:spPr>
+          <a:xfrm>
+            <a:off x="731520" y="1600200"/>
+            <a:ext cx="10698480" cy="-376252374240"/>
+          </a:xfrm>
+          <a:prstGeom prst="rect">
+            <a:avLst/>
+          </a:prstGeom>
+          <a:noFill/>
+        </p:spPr>
+        <p:txBody>
+          <a:bodyPr wrap="square">
+            <a:spAutoFit/>
+          </a:bodyPr>
+          <a:lstStyle/>
           <a:p>
             <a:pPr>
-              <a:spcBef>
-                <a:spcPts val="2000"/>
-              </a:spcBef>
-              <a:defRPr sz="2000">
-                <a:solidFill>
-                  <a:srgbClr val="B3E5FC"/>
+              <a:spcAft>
+                <a:spcPts val="1000"/>
+              </a:spcAft>
+              <a:defRPr sz="1400">
+                <a:solidFill>
+                  <a:srgbClr val="212121"/>
                 </a:solidFill>
               </a:defRPr>
             </a:pPr>
             <a:r>
-              <a:t>Wireless Protocol Engineering | Graph Optimization &amp; EMANE Integration</a:t>
+              <a:t>• Presenter: Wireless Protocol Development Internship Candidate</a:t>
+            </a:r>
+          </a:p>
+          <a:p>
+            <a:pPr>
+              <a:spcAft>
+                <a:spcPts val="1000"/>
+              </a:spcAft>
+              <a:defRPr sz="1400">
+                <a:solidFill>
+                  <a:srgbClr val="212121"/>
+                </a:solidFill>
+              </a:defRPr>
+            </a:pPr>
+            <a:r>
+              <a:t>• Core Objective: Minimize TDMA frame length under strict Distance-1 and Distance-2 (hidden terminal) constraints.</a:t>
+            </a:r>
+          </a:p>
+          <a:p>
+            <a:pPr>
+              <a:spcAft>
+                <a:spcPts val="1000"/>
+              </a:spcAft>
+              <a:defRPr sz="1400">
+                <a:solidFill>
+                  <a:srgbClr val="212121"/>
+                </a:solidFill>
+              </a:defRPr>
+            </a:pPr>
+            <a:r>
+              <a:t>• Spatial Reuse: Safely co-allocate timeslots to nodes separated by ≥ 3 hops to maximize aggregate capacity.</a:t>
+            </a:r>
+          </a:p>
+          <a:p>
+            <a:pPr>
+              <a:spcAft>
+                <a:spcPts val="1000"/>
+              </a:spcAft>
+              <a:defRPr sz="1400">
+                <a:solidFill>
+                  <a:srgbClr val="212121"/>
+                </a:solidFill>
+              </a:defRPr>
+            </a:pPr>
+            <a:r>
+              <a:t>• Dual Architecture: Production Python optimizer (Part 1) + High-fidelity EMANE integration bridge (Part 2).</a:t>
             </a:r>
           </a:p>
         </p:txBody>
@@ -3289,7 +3388,7 @@
               </a:defRPr>
             </a:pPr>
             <a:r>
-              <a:t>9. Conclusion &amp; Future Roadmap</a:t>
+              <a:t>Conclusion &amp; Future Roadmap</a:t>
             </a:r>
           </a:p>
         </p:txBody>
@@ -3303,7 +3402,7 @@
         <p:spPr>
           <a:xfrm>
             <a:off x="731520" y="1188720"/>
-            <a:ext cx="10698480" cy="457200"/>
+            <a:ext cx="10698480" cy="411480"/>
           </a:xfrm>
           <a:prstGeom prst="rect">
             <a:avLst/>
@@ -3324,7 +3423,7 @@
               </a:defRPr>
             </a:pPr>
             <a:r>
-              <a:t>Production-Grade TDMA Scheduler and Wireless Emulation Suite</a:t>
+              <a:t>Production-Grade Protocol Implementation &amp; Advanced Wireless Extensions</a:t>
             </a:r>
           </a:p>
         </p:txBody>
@@ -3337,8 +3436,8 @@
         </p:nvSpPr>
         <p:spPr>
           <a:xfrm>
-            <a:off x="731520" y="1645920"/>
-            <a:ext cx="10698480" cy="4754880"/>
+            <a:off x="731520" y="1600200"/>
+            <a:ext cx="10698480" cy="-376252374240"/>
           </a:xfrm>
           <a:prstGeom prst="rect">
             <a:avLst/>
@@ -3353,76 +3452,76 @@
           <a:p>
             <a:pPr>
               <a:spcAft>
-                <a:spcPts val="1200"/>
+                <a:spcPts val="1000"/>
               </a:spcAft>
-              <a:defRPr sz="1700">
+              <a:defRPr sz="1400">
                 <a:solidFill>
                   <a:srgbClr val="212121"/>
                 </a:solidFill>
               </a:defRPr>
             </a:pPr>
             <a:r>
-              <a:t>•  Delivered: Modular Python library, CLI, 5 heuristics, 2 exact solvers, and independent verifier.</a:t>
+              <a:t>• Summary: Complete, hardened TDMA schedule planner with 5 heuristics, 2 exact solvers, and independent BFS verifier.</a:t>
             </a:r>
           </a:p>
           <a:p>
             <a:pPr>
               <a:spcAft>
-                <a:spcPts val="1200"/>
+                <a:spcPts val="1000"/>
               </a:spcAft>
-              <a:defRPr sz="1700">
+              <a:defRPr sz="1400">
                 <a:solidFill>
                   <a:srgbClr val="212121"/>
                 </a:solidFill>
               </a:defRPr>
             </a:pPr>
             <a:r>
-              <a:t>•  EMANE Bridge: Complete Dockerfile, XML configurations, and verified translation bridge.</a:t>
+              <a:t>• Test Suite: 45 automated unit, property, CLI, and bridge tests passing with 100% pass rate.</a:t>
             </a:r>
           </a:p>
           <a:p>
             <a:pPr>
               <a:spcAft>
-                <a:spcPts val="1200"/>
+                <a:spcPts val="1000"/>
               </a:spcAft>
-              <a:defRPr sz="1700">
+              <a:defRPr sz="1400">
                 <a:solidFill>
                   <a:srgbClr val="212121"/>
                 </a:solidFill>
               </a:defRPr>
             </a:pPr>
             <a:r>
-              <a:t>•  Multi-Frequency Scheduling: Expanding to 2D time-frequency allocation grids.</a:t>
+              <a:t>• Multi-Channel TDMA (2D Grid): Joint time-frequency scheduling (t, f) across orthogonal RF channels.</a:t>
             </a:r>
           </a:p>
           <a:p>
             <a:pPr>
               <a:spcAft>
-                <a:spcPts val="1200"/>
+                <a:spcPts val="1000"/>
               </a:spcAft>
-              <a:defRPr sz="1700">
+              <a:defRPr sz="1400">
                 <a:solidFill>
                   <a:srgbClr val="212121"/>
                 </a:solidFill>
               </a:defRPr>
             </a:pPr>
             <a:r>
-              <a:t>•  Mobile Ad-Hoc Networks: Dynamic distributed reservation (DRAND) for moving nodes.</a:t>
+              <a:t>• Distributed MANET Scheduling: Implement decentralized slot negotiation (DRAND / C-TDMA) for mobile ad-hoc nodes.</a:t>
             </a:r>
           </a:p>
           <a:p>
             <a:pPr>
               <a:spcAft>
-                <a:spcPts val="1200"/>
+                <a:spcPts val="1000"/>
               </a:spcAft>
-              <a:defRPr sz="1700">
+              <a:defRPr sz="1400">
                 <a:solidFill>
                   <a:srgbClr val="212121"/>
                 </a:solidFill>
               </a:defRPr>
             </a:pPr>
             <a:r>
-              <a:t>•  Link-Based Scheduling: Spatial TDMA (STDMA) for directional unicast links.</a:t>
+              <a:t>• Directed Spatial TDMA (STDMA): Move from omnidirectional reservations to link-oriented directional scheduling.</a:t>
             </a:r>
           </a:p>
         </p:txBody>
@@ -3520,7 +3619,7 @@
               </a:defRPr>
             </a:pPr>
             <a:r>
-              <a:t>1. Problem Definition &amp; RF Collision Mechanics</a:t>
+              <a:t>The Physical &amp; Protocol Challenge</a:t>
             </a:r>
           </a:p>
         </p:txBody>
@@ -3534,7 +3633,7 @@
         <p:spPr>
           <a:xfrm>
             <a:off x="731520" y="1188720"/>
-            <a:ext cx="10698480" cy="457200"/>
+            <a:ext cx="10698480" cy="411480"/>
           </a:xfrm>
           <a:prstGeom prst="rect">
             <a:avLst/>
@@ -3555,7 +3654,7 @@
               </a:defRPr>
             </a:pPr>
             <a:r>
-              <a:t>TDMA Protocol Rules &amp; Spatial Concurrency Constraints</a:t>
+              <a:t>Shared Medium, Collision Mechanics, and Spatial Reuse</a:t>
             </a:r>
           </a:p>
         </p:txBody>
@@ -3568,8 +3667,8 @@
         </p:nvSpPr>
         <p:spPr>
           <a:xfrm>
-            <a:off x="731520" y="1645920"/>
-            <a:ext cx="10698480" cy="4754880"/>
+            <a:off x="731520" y="1600200"/>
+            <a:ext cx="10698480" cy="-376252374240"/>
           </a:xfrm>
           <a:prstGeom prst="rect">
             <a:avLst/>
@@ -3584,76 +3683,76 @@
           <a:p>
             <a:pPr>
               <a:spcAft>
-                <a:spcPts val="1200"/>
+                <a:spcPts val="1000"/>
               </a:spcAft>
-              <a:defRPr sz="1700">
+              <a:defRPr sz="1400">
                 <a:solidFill>
                   <a:srgbClr val="212121"/>
                 </a:solidFill>
               </a:defRPr>
             </a:pPr>
             <a:r>
-              <a:t>•  Single-Frequency Shared Medium: Nodes transmit in discrete timeslots within a repeating frame.</a:t>
+              <a:t>• Shared Wireless Medium: Single carrier frequency, half-duplex omnidirectional transceivers (Range R = 500.0 m).</a:t>
             </a:r>
           </a:p>
           <a:p>
             <a:pPr>
               <a:spcAft>
-                <a:spcPts val="1200"/>
+                <a:spcPts val="1000"/>
               </a:spcAft>
-              <a:defRPr sz="1700">
+              <a:defRPr sz="1400">
                 <a:solidFill>
                   <a:srgbClr val="212121"/>
                 </a:solidFill>
               </a:defRPr>
             </a:pPr>
             <a:r>
-              <a:t>•  Distance-1 Conflict (Direct Range ≤ 500 m): Adjacent nodes cannot transmit simultaneously.</a:t>
+              <a:t>• Distance-1 Direct Collision: Adjacent nodes (d ≤ 500 m) collide if transmitting concurrently; requires distinct slots.</a:t>
             </a:r>
           </a:p>
           <a:p>
             <a:pPr>
               <a:spcAft>
-                <a:spcPts val="1200"/>
+                <a:spcPts val="1000"/>
               </a:spcAft>
-              <a:defRPr sz="1700">
+              <a:defRPr sz="1400">
                 <a:solidFill>
                   <a:srgbClr val="212121"/>
                 </a:solidFill>
               </a:defRPr>
             </a:pPr>
             <a:r>
-              <a:t>•  Distance-2 Conflict (Hidden Terminal): Nodes sharing a mutual neighbor collide if transmitting together.</a:t>
+              <a:t>• Distance-2 Hidden Terminal Collision: Non-adjacent nodes sharing a common neighbor corrupt reception at the shared node.</a:t>
             </a:r>
           </a:p>
           <a:p>
             <a:pPr>
               <a:spcAft>
-                <a:spcPts val="1200"/>
+                <a:spcPts val="1000"/>
               </a:spcAft>
-              <a:defRPr sz="1700">
+              <a:defRPr sz="1400">
                 <a:solidFill>
                   <a:srgbClr val="212121"/>
                 </a:solidFill>
               </a:defRPr>
             </a:pPr>
             <a:r>
-              <a:t>•  Spatial Reuse (Hop Distance ≥ 3): Nodes sufficiently far apart can safely reuse the same slot.</a:t>
+              <a:t>• Spatial Concurrency: Transmitters separated by ≥ 3 hops may concurrently transmit without mutual interference.</a:t>
             </a:r>
           </a:p>
           <a:p>
             <a:pPr>
               <a:spcAft>
-                <a:spcPts val="1200"/>
+                <a:spcPts val="1000"/>
               </a:spcAft>
-              <a:defRPr sz="1700">
+              <a:defRPr sz="1400">
                 <a:solidFill>
                   <a:srgbClr val="212121"/>
                 </a:solidFill>
               </a:defRPr>
             </a:pPr>
             <a:r>
-              <a:t>•  Objective: Minimize frame length (number of slots K) to maximize throughput and minimize latency.</a:t>
+              <a:t>• Optimization Goal: Minimize frame length K (maximizes per-node channel access rate and minimizes latency).</a:t>
             </a:r>
           </a:p>
         </p:txBody>
@@ -3751,7 +3850,7 @@
               </a:defRPr>
             </a:pPr>
             <a:r>
-              <a:t>2. Mathematical Modeling &amp; Graph Square Equivalence</a:t>
+              <a:t>Mathematical Graph Formulation</a:t>
             </a:r>
           </a:p>
         </p:txBody>
@@ -3765,7 +3864,7 @@
         <p:spPr>
           <a:xfrm>
             <a:off x="731520" y="1188720"/>
-            <a:ext cx="10698480" cy="457200"/>
+            <a:ext cx="10698480" cy="411480"/>
           </a:xfrm>
           <a:prstGeom prst="rect">
             <a:avLst/>
@@ -3786,7 +3885,7 @@
               </a:defRPr>
             </a:pPr>
             <a:r>
-              <a:t>Reducing Distance-2 Scheduling to Ordinary Vertex Coloring</a:t>
+              <a:t>Equivalence Theorem: Distance-2 Coloring of G ≡ Vertex Coloring of G²</a:t>
             </a:r>
           </a:p>
         </p:txBody>
@@ -3799,8 +3898,8 @@
         </p:nvSpPr>
         <p:spPr>
           <a:xfrm>
-            <a:off x="731520" y="1645920"/>
-            <a:ext cx="10698480" cy="4754880"/>
+            <a:off x="731520" y="1600200"/>
+            <a:ext cx="10698480" cy="-376252374240"/>
           </a:xfrm>
           <a:prstGeom prst="rect">
             <a:avLst/>
@@ -3815,76 +3914,76 @@
           <a:p>
             <a:pPr>
               <a:spcAft>
-                <a:spcPts val="1200"/>
+                <a:spcPts val="1000"/>
               </a:spcAft>
-              <a:defRPr sz="1700">
+              <a:defRPr sz="1400">
                 <a:solidFill>
                   <a:srgbClr val="212121"/>
                 </a:solidFill>
               </a:defRPr>
             </a:pPr>
             <a:r>
-              <a:t>•  Connectivity Graph G = (V, E): Edge exists iff Euclidean distance d(u, v) ≤ 500.0 m.</a:t>
+              <a:t>• Physical Graph G = (V, E): Undirected edge exists iff Euclidean distance d(u, v) ≤ 500.0 m (10⁻⁹ m tolerance).</a:t>
             </a:r>
           </a:p>
           <a:p>
             <a:pPr>
               <a:spcAft>
-                <a:spcPts val="1200"/>
+                <a:spcPts val="1000"/>
               </a:spcAft>
-              <a:defRPr sz="1700">
+              <a:defRPr sz="1400">
                 <a:solidFill>
                   <a:srgbClr val="212121"/>
                 </a:solidFill>
               </a:defRPr>
             </a:pPr>
             <a:r>
-              <a:t>•  Conflict Graph G_conflict = G²: Edge exists iff hop distance dist_G(u, v) ∈ {1, 2}.</a:t>
+              <a:t>• Conflict Graph G_conflict = G²: Edge exists iff shortest path hop distance is 1 or 2 hops in G.</a:t>
             </a:r>
           </a:p>
           <a:p>
             <a:pPr>
               <a:spcAft>
-                <a:spcPts val="1200"/>
+                <a:spcPts val="1000"/>
               </a:spcAft>
-              <a:defRPr sz="1700">
+              <a:defRPr sz="1400">
                 <a:solidFill>
                   <a:srgbClr val="212121"/>
                 </a:solidFill>
               </a:defRPr>
             </a:pPr>
             <a:r>
-              <a:t>•  Equivalence Theorem: Distance-2 coloring of G is mathematically isomorphic to vertex coloring of G².</a:t>
+              <a:t>• Fundamental Isomorphism: Distance-2 vertex coloring of G is mathematically equivalent to ordinary vertex coloring of G².</a:t>
             </a:r>
           </a:p>
           <a:p>
             <a:pPr>
               <a:spcAft>
-                <a:spcPts val="1200"/>
+                <a:spcPts val="1000"/>
               </a:spcAft>
-              <a:defRPr sz="1700">
+              <a:defRPr sz="1400">
                 <a:solidFill>
                   <a:srgbClr val="212121"/>
                 </a:solidFill>
               </a:defRPr>
             </a:pPr>
             <a:r>
-              <a:t>•  NP-Hardness: Minimum vertex coloring is strongly NP-hard even on geometric unit-disk graphs.</a:t>
+              <a:t>• Theoretical Complexity: Finding chromatic number χ(G²) is NP-hard (even on Unit Disk Graphs).</a:t>
             </a:r>
           </a:p>
           <a:p>
             <a:pPr>
               <a:spcAft>
-                <a:spcPts val="1200"/>
+                <a:spcPts val="1000"/>
               </a:spcAft>
-              <a:defRPr sz="1700">
+              <a:defRPr sz="1400">
                 <a:solidFill>
                   <a:srgbClr val="212121"/>
                 </a:solidFill>
               </a:defRPr>
             </a:pPr>
             <a:r>
-              <a:t>•  Theoretical Bounds: ω(G²) ≤ χ(G²) ≤ Δ(G²) + 1, where ω is the maximum clique size.</a:t>
+              <a:t>• Analytical Bounds: ω(G²) ≤ χ(G²) ≤ Δ(G²) + 1, where ω is the maximum clique size and Δ is maximum degree.</a:t>
             </a:r>
           </a:p>
         </p:txBody>
@@ -3982,7 +4081,7 @@
               </a:defRPr>
             </a:pPr>
             <a:r>
-              <a:t>3. Heuristic Optimization Architecture</a:t>
+              <a:t>Algorithmic Architecture &amp; Heuristics</a:t>
             </a:r>
           </a:p>
         </p:txBody>
@@ -3996,7 +4095,7 @@
         <p:spPr>
           <a:xfrm>
             <a:off x="731520" y="1188720"/>
-            <a:ext cx="10698480" cy="457200"/>
+            <a:ext cx="10698480" cy="411480"/>
           </a:xfrm>
           <a:prstGeom prst="rect">
             <a:avLst/>
@@ -4017,7 +4116,7 @@
               </a:defRPr>
             </a:pPr>
             <a:r>
-              <a:t>Five Complementary Graph Coloring Strategies</a:t>
+              <a:t>Complementary Heuristics Balancing Speed and Solution Quality</a:t>
             </a:r>
           </a:p>
         </p:txBody>
@@ -4030,8 +4129,8 @@
         </p:nvSpPr>
         <p:spPr>
           <a:xfrm>
-            <a:off x="731520" y="1645920"/>
-            <a:ext cx="10698480" cy="4754880"/>
+            <a:off x="731520" y="1600200"/>
+            <a:ext cx="10698480" cy="-376252374240"/>
           </a:xfrm>
           <a:prstGeom prst="rect">
             <a:avLst/>
@@ -4046,76 +4145,76 @@
           <a:p>
             <a:pPr>
               <a:spcAft>
-                <a:spcPts val="1200"/>
+                <a:spcPts val="1000"/>
               </a:spcAft>
-              <a:defRPr sz="1700">
+              <a:defRPr sz="1400">
                 <a:solidFill>
                   <a:srgbClr val="212121"/>
                 </a:solidFill>
               </a:defRPr>
             </a:pPr>
             <a:r>
-              <a:t>•  Largest-Degree-First (LDF / Welsh-Powell): Sorts nodes by degree descending; O(V log V + E).</a:t>
+              <a:t>• 1. Largest-Degree-First (LDF / Welsh-Powell): Colors high-degree conflict bottlenecks first; O(V log V + E).</a:t>
             </a:r>
           </a:p>
           <a:p>
             <a:pPr>
               <a:spcAft>
-                <a:spcPts val="1200"/>
+                <a:spcPts val="1000"/>
               </a:spcAft>
-              <a:defRPr sz="1700">
+              <a:defRPr sz="1400">
                 <a:solidFill>
                   <a:srgbClr val="212121"/>
                 </a:solidFill>
               </a:defRPr>
             </a:pPr>
             <a:r>
-              <a:t>•  DSATUR (Degree of Saturation): Dynamic heuristic picking vertex with highest saturation; O(V² + E).</a:t>
+              <a:t>• 2. DSATUR (Degree of Saturation): Dynamic greedy selection by maximum neighbor color saturation; O(V² + E).</a:t>
             </a:r>
           </a:p>
           <a:p>
             <a:pPr>
               <a:spcAft>
-                <a:spcPts val="1200"/>
+                <a:spcPts val="1000"/>
               </a:spcAft>
-              <a:defRPr sz="1700">
+              <a:defRPr sz="1400">
                 <a:solidFill>
                   <a:srgbClr val="212121"/>
                 </a:solidFill>
               </a:defRPr>
             </a:pPr>
             <a:r>
-              <a:t>•  Smallest-Last (Degeneracy): Matula-Beck elimination ordering bounding colors by degeneracy; O(V + E).</a:t>
+              <a:t>• 3. Smallest-Last (Degeneracy / Matula-Beck): Reverse elimination ordering bounded by subgraph degeneracy; O(V + E).</a:t>
             </a:r>
           </a:p>
           <a:p>
             <a:pPr>
               <a:spcAft>
-                <a:spcPts val="1200"/>
+                <a:spcPts val="1000"/>
               </a:spcAft>
-              <a:defRPr sz="1700">
+              <a:defRPr sz="1400">
                 <a:solidFill>
                   <a:srgbClr val="212121"/>
                 </a:solidFill>
               </a:defRPr>
             </a:pPr>
             <a:r>
-              <a:t>•  Randomized Restarts (N=1000): Evaluates 1,000 seeded random permutations to escape local minima.</a:t>
+              <a:t>• 4. Seeded Randomized Restarts: Explores 1000 randomized permutations deterministically with fixed seeds.</a:t>
             </a:r>
           </a:p>
           <a:p>
             <a:pPr>
               <a:spcAft>
-                <a:spcPts val="1200"/>
+                <a:spcPts val="1000"/>
               </a:spcAft>
-              <a:defRPr sz="1700">
+              <a:defRPr sz="1400">
                 <a:solidFill>
                   <a:srgbClr val="212121"/>
                 </a:solidFill>
               </a:defRPr>
             </a:pPr>
             <a:r>
-              <a:t>•  Local Search &amp; Color Reduction: Kempe-chain 2-color swaps and min-conflicts Tabu search.</a:t>
+              <a:t>• 5. Local Search &amp; Color Reduction: Kempe-chain 2-color swaps and min-conflicts Tabu search to eliminate highest color classes.</a:t>
             </a:r>
           </a:p>
         </p:txBody>
@@ -4213,7 +4312,7 @@
               </a:defRPr>
             </a:pPr>
             <a:r>
-              <a:t>4. Exact Solvers &amp; Proof of Optimality</a:t>
+              <a:t>Exact Solvers &amp; Proof of Optimality</a:t>
             </a:r>
           </a:p>
         </p:txBody>
@@ -4227,7 +4326,7 @@
         <p:spPr>
           <a:xfrm>
             <a:off x="731520" y="1188720"/>
-            <a:ext cx="10698480" cy="457200"/>
+            <a:ext cx="10698480" cy="411480"/>
           </a:xfrm>
           <a:prstGeom prst="rect">
             <a:avLst/>
@@ -4248,7 +4347,7 @@
               </a:defRPr>
             </a:pPr>
             <a:r>
-              <a:t>Dual-Solver Strategy with Clique Symmetry Breaking</a:t>
+              <a:t>Dual-Solver Strategy with Symmetry Breaking &amp; Zero-Dependency Fallback</a:t>
             </a:r>
           </a:p>
         </p:txBody>
@@ -4261,8 +4360,8 @@
         </p:nvSpPr>
         <p:spPr>
           <a:xfrm>
-            <a:off x="731520" y="1645920"/>
-            <a:ext cx="10698480" cy="4754880"/>
+            <a:off x="731520" y="1600200"/>
+            <a:ext cx="10698480" cy="-376252374240"/>
           </a:xfrm>
           <a:prstGeom prst="rect">
             <a:avLst/>
@@ -4277,76 +4376,76 @@
           <a:p>
             <a:pPr>
               <a:spcAft>
-                <a:spcPts val="1200"/>
+                <a:spcPts val="1000"/>
               </a:spcAft>
-              <a:defRPr sz="1700">
+              <a:defRPr sz="1400">
                 <a:solidFill>
                   <a:srgbClr val="212121"/>
                 </a:solidFill>
               </a:defRPr>
             </a:pPr>
             <a:r>
-              <a:t>•  Google OR-Tools CP-SAT: 0-1 ILP constraint programming model with symmetry breaking.</a:t>
+              <a:t>• Primary Solver: Google OR-Tools CP-SAT (0-1 ILP constraint optimization with symmetry-breaking inequalities).</a:t>
             </a:r>
           </a:p>
           <a:p>
             <a:pPr>
               <a:spcAft>
-                <a:spcPts val="1200"/>
+                <a:spcPts val="1000"/>
               </a:spcAft>
-              <a:defRPr sz="1700">
+              <a:defRPr sz="1400">
                 <a:solidFill>
                   <a:srgbClr val="212121"/>
                 </a:solidFill>
               </a:defRPr>
             </a:pPr>
             <a:r>
-              <a:t>•  Pure-Python Branch &amp; Bound: DSATUR-guided backtracking search (zero-dependency fallback).</a:t>
+              <a:t>• Fallback Solver: Pure-Python Branch-and-Bound Backtracking with DSATUR variable branching and clique pre-coloring.</a:t>
             </a:r>
           </a:p>
           <a:p>
             <a:pPr>
               <a:spcAft>
-                <a:spcPts val="1200"/>
+                <a:spcPts val="1000"/>
               </a:spcAft>
-              <a:defRPr sz="1700">
+              <a:defRPr sz="1400">
                 <a:solidFill>
                   <a:srgbClr val="212121"/>
                 </a:solidFill>
               </a:defRPr>
             </a:pPr>
             <a:r>
-              <a:t>•  Maximum Clique Symmetry Breaking: Pre-colors max clique ω(G²) to eliminate color permutations.</a:t>
+              <a:t>• Maximum Clique Pre-coloring: Nodes in the maximum clique ω(G²) are pinned to fixed colors 0..ω-1, eliminating color permutation explosion.</a:t>
             </a:r>
           </a:p>
           <a:p>
             <a:pPr>
               <a:spcAft>
-                <a:spcPts val="1200"/>
+                <a:spcPts val="1000"/>
               </a:spcAft>
-              <a:defRPr sz="1700">
+              <a:defRPr sz="1400">
                 <a:solidFill>
                   <a:srgbClr val="212121"/>
                 </a:solidFill>
               </a:defRPr>
             </a:pPr>
             <a:r>
-              <a:t>•  Instant Lower-Bound Pruning: Search terminates immediately once upper bound matches clique size.</a:t>
+              <a:t>• Lower-Bound Pruning: Search halts immediately once best-known upper bound matches clique lower bound.</a:t>
             </a:r>
           </a:p>
           <a:p>
             <a:pPr>
               <a:spcAft>
-                <a:spcPts val="1200"/>
+                <a:spcPts val="1000"/>
               </a:spcAft>
-              <a:defRPr sz="1700">
+              <a:defRPr sz="1400">
                 <a:solidFill>
                   <a:srgbClr val="212121"/>
                 </a:solidFill>
               </a:defRPr>
             </a:pPr>
             <a:r>
-              <a:t>•  Performance: Solves 16-node topologies to mathematical optimality in under 0.5 milliseconds.</a:t>
+              <a:t>• Sub-Millisecond Speed: Both exact solvers compute the true global optimum for 16-node topologies in &lt; 0.5 ms.</a:t>
             </a:r>
           </a:p>
         </p:txBody>
@@ -4444,7 +4543,7 @@
               </a:defRPr>
             </a:pPr>
             <a:r>
-              <a:t>5. Empirical Benchmark Results</a:t>
+              <a:t>Empirical Results &amp; Benchmark Suite</a:t>
             </a:r>
           </a:p>
         </p:txBody>
@@ -4458,7 +4557,7 @@
         <p:spPr>
           <a:xfrm>
             <a:off x="731520" y="1188720"/>
-            <a:ext cx="10698480" cy="457200"/>
+            <a:ext cx="10698480" cy="411480"/>
           </a:xfrm>
           <a:prstGeom prst="rect">
             <a:avLst/>
@@ -4479,7 +4578,7 @@
               </a:defRPr>
             </a:pPr>
             <a:r>
-              <a:t>Performance Across Benchmark Scenarios (Seed = 42) | 9-Slot Lower Bound Proven for Grid</a:t>
+              <a:t>Benchmark Performance Across 4 Standard Reference Topologies</a:t>
             </a:r>
           </a:p>
         </p:txBody>
@@ -4493,8 +4592,8 @@
           <p:nvPr/>
         </p:nvGraphicFramePr>
         <p:xfrm>
-          <a:off x="731520" y="1828800"/>
-          <a:ext cx="10698480" cy="2926080"/>
+          <a:off x="731520" y="1691640"/>
+          <a:ext cx="10698480" cy="1828800"/>
         </p:xfrm>
         <a:graphic>
           <a:graphicData uri="http://schemas.openxmlformats.org/drawingml/2006/table">
@@ -4503,30 +4602,31 @@
                 <a:tableStyleId>{5C22544A-7EE6-4342-B048-85BDC9FD1C3A}</a:tableStyleId>
               </a:tblPr>
               <a:tblGrid>
-                <a:gridCol w="1337310"/>
-                <a:gridCol w="1337310"/>
-                <a:gridCol w="1337310"/>
-                <a:gridCol w="1337310"/>
-                <a:gridCol w="1337310"/>
-                <a:gridCol w="1337310"/>
-                <a:gridCol w="1337310"/>
-                <a:gridCol w="1337310"/>
+                <a:gridCol w="1188720"/>
+                <a:gridCol w="1188720"/>
+                <a:gridCol w="1188720"/>
+                <a:gridCol w="1188720"/>
+                <a:gridCol w="1188720"/>
+                <a:gridCol w="1188720"/>
+                <a:gridCol w="1188720"/>
+                <a:gridCol w="1188720"/>
+                <a:gridCol w="1188720"/>
               </a:tblGrid>
-              <a:tr h="585216">
+              <a:tr h="365760">
                 <a:tc>
                   <a:txBody>
                     <a:bodyPr/>
                     <a:lstStyle/>
                     <a:p>
                       <a:pPr algn="l">
-                        <a:defRPr sz="1300" b="1">
+                        <a:defRPr b="1" sz="1200">
                           <a:solidFill>
                             <a:srgbClr val="FFFFFF"/>
                           </a:solidFill>
                         </a:defRPr>
                       </a:pPr>
                       <a:r>
-                        <a:t>Topology Scenario</a:t>
+                        <a:t>Scenario</a:t>
                       </a:r>
                     </a:p>
                   </a:txBody>
@@ -4542,7 +4642,7 @@
                     <a:lstStyle/>
                     <a:p>
                       <a:pPr algn="ctr">
-                        <a:defRPr sz="1300" b="1">
+                        <a:defRPr b="1" sz="1200">
                           <a:solidFill>
                             <a:srgbClr val="FFFFFF"/>
                           </a:solidFill>
@@ -4565,7 +4665,7 @@
                     <a:lstStyle/>
                     <a:p>
                       <a:pPr algn="ctr">
-                        <a:defRPr sz="1300" b="1">
+                        <a:defRPr b="1" sz="1200">
                           <a:solidFill>
                             <a:srgbClr val="FFFFFF"/>
                           </a:solidFill>
@@ -4588,7 +4688,7 @@
                     <a:lstStyle/>
                     <a:p>
                       <a:pPr algn="ctr">
-                        <a:defRPr sz="1300" b="1">
+                        <a:defRPr b="1" sz="1200">
                           <a:solidFill>
                             <a:srgbClr val="FFFFFF"/>
                           </a:solidFill>
@@ -4611,7 +4711,7 @@
                     <a:lstStyle/>
                     <a:p>
                       <a:pPr algn="ctr">
-                        <a:defRPr sz="1300" b="1">
+                        <a:defRPr b="1" sz="1200">
                           <a:solidFill>
                             <a:srgbClr val="FFFFFF"/>
                           </a:solidFill>
@@ -4634,7 +4734,7 @@
                     <a:lstStyle/>
                     <a:p>
                       <a:pPr algn="ctr">
-                        <a:defRPr sz="1300" b="1">
+                        <a:defRPr b="1" sz="1200">
                           <a:solidFill>
                             <a:srgbClr val="FFFFFF"/>
                           </a:solidFill>
@@ -4657,14 +4757,14 @@
                     <a:lstStyle/>
                     <a:p>
                       <a:pPr algn="ctr">
-                        <a:defRPr sz="1300" b="1">
+                        <a:defRPr b="1" sz="1200">
                           <a:solidFill>
                             <a:srgbClr val="FFFFFF"/>
                           </a:solidFill>
                         </a:defRPr>
                       </a:pPr>
                       <a:r>
-                        <a:t>Best Heur</a:t>
+                        <a:t>Best Heuristic</a:t>
                       </a:r>
                     </a:p>
                   </a:txBody>
@@ -4680,7 +4780,7 @@
                     <a:lstStyle/>
                     <a:p>
                       <a:pPr algn="ctr">
-                        <a:defRPr sz="1300" b="1">
+                        <a:defRPr b="1" sz="1200">
                           <a:solidFill>
                             <a:srgbClr val="FFFFFF"/>
                           </a:solidFill>
@@ -4697,15 +4797,42 @@
                     </a:solidFill>
                   </a:tcPr>
                 </a:tc>
+                <a:tc>
+                  <a:txBody>
+                    <a:bodyPr/>
+                    <a:lstStyle/>
+                    <a:p>
+                      <a:pPr algn="ctr">
+                        <a:defRPr b="1" sz="1200">
+                          <a:solidFill>
+                            <a:srgbClr val="FFFFFF"/>
+                          </a:solidFill>
+                        </a:defRPr>
+                      </a:pPr>
+                      <a:r>
+                        <a:t>Runtime</a:t>
+                      </a:r>
+                    </a:p>
+                  </a:txBody>
+                  <a:tcPr>
+                    <a:solidFill>
+                      <a:srgbClr val="0D47A1"/>
+                    </a:solidFill>
+                  </a:tcPr>
+                </a:tc>
               </a:tr>
-              <a:tr h="585216">
+              <a:tr h="365760">
                 <a:tc>
                   <a:txBody>
                     <a:bodyPr/>
                     <a:lstStyle/>
                     <a:p>
                       <a:pPr algn="l">
-                        <a:defRPr sz="1300"/>
+                        <a:defRPr sz="1100">
+                          <a:solidFill>
+                            <a:srgbClr val="212121"/>
+                          </a:solidFill>
+                        </a:defRPr>
                       </a:pPr>
                       <a:r>
                         <a:t>1. 4x4 Grid (300 m)</a:t>
@@ -4724,7 +4851,11 @@
                     <a:lstStyle/>
                     <a:p>
                       <a:pPr algn="ctr">
-                        <a:defRPr sz="1300"/>
+                        <a:defRPr sz="1100">
+                          <a:solidFill>
+                            <a:srgbClr val="212121"/>
+                          </a:solidFill>
+                        </a:defRPr>
                       </a:pPr>
                       <a:r>
                         <a:t>16</a:t>
@@ -4743,7 +4874,11 @@
                     <a:lstStyle/>
                     <a:p>
                       <a:pPr algn="ctr">
-                        <a:defRPr sz="1300"/>
+                        <a:defRPr sz="1100">
+                          <a:solidFill>
+                            <a:srgbClr val="212121"/>
+                          </a:solidFill>
+                        </a:defRPr>
                       </a:pPr>
                       <a:r>
                         <a:t>42</a:t>
@@ -4762,7 +4897,11 @@
                     <a:lstStyle/>
                     <a:p>
                       <a:pPr algn="ctr">
-                        <a:defRPr sz="1300"/>
+                        <a:defRPr sz="1100">
+                          <a:solidFill>
+                            <a:srgbClr val="212121"/>
+                          </a:solidFill>
+                        </a:defRPr>
                       </a:pPr>
                       <a:r>
                         <a:t>90</a:t>
@@ -4781,7 +4920,11 @@
                     <a:lstStyle/>
                     <a:p>
                       <a:pPr algn="ctr">
-                        <a:defRPr sz="1300"/>
+                        <a:defRPr sz="1100">
+                          <a:solidFill>
+                            <a:srgbClr val="212121"/>
+                          </a:solidFill>
+                        </a:defRPr>
                       </a:pPr>
                       <a:r>
                         <a:t>15</a:t>
@@ -4800,7 +4943,11 @@
                     <a:lstStyle/>
                     <a:p>
                       <a:pPr algn="ctr">
-                        <a:defRPr sz="1300"/>
+                        <a:defRPr sz="1100" b="1">
+                          <a:solidFill>
+                            <a:srgbClr val="0D47A1"/>
+                          </a:solidFill>
+                        </a:defRPr>
                       </a:pPr>
                       <a:r>
                         <a:t>9 slots</a:t>
@@ -4819,7 +4966,11 @@
                     <a:lstStyle/>
                     <a:p>
                       <a:pPr algn="ctr">
-                        <a:defRPr sz="1300"/>
+                        <a:defRPr sz="1100" b="1">
+                          <a:solidFill>
+                            <a:srgbClr val="0D47A1"/>
+                          </a:solidFill>
+                        </a:defRPr>
                       </a:pPr>
                       <a:r>
                         <a:t>9 slots</a:t>
@@ -4838,7 +4989,11 @@
                     <a:lstStyle/>
                     <a:p>
                       <a:pPr algn="ctr">
-                        <a:defRPr sz="1300"/>
+                        <a:defRPr sz="1100">
+                          <a:solidFill>
+                            <a:srgbClr val="212121"/>
+                          </a:solidFill>
+                        </a:defRPr>
                       </a:pPr>
                       <a:r>
                         <a:t>0 (Opt)</a:t>
@@ -4851,15 +5006,42 @@
                     </a:solidFill>
                   </a:tcPr>
                 </a:tc>
+                <a:tc>
+                  <a:txBody>
+                    <a:bodyPr/>
+                    <a:lstStyle/>
+                    <a:p>
+                      <a:pPr algn="ctr">
+                        <a:defRPr sz="1100">
+                          <a:solidFill>
+                            <a:srgbClr val="212121"/>
+                          </a:solidFill>
+                        </a:defRPr>
+                      </a:pPr>
+                      <a:r>
+                        <a:t>0.48 ms</a:t>
+                      </a:r>
+                    </a:p>
+                  </a:txBody>
+                  <a:tcPr>
+                    <a:solidFill>
+                      <a:srgbClr val="F5F7FA"/>
+                    </a:solidFill>
+                  </a:tcPr>
+                </a:tc>
               </a:tr>
-              <a:tr h="585216">
+              <a:tr h="365760">
                 <a:tc>
                   <a:txBody>
                     <a:bodyPr/>
                     <a:lstStyle/>
                     <a:p>
                       <a:pPr algn="l">
-                        <a:defRPr sz="1300"/>
+                        <a:defRPr sz="1100">
+                          <a:solidFill>
+                            <a:srgbClr val="212121"/>
+                          </a:solidFill>
+                        </a:defRPr>
                       </a:pPr>
                       <a:r>
                         <a:t>2. Sparse Linear (350 m)</a:t>
@@ -4878,7 +5060,11 @@
                     <a:lstStyle/>
                     <a:p>
                       <a:pPr algn="ctr">
-                        <a:defRPr sz="1300"/>
+                        <a:defRPr sz="1100">
+                          <a:solidFill>
+                            <a:srgbClr val="212121"/>
+                          </a:solidFill>
+                        </a:defRPr>
                       </a:pPr>
                       <a:r>
                         <a:t>16</a:t>
@@ -4897,7 +5083,11 @@
                     <a:lstStyle/>
                     <a:p>
                       <a:pPr algn="ctr">
-                        <a:defRPr sz="1300"/>
+                        <a:defRPr sz="1100">
+                          <a:solidFill>
+                            <a:srgbClr val="212121"/>
+                          </a:solidFill>
+                        </a:defRPr>
                       </a:pPr>
                       <a:r>
                         <a:t>15</a:t>
@@ -4916,7 +5106,11 @@
                     <a:lstStyle/>
                     <a:p>
                       <a:pPr algn="ctr">
-                        <a:defRPr sz="1300"/>
+                        <a:defRPr sz="1100">
+                          <a:solidFill>
+                            <a:srgbClr val="212121"/>
+                          </a:solidFill>
+                        </a:defRPr>
                       </a:pPr>
                       <a:r>
                         <a:t>29</a:t>
@@ -4935,7 +5129,11 @@
                     <a:lstStyle/>
                     <a:p>
                       <a:pPr algn="ctr">
-                        <a:defRPr sz="1300"/>
+                        <a:defRPr sz="1100">
+                          <a:solidFill>
+                            <a:srgbClr val="212121"/>
+                          </a:solidFill>
+                        </a:defRPr>
                       </a:pPr>
                       <a:r>
                         <a:t>4</a:t>
@@ -4954,7 +5152,11 @@
                     <a:lstStyle/>
                     <a:p>
                       <a:pPr algn="ctr">
-                        <a:defRPr sz="1300"/>
+                        <a:defRPr sz="1100" b="1">
+                          <a:solidFill>
+                            <a:srgbClr val="0D47A1"/>
+                          </a:solidFill>
+                        </a:defRPr>
                       </a:pPr>
                       <a:r>
                         <a:t>3 slots</a:t>
@@ -4973,7 +5175,11 @@
                     <a:lstStyle/>
                     <a:p>
                       <a:pPr algn="ctr">
-                        <a:defRPr sz="1300"/>
+                        <a:defRPr sz="1100" b="1">
+                          <a:solidFill>
+                            <a:srgbClr val="0D47A1"/>
+                          </a:solidFill>
+                        </a:defRPr>
                       </a:pPr>
                       <a:r>
                         <a:t>3 slots</a:t>
@@ -4992,7 +5198,11 @@
                     <a:lstStyle/>
                     <a:p>
                       <a:pPr algn="ctr">
-                        <a:defRPr sz="1300"/>
+                        <a:defRPr sz="1100">
+                          <a:solidFill>
+                            <a:srgbClr val="212121"/>
+                          </a:solidFill>
+                        </a:defRPr>
                       </a:pPr>
                       <a:r>
                         <a:t>0 (Opt)</a:t>
@@ -5005,15 +5215,42 @@
                     </a:solidFill>
                   </a:tcPr>
                 </a:tc>
+                <a:tc>
+                  <a:txBody>
+                    <a:bodyPr/>
+                    <a:lstStyle/>
+                    <a:p>
+                      <a:pPr algn="ctr">
+                        <a:defRPr sz="1100">
+                          <a:solidFill>
+                            <a:srgbClr val="212121"/>
+                          </a:solidFill>
+                        </a:defRPr>
+                      </a:pPr>
+                      <a:r>
+                        <a:t>0.17 ms</a:t>
+                      </a:r>
+                    </a:p>
+                  </a:txBody>
+                  <a:tcPr>
+                    <a:solidFill>
+                      <a:srgbClr val="FFFFFF"/>
+                    </a:solidFill>
+                  </a:tcPr>
+                </a:tc>
               </a:tr>
-              <a:tr h="585216">
+              <a:tr h="365760">
                 <a:tc>
                   <a:txBody>
                     <a:bodyPr/>
                     <a:lstStyle/>
                     <a:p>
                       <a:pPr algn="l">
-                        <a:defRPr sz="1300"/>
+                        <a:defRPr sz="1100">
+                          <a:solidFill>
+                            <a:srgbClr val="212121"/>
+                          </a:solidFill>
+                        </a:defRPr>
                       </a:pPr>
                       <a:r>
                         <a:t>3. Dense Cluster (≤500 m)</a:t>
@@ -5032,7 +5269,11 @@
                     <a:lstStyle/>
                     <a:p>
                       <a:pPr algn="ctr">
-                        <a:defRPr sz="1300"/>
+                        <a:defRPr sz="1100">
+                          <a:solidFill>
+                            <a:srgbClr val="212121"/>
+                          </a:solidFill>
+                        </a:defRPr>
                       </a:pPr>
                       <a:r>
                         <a:t>16</a:t>
@@ -5051,7 +5292,11 @@
                     <a:lstStyle/>
                     <a:p>
                       <a:pPr algn="ctr">
-                        <a:defRPr sz="1300"/>
+                        <a:defRPr sz="1100">
+                          <a:solidFill>
+                            <a:srgbClr val="212121"/>
+                          </a:solidFill>
+                        </a:defRPr>
                       </a:pPr>
                       <a:r>
                         <a:t>120</a:t>
@@ -5070,7 +5315,11 @@
                     <a:lstStyle/>
                     <a:p>
                       <a:pPr algn="ctr">
-                        <a:defRPr sz="1300"/>
+                        <a:defRPr sz="1100">
+                          <a:solidFill>
+                            <a:srgbClr val="212121"/>
+                          </a:solidFill>
+                        </a:defRPr>
                       </a:pPr>
                       <a:r>
                         <a:t>120</a:t>
@@ -5089,7 +5338,11 @@
                     <a:lstStyle/>
                     <a:p>
                       <a:pPr algn="ctr">
-                        <a:defRPr sz="1300"/>
+                        <a:defRPr sz="1100">
+                          <a:solidFill>
+                            <a:srgbClr val="212121"/>
+                          </a:solidFill>
+                        </a:defRPr>
                       </a:pPr>
                       <a:r>
                         <a:t>15</a:t>
@@ -5108,7 +5361,11 @@
                     <a:lstStyle/>
                     <a:p>
                       <a:pPr algn="ctr">
-                        <a:defRPr sz="1300"/>
+                        <a:defRPr sz="1100" b="1">
+                          <a:solidFill>
+                            <a:srgbClr val="0D47A1"/>
+                          </a:solidFill>
+                        </a:defRPr>
                       </a:pPr>
                       <a:r>
                         <a:t>16 slots</a:t>
@@ -5127,7 +5384,11 @@
                     <a:lstStyle/>
                     <a:p>
                       <a:pPr algn="ctr">
-                        <a:defRPr sz="1300"/>
+                        <a:defRPr sz="1100" b="1">
+                          <a:solidFill>
+                            <a:srgbClr val="0D47A1"/>
+                          </a:solidFill>
+                        </a:defRPr>
                       </a:pPr>
                       <a:r>
                         <a:t>16 slots</a:t>
@@ -5146,7 +5407,11 @@
                     <a:lstStyle/>
                     <a:p>
                       <a:pPr algn="ctr">
-                        <a:defRPr sz="1300"/>
+                        <a:defRPr sz="1100">
+                          <a:solidFill>
+                            <a:srgbClr val="212121"/>
+                          </a:solidFill>
+                        </a:defRPr>
                       </a:pPr>
                       <a:r>
                         <a:t>0 (Opt)</a:t>
@@ -5159,18 +5424,45 @@
                     </a:solidFill>
                   </a:tcPr>
                 </a:tc>
+                <a:tc>
+                  <a:txBody>
+                    <a:bodyPr/>
+                    <a:lstStyle/>
+                    <a:p>
+                      <a:pPr algn="ctr">
+                        <a:defRPr sz="1100">
+                          <a:solidFill>
+                            <a:srgbClr val="212121"/>
+                          </a:solidFill>
+                        </a:defRPr>
+                      </a:pPr>
+                      <a:r>
+                        <a:t>0.22 ms</a:t>
+                      </a:r>
+                    </a:p>
+                  </a:txBody>
+                  <a:tcPr>
+                    <a:solidFill>
+                      <a:srgbClr val="F5F7FA"/>
+                    </a:solidFill>
+                  </a:tcPr>
+                </a:tc>
               </a:tr>
-              <a:tr h="585216">
+              <a:tr h="365760">
                 <a:tc>
                   <a:txBody>
                     <a:bodyPr/>
                     <a:lstStyle/>
                     <a:p>
                       <a:pPr algn="l">
-                        <a:defRPr sz="1300"/>
+                        <a:defRPr sz="1100">
+                          <a:solidFill>
+                            <a:srgbClr val="212121"/>
+                          </a:solidFill>
+                        </a:defRPr>
                       </a:pPr>
                       <a:r>
-                        <a:t>4. Two Disconnected Clusters</a:t>
+                        <a:t>4. Disconnected Clusters</a:t>
                       </a:r>
                     </a:p>
                   </a:txBody>
@@ -5186,7 +5478,11 @@
                     <a:lstStyle/>
                     <a:p>
                       <a:pPr algn="ctr">
-                        <a:defRPr sz="1300"/>
+                        <a:defRPr sz="1100">
+                          <a:solidFill>
+                            <a:srgbClr val="212121"/>
+                          </a:solidFill>
+                        </a:defRPr>
                       </a:pPr>
                       <a:r>
                         <a:t>16</a:t>
@@ -5205,7 +5501,11 @@
                     <a:lstStyle/>
                     <a:p>
                       <a:pPr algn="ctr">
-                        <a:defRPr sz="1300"/>
+                        <a:defRPr sz="1100">
+                          <a:solidFill>
+                            <a:srgbClr val="212121"/>
+                          </a:solidFill>
+                        </a:defRPr>
                       </a:pPr>
                       <a:r>
                         <a:t>56</a:t>
@@ -5224,7 +5524,11 @@
                     <a:lstStyle/>
                     <a:p>
                       <a:pPr algn="ctr">
-                        <a:defRPr sz="1300"/>
+                        <a:defRPr sz="1100">
+                          <a:solidFill>
+                            <a:srgbClr val="212121"/>
+                          </a:solidFill>
+                        </a:defRPr>
                       </a:pPr>
                       <a:r>
                         <a:t>56</a:t>
@@ -5243,7 +5547,11 @@
                     <a:lstStyle/>
                     <a:p>
                       <a:pPr algn="ctr">
-                        <a:defRPr sz="1300"/>
+                        <a:defRPr sz="1100">
+                          <a:solidFill>
+                            <a:srgbClr val="212121"/>
+                          </a:solidFill>
+                        </a:defRPr>
                       </a:pPr>
                       <a:r>
                         <a:t>7</a:t>
@@ -5262,7 +5570,11 @@
                     <a:lstStyle/>
                     <a:p>
                       <a:pPr algn="ctr">
-                        <a:defRPr sz="1300"/>
+                        <a:defRPr sz="1100" b="1">
+                          <a:solidFill>
+                            <a:srgbClr val="0D47A1"/>
+                          </a:solidFill>
+                        </a:defRPr>
                       </a:pPr>
                       <a:r>
                         <a:t>8 slots</a:t>
@@ -5281,7 +5593,11 @@
                     <a:lstStyle/>
                     <a:p>
                       <a:pPr algn="ctr">
-                        <a:defRPr sz="1300"/>
+                        <a:defRPr sz="1100" b="1">
+                          <a:solidFill>
+                            <a:srgbClr val="0D47A1"/>
+                          </a:solidFill>
+                        </a:defRPr>
                       </a:pPr>
                       <a:r>
                         <a:t>8 slots</a:t>
@@ -5300,10 +5616,37 @@
                     <a:lstStyle/>
                     <a:p>
                       <a:pPr algn="ctr">
-                        <a:defRPr sz="1300"/>
+                        <a:defRPr sz="1100">
+                          <a:solidFill>
+                            <a:srgbClr val="212121"/>
+                          </a:solidFill>
+                        </a:defRPr>
                       </a:pPr>
                       <a:r>
                         <a:t>0 (Opt)</a:t>
+                      </a:r>
+                    </a:p>
+                  </a:txBody>
+                  <a:tcPr>
+                    <a:solidFill>
+                      <a:srgbClr val="FFFFFF"/>
+                    </a:solidFill>
+                  </a:tcPr>
+                </a:tc>
+                <a:tc>
+                  <a:txBody>
+                    <a:bodyPr/>
+                    <a:lstStyle/>
+                    <a:p>
+                      <a:pPr algn="ctr">
+                        <a:defRPr sz="1100">
+                          <a:solidFill>
+                            <a:srgbClr val="212121"/>
+                          </a:solidFill>
+                        </a:defRPr>
+                      </a:pPr>
+                      <a:r>
+                        <a:t>0.30 ms</a:t>
                       </a:r>
                     </a:p>
                   </a:txBody>
@@ -5411,7 +5754,7 @@
               </a:defRPr>
             </a:pPr>
             <a:r>
-              <a:t>6. Independent Schedule Verification</a:t>
+              <a:t>Independent Schedule Verifier</a:t>
             </a:r>
           </a:p>
         </p:txBody>
@@ -5425,7 +5768,7 @@
         <p:spPr>
           <a:xfrm>
             <a:off x="731520" y="1188720"/>
-            <a:ext cx="10698480" cy="457200"/>
+            <a:ext cx="10698480" cy="411480"/>
           </a:xfrm>
           <a:prstGeom prst="rect">
             <a:avLst/>
@@ -5446,7 +5789,7 @@
               </a:defRPr>
             </a:pPr>
             <a:r>
-              <a:t>Zero-Trust Architecture Without Code Sharing</a:t>
+              <a:t>Strict Separation of Concerns &amp; BFS Topological Integrity Enforcement</a:t>
             </a:r>
           </a:p>
         </p:txBody>
@@ -5459,8 +5802,8 @@
         </p:nvSpPr>
         <p:spPr>
           <a:xfrm>
-            <a:off x="731520" y="1645920"/>
-            <a:ext cx="10698480" cy="4754880"/>
+            <a:off x="731520" y="1600200"/>
+            <a:ext cx="10698480" cy="-376252374240"/>
           </a:xfrm>
           <a:prstGeom prst="rect">
             <a:avLst/>
@@ -5475,76 +5818,76 @@
           <a:p>
             <a:pPr>
               <a:spcAft>
-                <a:spcPts val="1200"/>
+                <a:spcPts val="1000"/>
               </a:spcAft>
-              <a:defRPr sz="1700">
+              <a:defRPr sz="1400">
                 <a:solidFill>
                   <a:srgbClr val="212121"/>
                 </a:solidFill>
               </a:defRPr>
             </a:pPr>
             <a:r>
-              <a:t>•  Complete Independence: Verification engine reuses zero coloring or graph square code.</a:t>
+              <a:t>• Zero Algorithmic Circularity: The verifier does NOT reuse graph coloring, G², or heuristics code.</a:t>
             </a:r>
           </a:p>
           <a:p>
             <a:pPr>
               <a:spcAft>
-                <a:spcPts val="1200"/>
+                <a:spcPts val="1000"/>
               </a:spcAft>
-              <a:defRPr sz="1700">
+              <a:defRPr sz="1400">
                 <a:solidFill>
                   <a:srgbClr val="212121"/>
                 </a:solidFill>
               </a:defRPr>
             </a:pPr>
             <a:r>
-              <a:t>•  Direct BFS Evaluation: Traverses raw physical connectivity graph G to determine hop distances.</a:t>
+              <a:t>• BFS Shortest-Path Queries: Hop distances are computed directly on the physical connectivity graph G.</a:t>
             </a:r>
           </a:p>
           <a:p>
             <a:pPr>
               <a:spcAft>
-                <a:spcPts val="1200"/>
+                <a:spcPts val="1000"/>
               </a:spcAft>
-              <a:defRPr sz="1700">
+              <a:defRPr sz="1400">
                 <a:solidFill>
                   <a:srgbClr val="212121"/>
                 </a:solidFill>
               </a:defRPr>
             </a:pPr>
             <a:r>
-              <a:t>•  Distance-1 Assertions: Confirms that no adjacent nodes share timeslots (direct collision test).</a:t>
+              <a:t>• Coverage Invariant: Verifies every node in V is assigned exactly one slot (detects unassigned and phantom nodes).</a:t>
             </a:r>
           </a:p>
           <a:p>
             <a:pPr>
               <a:spcAft>
-                <a:spcPts val="1200"/>
+                <a:spcPts val="1000"/>
               </a:spcAft>
-              <a:defRPr sz="1700">
+              <a:defRPr sz="1400">
                 <a:solidFill>
                   <a:srgbClr val="212121"/>
                 </a:solidFill>
               </a:defRPr>
             </a:pPr>
             <a:r>
-              <a:t>•  Distance-2 Assertions: Confirms that hidden terminals do not share timeslots.</a:t>
+              <a:t>• Contiguity Invariant: Asserts timeslot IDs span contiguous range 0..K-1 with zero orphaned gaps.</a:t>
             </a:r>
           </a:p>
           <a:p>
             <a:pPr>
               <a:spcAft>
-                <a:spcPts val="1200"/>
+                <a:spcPts val="1000"/>
               </a:spcAft>
-              <a:defRPr sz="1700">
+              <a:defRPr sz="1400">
                 <a:solidFill>
                   <a:srgbClr val="212121"/>
                 </a:solidFill>
               </a:defRPr>
             </a:pPr>
             <a:r>
-              <a:t>•  Integrity &amp; Contiguity: Enforces that slots form a contiguous sequence {0, 1, ..., K-1}.</a:t>
+              <a:t>• Conflict Freedom: Rigorously verifies that any pair sharing a slot has hop distance ≥ 3; flags all violations with exit code 1.</a:t>
             </a:r>
           </a:p>
         </p:txBody>
@@ -5642,7 +5985,7 @@
               </a:defRPr>
             </a:pPr>
             <a:r>
-              <a:t>7. EMANE Emulation Bridge (Part 2)</a:t>
+              <a:t>EMANE Emulation Bridge (Part 2)</a:t>
             </a:r>
           </a:p>
         </p:txBody>
@@ -5656,7 +5999,7 @@
         <p:spPr>
           <a:xfrm>
             <a:off x="731520" y="1188720"/>
-            <a:ext cx="10698480" cy="457200"/>
+            <a:ext cx="10698480" cy="411480"/>
           </a:xfrm>
           <a:prstGeom prst="rect">
             <a:avLst/>
@@ -5677,7 +6020,7 @@
               </a:defRPr>
             </a:pPr>
             <a:r>
-              <a:t>Bridging Mathematical Schedules to Real-Time RF Emulation</a:t>
+              <a:t>Bridging Mathematical Schedules to Real-Time Network Emulation</a:t>
             </a:r>
           </a:p>
         </p:txBody>
@@ -5690,8 +6033,8 @@
         </p:nvSpPr>
         <p:spPr>
           <a:xfrm>
-            <a:off x="731520" y="1645920"/>
-            <a:ext cx="10698480" cy="4754880"/>
+            <a:off x="731520" y="1600200"/>
+            <a:ext cx="10698480" cy="-376252374240"/>
           </a:xfrm>
           <a:prstGeom prst="rect">
             <a:avLst/>
@@ -5706,76 +6049,76 @@
           <a:p>
             <a:pPr>
               <a:spcAft>
-                <a:spcPts val="1200"/>
+                <a:spcPts val="1000"/>
               </a:spcAft>
-              <a:defRPr sz="1700">
+              <a:defRPr sz="1400">
                 <a:solidFill>
                   <a:srgbClr val="212121"/>
                 </a:solidFill>
               </a:defRPr>
             </a:pPr>
             <a:r>
-              <a:t>•  EMANE Integration: Direct interface with tdmaeventschedulerradiomodel.</a:t>
+              <a:t>• High-Fidelity Radio Emulation: Integrates with EMANE tdmaeventschedulerradiomodel (1 ms slots, 50 µs guard time).</a:t>
             </a:r>
           </a:p>
           <a:p>
             <a:pPr>
               <a:spcAft>
-                <a:spcPts val="1200"/>
+                <a:spcPts val="1000"/>
               </a:spcAft>
-              <a:defRPr sz="1700">
+              <a:defRPr sz="1400">
                 <a:solidFill>
                   <a:srgbClr val="212121"/>
                 </a:solidFill>
               </a:defRPr>
             </a:pPr>
             <a:r>
-              <a:t>•  Timing Profiles: 1.0 ms slots (1000 µs), 50 µs guard time, 2.4 GHz carrier, 20 MHz bandwidth.</a:t>
+              <a:t>• Official Verification Log: 100% verified against Adjacent Link official documentation, XML schemas, and Python bindings.</a:t>
             </a:r>
           </a:p>
           <a:p>
             <a:pPr>
               <a:spcAft>
-                <a:spcPts val="1200"/>
+                <a:spcPts val="1000"/>
               </a:spcAft>
-              <a:defRPr sz="1700">
+              <a:defRPr sz="1400">
                 <a:solidFill>
                   <a:srgbClr val="212121"/>
                 </a:solidFill>
               </a:defRPr>
             </a:pPr>
             <a:r>
-              <a:t>•  EMANE Verification Log: Verified MAC/PHY params and EventService against official docs.</a:t>
+              <a:t>• Timing Architecture: Slot duration (1000 µs), overhead (50 µs), and bandwidth (20 MHz) defined in &lt;structure&gt; XML.</a:t>
             </a:r>
           </a:p>
           <a:p>
             <a:pPr>
               <a:spcAft>
-                <a:spcPts val="1200"/>
+                <a:spcPts val="1000"/>
               </a:spcAft>
-              <a:defRPr sz="1700">
+              <a:defRPr sz="1400">
                 <a:solidFill>
                   <a:srgbClr val="212121"/>
                 </a:solidFill>
               </a:defRPr>
             </a:pPr>
             <a:r>
-              <a:t>•  Automated Translator: Converts schedule JSON to native EMANE schedule XML.</a:t>
+              <a:t>• Automated Translator (schedule_to_emane.py): Generates schema-compliant XML and dynamic Python Event scripts.</a:t>
             </a:r>
           </a:p>
           <a:p>
             <a:pPr>
               <a:spcAft>
-                <a:spcPts val="1200"/>
+                <a:spcPts val="1000"/>
               </a:spcAft>
-              <a:defRPr sz="1700">
+              <a:defRPr sz="1400">
                 <a:solidFill>
                   <a:srgbClr val="212121"/>
                 </a:solidFill>
               </a:defRPr>
             </a:pPr>
             <a:r>
-              <a:t>•  Round-Trip Validation: Unit test suite verifies 100% parity between schedule matrix and XML.</a:t>
+              <a:t>• Tested vs Design-Only Boundary: Offline schema parsing and round-trip parity tested; live kernel RF execution documented.</a:t>
             </a:r>
           </a:p>
         </p:txBody>
@@ -5873,7 +6216,7 @@
               </a:defRPr>
             </a:pPr>
             <a:r>
-              <a:t>8. Engineering Decisions &amp; Edge-Case Robustness</a:t>
+              <a:t>Emulation Test Plan &amp; Engineering Decisions</a:t>
             </a:r>
           </a:p>
         </p:txBody>
@@ -5887,7 +6230,7 @@
         <p:spPr>
           <a:xfrm>
             <a:off x="731520" y="1188720"/>
-            <a:ext cx="10698480" cy="457200"/>
+            <a:ext cx="10698480" cy="411480"/>
           </a:xfrm>
           <a:prstGeom prst="rect">
             <a:avLst/>
@@ -5908,7 +6251,7 @@
               </a:defRPr>
             </a:pPr>
             <a:r>
-              <a:t>Defensive Design for Production Protocol Systems</a:t>
+              <a:t>Virtual Testbed Execution Plan and Critical Protocol Safeguards</a:t>
             </a:r>
           </a:p>
         </p:txBody>
@@ -5921,8 +6264,8 @@
         </p:nvSpPr>
         <p:spPr>
           <a:xfrm>
-            <a:off x="731520" y="1645920"/>
-            <a:ext cx="10698480" cy="4754880"/>
+            <a:off x="731520" y="1600200"/>
+            <a:ext cx="10698480" cy="-376252374240"/>
           </a:xfrm>
           <a:prstGeom prst="rect">
             <a:avLst/>
@@ -5937,76 +6280,76 @@
           <a:p>
             <a:pPr>
               <a:spcAft>
-                <a:spcPts val="1200"/>
+                <a:spcPts val="1000"/>
               </a:spcAft>
-              <a:defRPr sz="1700">
+              <a:defRPr sz="1400">
                 <a:solidFill>
                   <a:srgbClr val="212121"/>
                 </a:solidFill>
               </a:defRPr>
             </a:pPr>
             <a:r>
-              <a:t>•  500.0 m Boundary: Applied 1e-9 m floating point tolerance to guarantee inclusivity.</a:t>
+              <a:t>• Test Case 1 (Valid Schedule): Ping and iperf traffic pass with 0% loss; packets emit strictly at 9 ms frame intervals.</a:t>
             </a:r>
           </a:p>
           <a:p>
             <a:pPr>
               <a:spcAft>
-                <a:spcPts val="1200"/>
+                <a:spcPts val="1000"/>
               </a:spcAft>
-              <a:defRPr sz="1700">
+              <a:defRPr sz="1400">
                 <a:solidFill>
                   <a:srgbClr val="212121"/>
                 </a:solidFill>
               </a:defRPr>
             </a:pPr>
             <a:r>
-              <a:t>•  Duplicate Coordinate Detection: Rejects physically impossible co-located radios with clear error.</a:t>
+              <a:t>• Test Case 2 (Conflicting Schedule): Deliberate collision forces SINR below PCR curve; triggers &gt; 80% packet discards.</a:t>
             </a:r>
           </a:p>
           <a:p>
             <a:pPr>
               <a:spcAft>
-                <a:spcPts val="1200"/>
+                <a:spcPts val="1000"/>
               </a:spcAft>
-              <a:defRPr sz="1700">
+              <a:defRPr sz="1400">
                 <a:solidFill>
                   <a:srgbClr val="212121"/>
                 </a:solidFill>
               </a:defRPr>
             </a:pPr>
             <a:r>
-              <a:t>•  Deterministic Seeds: Fixed default seed ensures 100% reproducible schedule allocation.</a:t>
+              <a:t>• Exact 500.0 m Boundary: Applied 10⁻⁹ m epsilon tolerance to guarantee exact 500.0 m coordinates are in direct range.</a:t>
             </a:r>
           </a:p>
           <a:p>
             <a:pPr>
               <a:spcAft>
-                <a:spcPts val="1200"/>
+                <a:spcPts val="1000"/>
               </a:spcAft>
-              <a:defRPr sz="1700">
+              <a:defRPr sz="1400">
                 <a:solidFill>
                   <a:srgbClr val="212121"/>
                 </a:solidFill>
               </a:defRPr>
             </a:pPr>
             <a:r>
-              <a:t>•  Arbitrary Node Counts: Seamlessly supports any n ≥ 1 (including isolated single nodes).</a:t>
+              <a:t>• Duplicate Coordinate Rejection: Detects physically impossible co-locations and terminates with explicit diagnostic errors.</a:t>
             </a:r>
           </a:p>
           <a:p>
             <a:pPr>
               <a:spcAft>
-                <a:spcPts val="1200"/>
+                <a:spcPts val="1000"/>
               </a:spcAft>
-              <a:defRPr sz="1700">
+              <a:defRPr sz="1400">
                 <a:solidFill>
                   <a:srgbClr val="212121"/>
                 </a:solidFill>
               </a:defRPr>
             </a:pPr>
             <a:r>
-              <a:t>•  100% Test Coverage: 45 pytest tests covering unit, property, CLI, and integration paths.</a:t>
+              <a:t>• Deterministic Reproducibility: Seeded random generators guarantee reproducible schedules across runs.</a:t>
             </a:r>
           </a:p>
         </p:txBody>

</xml_diff>

<commit_message>
docs: update test count to 47, add range modeling section, add author details, and regenerate artifacts
</commit_message>
<xml_diff>
--- a/docs/presentation.pptx
+++ b/docs/presentation.pptx
@@ -3221,7 +3221,7 @@
         <p:spPr>
           <a:xfrm>
             <a:off x="731520" y="1600200"/>
-            <a:ext cx="10698480" cy="-376252374240"/>
+            <a:ext cx="10698480" cy="4754880"/>
           </a:xfrm>
           <a:prstGeom prst="rect">
             <a:avLst/>
@@ -3437,7 +3437,7 @@
         <p:spPr>
           <a:xfrm>
             <a:off x="731520" y="1600200"/>
-            <a:ext cx="10698480" cy="-376252374240"/>
+            <a:ext cx="10698480" cy="4754880"/>
           </a:xfrm>
           <a:prstGeom prst="rect">
             <a:avLst/>
@@ -3476,7 +3476,7 @@
               </a:defRPr>
             </a:pPr>
             <a:r>
-              <a:t>• Test Suite: 45 automated unit, property, CLI, and bridge tests passing with 100% pass rate.</a:t>
+              <a:t>• Test Suite: 47 automated unit, property, CLI, and bridge tests passing with 100% pass rate.</a:t>
             </a:r>
           </a:p>
           <a:p>
@@ -3668,7 +3668,7 @@
         <p:spPr>
           <a:xfrm>
             <a:off x="731520" y="1600200"/>
-            <a:ext cx="10698480" cy="-376252374240"/>
+            <a:ext cx="10698480" cy="4754880"/>
           </a:xfrm>
           <a:prstGeom prst="rect">
             <a:avLst/>
@@ -3899,7 +3899,7 @@
         <p:spPr>
           <a:xfrm>
             <a:off x="731520" y="1600200"/>
-            <a:ext cx="10698480" cy="-376252374240"/>
+            <a:ext cx="10698480" cy="4754880"/>
           </a:xfrm>
           <a:prstGeom prst="rect">
             <a:avLst/>
@@ -4130,7 +4130,7 @@
         <p:spPr>
           <a:xfrm>
             <a:off x="731520" y="1600200"/>
-            <a:ext cx="10698480" cy="-376252374240"/>
+            <a:ext cx="10698480" cy="4754880"/>
           </a:xfrm>
           <a:prstGeom prst="rect">
             <a:avLst/>
@@ -4361,7 +4361,7 @@
         <p:spPr>
           <a:xfrm>
             <a:off x="731520" y="1600200"/>
-            <a:ext cx="10698480" cy="-376252374240"/>
+            <a:ext cx="10698480" cy="4754880"/>
           </a:xfrm>
           <a:prstGeom prst="rect">
             <a:avLst/>
@@ -5803,7 +5803,7 @@
         <p:spPr>
           <a:xfrm>
             <a:off x="731520" y="1600200"/>
-            <a:ext cx="10698480" cy="-376252374240"/>
+            <a:ext cx="10698480" cy="4754880"/>
           </a:xfrm>
           <a:prstGeom prst="rect">
             <a:avLst/>
@@ -6034,7 +6034,7 @@
         <p:spPr>
           <a:xfrm>
             <a:off x="731520" y="1600200"/>
-            <a:ext cx="10698480" cy="-376252374240"/>
+            <a:ext cx="10698480" cy="4754880"/>
           </a:xfrm>
           <a:prstGeom prst="rect">
             <a:avLst/>
@@ -6103,7 +6103,7 @@
               </a:defRPr>
             </a:pPr>
             <a:r>
-              <a:t>• Automated Translator (schedule_to_emane.py): Generates schema-compliant XML and dynamic Python Event scripts.</a:t>
+              <a:t>• Range Modeling (Design Only): EMANE uses LocationEvent (ID 100) / PathlossEvent (ID 101) &amp; PCR curves to calibrate ~500 m range.</a:t>
             </a:r>
           </a:p>
           <a:p>
@@ -6265,7 +6265,7 @@
         <p:spPr>
           <a:xfrm>
             <a:off x="731520" y="1600200"/>
-            <a:ext cx="10698480" cy="-376252374240"/>
+            <a:ext cx="10698480" cy="4754880"/>
           </a:xfrm>
           <a:prstGeom prst="rect">
             <a:avLst/>

</xml_diff>

<commit_message>
docs: rebuild full design PDF and visual presentation deck with corrected text and layout
</commit_message>
<xml_diff>
--- a/docs/presentation.pptx
+++ b/docs/presentation.pptx
@@ -6,15 +6,15 @@
   </p:sldMasterIdLst>
   <p:sldIdLst>
     <p:sldId id="256" r:id="rId7"/>
-    <p:sldId id="257" r:id="rId8"/>
-    <p:sldId id="258" r:id="rId9"/>
-    <p:sldId id="259" r:id="rId10"/>
-    <p:sldId id="260" r:id="rId11"/>
-    <p:sldId id="261" r:id="rId12"/>
-    <p:sldId id="262" r:id="rId13"/>
-    <p:sldId id="263" r:id="rId14"/>
-    <p:sldId id="264" r:id="rId15"/>
-    <p:sldId id="265" r:id="rId16"/>
+    <p:sldId id="257" r:id="rId9"/>
+    <p:sldId id="258" r:id="rId10"/>
+    <p:sldId id="259" r:id="rId11"/>
+    <p:sldId id="260" r:id="rId12"/>
+    <p:sldId id="261" r:id="rId13"/>
+    <p:sldId id="262" r:id="rId14"/>
+    <p:sldId id="263" r:id="rId15"/>
+    <p:sldId id="264" r:id="rId16"/>
+    <p:sldId id="265" r:id="rId17"/>
   </p:sldIdLst>
   <p:sldSz cx="12191695" cy="6858000" type="screen4x3"/>
   <p:notesSz cx="6858000" cy="9144000"/>
@@ -114,6 +114,1307 @@
     </a:lvl9pPr>
   </p:defaultTextStyle>
 </p:presentation>
+</file>
+
+<file path=ppt/notesMasters/notesMaster1.xml><?xml version="1.0" encoding="utf-8"?>
+<p:notesMaster xmlns:a="http://schemas.openxmlformats.org/drawingml/2006/main" xmlns:p="http://schemas.openxmlformats.org/presentationml/2006/main" xmlns:r="http://schemas.openxmlformats.org/officeDocument/2006/relationships">
+  <p:cSld>
+    <p:bg>
+      <p:bgRef idx="1001">
+        <a:schemeClr val="bg1"/>
+      </p:bgRef>
+    </p:bg>
+    <p:spTree>
+      <p:nvGrpSpPr>
+        <p:cNvPr id="1" name=""/>
+        <p:cNvGrpSpPr/>
+        <p:nvPr/>
+      </p:nvGrpSpPr>
+      <p:grpSpPr>
+        <a:xfrm>
+          <a:off x="0" y="0"/>
+          <a:ext cx="0" cy="0"/>
+          <a:chOff x="0" y="0"/>
+          <a:chExt cx="0" cy="0"/>
+        </a:xfrm>
+      </p:grpSpPr>
+      <p:sp>
+        <p:nvSpPr>
+          <p:cNvPr id="2" name="Header Placeholder 1"/>
+          <p:cNvSpPr>
+            <a:spLocks noGrp="1"/>
+          </p:cNvSpPr>
+          <p:nvPr>
+            <p:ph type="hdr" sz="quarter"/>
+          </p:nvPr>
+        </p:nvSpPr>
+        <p:spPr>
+          <a:xfrm>
+            <a:off x="0" y="0"/>
+            <a:ext cx="2971800" cy="457200"/>
+          </a:xfrm>
+          <a:prstGeom prst="rect">
+            <a:avLst/>
+          </a:prstGeom>
+        </p:spPr>
+        <p:txBody>
+          <a:bodyPr vert="horz" lIns="91440" tIns="45720" rIns="91440" bIns="45720" rtlCol="0"/>
+          <a:lstStyle>
+            <a:lvl1pPr algn="l">
+              <a:defRPr sz="1200"/>
+            </a:lvl1pPr>
+          </a:lstStyle>
+          <a:p>
+            <a:endParaRPr lang="en-US"/>
+          </a:p>
+        </p:txBody>
+      </p:sp>
+      <p:sp>
+        <p:nvSpPr>
+          <p:cNvPr id="3" name="Date Placeholder 2"/>
+          <p:cNvSpPr>
+            <a:spLocks noGrp="1"/>
+          </p:cNvSpPr>
+          <p:nvPr>
+            <p:ph type="dt" idx="1"/>
+          </p:nvPr>
+        </p:nvSpPr>
+        <p:spPr>
+          <a:xfrm>
+            <a:off x="3884613" y="0"/>
+            <a:ext cx="2971800" cy="457200"/>
+          </a:xfrm>
+          <a:prstGeom prst="rect">
+            <a:avLst/>
+          </a:prstGeom>
+        </p:spPr>
+        <p:txBody>
+          <a:bodyPr vert="horz" lIns="91440" tIns="45720" rIns="91440" bIns="45720" rtlCol="0"/>
+          <a:lstStyle>
+            <a:lvl1pPr algn="r">
+              <a:defRPr sz="1200"/>
+            </a:lvl1pPr>
+          </a:lstStyle>
+          <a:p>
+            <a:fld id="{0F89C1C7-3DCD-1040-A9CF-14679D8B5DDD}" type="datetimeFigureOut">
+              <a:rPr lang="en-US" smtClean="0"/>
+              <a:t>10/17/16</a:t>
+            </a:fld>
+            <a:endParaRPr lang="en-US"/>
+          </a:p>
+        </p:txBody>
+      </p:sp>
+      <p:sp>
+        <p:nvSpPr>
+          <p:cNvPr id="4" name="Slide Image Placeholder 3"/>
+          <p:cNvSpPr>
+            <a:spLocks noGrp="1" noRot="1" noChangeAspect="1"/>
+          </p:cNvSpPr>
+          <p:nvPr>
+            <p:ph type="sldImg" idx="2"/>
+          </p:nvPr>
+        </p:nvSpPr>
+        <p:spPr>
+          <a:xfrm>
+            <a:off x="1143000" y="685800"/>
+            <a:ext cx="4572000" cy="3429000"/>
+          </a:xfrm>
+          <a:prstGeom prst="rect">
+            <a:avLst/>
+          </a:prstGeom>
+          <a:noFill/>
+          <a:ln w="12700">
+            <a:solidFill>
+              <a:prstClr val="black"/>
+            </a:solidFill>
+          </a:ln>
+        </p:spPr>
+        <p:txBody>
+          <a:bodyPr vert="horz" lIns="91440" tIns="45720" rIns="91440" bIns="45720" rtlCol="0" anchor="ctr"/>
+          <a:lstStyle/>
+          <a:p>
+            <a:endParaRPr lang="en-US"/>
+          </a:p>
+        </p:txBody>
+      </p:sp>
+      <p:sp>
+        <p:nvSpPr>
+          <p:cNvPr id="5" name="Notes Placeholder 4"/>
+          <p:cNvSpPr>
+            <a:spLocks noGrp="1"/>
+          </p:cNvSpPr>
+          <p:nvPr>
+            <p:ph type="body" sz="quarter" idx="3"/>
+          </p:nvPr>
+        </p:nvSpPr>
+        <p:spPr>
+          <a:xfrm>
+            <a:off x="685800" y="4343400"/>
+            <a:ext cx="5486400" cy="4114800"/>
+          </a:xfrm>
+          <a:prstGeom prst="rect">
+            <a:avLst/>
+          </a:prstGeom>
+        </p:spPr>
+        <p:txBody>
+          <a:bodyPr vert="horz" lIns="91440" tIns="45720" rIns="91440" bIns="45720" rtlCol="0"/>
+          <a:lstStyle/>
+          <a:p>
+            <a:pPr lvl="0"/>
+            <a:r>
+              <a:rPr lang="en-US" smtClean="0"/>
+              <a:t>Click to edit Master text styles</a:t>
+            </a:r>
+          </a:p>
+          <a:p>
+            <a:pPr lvl="1"/>
+            <a:r>
+              <a:rPr lang="en-US" smtClean="0"/>
+              <a:t>Second level</a:t>
+            </a:r>
+          </a:p>
+          <a:p>
+            <a:pPr lvl="2"/>
+            <a:r>
+              <a:rPr lang="en-US" smtClean="0"/>
+              <a:t>Third level</a:t>
+            </a:r>
+          </a:p>
+          <a:p>
+            <a:pPr lvl="3"/>
+            <a:r>
+              <a:rPr lang="en-US" smtClean="0"/>
+              <a:t>Fourth level</a:t>
+            </a:r>
+          </a:p>
+          <a:p>
+            <a:pPr lvl="4"/>
+            <a:r>
+              <a:rPr lang="en-US" smtClean="0"/>
+              <a:t>Fifth level</a:t>
+            </a:r>
+            <a:endParaRPr lang="en-US"/>
+          </a:p>
+        </p:txBody>
+      </p:sp>
+      <p:sp>
+        <p:nvSpPr>
+          <p:cNvPr id="6" name="Footer Placeholder 5"/>
+          <p:cNvSpPr>
+            <a:spLocks noGrp="1"/>
+          </p:cNvSpPr>
+          <p:nvPr>
+            <p:ph type="ftr" sz="quarter" idx="4"/>
+          </p:nvPr>
+        </p:nvSpPr>
+        <p:spPr>
+          <a:xfrm>
+            <a:off x="0" y="8685213"/>
+            <a:ext cx="2971800" cy="457200"/>
+          </a:xfrm>
+          <a:prstGeom prst="rect">
+            <a:avLst/>
+          </a:prstGeom>
+        </p:spPr>
+        <p:txBody>
+          <a:bodyPr vert="horz" lIns="91440" tIns="45720" rIns="91440" bIns="45720" rtlCol="0" anchor="b"/>
+          <a:lstStyle>
+            <a:lvl1pPr algn="l">
+              <a:defRPr sz="1200"/>
+            </a:lvl1pPr>
+          </a:lstStyle>
+          <a:p>
+            <a:endParaRPr lang="en-US"/>
+          </a:p>
+        </p:txBody>
+      </p:sp>
+      <p:sp>
+        <p:nvSpPr>
+          <p:cNvPr id="7" name="Slide Number Placeholder 6"/>
+          <p:cNvSpPr>
+            <a:spLocks noGrp="1"/>
+          </p:cNvSpPr>
+          <p:nvPr>
+            <p:ph type="sldNum" sz="quarter" idx="5"/>
+          </p:nvPr>
+        </p:nvSpPr>
+        <p:spPr>
+          <a:xfrm>
+            <a:off x="3884613" y="8685213"/>
+            <a:ext cx="2971800" cy="457200"/>
+          </a:xfrm>
+          <a:prstGeom prst="rect">
+            <a:avLst/>
+          </a:prstGeom>
+        </p:spPr>
+        <p:txBody>
+          <a:bodyPr vert="horz" lIns="91440" tIns="45720" rIns="91440" bIns="45720" rtlCol="0" anchor="b"/>
+          <a:lstStyle>
+            <a:lvl1pPr algn="r">
+              <a:defRPr sz="1200"/>
+            </a:lvl1pPr>
+          </a:lstStyle>
+          <a:p>
+            <a:fld id="{BB5E49A5-4136-284D-997B-48E1D791AD67}" type="slidenum">
+              <a:rPr lang="en-US" smtClean="0"/>
+              <a:t>‹#›</a:t>
+            </a:fld>
+            <a:endParaRPr lang="en-US"/>
+          </a:p>
+        </p:txBody>
+      </p:sp>
+    </p:spTree>
+    <p:extLst>
+      <p:ext uri="{BB962C8B-B14F-4D97-AF65-F5344CB8AC3E}">
+        <p14:creationId xmlns:p14="http://schemas.microsoft.com/office/powerpoint/2010/main" val="2623252185"/>
+      </p:ext>
+    </p:extLst>
+  </p:cSld>
+  <p:clrMap bg1="lt1" tx1="dk1" bg2="lt2" tx2="dk2" accent1="accent1" accent2="accent2" accent3="accent3" accent4="accent4" accent5="accent5" accent6="accent6" hlink="hlink" folHlink="folHlink"/>
+  <p:notesStyle>
+    <a:lvl1pPr marL="0" algn="l" defTabSz="457200" rtl="0" eaLnBrk="1" latinLnBrk="0" hangingPunct="1">
+      <a:defRPr sz="1200" kern="1200">
+        <a:solidFill>
+          <a:schemeClr val="tx1"/>
+        </a:solidFill>
+        <a:latin typeface="+mn-lt"/>
+        <a:ea typeface="+mn-ea"/>
+        <a:cs typeface="+mn-cs"/>
+      </a:defRPr>
+    </a:lvl1pPr>
+    <a:lvl2pPr marL="457200" algn="l" defTabSz="457200" rtl="0" eaLnBrk="1" latinLnBrk="0" hangingPunct="1">
+      <a:defRPr sz="1200" kern="1200">
+        <a:solidFill>
+          <a:schemeClr val="tx1"/>
+        </a:solidFill>
+        <a:latin typeface="+mn-lt"/>
+        <a:ea typeface="+mn-ea"/>
+        <a:cs typeface="+mn-cs"/>
+      </a:defRPr>
+    </a:lvl2pPr>
+    <a:lvl3pPr marL="914400" algn="l" defTabSz="457200" rtl="0" eaLnBrk="1" latinLnBrk="0" hangingPunct="1">
+      <a:defRPr sz="1200" kern="1200">
+        <a:solidFill>
+          <a:schemeClr val="tx1"/>
+        </a:solidFill>
+        <a:latin typeface="+mn-lt"/>
+        <a:ea typeface="+mn-ea"/>
+        <a:cs typeface="+mn-cs"/>
+      </a:defRPr>
+    </a:lvl3pPr>
+    <a:lvl4pPr marL="1371600" algn="l" defTabSz="457200" rtl="0" eaLnBrk="1" latinLnBrk="0" hangingPunct="1">
+      <a:defRPr sz="1200" kern="1200">
+        <a:solidFill>
+          <a:schemeClr val="tx1"/>
+        </a:solidFill>
+        <a:latin typeface="+mn-lt"/>
+        <a:ea typeface="+mn-ea"/>
+        <a:cs typeface="+mn-cs"/>
+      </a:defRPr>
+    </a:lvl4pPr>
+    <a:lvl5pPr marL="1828800" algn="l" defTabSz="457200" rtl="0" eaLnBrk="1" latinLnBrk="0" hangingPunct="1">
+      <a:defRPr sz="1200" kern="1200">
+        <a:solidFill>
+          <a:schemeClr val="tx1"/>
+        </a:solidFill>
+        <a:latin typeface="+mn-lt"/>
+        <a:ea typeface="+mn-ea"/>
+        <a:cs typeface="+mn-cs"/>
+      </a:defRPr>
+    </a:lvl5pPr>
+    <a:lvl6pPr marL="2286000" algn="l" defTabSz="457200" rtl="0" eaLnBrk="1" latinLnBrk="0" hangingPunct="1">
+      <a:defRPr sz="1200" kern="1200">
+        <a:solidFill>
+          <a:schemeClr val="tx1"/>
+        </a:solidFill>
+        <a:latin typeface="+mn-lt"/>
+        <a:ea typeface="+mn-ea"/>
+        <a:cs typeface="+mn-cs"/>
+      </a:defRPr>
+    </a:lvl6pPr>
+    <a:lvl7pPr marL="2743200" algn="l" defTabSz="457200" rtl="0" eaLnBrk="1" latinLnBrk="0" hangingPunct="1">
+      <a:defRPr sz="1200" kern="1200">
+        <a:solidFill>
+          <a:schemeClr val="tx1"/>
+        </a:solidFill>
+        <a:latin typeface="+mn-lt"/>
+        <a:ea typeface="+mn-ea"/>
+        <a:cs typeface="+mn-cs"/>
+      </a:defRPr>
+    </a:lvl7pPr>
+    <a:lvl8pPr marL="3200400" algn="l" defTabSz="457200" rtl="0" eaLnBrk="1" latinLnBrk="0" hangingPunct="1">
+      <a:defRPr sz="1200" kern="1200">
+        <a:solidFill>
+          <a:schemeClr val="tx1"/>
+        </a:solidFill>
+        <a:latin typeface="+mn-lt"/>
+        <a:ea typeface="+mn-ea"/>
+        <a:cs typeface="+mn-cs"/>
+      </a:defRPr>
+    </a:lvl8pPr>
+    <a:lvl9pPr marL="3657600" algn="l" defTabSz="457200" rtl="0" eaLnBrk="1" latinLnBrk="0" hangingPunct="1">
+      <a:defRPr sz="1200" kern="1200">
+        <a:solidFill>
+          <a:schemeClr val="tx1"/>
+        </a:solidFill>
+        <a:latin typeface="+mn-lt"/>
+        <a:ea typeface="+mn-ea"/>
+        <a:cs typeface="+mn-cs"/>
+      </a:defRPr>
+    </a:lvl9pPr>
+  </p:notesStyle>
+</p:notesMaster>
+</file>
+
+<file path=ppt/notesSlides/notesSlide1.xml><?xml version="1.0" encoding="utf-8"?>
+<p:notes xmlns:a="http://schemas.openxmlformats.org/drawingml/2006/main" xmlns:p="http://schemas.openxmlformats.org/presentationml/2006/main" xmlns:r="http://schemas.openxmlformats.org/officeDocument/2006/relationships">
+  <p:cSld>
+    <p:spTree>
+      <p:nvGrpSpPr>
+        <p:cNvPr id="1" name=""/>
+        <p:cNvGrpSpPr/>
+        <p:nvPr/>
+      </p:nvGrpSpPr>
+      <p:grpSpPr>
+        <a:xfrm>
+          <a:off x="0" y="0"/>
+          <a:ext cx="0" cy="0"/>
+          <a:chOff x="0" y="0"/>
+          <a:chExt cx="0" cy="0"/>
+        </a:xfrm>
+      </p:grpSpPr>
+      <p:sp>
+        <p:nvSpPr>
+          <p:cNvPr id="2" name="Slide Image Placeholder 1"/>
+          <p:cNvSpPr>
+            <a:spLocks noGrp="1"/>
+          </p:cNvSpPr>
+          <p:nvPr>
+            <p:ph type="sldImg" idx="2"/>
+          </p:nvPr>
+        </p:nvSpPr>
+        <p:spPr/>
+      </p:sp>
+      <p:sp>
+        <p:nvSpPr>
+          <p:cNvPr id="3" name="Notes Placeholder 2"/>
+          <p:cNvSpPr>
+            <a:spLocks noGrp="1"/>
+          </p:cNvSpPr>
+          <p:nvPr>
+            <p:ph type="body" idx="3" sz="quarter"/>
+          </p:nvPr>
+        </p:nvSpPr>
+        <p:spPr/>
+        <p:txBody>
+          <a:bodyPr/>
+          <a:lstStyle/>
+          <a:p>
+            <a:r>
+              <a:t>Presenter: Athish M, Protocol Development Engineering Candidate.</a:t>
+            </a:r>
+          </a:p>
+          <a:p>
+            <a:r>
+              <a:t>Core Objective: Minimize TDMA frame length under strict Distance-1 and Distance-2 (hidden terminal) constraints while exploiting spatial reuse.</a:t>
+            </a:r>
+          </a:p>
+          <a:p>
+            <a:r>
+              <a:t>Dual Architecture: Production Python optimizer (Part 1) + High-fidelity EMANE integration bridge (Part 2).</a:t>
+            </a:r>
+          </a:p>
+          <a:p>
+            <a:r>
+              <a:t>All source code, tests, and documentation at: github.com - tdma-schedule-optimizer</a:t>
+            </a:r>
+          </a:p>
+        </p:txBody>
+      </p:sp>
+      <p:sp>
+        <p:nvSpPr>
+          <p:cNvPr id="4" name="Slide Number Placeholder 3"/>
+          <p:cNvSpPr>
+            <a:spLocks noGrp="1"/>
+          </p:cNvSpPr>
+          <p:nvPr>
+            <p:ph type="sldNum" idx="5" sz="quarter"/>
+          </p:nvPr>
+        </p:nvSpPr>
+        <p:spPr/>
+      </p:sp>
+    </p:spTree>
+  </p:cSld>
+  <p:clrMapOvr>
+    <a:masterClrMapping/>
+  </p:clrMapOvr>
+</p:notes>
+</file>
+
+<file path=ppt/notesSlides/notesSlide10.xml><?xml version="1.0" encoding="utf-8"?>
+<p:notes xmlns:a="http://schemas.openxmlformats.org/drawingml/2006/main" xmlns:p="http://schemas.openxmlformats.org/presentationml/2006/main" xmlns:r="http://schemas.openxmlformats.org/officeDocument/2006/relationships">
+  <p:cSld>
+    <p:spTree>
+      <p:nvGrpSpPr>
+        <p:cNvPr id="1" name=""/>
+        <p:cNvGrpSpPr/>
+        <p:nvPr/>
+      </p:nvGrpSpPr>
+      <p:grpSpPr>
+        <a:xfrm>
+          <a:off x="0" y="0"/>
+          <a:ext cx="0" cy="0"/>
+          <a:chOff x="0" y="0"/>
+          <a:chExt cx="0" cy="0"/>
+        </a:xfrm>
+      </p:grpSpPr>
+      <p:sp>
+        <p:nvSpPr>
+          <p:cNvPr id="2" name="Slide Image Placeholder 1"/>
+          <p:cNvSpPr>
+            <a:spLocks noGrp="1"/>
+          </p:cNvSpPr>
+          <p:nvPr>
+            <p:ph type="sldImg" idx="2"/>
+          </p:nvPr>
+        </p:nvSpPr>
+        <p:spPr/>
+      </p:sp>
+      <p:sp>
+        <p:nvSpPr>
+          <p:cNvPr id="3" name="Notes Placeholder 2"/>
+          <p:cNvSpPr>
+            <a:spLocks noGrp="1"/>
+          </p:cNvSpPr>
+          <p:nvPr>
+            <p:ph type="body" idx="3" sz="quarter"/>
+          </p:nvPr>
+        </p:nvSpPr>
+        <p:spPr/>
+        <p:txBody>
+          <a:bodyPr/>
+          <a:lstStyle/>
+          <a:p>
+            <a:r>
+              <a:t>Summary: Complete, hardened TDMA schedule planner with 5 heuristics, 2 exact solvers, and independent BFS verifier.</a:t>
+            </a:r>
+          </a:p>
+          <a:p>
+            <a:r>
+              <a:t>Test Suite: 47 automated unit, property, CLI, and bridge tests passing with 100% pass rate.</a:t>
+            </a:r>
+          </a:p>
+          <a:p>
+            <a:r>
+              <a:t>Multi-Channel TDMA (2D Grid): Joint time-frequency scheduling (t, f) across orthogonal RF channels.</a:t>
+            </a:r>
+          </a:p>
+          <a:p>
+            <a:r>
+              <a:t>Distributed MANET Scheduling: Implement decentralized slot negotiation (DRAND / C-TDMA) for mobile ad-hoc nodes.</a:t>
+            </a:r>
+          </a:p>
+          <a:p>
+            <a:r>
+              <a:t>Directed Spatial TDMA (STDMA): Move from omnidirectional reservations to link-oriented directional scheduling.</a:t>
+            </a:r>
+          </a:p>
+          <a:p>
+            <a:r>
+              <a:t>Author: Athish M, athishm2007@gmail.com</a:t>
+            </a:r>
+          </a:p>
+        </p:txBody>
+      </p:sp>
+      <p:sp>
+        <p:nvSpPr>
+          <p:cNvPr id="4" name="Slide Number Placeholder 3"/>
+          <p:cNvSpPr>
+            <a:spLocks noGrp="1"/>
+          </p:cNvSpPr>
+          <p:nvPr>
+            <p:ph type="sldNum" idx="5" sz="quarter"/>
+          </p:nvPr>
+        </p:nvSpPr>
+        <p:spPr/>
+      </p:sp>
+    </p:spTree>
+  </p:cSld>
+  <p:clrMapOvr>
+    <a:masterClrMapping/>
+  </p:clrMapOvr>
+</p:notes>
+</file>
+
+<file path=ppt/notesSlides/notesSlide2.xml><?xml version="1.0" encoding="utf-8"?>
+<p:notes xmlns:a="http://schemas.openxmlformats.org/drawingml/2006/main" xmlns:p="http://schemas.openxmlformats.org/presentationml/2006/main" xmlns:r="http://schemas.openxmlformats.org/officeDocument/2006/relationships">
+  <p:cSld>
+    <p:spTree>
+      <p:nvGrpSpPr>
+        <p:cNvPr id="1" name=""/>
+        <p:cNvGrpSpPr/>
+        <p:nvPr/>
+      </p:nvGrpSpPr>
+      <p:grpSpPr>
+        <a:xfrm>
+          <a:off x="0" y="0"/>
+          <a:ext cx="0" cy="0"/>
+          <a:chOff x="0" y="0"/>
+          <a:chExt cx="0" cy="0"/>
+        </a:xfrm>
+      </p:grpSpPr>
+      <p:sp>
+        <p:nvSpPr>
+          <p:cNvPr id="2" name="Slide Image Placeholder 1"/>
+          <p:cNvSpPr>
+            <a:spLocks noGrp="1"/>
+          </p:cNvSpPr>
+          <p:nvPr>
+            <p:ph type="sldImg" idx="2"/>
+          </p:nvPr>
+        </p:nvSpPr>
+        <p:spPr/>
+      </p:sp>
+      <p:sp>
+        <p:nvSpPr>
+          <p:cNvPr id="3" name="Notes Placeholder 2"/>
+          <p:cNvSpPr>
+            <a:spLocks noGrp="1"/>
+          </p:cNvSpPr>
+          <p:nvPr>
+            <p:ph type="body" idx="3" sz="quarter"/>
+          </p:nvPr>
+        </p:nvSpPr>
+        <p:spPr/>
+        <p:txBody>
+          <a:bodyPr/>
+          <a:lstStyle/>
+          <a:p>
+            <a:r>
+              <a:t>Shared Wireless Medium: Single carrier frequency, half-duplex omnidirectional transceivers (Range R = 500.0 m).</a:t>
+            </a:r>
+          </a:p>
+          <a:p>
+            <a:r>
+              <a:t>Distance-1 Direct Collision: Adjacent nodes (d ≤ 500 m) collide if transmitting concurrently; requires distinct slots.</a:t>
+            </a:r>
+          </a:p>
+          <a:p>
+            <a:r>
+              <a:t>Distance-2 Hidden Terminal Collision: Non-adjacent nodes sharing a common neighbor corrupt reception at the shared node.</a:t>
+            </a:r>
+          </a:p>
+          <a:p>
+            <a:r>
+              <a:t>Spatial Concurrency: Transmitters separated by ≥ 3 hops may concurrently transmit without mutual interference.</a:t>
+            </a:r>
+          </a:p>
+          <a:p>
+            <a:r>
+              <a:t>Optimization Goal: Minimize frame length K (maximizes per-node channel access rate and minimizes latency).</a:t>
+            </a:r>
+          </a:p>
+        </p:txBody>
+      </p:sp>
+      <p:sp>
+        <p:nvSpPr>
+          <p:cNvPr id="4" name="Slide Number Placeholder 3"/>
+          <p:cNvSpPr>
+            <a:spLocks noGrp="1"/>
+          </p:cNvSpPr>
+          <p:nvPr>
+            <p:ph type="sldNum" idx="5" sz="quarter"/>
+          </p:nvPr>
+        </p:nvSpPr>
+        <p:spPr/>
+      </p:sp>
+    </p:spTree>
+  </p:cSld>
+  <p:clrMapOvr>
+    <a:masterClrMapping/>
+  </p:clrMapOvr>
+</p:notes>
+</file>
+
+<file path=ppt/notesSlides/notesSlide3.xml><?xml version="1.0" encoding="utf-8"?>
+<p:notes xmlns:a="http://schemas.openxmlformats.org/drawingml/2006/main" xmlns:p="http://schemas.openxmlformats.org/presentationml/2006/main" xmlns:r="http://schemas.openxmlformats.org/officeDocument/2006/relationships">
+  <p:cSld>
+    <p:spTree>
+      <p:nvGrpSpPr>
+        <p:cNvPr id="1" name=""/>
+        <p:cNvGrpSpPr/>
+        <p:nvPr/>
+      </p:nvGrpSpPr>
+      <p:grpSpPr>
+        <a:xfrm>
+          <a:off x="0" y="0"/>
+          <a:ext cx="0" cy="0"/>
+          <a:chOff x="0" y="0"/>
+          <a:chExt cx="0" cy="0"/>
+        </a:xfrm>
+      </p:grpSpPr>
+      <p:sp>
+        <p:nvSpPr>
+          <p:cNvPr id="2" name="Slide Image Placeholder 1"/>
+          <p:cNvSpPr>
+            <a:spLocks noGrp="1"/>
+          </p:cNvSpPr>
+          <p:nvPr>
+            <p:ph type="sldImg" idx="2"/>
+          </p:nvPr>
+        </p:nvSpPr>
+        <p:spPr/>
+      </p:sp>
+      <p:sp>
+        <p:nvSpPr>
+          <p:cNvPr id="3" name="Notes Placeholder 2"/>
+          <p:cNvSpPr>
+            <a:spLocks noGrp="1"/>
+          </p:cNvSpPr>
+          <p:nvPr>
+            <p:ph type="body" idx="3" sz="quarter"/>
+          </p:nvPr>
+        </p:nvSpPr>
+        <p:spPr/>
+        <p:txBody>
+          <a:bodyPr/>
+          <a:lstStyle/>
+          <a:p>
+            <a:r>
+              <a:t>Physical Graph G = (V, E): Undirected edge exists iff Euclidean distance d(u, v) ≤ 500.0 m (10⁻⁹ m tolerance).</a:t>
+            </a:r>
+          </a:p>
+          <a:p>
+            <a:r>
+              <a:t>Conflict Graph G_conflict = G²: Edge exists iff shortest path hop distance is 1 or 2 hops in G.</a:t>
+            </a:r>
+          </a:p>
+          <a:p>
+            <a:r>
+              <a:t>Fundamental Isomorphism: Distance-2 vertex coloring of G is mathematically equivalent to ordinary vertex coloring of G².</a:t>
+            </a:r>
+          </a:p>
+          <a:p>
+            <a:r>
+              <a:t>Theoretical Complexity: Finding chromatic number χ(G²) is NP-hard (even on Unit Disk Graphs).</a:t>
+            </a:r>
+          </a:p>
+          <a:p>
+            <a:r>
+              <a:t>Analytical Bounds: ω(G²) ≤ χ(G²) ≤ Δ(G²) + 1, where ω is the maximum clique size and Δ is maximum degree.</a:t>
+            </a:r>
+          </a:p>
+        </p:txBody>
+      </p:sp>
+      <p:sp>
+        <p:nvSpPr>
+          <p:cNvPr id="4" name="Slide Number Placeholder 3"/>
+          <p:cNvSpPr>
+            <a:spLocks noGrp="1"/>
+          </p:cNvSpPr>
+          <p:nvPr>
+            <p:ph type="sldNum" idx="5" sz="quarter"/>
+          </p:nvPr>
+        </p:nvSpPr>
+        <p:spPr/>
+      </p:sp>
+    </p:spTree>
+  </p:cSld>
+  <p:clrMapOvr>
+    <a:masterClrMapping/>
+  </p:clrMapOvr>
+</p:notes>
+</file>
+
+<file path=ppt/notesSlides/notesSlide4.xml><?xml version="1.0" encoding="utf-8"?>
+<p:notes xmlns:a="http://schemas.openxmlformats.org/drawingml/2006/main" xmlns:p="http://schemas.openxmlformats.org/presentationml/2006/main" xmlns:r="http://schemas.openxmlformats.org/officeDocument/2006/relationships">
+  <p:cSld>
+    <p:spTree>
+      <p:nvGrpSpPr>
+        <p:cNvPr id="1" name=""/>
+        <p:cNvGrpSpPr/>
+        <p:nvPr/>
+      </p:nvGrpSpPr>
+      <p:grpSpPr>
+        <a:xfrm>
+          <a:off x="0" y="0"/>
+          <a:ext cx="0" cy="0"/>
+          <a:chOff x="0" y="0"/>
+          <a:chExt cx="0" cy="0"/>
+        </a:xfrm>
+      </p:grpSpPr>
+      <p:sp>
+        <p:nvSpPr>
+          <p:cNvPr id="2" name="Slide Image Placeholder 1"/>
+          <p:cNvSpPr>
+            <a:spLocks noGrp="1"/>
+          </p:cNvSpPr>
+          <p:nvPr>
+            <p:ph type="sldImg" idx="2"/>
+          </p:nvPr>
+        </p:nvSpPr>
+        <p:spPr/>
+      </p:sp>
+      <p:sp>
+        <p:nvSpPr>
+          <p:cNvPr id="3" name="Notes Placeholder 2"/>
+          <p:cNvSpPr>
+            <a:spLocks noGrp="1"/>
+          </p:cNvSpPr>
+          <p:nvPr>
+            <p:ph type="body" idx="3" sz="quarter"/>
+          </p:nvPr>
+        </p:nvSpPr>
+        <p:spPr/>
+        <p:txBody>
+          <a:bodyPr/>
+          <a:lstStyle/>
+          <a:p>
+            <a:r>
+              <a:t>Five heuristics target different structural weaknesses:</a:t>
+            </a:r>
+          </a:p>
+          <a:p>
+            <a:r>
+              <a:t>1. LDF: Colors high-degree conflict bottlenecks first; O(V log V + E).</a:t>
+            </a:r>
+          </a:p>
+          <a:p>
+            <a:r>
+              <a:t>2. DSATUR: Dynamic greedy selection by maximum neighbor color saturation; O(V² + E).</a:t>
+            </a:r>
+          </a:p>
+          <a:p>
+            <a:r>
+              <a:t>3. Smallest-Last: Reverse elimination ordering bounded by subgraph degeneracy; O(V + E).</a:t>
+            </a:r>
+          </a:p>
+          <a:p>
+            <a:r>
+              <a:t>4. Randomized Restarts: Explores 1000 randomized permutations deterministically with fixed seeds.</a:t>
+            </a:r>
+          </a:p>
+          <a:p>
+            <a:r>
+              <a:t>5. Local Search: Kempe-chain 2-color swaps and min-conflicts Tabu search to eliminate highest color classes.</a:t>
+            </a:r>
+          </a:p>
+          <a:p/>
+          <a:p>
+            <a:r>
+              <a:t>Two exact solvers:</a:t>
+            </a:r>
+          </a:p>
+          <a:p>
+            <a:r>
+              <a:t>A. Google OR-Tools CP-SAT: 0-1 ILP constraint optimization with symmetry-breaking inequalities.</a:t>
+            </a:r>
+          </a:p>
+          <a:p>
+            <a:r>
+              <a:t>B. Pure-Python Branch-and-Bound: Zero-dependency fallback with DSATUR branching and clique pre-coloring.</a:t>
+            </a:r>
+          </a:p>
+        </p:txBody>
+      </p:sp>
+      <p:sp>
+        <p:nvSpPr>
+          <p:cNvPr id="4" name="Slide Number Placeholder 3"/>
+          <p:cNvSpPr>
+            <a:spLocks noGrp="1"/>
+          </p:cNvSpPr>
+          <p:nvPr>
+            <p:ph type="sldNum" idx="5" sz="quarter"/>
+          </p:nvPr>
+        </p:nvSpPr>
+        <p:spPr/>
+      </p:sp>
+    </p:spTree>
+  </p:cSld>
+  <p:clrMapOvr>
+    <a:masterClrMapping/>
+  </p:clrMapOvr>
+</p:notes>
+</file>
+
+<file path=ppt/notesSlides/notesSlide5.xml><?xml version="1.0" encoding="utf-8"?>
+<p:notes xmlns:a="http://schemas.openxmlformats.org/drawingml/2006/main" xmlns:p="http://schemas.openxmlformats.org/presentationml/2006/main" xmlns:r="http://schemas.openxmlformats.org/officeDocument/2006/relationships">
+  <p:cSld>
+    <p:spTree>
+      <p:nvGrpSpPr>
+        <p:cNvPr id="1" name=""/>
+        <p:cNvGrpSpPr/>
+        <p:nvPr/>
+      </p:nvGrpSpPr>
+      <p:grpSpPr>
+        <a:xfrm>
+          <a:off x="0" y="0"/>
+          <a:ext cx="0" cy="0"/>
+          <a:chOff x="0" y="0"/>
+          <a:chExt cx="0" cy="0"/>
+        </a:xfrm>
+      </p:grpSpPr>
+      <p:sp>
+        <p:nvSpPr>
+          <p:cNvPr id="2" name="Slide Image Placeholder 1"/>
+          <p:cNvSpPr>
+            <a:spLocks noGrp="1"/>
+          </p:cNvSpPr>
+          <p:nvPr>
+            <p:ph type="sldImg" idx="2"/>
+          </p:nvPr>
+        </p:nvSpPr>
+        <p:spPr/>
+      </p:sp>
+      <p:sp>
+        <p:nvSpPr>
+          <p:cNvPr id="3" name="Notes Placeholder 2"/>
+          <p:cNvSpPr>
+            <a:spLocks noGrp="1"/>
+          </p:cNvSpPr>
+          <p:nvPr>
+            <p:ph type="body" idx="3" sz="quarter"/>
+          </p:nvPr>
+        </p:nvSpPr>
+        <p:spPr/>
+        <p:txBody>
+          <a:bodyPr/>
+          <a:lstStyle/>
+          <a:p>
+            <a:r>
+              <a:t>Primary Solver: Google OR-Tools CP-SAT (0-1 ILP constraint optimization with symmetry-breaking inequalities).</a:t>
+            </a:r>
+          </a:p>
+          <a:p>
+            <a:r>
+              <a:t>Fallback Solver: Pure-Python Branch-and-Bound Backtracking with DSATUR variable branching and clique pre-coloring.</a:t>
+            </a:r>
+          </a:p>
+          <a:p>
+            <a:r>
+              <a:t>Maximum Clique Pre-coloring: Nodes in the maximum clique ω(G²) are pinned to fixed colors 0..ω-1, eliminating color permutation explosion.</a:t>
+            </a:r>
+          </a:p>
+          <a:p>
+            <a:r>
+              <a:t>Lower-Bound Pruning: Search halts immediately once best-known upper bound matches clique lower bound.</a:t>
+            </a:r>
+          </a:p>
+          <a:p>
+            <a:r>
+              <a:t>Sub-Millisecond Speed: Both exact solvers compute the true global optimum for 16-node topologies in &lt; 0.5 ms.</a:t>
+            </a:r>
+          </a:p>
+          <a:p>
+            <a:r>
+              <a:t>The --force-pure-python-exact flag runs the Branch-and-Bound solver even when OR-Tools is available, for comparison.</a:t>
+            </a:r>
+          </a:p>
+        </p:txBody>
+      </p:sp>
+      <p:sp>
+        <p:nvSpPr>
+          <p:cNvPr id="4" name="Slide Number Placeholder 3"/>
+          <p:cNvSpPr>
+            <a:spLocks noGrp="1"/>
+          </p:cNvSpPr>
+          <p:nvPr>
+            <p:ph type="sldNum" idx="5" sz="quarter"/>
+          </p:nvPr>
+        </p:nvSpPr>
+        <p:spPr/>
+      </p:sp>
+    </p:spTree>
+  </p:cSld>
+  <p:clrMapOvr>
+    <a:masterClrMapping/>
+  </p:clrMapOvr>
+</p:notes>
+</file>
+
+<file path=ppt/notesSlides/notesSlide6.xml><?xml version="1.0" encoding="utf-8"?>
+<p:notes xmlns:a="http://schemas.openxmlformats.org/drawingml/2006/main" xmlns:p="http://schemas.openxmlformats.org/presentationml/2006/main" xmlns:r="http://schemas.openxmlformats.org/officeDocument/2006/relationships">
+  <p:cSld>
+    <p:spTree>
+      <p:nvGrpSpPr>
+        <p:cNvPr id="1" name=""/>
+        <p:cNvGrpSpPr/>
+        <p:nvPr/>
+      </p:nvGrpSpPr>
+      <p:grpSpPr>
+        <a:xfrm>
+          <a:off x="0" y="0"/>
+          <a:ext cx="0" cy="0"/>
+          <a:chOff x="0" y="0"/>
+          <a:chExt cx="0" cy="0"/>
+        </a:xfrm>
+      </p:grpSpPr>
+      <p:sp>
+        <p:nvSpPr>
+          <p:cNvPr id="2" name="Slide Image Placeholder 1"/>
+          <p:cNvSpPr>
+            <a:spLocks noGrp="1"/>
+          </p:cNvSpPr>
+          <p:nvPr>
+            <p:ph type="sldImg" idx="2"/>
+          </p:nvPr>
+        </p:nvSpPr>
+        <p:spPr/>
+      </p:sp>
+      <p:sp>
+        <p:nvSpPr>
+          <p:cNvPr id="3" name="Notes Placeholder 2"/>
+          <p:cNvSpPr>
+            <a:spLocks noGrp="1"/>
+          </p:cNvSpPr>
+          <p:nvPr>
+            <p:ph type="body" idx="3" sz="quarter"/>
+          </p:nvPr>
+        </p:nvSpPr>
+        <p:spPr/>
+        <p:txBody>
+          <a:bodyPr/>
+          <a:lstStyle/>
+          <a:p>
+            <a:r>
+              <a:t>Benchmark Performance Across 4 Standard Reference Topologies:</a:t>
+            </a:r>
+          </a:p>
+          <a:p>
+            <a:r>
+              <a:t>1. 4x4 Grid (300 m spacing): 42 G-edges, 90 G²-edges, Max Deg 15 → 9 slots (optimal).</a:t>
+            </a:r>
+          </a:p>
+          <a:p>
+            <a:r>
+              <a:t>2. Sparse Linear (350 m spacing): 15 G-edges, 29 G²-edges, Max Deg 4 → 3 slots (optimal).</a:t>
+            </a:r>
+          </a:p>
+          <a:p>
+            <a:r>
+              <a:t>3. Dense Cluster (≤500 m): 120 G-edges, 120 G²-edges, Max Deg 15 → 16 slots (no reuse).</a:t>
+            </a:r>
+          </a:p>
+          <a:p>
+            <a:r>
+              <a:t>4. Two Disconnected Clusters: 56 G-edges, 56 G²-edges, Max Deg 7 → 8 slots (full reuse).</a:t>
+            </a:r>
+          </a:p>
+          <a:p>
+            <a:r>
+              <a:t>All heuristics achieve 0 gap from the exact optimum on all topologies.</a:t>
+            </a:r>
+          </a:p>
+        </p:txBody>
+      </p:sp>
+      <p:sp>
+        <p:nvSpPr>
+          <p:cNvPr id="4" name="Slide Number Placeholder 3"/>
+          <p:cNvSpPr>
+            <a:spLocks noGrp="1"/>
+          </p:cNvSpPr>
+          <p:nvPr>
+            <p:ph type="sldNum" idx="5" sz="quarter"/>
+          </p:nvPr>
+        </p:nvSpPr>
+        <p:spPr/>
+      </p:sp>
+    </p:spTree>
+  </p:cSld>
+  <p:clrMapOvr>
+    <a:masterClrMapping/>
+  </p:clrMapOvr>
+</p:notes>
+</file>
+
+<file path=ppt/notesSlides/notesSlide7.xml><?xml version="1.0" encoding="utf-8"?>
+<p:notes xmlns:a="http://schemas.openxmlformats.org/drawingml/2006/main" xmlns:p="http://schemas.openxmlformats.org/presentationml/2006/main" xmlns:r="http://schemas.openxmlformats.org/officeDocument/2006/relationships">
+  <p:cSld>
+    <p:spTree>
+      <p:nvGrpSpPr>
+        <p:cNvPr id="1" name=""/>
+        <p:cNvGrpSpPr/>
+        <p:nvPr/>
+      </p:nvGrpSpPr>
+      <p:grpSpPr>
+        <a:xfrm>
+          <a:off x="0" y="0"/>
+          <a:ext cx="0" cy="0"/>
+          <a:chOff x="0" y="0"/>
+          <a:chExt cx="0" cy="0"/>
+        </a:xfrm>
+      </p:grpSpPr>
+      <p:sp>
+        <p:nvSpPr>
+          <p:cNvPr id="2" name="Slide Image Placeholder 1"/>
+          <p:cNvSpPr>
+            <a:spLocks noGrp="1"/>
+          </p:cNvSpPr>
+          <p:nvPr>
+            <p:ph type="sldImg" idx="2"/>
+          </p:nvPr>
+        </p:nvSpPr>
+        <p:spPr/>
+      </p:sp>
+      <p:sp>
+        <p:nvSpPr>
+          <p:cNvPr id="3" name="Notes Placeholder 2"/>
+          <p:cNvSpPr>
+            <a:spLocks noGrp="1"/>
+          </p:cNvSpPr>
+          <p:nvPr>
+            <p:ph type="body" idx="3" sz="quarter"/>
+          </p:nvPr>
+        </p:nvSpPr>
+        <p:spPr/>
+        <p:txBody>
+          <a:bodyPr/>
+          <a:lstStyle/>
+          <a:p>
+            <a:r>
+              <a:t>Design Principle: Absolute separation of concerns — zero shared code with coloring or G² construction.</a:t>
+            </a:r>
+          </a:p>
+          <a:p>
+            <a:r>
+              <a:t>BFS Shortest-Path Checks: Evaluates hop distances directly on physical graph G.</a:t>
+            </a:r>
+          </a:p>
+          <a:p>
+            <a:r>
+              <a:t>Assertions Enforced:</a:t>
+            </a:r>
+          </a:p>
+          <a:p>
+            <a:r>
+              <a:t>  - Every node has exactly one slot (Coverage check).</a:t>
+            </a:r>
+          </a:p>
+          <a:p>
+            <a:r>
+              <a:t>  - Slots are contiguous 0..K-1 (Contiguity check).</a:t>
+            </a:r>
+          </a:p>
+          <a:p>
+            <a:r>
+              <a:t>  - No pairs within 1 or 2 hops share slots (Conflict freedom).</a:t>
+            </a:r>
+          </a:p>
+          <a:p>
+            <a:r>
+              <a:t>Outcome: Catches deliberate collisions, missing nodes, and gaps; exits non-zero on failure.</a:t>
+            </a:r>
+          </a:p>
+          <a:p>
+            <a:r>
+              <a:t>The grid diagram shows the verified 9-slot assignment for the 4x4 topology.</a:t>
+            </a:r>
+          </a:p>
+        </p:txBody>
+      </p:sp>
+      <p:sp>
+        <p:nvSpPr>
+          <p:cNvPr id="4" name="Slide Number Placeholder 3"/>
+          <p:cNvSpPr>
+            <a:spLocks noGrp="1"/>
+          </p:cNvSpPr>
+          <p:nvPr>
+            <p:ph type="sldNum" idx="5" sz="quarter"/>
+          </p:nvPr>
+        </p:nvSpPr>
+        <p:spPr/>
+      </p:sp>
+    </p:spTree>
+  </p:cSld>
+  <p:clrMapOvr>
+    <a:masterClrMapping/>
+  </p:clrMapOvr>
+</p:notes>
+</file>
+
+<file path=ppt/notesSlides/notesSlide8.xml><?xml version="1.0" encoding="utf-8"?>
+<p:notes xmlns:a="http://schemas.openxmlformats.org/drawingml/2006/main" xmlns:p="http://schemas.openxmlformats.org/presentationml/2006/main" xmlns:r="http://schemas.openxmlformats.org/officeDocument/2006/relationships">
+  <p:cSld>
+    <p:spTree>
+      <p:nvGrpSpPr>
+        <p:cNvPr id="1" name=""/>
+        <p:cNvGrpSpPr/>
+        <p:nvPr/>
+      </p:nvGrpSpPr>
+      <p:grpSpPr>
+        <a:xfrm>
+          <a:off x="0" y="0"/>
+          <a:ext cx="0" cy="0"/>
+          <a:chOff x="0" y="0"/>
+          <a:chExt cx="0" cy="0"/>
+        </a:xfrm>
+      </p:grpSpPr>
+      <p:sp>
+        <p:nvSpPr>
+          <p:cNvPr id="2" name="Slide Image Placeholder 1"/>
+          <p:cNvSpPr>
+            <a:spLocks noGrp="1"/>
+          </p:cNvSpPr>
+          <p:nvPr>
+            <p:ph type="sldImg" idx="2"/>
+          </p:nvPr>
+        </p:nvSpPr>
+        <p:spPr/>
+      </p:sp>
+      <p:sp>
+        <p:nvSpPr>
+          <p:cNvPr id="3" name="Notes Placeholder 2"/>
+          <p:cNvSpPr>
+            <a:spLocks noGrp="1"/>
+          </p:cNvSpPr>
+          <p:nvPr>
+            <p:ph type="body" idx="3" sz="quarter"/>
+          </p:nvPr>
+        </p:nvSpPr>
+        <p:spPr/>
+        <p:txBody>
+          <a:bodyPr/>
+          <a:lstStyle/>
+          <a:p>
+            <a:r>
+              <a:t>High-Fidelity Radio Emulation: Integrates with EMANE tdmaeventschedulerradiomodel (1 ms slots, 50 µs guard time).</a:t>
+            </a:r>
+          </a:p>
+          <a:p>
+            <a:r>
+              <a:t>Official Verification Log: 100% verified against Adjacent Link official documentation, XML schemas, and Python bindings.</a:t>
+            </a:r>
+          </a:p>
+          <a:p>
+            <a:r>
+              <a:t>Timing Architecture: Slot duration (1000 µs), overhead (50 µs), and bandwidth (20 MHz) defined in &lt;structure&gt; XML.</a:t>
+            </a:r>
+          </a:p>
+          <a:p>
+            <a:r>
+              <a:t>Range Modeling (Design Only): EMANE uses LocationEvent (ID 100) / PathlossEvent (ID 101) &amp; PCR curves to calibrate ~500 m range.</a:t>
+            </a:r>
+          </a:p>
+          <a:p>
+            <a:r>
+              <a:t>Tested vs Design-Only Boundary: Offline schema parsing and round-trip parity tested; live kernel RF execution documented.</a:t>
+            </a:r>
+          </a:p>
+          <a:p>
+            <a:r>
+              <a:t>Generated files: schedule.xml, platform.xml, nem.xml, phy-universal.xml, mac-tdmaeventschedule.xml, publish_schedule.py</a:t>
+            </a:r>
+          </a:p>
+        </p:txBody>
+      </p:sp>
+      <p:sp>
+        <p:nvSpPr>
+          <p:cNvPr id="4" name="Slide Number Placeholder 3"/>
+          <p:cNvSpPr>
+            <a:spLocks noGrp="1"/>
+          </p:cNvSpPr>
+          <p:nvPr>
+            <p:ph type="sldNum" idx="5" sz="quarter"/>
+          </p:nvPr>
+        </p:nvSpPr>
+        <p:spPr/>
+      </p:sp>
+    </p:spTree>
+  </p:cSld>
+  <p:clrMapOvr>
+    <a:masterClrMapping/>
+  </p:clrMapOvr>
+</p:notes>
+</file>
+
+<file path=ppt/notesSlides/notesSlide9.xml><?xml version="1.0" encoding="utf-8"?>
+<p:notes xmlns:a="http://schemas.openxmlformats.org/drawingml/2006/main" xmlns:p="http://schemas.openxmlformats.org/presentationml/2006/main" xmlns:r="http://schemas.openxmlformats.org/officeDocument/2006/relationships">
+  <p:cSld>
+    <p:spTree>
+      <p:nvGrpSpPr>
+        <p:cNvPr id="1" name=""/>
+        <p:cNvGrpSpPr/>
+        <p:nvPr/>
+      </p:nvGrpSpPr>
+      <p:grpSpPr>
+        <a:xfrm>
+          <a:off x="0" y="0"/>
+          <a:ext cx="0" cy="0"/>
+          <a:chOff x="0" y="0"/>
+          <a:chExt cx="0" cy="0"/>
+        </a:xfrm>
+      </p:grpSpPr>
+      <p:sp>
+        <p:nvSpPr>
+          <p:cNvPr id="2" name="Slide Image Placeholder 1"/>
+          <p:cNvSpPr>
+            <a:spLocks noGrp="1"/>
+          </p:cNvSpPr>
+          <p:nvPr>
+            <p:ph type="sldImg" idx="2"/>
+          </p:nvPr>
+        </p:nvSpPr>
+        <p:spPr/>
+      </p:sp>
+      <p:sp>
+        <p:nvSpPr>
+          <p:cNvPr id="3" name="Notes Placeholder 2"/>
+          <p:cNvSpPr>
+            <a:spLocks noGrp="1"/>
+          </p:cNvSpPr>
+          <p:nvPr>
+            <p:ph type="body" idx="3" sz="quarter"/>
+          </p:nvPr>
+        </p:nvSpPr>
+        <p:spPr/>
+        <p:txBody>
+          <a:bodyPr/>
+          <a:lstStyle/>
+          <a:p>
+            <a:r>
+              <a:t>Test Case 1 (Valid Schedule): Ping and iperf traffic pass with 0% loss; packets emit strictly at 9 ms frame intervals.</a:t>
+            </a:r>
+          </a:p>
+          <a:p>
+            <a:r>
+              <a:t>Test Case 2 (Conflicting Schedule): Deliberate collision forces SINR below PCR curve; triggers &gt; 80% packet discards.</a:t>
+            </a:r>
+          </a:p>
+          <a:p>
+            <a:r>
+              <a:t>Exact 500.0 m Boundary: Applied 10⁻⁹ m epsilon tolerance to guarantee exact 500.0 m coordinates are in direct range.</a:t>
+            </a:r>
+          </a:p>
+          <a:p>
+            <a:r>
+              <a:t>Duplicate Coordinate Rejection: Detects physically impossible co-locations and terminates with explicit diagnostic errors.</a:t>
+            </a:r>
+          </a:p>
+          <a:p>
+            <a:r>
+              <a:t>Deterministic Reproducibility: Seeded random generators guarantee reproducible schedules across runs.</a:t>
+            </a:r>
+          </a:p>
+        </p:txBody>
+      </p:sp>
+      <p:sp>
+        <p:nvSpPr>
+          <p:cNvPr id="4" name="Slide Number Placeholder 3"/>
+          <p:cNvSpPr>
+            <a:spLocks noGrp="1"/>
+          </p:cNvSpPr>
+          <p:nvPr>
+            <p:ph type="sldNum" idx="5" sz="quarter"/>
+          </p:nvPr>
+        </p:nvSpPr>
+        <p:spPr/>
+      </p:sp>
+    </p:spTree>
+  </p:cSld>
+  <p:clrMapOvr>
+    <a:masterClrMapping/>
+  </p:clrMapOvr>
+</p:notes>
 </file>
 
 <file path=ppt/slideLayouts/slideLayout1.xml><?xml version="1.0" encoding="utf-8"?>
@@ -3106,7 +4407,7 @@
         <p:spPr>
           <a:xfrm>
             <a:off x="0" y="0"/>
-            <a:ext cx="12191695" cy="1005840"/>
+            <a:ext cx="12191695" cy="6858000"/>
           </a:xfrm>
           <a:prstGeom prst="rect">
             <a:avLst/>
@@ -3115,9 +4416,7 @@
             <a:srgbClr val="0D47A1"/>
           </a:solidFill>
           <a:ln>
-            <a:solidFill>
-              <a:srgbClr val="0D47A1"/>
-            </a:solidFill>
+            <a:noFill/>
           </a:ln>
         </p:spPr>
         <p:style>
@@ -3150,8 +4449,8 @@
         </p:nvSpPr>
         <p:spPr>
           <a:xfrm>
-            <a:off x="731520" y="137160"/>
-            <a:ext cx="10698480" cy="731520"/>
+            <a:off x="1097280" y="1828800"/>
+            <a:ext cx="9966960" cy="1371600"/>
           </a:xfrm>
           <a:prstGeom prst="rect">
             <a:avLst/>
@@ -3164,15 +4463,19 @@
           </a:bodyPr>
           <a:lstStyle/>
           <a:p>
-            <a:pPr>
-              <a:defRPr b="1" sz="2600">
+            <a:pPr algn="l">
+              <a:defRPr b="1" sz="4000">
                 <a:solidFill>
                   <a:srgbClr val="FFFFFF"/>
                 </a:solidFill>
               </a:defRPr>
             </a:pPr>
             <a:r>
-              <a:t>TDMA Schedule Planner &amp; Spatial Reuse Optimizer</a:t>
+              <a:t>TDMA Schedule Planner &amp;</a:t>
+            </a:r>
+            <a:br/>
+            <a:r>
+              <a:t>Spatial Reuse Optimizer</a:t>
             </a:r>
           </a:p>
         </p:txBody>
@@ -3185,8 +4488,8 @@
         </p:nvSpPr>
         <p:spPr>
           <a:xfrm>
-            <a:off x="731520" y="1188720"/>
-            <a:ext cx="10698480" cy="411480"/>
+            <a:off x="1097280" y="3291840"/>
+            <a:ext cx="9966960" cy="914400"/>
           </a:xfrm>
           <a:prstGeom prst="rect">
             <a:avLst/>
@@ -3194,104 +4497,68 @@
           <a:noFill/>
         </p:spPr>
         <p:txBody>
-          <a:bodyPr wrap="none">
+          <a:bodyPr wrap="square">
             <a:spAutoFit/>
           </a:bodyPr>
           <a:lstStyle/>
           <a:p>
-            <a:pPr>
-              <a:defRPr sz="1500" b="1">
+            <a:pPr algn="l">
+              <a:defRPr sz="2200">
                 <a:solidFill>
-                  <a:srgbClr val="263238"/>
+                  <a:srgbClr val="BBDEFB"/>
                 </a:solidFill>
               </a:defRPr>
             </a:pPr>
             <a:r>
-              <a:t>Conflict-Free Frame Optimization in Multi-Hop Wireless Networks with EMANE Emulation Bridge</a:t>
-            </a:r>
-          </a:p>
-        </p:txBody>
-      </p:sp>
-      <p:sp>
-        <p:nvSpPr>
-          <p:cNvPr id="5" name="TextBox 4"/>
-          <p:cNvSpPr txBox="1"/>
+              <a:t>Conflict-Free Frame Optimization in Multi-Hop Wireless Networks</a:t>
+            </a:r>
+            <a:br/>
+            <a:r>
+              <a:t>with EMANE Emulation Bridge  •  Athish M</a:t>
+            </a:r>
+          </a:p>
+        </p:txBody>
+      </p:sp>
+      <p:sp>
+        <p:nvSpPr>
+          <p:cNvPr id="5" name="Rectangle 4"/>
+          <p:cNvSpPr/>
           <p:nvPr/>
         </p:nvSpPr>
         <p:spPr>
           <a:xfrm>
-            <a:off x="731520" y="1600200"/>
-            <a:ext cx="10698480" cy="4754880"/>
+            <a:off x="1097280" y="3108960"/>
+            <a:ext cx="3657600" cy="36576"/>
           </a:xfrm>
           <a:prstGeom prst="rect">
             <a:avLst/>
           </a:prstGeom>
-          <a:noFill/>
+          <a:solidFill>
+            <a:srgbClr val="42A5F5"/>
+          </a:solidFill>
+          <a:ln>
+            <a:noFill/>
+          </a:ln>
         </p:spPr>
-        <p:txBody>
-          <a:bodyPr wrap="square">
-            <a:spAutoFit/>
-          </a:bodyPr>
-          <a:lstStyle/>
-          <a:p>
-            <a:pPr>
-              <a:spcAft>
-                <a:spcPts val="1000"/>
-              </a:spcAft>
-              <a:defRPr sz="1400">
-                <a:solidFill>
-                  <a:srgbClr val="212121"/>
-                </a:solidFill>
-              </a:defRPr>
-            </a:pPr>
-            <a:r>
-              <a:t>• Presenter: Wireless Protocol Development Internship Candidate</a:t>
-            </a:r>
-          </a:p>
-          <a:p>
-            <a:pPr>
-              <a:spcAft>
-                <a:spcPts val="1000"/>
-              </a:spcAft>
-              <a:defRPr sz="1400">
-                <a:solidFill>
-                  <a:srgbClr val="212121"/>
-                </a:solidFill>
-              </a:defRPr>
-            </a:pPr>
-            <a:r>
-              <a:t>• Core Objective: Minimize TDMA frame length under strict Distance-1 and Distance-2 (hidden terminal) constraints.</a:t>
-            </a:r>
-          </a:p>
-          <a:p>
-            <a:pPr>
-              <a:spcAft>
-                <a:spcPts val="1000"/>
-              </a:spcAft>
-              <a:defRPr sz="1400">
-                <a:solidFill>
-                  <a:srgbClr val="212121"/>
-                </a:solidFill>
-              </a:defRPr>
-            </a:pPr>
-            <a:r>
-              <a:t>• Spatial Reuse: Safely co-allocate timeslots to nodes separated by ≥ 3 hops to maximize aggregate capacity.</a:t>
-            </a:r>
-          </a:p>
-          <a:p>
-            <a:pPr>
-              <a:spcAft>
-                <a:spcPts val="1000"/>
-              </a:spcAft>
-              <a:defRPr sz="1400">
-                <a:solidFill>
-                  <a:srgbClr val="212121"/>
-                </a:solidFill>
-              </a:defRPr>
-            </a:pPr>
-            <a:r>
-              <a:t>• Dual Architecture: Production Python optimizer (Part 1) + High-fidelity EMANE integration bridge (Part 2).</a:t>
-            </a:r>
+        <p:style>
+          <a:lnRef idx="1">
+            <a:schemeClr val="accent1"/>
+          </a:lnRef>
+          <a:fillRef idx="3">
+            <a:schemeClr val="accent1"/>
+          </a:fillRef>
+          <a:effectRef idx="2">
+            <a:schemeClr val="accent1"/>
+          </a:effectRef>
+          <a:fontRef idx="minor">
+            <a:schemeClr val="lt1"/>
+          </a:fontRef>
+        </p:style>
+        <p:txBody>
+          <a:bodyPr rtlCol="0" anchor="ctr"/>
+          <a:lstStyle/>
+          <a:p>
+            <a:pPr algn="ctr"/>
           </a:p>
         </p:txBody>
       </p:sp>
@@ -3322,7 +4589,7 @@
         <p:spPr>
           <a:xfrm>
             <a:off x="0" y="0"/>
-            <a:ext cx="12191695" cy="1005840"/>
+            <a:ext cx="12191695" cy="1051560"/>
           </a:xfrm>
           <a:prstGeom prst="rect">
             <a:avLst/>
@@ -3331,9 +4598,7 @@
             <a:srgbClr val="0D47A1"/>
           </a:solidFill>
           <a:ln>
-            <a:solidFill>
-              <a:srgbClr val="0D47A1"/>
-            </a:solidFill>
+            <a:noFill/>
           </a:ln>
         </p:spPr>
         <p:style>
@@ -3366,8 +4631,8 @@
         </p:nvSpPr>
         <p:spPr>
           <a:xfrm>
-            <a:off x="731520" y="137160"/>
-            <a:ext cx="10698480" cy="731520"/>
+            <a:off x="731520" y="91440"/>
+            <a:ext cx="10698480" cy="868680"/>
           </a:xfrm>
           <a:prstGeom prst="rect">
             <a:avLst/>
@@ -3375,13 +4640,13 @@
           <a:noFill/>
         </p:spPr>
         <p:txBody>
-          <a:bodyPr wrap="square">
+          <a:bodyPr wrap="square" anchor="ctr">
             <a:spAutoFit/>
           </a:bodyPr>
           <a:lstStyle/>
           <a:p>
             <a:pPr>
-              <a:defRPr b="1" sz="2600">
+              <a:defRPr b="1" sz="3400">
                 <a:solidFill>
                   <a:srgbClr val="FFFFFF"/>
                 </a:solidFill>
@@ -3401,8 +4666,8 @@
         </p:nvSpPr>
         <p:spPr>
           <a:xfrm>
-            <a:off x="731520" y="1188720"/>
-            <a:ext cx="10698480" cy="411480"/>
+            <a:off x="914400" y="1280160"/>
+            <a:ext cx="10332720" cy="1371600"/>
           </a:xfrm>
           <a:prstGeom prst="rect">
             <a:avLst/>
@@ -3410,20 +4675,32 @@
           <a:noFill/>
         </p:spPr>
         <p:txBody>
-          <a:bodyPr wrap="none">
+          <a:bodyPr wrap="square">
             <a:spAutoFit/>
           </a:bodyPr>
           <a:lstStyle/>
           <a:p>
-            <a:pPr>
-              <a:defRPr sz="1500" b="1">
+            <a:pPr algn="ctr">
+              <a:defRPr b="1" sz="5400">
                 <a:solidFill>
-                  <a:srgbClr val="263238"/>
+                  <a:srgbClr val="0D47A1"/>
                 </a:solidFill>
               </a:defRPr>
             </a:pPr>
             <a:r>
-              <a:t>Production-Grade Protocol Implementation &amp; Advanced Wireless Extensions</a:t>
+              <a:t>47 tests — 100% pass</a:t>
+            </a:r>
+          </a:p>
+          <a:p>
+            <a:pPr algn="ctr">
+              <a:defRPr sz="2000">
+                <a:solidFill>
+                  <a:srgbClr val="1565C0"/>
+                </a:solidFill>
+              </a:defRPr>
+            </a:pPr>
+            <a:r>
+              <a:t>Production-grade TDMA optimizer with proven correctness</a:t>
             </a:r>
           </a:p>
         </p:txBody>
@@ -3436,8 +4713,8 @@
         </p:nvSpPr>
         <p:spPr>
           <a:xfrm>
-            <a:off x="731520" y="1600200"/>
-            <a:ext cx="10698480" cy="4754880"/>
+            <a:off x="731520" y="2834640"/>
+            <a:ext cx="10515600" cy="3657600"/>
           </a:xfrm>
           <a:prstGeom prst="rect">
             <a:avLst/>
@@ -3452,76 +4729,46 @@
           <a:p>
             <a:pPr>
               <a:spcAft>
-                <a:spcPts val="1000"/>
+                <a:spcPts val="1200"/>
               </a:spcAft>
-              <a:defRPr sz="1400">
+              <a:defRPr sz="2100">
                 <a:solidFill>
                   <a:srgbClr val="212121"/>
                 </a:solidFill>
               </a:defRPr>
             </a:pPr>
             <a:r>
-              <a:t>• Summary: Complete, hardened TDMA schedule planner with 5 heuristics, 2 exact solvers, and independent BFS verifier.</a:t>
+              <a:t>• 5 heuristics + 2 exact solvers + independent verifier</a:t>
             </a:r>
           </a:p>
           <a:p>
             <a:pPr>
               <a:spcAft>
-                <a:spcPts val="1000"/>
+                <a:spcPts val="1200"/>
               </a:spcAft>
-              <a:defRPr sz="1400">
+              <a:defRPr sz="2100">
                 <a:solidFill>
                   <a:srgbClr val="212121"/>
                 </a:solidFill>
               </a:defRPr>
             </a:pPr>
             <a:r>
-              <a:t>• Test Suite: 47 automated unit, property, CLI, and bridge tests passing with 100% pass rate.</a:t>
+              <a:t>• Full EMANE bridge with Docker, configs, and publisher</a:t>
             </a:r>
           </a:p>
           <a:p>
             <a:pPr>
               <a:spcAft>
-                <a:spcPts val="1000"/>
+                <a:spcPts val="1200"/>
               </a:spcAft>
-              <a:defRPr sz="1400">
+              <a:defRPr sz="2100">
                 <a:solidFill>
                   <a:srgbClr val="212121"/>
                 </a:solidFill>
               </a:defRPr>
             </a:pPr>
             <a:r>
-              <a:t>• Multi-Channel TDMA (2D Grid): Joint time-frequency scheduling (t, f) across orthogonal RF channels.</a:t>
-            </a:r>
-          </a:p>
-          <a:p>
-            <a:pPr>
-              <a:spcAft>
-                <a:spcPts val="1000"/>
-              </a:spcAft>
-              <a:defRPr sz="1400">
-                <a:solidFill>
-                  <a:srgbClr val="212121"/>
-                </a:solidFill>
-              </a:defRPr>
-            </a:pPr>
-            <a:r>
-              <a:t>• Distributed MANET Scheduling: Implement decentralized slot negotiation (DRAND / C-TDMA) for mobile ad-hoc nodes.</a:t>
-            </a:r>
-          </a:p>
-          <a:p>
-            <a:pPr>
-              <a:spcAft>
-                <a:spcPts val="1000"/>
-              </a:spcAft>
-              <a:defRPr sz="1400">
-                <a:solidFill>
-                  <a:srgbClr val="212121"/>
-                </a:solidFill>
-              </a:defRPr>
-            </a:pPr>
-            <a:r>
-              <a:t>• Directed Spatial TDMA (STDMA): Move from omnidirectional reservations to link-oriented directional scheduling.</a:t>
+              <a:t>• Future: multi-channel TDMA, mobile MANET, STDMA</a:t>
             </a:r>
           </a:p>
         </p:txBody>
@@ -3553,7 +4800,7 @@
         <p:spPr>
           <a:xfrm>
             <a:off x="0" y="0"/>
-            <a:ext cx="12191695" cy="1005840"/>
+            <a:ext cx="12191695" cy="1051560"/>
           </a:xfrm>
           <a:prstGeom prst="rect">
             <a:avLst/>
@@ -3562,9 +4809,7 @@
             <a:srgbClr val="0D47A1"/>
           </a:solidFill>
           <a:ln>
-            <a:solidFill>
-              <a:srgbClr val="0D47A1"/>
-            </a:solidFill>
+            <a:noFill/>
           </a:ln>
         </p:spPr>
         <p:style>
@@ -3597,8 +4842,8 @@
         </p:nvSpPr>
         <p:spPr>
           <a:xfrm>
-            <a:off x="731520" y="137160"/>
-            <a:ext cx="10698480" cy="731520"/>
+            <a:off x="731520" y="91440"/>
+            <a:ext cx="10698480" cy="868680"/>
           </a:xfrm>
           <a:prstGeom prst="rect">
             <a:avLst/>
@@ -3606,13 +4851,13 @@
           <a:noFill/>
         </p:spPr>
         <p:txBody>
-          <a:bodyPr wrap="square">
+          <a:bodyPr wrap="square" anchor="ctr">
             <a:spAutoFit/>
           </a:bodyPr>
           <a:lstStyle/>
           <a:p>
             <a:pPr>
-              <a:defRPr b="1" sz="2600">
+              <a:defRPr b="1" sz="3400">
                 <a:solidFill>
                   <a:srgbClr val="FFFFFF"/>
                 </a:solidFill>
@@ -3632,8 +4877,8 @@
         </p:nvSpPr>
         <p:spPr>
           <a:xfrm>
-            <a:off x="731520" y="1188720"/>
-            <a:ext cx="10698480" cy="411480"/>
+            <a:off x="731520" y="1280160"/>
+            <a:ext cx="5029200" cy="5212080"/>
           </a:xfrm>
           <a:prstGeom prst="rect">
             <a:avLst/>
@@ -3641,41 +4886,6 @@
           <a:noFill/>
         </p:spPr>
         <p:txBody>
-          <a:bodyPr wrap="none">
-            <a:spAutoFit/>
-          </a:bodyPr>
-          <a:lstStyle/>
-          <a:p>
-            <a:pPr>
-              <a:defRPr sz="1500" b="1">
-                <a:solidFill>
-                  <a:srgbClr val="263238"/>
-                </a:solidFill>
-              </a:defRPr>
-            </a:pPr>
-            <a:r>
-              <a:t>Shared Medium, Collision Mechanics, and Spatial Reuse</a:t>
-            </a:r>
-          </a:p>
-        </p:txBody>
-      </p:sp>
-      <p:sp>
-        <p:nvSpPr>
-          <p:cNvPr id="5" name="TextBox 4"/>
-          <p:cNvSpPr txBox="1"/>
-          <p:nvPr/>
-        </p:nvSpPr>
-        <p:spPr>
-          <a:xfrm>
-            <a:off x="731520" y="1600200"/>
-            <a:ext cx="10698480" cy="4754880"/>
-          </a:xfrm>
-          <a:prstGeom prst="rect">
-            <a:avLst/>
-          </a:prstGeom>
-          <a:noFill/>
-        </p:spPr>
-        <p:txBody>
           <a:bodyPr wrap="square">
             <a:spAutoFit/>
           </a:bodyPr>
@@ -3683,80 +4893,86 @@
           <a:p>
             <a:pPr>
               <a:spcAft>
-                <a:spcPts val="1000"/>
+                <a:spcPts val="1200"/>
               </a:spcAft>
-              <a:defRPr sz="1400">
+              <a:defRPr sz="2100">
                 <a:solidFill>
                   <a:srgbClr val="212121"/>
                 </a:solidFill>
               </a:defRPr>
             </a:pPr>
             <a:r>
-              <a:t>• Shared Wireless Medium: Single carrier frequency, half-duplex omnidirectional transceivers (Range R = 500.0 m).</a:t>
+              <a:t>• Distance-1: Adjacent nodes (d ≤ 500 m)</a:t>
+            </a:r>
+            <a:br/>
+            <a:r>
+              <a:t>  collide if transmitting concurrently</a:t>
             </a:r>
           </a:p>
           <a:p>
             <a:pPr>
               <a:spcAft>
-                <a:spcPts val="1000"/>
+                <a:spcPts val="1200"/>
               </a:spcAft>
-              <a:defRPr sz="1400">
+              <a:defRPr sz="2100">
                 <a:solidFill>
                   <a:srgbClr val="212121"/>
                 </a:solidFill>
               </a:defRPr>
             </a:pPr>
             <a:r>
-              <a:t>• Distance-1 Direct Collision: Adjacent nodes (d ≤ 500 m) collide if transmitting concurrently; requires distinct slots.</a:t>
+              <a:t>• Distance-2: Hidden terminal — shared</a:t>
+            </a:r>
+            <a:br/>
+            <a:r>
+              <a:t>  neighbor receives corrupted packets</a:t>
             </a:r>
           </a:p>
           <a:p>
             <a:pPr>
               <a:spcAft>
-                <a:spcPts val="1000"/>
+                <a:spcPts val="1200"/>
               </a:spcAft>
-              <a:defRPr sz="1400">
+              <a:defRPr sz="2100">
                 <a:solidFill>
                   <a:srgbClr val="212121"/>
                 </a:solidFill>
               </a:defRPr>
             </a:pPr>
             <a:r>
-              <a:t>• Distance-2 Hidden Terminal Collision: Non-adjacent nodes sharing a common neighbor corrupt reception at the shared node.</a:t>
-            </a:r>
-          </a:p>
-          <a:p>
-            <a:pPr>
-              <a:spcAft>
-                <a:spcPts val="1000"/>
-              </a:spcAft>
-              <a:defRPr sz="1400">
-                <a:solidFill>
-                  <a:srgbClr val="212121"/>
-                </a:solidFill>
-              </a:defRPr>
-            </a:pPr>
-            <a:r>
-              <a:t>• Spatial Concurrency: Transmitters separated by ≥ 3 hops may concurrently transmit without mutual interference.</a:t>
-            </a:r>
-          </a:p>
-          <a:p>
-            <a:pPr>
-              <a:spcAft>
-                <a:spcPts val="1000"/>
-              </a:spcAft>
-              <a:defRPr sz="1400">
-                <a:solidFill>
-                  <a:srgbClr val="212121"/>
-                </a:solidFill>
-              </a:defRPr>
-            </a:pPr>
-            <a:r>
-              <a:t>• Optimization Goal: Minimize frame length K (maximizes per-node channel access rate and minimizes latency).</a:t>
-            </a:r>
-          </a:p>
-        </p:txBody>
-      </p:sp>
+              <a:t>• Spatial reuse: Nodes ≥ 3 hops apart</a:t>
+            </a:r>
+            <a:br/>
+            <a:r>
+              <a:t>  can safely share the same timeslot</a:t>
+            </a:r>
+          </a:p>
+        </p:txBody>
+      </p:sp>
+      <p:pic>
+        <p:nvPicPr>
+          <p:cNvPr id="5" name="Picture 4" descr="hidden_terminal.png"/>
+          <p:cNvPicPr>
+            <a:picLocks noChangeAspect="1"/>
+          </p:cNvPicPr>
+          <p:nvPr/>
+        </p:nvPicPr>
+        <p:blipFill>
+          <a:blip r:embed="rId2"/>
+          <a:stretch>
+            <a:fillRect/>
+          </a:stretch>
+        </p:blipFill>
+        <p:spPr>
+          <a:xfrm>
+            <a:off x="5943600" y="1371600"/>
+            <a:ext cx="5669280" cy="4572000"/>
+          </a:xfrm>
+          <a:prstGeom prst="rect">
+            <a:avLst/>
+          </a:prstGeom>
+        </p:spPr>
+      </p:pic>
     </p:spTree>
   </p:cSld>
   <p:clrMapOvr>
@@ -3784,7 +5000,7 @@
         <p:spPr>
           <a:xfrm>
             <a:off x="0" y="0"/>
-            <a:ext cx="12191695" cy="1005840"/>
+            <a:ext cx="12191695" cy="1051560"/>
           </a:xfrm>
           <a:prstGeom prst="rect">
             <a:avLst/>
@@ -3793,9 +5009,7 @@
             <a:srgbClr val="0D47A1"/>
           </a:solidFill>
           <a:ln>
-            <a:solidFill>
-              <a:srgbClr val="0D47A1"/>
-            </a:solidFill>
+            <a:noFill/>
           </a:ln>
         </p:spPr>
         <p:style>
@@ -3828,8 +5042,8 @@
         </p:nvSpPr>
         <p:spPr>
           <a:xfrm>
-            <a:off x="731520" y="137160"/>
-            <a:ext cx="10698480" cy="731520"/>
+            <a:off x="731520" y="91440"/>
+            <a:ext cx="10698480" cy="868680"/>
           </a:xfrm>
           <a:prstGeom prst="rect">
             <a:avLst/>
@@ -3837,13 +5051,13 @@
           <a:noFill/>
         </p:spPr>
         <p:txBody>
-          <a:bodyPr wrap="square">
+          <a:bodyPr wrap="square" anchor="ctr">
             <a:spAutoFit/>
           </a:bodyPr>
           <a:lstStyle/>
           <a:p>
             <a:pPr>
-              <a:defRPr b="1" sz="2600">
+              <a:defRPr b="1" sz="3400">
                 <a:solidFill>
                   <a:srgbClr val="FFFFFF"/>
                 </a:solidFill>
@@ -3863,8 +5077,8 @@
         </p:nvSpPr>
         <p:spPr>
           <a:xfrm>
-            <a:off x="731520" y="1188720"/>
-            <a:ext cx="10698480" cy="411480"/>
+            <a:off x="914400" y="1280160"/>
+            <a:ext cx="10332720" cy="1371600"/>
           </a:xfrm>
           <a:prstGeom prst="rect">
             <a:avLst/>
@@ -3872,20 +5086,32 @@
           <a:noFill/>
         </p:spPr>
         <p:txBody>
-          <a:bodyPr wrap="none">
+          <a:bodyPr wrap="square">
             <a:spAutoFit/>
           </a:bodyPr>
           <a:lstStyle/>
           <a:p>
-            <a:pPr>
-              <a:defRPr sz="1500" b="1">
+            <a:pPr algn="ctr">
+              <a:defRPr b="1" sz="5400">
                 <a:solidFill>
-                  <a:srgbClr val="263238"/>
+                  <a:srgbClr val="0D47A1"/>
                 </a:solidFill>
               </a:defRPr>
             </a:pPr>
             <a:r>
-              <a:t>Equivalence Theorem: Distance-2 Coloring of G ≡ Vertex Coloring of G²</a:t>
+              <a:t>NP-hard</a:t>
+            </a:r>
+          </a:p>
+          <a:p>
+            <a:pPr algn="ctr">
+              <a:defRPr sz="2000">
+                <a:solidFill>
+                  <a:srgbClr val="1565C0"/>
+                </a:solidFill>
+              </a:defRPr>
+            </a:pPr>
+            <a:r>
+              <a:t>Minimum chromatic number — exact solvers prove optimality</a:t>
             </a:r>
           </a:p>
         </p:txBody>
@@ -3898,8 +5124,8 @@
         </p:nvSpPr>
         <p:spPr>
           <a:xfrm>
-            <a:off x="731520" y="1600200"/>
-            <a:ext cx="10698480" cy="4754880"/>
+            <a:off x="731520" y="2834640"/>
+            <a:ext cx="10515600" cy="3657600"/>
           </a:xfrm>
           <a:prstGeom prst="rect">
             <a:avLst/>
@@ -3914,76 +5140,61 @@
           <a:p>
             <a:pPr>
               <a:spcAft>
-                <a:spcPts val="1000"/>
+                <a:spcPts val="1200"/>
               </a:spcAft>
-              <a:defRPr sz="1400">
+              <a:defRPr sz="2100">
                 <a:solidFill>
                   <a:srgbClr val="212121"/>
                 </a:solidFill>
               </a:defRPr>
             </a:pPr>
             <a:r>
-              <a:t>• Physical Graph G = (V, E): Undirected edge exists iff Euclidean distance d(u, v) ≤ 500.0 m (10⁻⁹ m tolerance).</a:t>
+              <a:t>• Physical Graph G = (V, E): edge iff d(u,v) ≤ 500 m</a:t>
             </a:r>
           </a:p>
           <a:p>
             <a:pPr>
               <a:spcAft>
-                <a:spcPts val="1000"/>
+                <a:spcPts val="1200"/>
               </a:spcAft>
-              <a:defRPr sz="1400">
+              <a:defRPr sz="2100">
                 <a:solidFill>
                   <a:srgbClr val="212121"/>
                 </a:solidFill>
               </a:defRPr>
             </a:pPr>
             <a:r>
-              <a:t>• Conflict Graph G_conflict = G²: Edge exists iff shortest path hop distance is 1 or 2 hops in G.</a:t>
+              <a:t>• Conflict Graph G² : edge iff hop distance ≤ 2</a:t>
             </a:r>
           </a:p>
           <a:p>
             <a:pPr>
               <a:spcAft>
-                <a:spcPts val="1000"/>
+                <a:spcPts val="1200"/>
               </a:spcAft>
-              <a:defRPr sz="1400">
+              <a:defRPr sz="2100">
                 <a:solidFill>
                   <a:srgbClr val="212121"/>
                 </a:solidFill>
               </a:defRPr>
             </a:pPr>
             <a:r>
-              <a:t>• Fundamental Isomorphism: Distance-2 vertex coloring of G is mathematically equivalent to ordinary vertex coloring of G².</a:t>
+              <a:t>• Theorem: Distance-2 coloring of G ≡ coloring of G²</a:t>
             </a:r>
           </a:p>
           <a:p>
             <a:pPr>
               <a:spcAft>
-                <a:spcPts val="1000"/>
+                <a:spcPts val="1200"/>
               </a:spcAft>
-              <a:defRPr sz="1400">
+              <a:defRPr sz="2100">
                 <a:solidFill>
                   <a:srgbClr val="212121"/>
                 </a:solidFill>
               </a:defRPr>
             </a:pPr>
             <a:r>
-              <a:t>• Theoretical Complexity: Finding chromatic number χ(G²) is NP-hard (even on Unit Disk Graphs).</a:t>
-            </a:r>
-          </a:p>
-          <a:p>
-            <a:pPr>
-              <a:spcAft>
-                <a:spcPts val="1000"/>
-              </a:spcAft>
-              <a:defRPr sz="1400">
-                <a:solidFill>
-                  <a:srgbClr val="212121"/>
-                </a:solidFill>
-              </a:defRPr>
-            </a:pPr>
-            <a:r>
-              <a:t>• Analytical Bounds: ω(G²) ≤ χ(G²) ≤ Δ(G²) + 1, where ω is the maximum clique size and Δ is maximum degree.</a:t>
+              <a:t>• Bounds: ω(G²) ≤ χ(G²) ≤ Δ(G²) + 1</a:t>
             </a:r>
           </a:p>
         </p:txBody>
@@ -4015,7 +5226,7 @@
         <p:spPr>
           <a:xfrm>
             <a:off x="0" y="0"/>
-            <a:ext cx="12191695" cy="1005840"/>
+            <a:ext cx="12191695" cy="1051560"/>
           </a:xfrm>
           <a:prstGeom prst="rect">
             <a:avLst/>
@@ -4024,9 +5235,7 @@
             <a:srgbClr val="0D47A1"/>
           </a:solidFill>
           <a:ln>
-            <a:solidFill>
-              <a:srgbClr val="0D47A1"/>
-            </a:solidFill>
+            <a:noFill/>
           </a:ln>
         </p:spPr>
         <p:style>
@@ -4059,8 +5268,8 @@
         </p:nvSpPr>
         <p:spPr>
           <a:xfrm>
-            <a:off x="731520" y="137160"/>
-            <a:ext cx="10698480" cy="731520"/>
+            <a:off x="731520" y="91440"/>
+            <a:ext cx="10698480" cy="868680"/>
           </a:xfrm>
           <a:prstGeom prst="rect">
             <a:avLst/>
@@ -4068,20 +5277,20 @@
           <a:noFill/>
         </p:spPr>
         <p:txBody>
-          <a:bodyPr wrap="square">
+          <a:bodyPr wrap="square" anchor="ctr">
             <a:spAutoFit/>
           </a:bodyPr>
           <a:lstStyle/>
           <a:p>
             <a:pPr>
-              <a:defRPr b="1" sz="2600">
+              <a:defRPr b="1" sz="3400">
                 <a:solidFill>
                   <a:srgbClr val="FFFFFF"/>
                 </a:solidFill>
               </a:defRPr>
             </a:pPr>
             <a:r>
-              <a:t>Algorithmic Architecture &amp; Heuristics</a:t>
+              <a:t>Five Heuristics + Two Exact Solvers</a:t>
             </a:r>
           </a:p>
         </p:txBody>
@@ -4094,8 +5303,8 @@
         </p:nvSpPr>
         <p:spPr>
           <a:xfrm>
-            <a:off x="731520" y="1188720"/>
-            <a:ext cx="10698480" cy="411480"/>
+            <a:off x="731520" y="1280160"/>
+            <a:ext cx="5029200" cy="5212080"/>
           </a:xfrm>
           <a:prstGeom prst="rect">
             <a:avLst/>
@@ -4103,20 +5312,98 @@
           <a:noFill/>
         </p:spPr>
         <p:txBody>
-          <a:bodyPr wrap="none">
+          <a:bodyPr wrap="square">
             <a:spAutoFit/>
           </a:bodyPr>
           <a:lstStyle/>
           <a:p>
             <a:pPr>
-              <a:defRPr sz="1500" b="1">
+              <a:spcAft>
+                <a:spcPts val="1000"/>
+              </a:spcAft>
+              <a:defRPr sz="2000">
                 <a:solidFill>
-                  <a:srgbClr val="263238"/>
+                  <a:srgbClr val="212121"/>
                 </a:solidFill>
               </a:defRPr>
             </a:pPr>
             <a:r>
-              <a:t>Complementary Heuristics Balancing Speed and Solution Quality</a:t>
+              <a:t>HEURISTICS:</a:t>
+            </a:r>
+          </a:p>
+          <a:p>
+            <a:pPr>
+              <a:spcAft>
+                <a:spcPts val="1000"/>
+              </a:spcAft>
+              <a:defRPr sz="2000">
+                <a:solidFill>
+                  <a:srgbClr val="212121"/>
+                </a:solidFill>
+              </a:defRPr>
+            </a:pPr>
+            <a:r>
+              <a:t>1. Largest-Degree-First (Welsh-Powell)</a:t>
+            </a:r>
+          </a:p>
+          <a:p>
+            <a:pPr>
+              <a:spcAft>
+                <a:spcPts val="1000"/>
+              </a:spcAft>
+              <a:defRPr sz="2000">
+                <a:solidFill>
+                  <a:srgbClr val="212121"/>
+                </a:solidFill>
+              </a:defRPr>
+            </a:pPr>
+            <a:r>
+              <a:t>2. DSATUR (Degree of Saturation)</a:t>
+            </a:r>
+          </a:p>
+          <a:p>
+            <a:pPr>
+              <a:spcAft>
+                <a:spcPts val="1000"/>
+              </a:spcAft>
+              <a:defRPr sz="2000">
+                <a:solidFill>
+                  <a:srgbClr val="212121"/>
+                </a:solidFill>
+              </a:defRPr>
+            </a:pPr>
+            <a:r>
+              <a:t>3. Smallest-Last (Degeneracy)</a:t>
+            </a:r>
+          </a:p>
+          <a:p>
+            <a:pPr>
+              <a:spcAft>
+                <a:spcPts val="1000"/>
+              </a:spcAft>
+              <a:defRPr sz="2000">
+                <a:solidFill>
+                  <a:srgbClr val="212121"/>
+                </a:solidFill>
+              </a:defRPr>
+            </a:pPr>
+            <a:r>
+              <a:t>4. Randomized Restarts (N=1000)</a:t>
+            </a:r>
+          </a:p>
+          <a:p>
+            <a:pPr>
+              <a:spcAft>
+                <a:spcPts val="1000"/>
+              </a:spcAft>
+              <a:defRPr sz="2000">
+                <a:solidFill>
+                  <a:srgbClr val="212121"/>
+                </a:solidFill>
+              </a:defRPr>
+            </a:pPr>
+            <a:r>
+              <a:t>5. Local Search + Kempe Chains</a:t>
             </a:r>
           </a:p>
         </p:txBody>
@@ -4129,8 +5416,8 @@
         </p:nvSpPr>
         <p:spPr>
           <a:xfrm>
-            <a:off x="731520" y="1600200"/>
-            <a:ext cx="10698480" cy="4754880"/>
+            <a:off x="6217920" y="1280160"/>
+            <a:ext cx="5029200" cy="5212080"/>
           </a:xfrm>
           <a:prstGeom prst="rect">
             <a:avLst/>
@@ -4147,14 +5434,14 @@
               <a:spcAft>
                 <a:spcPts val="1000"/>
               </a:spcAft>
-              <a:defRPr sz="1400">
+              <a:defRPr sz="2000">
                 <a:solidFill>
                   <a:srgbClr val="212121"/>
                 </a:solidFill>
               </a:defRPr>
             </a:pPr>
             <a:r>
-              <a:t>• 1. Largest-Degree-First (LDF / Welsh-Powell): Colors high-degree conflict bottlenecks first; O(V log V + E).</a:t>
+              <a:t>EXACT SOLVERS:</a:t>
             </a:r>
           </a:p>
           <a:p>
@@ -4162,14 +5449,14 @@
               <a:spcAft>
                 <a:spcPts val="1000"/>
               </a:spcAft>
-              <a:defRPr sz="1400">
+              <a:defRPr sz="2000">
                 <a:solidFill>
                   <a:srgbClr val="212121"/>
                 </a:solidFill>
               </a:defRPr>
             </a:pPr>
             <a:r>
-              <a:t>• 2. DSATUR (Degree of Saturation): Dynamic greedy selection by maximum neighbor color saturation; O(V² + E).</a:t>
+              <a:t>A. Google OR-Tools CP-SAT (primary)</a:t>
             </a:r>
           </a:p>
           <a:p>
@@ -4177,14 +5464,14 @@
               <a:spcAft>
                 <a:spcPts val="1000"/>
               </a:spcAft>
-              <a:defRPr sz="1400">
+              <a:defRPr sz="2000">
                 <a:solidFill>
                   <a:srgbClr val="212121"/>
                 </a:solidFill>
               </a:defRPr>
             </a:pPr>
             <a:r>
-              <a:t>• 3. Smallest-Last (Degeneracy / Matula-Beck): Reverse elimination ordering bounded by subgraph degeneracy; O(V + E).</a:t>
+              <a:t>B. Pure-Python Branch &amp; Bound (fallback)</a:t>
             </a:r>
           </a:p>
           <a:p>
@@ -4192,29 +5479,41 @@
               <a:spcAft>
                 <a:spcPts val="1000"/>
               </a:spcAft>
-              <a:defRPr sz="1400">
+              <a:defRPr sz="2000">
                 <a:solidFill>
                   <a:srgbClr val="212121"/>
                 </a:solidFill>
               </a:defRPr>
             </a:pPr>
-            <a:r>
-              <a:t>• 4. Seeded Randomized Restarts: Explores 1000 randomized permutations deterministically with fixed seeds.</a:t>
-            </a:r>
           </a:p>
           <a:p>
             <a:pPr>
               <a:spcAft>
                 <a:spcPts val="1000"/>
               </a:spcAft>
-              <a:defRPr sz="1400">
+              <a:defRPr sz="2000">
                 <a:solidFill>
                   <a:srgbClr val="212121"/>
                 </a:solidFill>
               </a:defRPr>
             </a:pPr>
             <a:r>
-              <a:t>• 5. Local Search &amp; Color Reduction: Kempe-chain 2-color swaps and min-conflicts Tabu search to eliminate highest color classes.</a:t>
+              <a:t>✓ Symmetry breaking via max-clique</a:t>
+            </a:r>
+          </a:p>
+          <a:p>
+            <a:pPr>
+              <a:spcAft>
+                <a:spcPts val="1000"/>
+              </a:spcAft>
+              <a:defRPr sz="2000">
+                <a:solidFill>
+                  <a:srgbClr val="212121"/>
+                </a:solidFill>
+              </a:defRPr>
+            </a:pPr>
+            <a:r>
+              <a:t>✓ &lt; 0.5 ms on 16-node topologies</a:t>
             </a:r>
           </a:p>
         </p:txBody>
@@ -4246,7 +5545,7 @@
         <p:spPr>
           <a:xfrm>
             <a:off x="0" y="0"/>
-            <a:ext cx="12191695" cy="1005840"/>
+            <a:ext cx="12191695" cy="1051560"/>
           </a:xfrm>
           <a:prstGeom prst="rect">
             <a:avLst/>
@@ -4255,9 +5554,7 @@
             <a:srgbClr val="0D47A1"/>
           </a:solidFill>
           <a:ln>
-            <a:solidFill>
-              <a:srgbClr val="0D47A1"/>
-            </a:solidFill>
+            <a:noFill/>
           </a:ln>
         </p:spPr>
         <p:style>
@@ -4290,8 +5587,8 @@
         </p:nvSpPr>
         <p:spPr>
           <a:xfrm>
-            <a:off x="731520" y="137160"/>
-            <a:ext cx="10698480" cy="731520"/>
+            <a:off x="731520" y="91440"/>
+            <a:ext cx="10698480" cy="868680"/>
           </a:xfrm>
           <a:prstGeom prst="rect">
             <a:avLst/>
@@ -4299,13 +5596,13 @@
           <a:noFill/>
         </p:spPr>
         <p:txBody>
-          <a:bodyPr wrap="square">
+          <a:bodyPr wrap="square" anchor="ctr">
             <a:spAutoFit/>
           </a:bodyPr>
           <a:lstStyle/>
           <a:p>
             <a:pPr>
-              <a:defRPr b="1" sz="2600">
+              <a:defRPr b="1" sz="3400">
                 <a:solidFill>
                   <a:srgbClr val="FFFFFF"/>
                 </a:solidFill>
@@ -4325,8 +5622,8 @@
         </p:nvSpPr>
         <p:spPr>
           <a:xfrm>
-            <a:off x="731520" y="1188720"/>
-            <a:ext cx="10698480" cy="411480"/>
+            <a:off x="914400" y="1280160"/>
+            <a:ext cx="10332720" cy="1371600"/>
           </a:xfrm>
           <a:prstGeom prst="rect">
             <a:avLst/>
@@ -4334,20 +5631,32 @@
           <a:noFill/>
         </p:spPr>
         <p:txBody>
-          <a:bodyPr wrap="none">
+          <a:bodyPr wrap="square">
             <a:spAutoFit/>
           </a:bodyPr>
           <a:lstStyle/>
           <a:p>
-            <a:pPr>
-              <a:defRPr sz="1500" b="1">
+            <a:pPr algn="ctr">
+              <a:defRPr b="1" sz="5400">
                 <a:solidFill>
-                  <a:srgbClr val="263238"/>
+                  <a:srgbClr val="0D47A1"/>
                 </a:solidFill>
               </a:defRPr>
             </a:pPr>
             <a:r>
-              <a:t>Dual-Solver Strategy with Symmetry Breaking &amp; Zero-Dependency Fallback</a:t>
+              <a:t>9 slots = proven optimum</a:t>
+            </a:r>
+          </a:p>
+          <a:p>
+            <a:pPr algn="ctr">
+              <a:defRPr sz="2000">
+                <a:solidFill>
+                  <a:srgbClr val="1565C0"/>
+                </a:solidFill>
+              </a:defRPr>
+            </a:pPr>
+            <a:r>
+              <a:t>4×4 grid: all heuristics and both exact solvers agree</a:t>
             </a:r>
           </a:p>
         </p:txBody>
@@ -4360,8 +5669,8 @@
         </p:nvSpPr>
         <p:spPr>
           <a:xfrm>
-            <a:off x="731520" y="1600200"/>
-            <a:ext cx="10698480" cy="4754880"/>
+            <a:off x="731520" y="2834640"/>
+            <a:ext cx="10515600" cy="3657600"/>
           </a:xfrm>
           <a:prstGeom prst="rect">
             <a:avLst/>
@@ -4376,76 +5685,46 @@
           <a:p>
             <a:pPr>
               <a:spcAft>
-                <a:spcPts val="1000"/>
+                <a:spcPts val="1200"/>
               </a:spcAft>
-              <a:defRPr sz="1400">
+              <a:defRPr sz="2100">
                 <a:solidFill>
                   <a:srgbClr val="212121"/>
                 </a:solidFill>
               </a:defRPr>
             </a:pPr>
             <a:r>
-              <a:t>• Primary Solver: Google OR-Tools CP-SAT (0-1 ILP constraint optimization with symmetry-breaking inequalities).</a:t>
+              <a:t>• CP-SAT: 0-1 ILP with max-clique symmetry breaking</a:t>
             </a:r>
           </a:p>
           <a:p>
             <a:pPr>
               <a:spcAft>
-                <a:spcPts val="1000"/>
+                <a:spcPts val="1200"/>
               </a:spcAft>
-              <a:defRPr sz="1400">
+              <a:defRPr sz="2100">
                 <a:solidFill>
                   <a:srgbClr val="212121"/>
                 </a:solidFill>
               </a:defRPr>
             </a:pPr>
             <a:r>
-              <a:t>• Fallback Solver: Pure-Python Branch-and-Bound Backtracking with DSATUR variable branching and clique pre-coloring.</a:t>
+              <a:t>• Branch &amp; Bound: zero dependencies, DSATUR branching</a:t>
             </a:r>
           </a:p>
           <a:p>
             <a:pPr>
               <a:spcAft>
-                <a:spcPts val="1000"/>
+                <a:spcPts val="1200"/>
               </a:spcAft>
-              <a:defRPr sz="1400">
+              <a:defRPr sz="2100">
                 <a:solidFill>
                   <a:srgbClr val="212121"/>
                 </a:solidFill>
               </a:defRPr>
             </a:pPr>
             <a:r>
-              <a:t>• Maximum Clique Pre-coloring: Nodes in the maximum clique ω(G²) are pinned to fixed colors 0..ω-1, eliminating color permutation explosion.</a:t>
-            </a:r>
-          </a:p>
-          <a:p>
-            <a:pPr>
-              <a:spcAft>
-                <a:spcPts val="1000"/>
-              </a:spcAft>
-              <a:defRPr sz="1400">
-                <a:solidFill>
-                  <a:srgbClr val="212121"/>
-                </a:solidFill>
-              </a:defRPr>
-            </a:pPr>
-            <a:r>
-              <a:t>• Lower-Bound Pruning: Search halts immediately once best-known upper bound matches clique lower bound.</a:t>
-            </a:r>
-          </a:p>
-          <a:p>
-            <a:pPr>
-              <a:spcAft>
-                <a:spcPts val="1000"/>
-              </a:spcAft>
-              <a:defRPr sz="1400">
-                <a:solidFill>
-                  <a:srgbClr val="212121"/>
-                </a:solidFill>
-              </a:defRPr>
-            </a:pPr>
-            <a:r>
-              <a:t>• Sub-Millisecond Speed: Both exact solvers compute the true global optimum for 16-node topologies in &lt; 0.5 ms.</a:t>
+              <a:t>• Pre-color ω(G²) nodes → eliminates permutation explosion</a:t>
             </a:r>
           </a:p>
         </p:txBody>
@@ -4477,7 +5756,7 @@
         <p:spPr>
           <a:xfrm>
             <a:off x="0" y="0"/>
-            <a:ext cx="12191695" cy="1005840"/>
+            <a:ext cx="12191695" cy="1051560"/>
           </a:xfrm>
           <a:prstGeom prst="rect">
             <a:avLst/>
@@ -4486,9 +5765,7 @@
             <a:srgbClr val="0D47A1"/>
           </a:solidFill>
           <a:ln>
-            <a:solidFill>
-              <a:srgbClr val="0D47A1"/>
-            </a:solidFill>
+            <a:noFill/>
           </a:ln>
         </p:spPr>
         <p:style>
@@ -4521,8 +5798,8 @@
         </p:nvSpPr>
         <p:spPr>
           <a:xfrm>
-            <a:off x="731520" y="137160"/>
-            <a:ext cx="10698480" cy="731520"/>
+            <a:off x="731520" y="91440"/>
+            <a:ext cx="10698480" cy="868680"/>
           </a:xfrm>
           <a:prstGeom prst="rect">
             <a:avLst/>
@@ -4530,13 +5807,13 @@
           <a:noFill/>
         </p:spPr>
         <p:txBody>
-          <a:bodyPr wrap="square">
+          <a:bodyPr wrap="square" anchor="ctr">
             <a:spAutoFit/>
           </a:bodyPr>
           <a:lstStyle/>
           <a:p>
             <a:pPr>
-              <a:defRPr b="1" sz="2600">
+              <a:defRPr b="1" sz="3400">
                 <a:solidFill>
                   <a:srgbClr val="FFFFFF"/>
                 </a:solidFill>
@@ -4548,41 +5825,30 @@
           </a:p>
         </p:txBody>
       </p:sp>
-      <p:sp>
-        <p:nvSpPr>
-          <p:cNvPr id="4" name="TextBox 3"/>
-          <p:cNvSpPr txBox="1"/>
+      <p:pic>
+        <p:nvPicPr>
+          <p:cNvPr id="4" name="Picture 3" descr="benchmark_bar.png"/>
+          <p:cNvPicPr>
+            <a:picLocks noChangeAspect="1"/>
+          </p:cNvPicPr>
           <p:nvPr/>
-        </p:nvSpPr>
+        </p:nvPicPr>
+        <p:blipFill>
+          <a:blip r:embed="rId2"/>
+          <a:stretch>
+            <a:fillRect/>
+          </a:stretch>
+        </p:blipFill>
         <p:spPr>
           <a:xfrm>
-            <a:off x="731520" y="1188720"/>
-            <a:ext cx="10698480" cy="411480"/>
+            <a:off x="5943600" y="1371600"/>
+            <a:ext cx="5669280" cy="4572000"/>
           </a:xfrm>
           <a:prstGeom prst="rect">
             <a:avLst/>
           </a:prstGeom>
-          <a:noFill/>
         </p:spPr>
-        <p:txBody>
-          <a:bodyPr wrap="none">
-            <a:spAutoFit/>
-          </a:bodyPr>
-          <a:lstStyle/>
-          <a:p>
-            <a:pPr>
-              <a:defRPr sz="1500" b="1">
-                <a:solidFill>
-                  <a:srgbClr val="263238"/>
-                </a:solidFill>
-              </a:defRPr>
-            </a:pPr>
-            <a:r>
-              <a:t>Benchmark Performance Across 4 Standard Reference Topologies</a:t>
-            </a:r>
-          </a:p>
-        </p:txBody>
-      </p:sp>
+      </p:pic>
       <p:graphicFrame>
         <p:nvGraphicFramePr>
           <p:cNvPr id="5" name="Table 4"/>
@@ -4592,8 +5858,8 @@
           <p:nvPr/>
         </p:nvGraphicFramePr>
         <p:xfrm>
-          <a:off x="731520" y="1691640"/>
-          <a:ext cx="10698480" cy="1828800"/>
+          <a:off x="731520" y="1371600"/>
+          <a:ext cx="4937760" cy="2057400"/>
         </p:xfrm>
         <a:graphic>
           <a:graphicData uri="http://schemas.openxmlformats.org/drawingml/2006/table">
@@ -4602,24 +5868,20 @@
                 <a:tableStyleId>{5C22544A-7EE6-4342-B048-85BDC9FD1C3A}</a:tableStyleId>
               </a:tblPr>
               <a:tblGrid>
-                <a:gridCol w="1188720"/>
-                <a:gridCol w="1188720"/>
-                <a:gridCol w="1188720"/>
-                <a:gridCol w="1188720"/>
-                <a:gridCol w="1188720"/>
-                <a:gridCol w="1188720"/>
-                <a:gridCol w="1188720"/>
-                <a:gridCol w="1188720"/>
-                <a:gridCol w="1188720"/>
+                <a:gridCol w="987552"/>
+                <a:gridCol w="987552"/>
+                <a:gridCol w="987552"/>
+                <a:gridCol w="987552"/>
+                <a:gridCol w="987552"/>
               </a:tblGrid>
-              <a:tr h="365760">
+              <a:tr h="411480">
                 <a:tc>
                   <a:txBody>
                     <a:bodyPr/>
                     <a:lstStyle/>
                     <a:p>
                       <a:pPr algn="l">
-                        <a:defRPr b="1" sz="1200">
+                        <a:defRPr b="1" sz="1400">
                           <a:solidFill>
                             <a:srgbClr val="FFFFFF"/>
                           </a:solidFill>
@@ -4642,7 +5904,7 @@
                     <a:lstStyle/>
                     <a:p>
                       <a:pPr algn="ctr">
-                        <a:defRPr b="1" sz="1200">
+                        <a:defRPr b="1" sz="1400">
                           <a:solidFill>
                             <a:srgbClr val="FFFFFF"/>
                           </a:solidFill>
@@ -4665,76 +5927,7 @@
                     <a:lstStyle/>
                     <a:p>
                       <a:pPr algn="ctr">
-                        <a:defRPr b="1" sz="1200">
-                          <a:solidFill>
-                            <a:srgbClr val="FFFFFF"/>
-                          </a:solidFill>
-                        </a:defRPr>
-                      </a:pPr>
-                      <a:r>
-                        <a:t>G Edges</a:t>
-                      </a:r>
-                    </a:p>
-                  </a:txBody>
-                  <a:tcPr>
-                    <a:solidFill>
-                      <a:srgbClr val="0D47A1"/>
-                    </a:solidFill>
-                  </a:tcPr>
-                </a:tc>
-                <a:tc>
-                  <a:txBody>
-                    <a:bodyPr/>
-                    <a:lstStyle/>
-                    <a:p>
-                      <a:pPr algn="ctr">
-                        <a:defRPr b="1" sz="1200">
-                          <a:solidFill>
-                            <a:srgbClr val="FFFFFF"/>
-                          </a:solidFill>
-                        </a:defRPr>
-                      </a:pPr>
-                      <a:r>
-                        <a:t>G² Edges</a:t>
-                      </a:r>
-                    </a:p>
-                  </a:txBody>
-                  <a:tcPr>
-                    <a:solidFill>
-                      <a:srgbClr val="0D47A1"/>
-                    </a:solidFill>
-                  </a:tcPr>
-                </a:tc>
-                <a:tc>
-                  <a:txBody>
-                    <a:bodyPr/>
-                    <a:lstStyle/>
-                    <a:p>
-                      <a:pPr algn="ctr">
-                        <a:defRPr b="1" sz="1200">
-                          <a:solidFill>
-                            <a:srgbClr val="FFFFFF"/>
-                          </a:solidFill>
-                        </a:defRPr>
-                      </a:pPr>
-                      <a:r>
-                        <a:t>Max Deg</a:t>
-                      </a:r>
-                    </a:p>
-                  </a:txBody>
-                  <a:tcPr>
-                    <a:solidFill>
-                      <a:srgbClr val="0D47A1"/>
-                    </a:solidFill>
-                  </a:tcPr>
-                </a:tc>
-                <a:tc>
-                  <a:txBody>
-                    <a:bodyPr/>
-                    <a:lstStyle/>
-                    <a:p>
-                      <a:pPr algn="ctr">
-                        <a:defRPr b="1" sz="1200">
+                        <a:defRPr b="1" sz="1400">
                           <a:solidFill>
                             <a:srgbClr val="FFFFFF"/>
                           </a:solidFill>
@@ -4757,14 +5950,14 @@
                     <a:lstStyle/>
                     <a:p>
                       <a:pPr algn="ctr">
-                        <a:defRPr b="1" sz="1200">
+                        <a:defRPr b="1" sz="1400">
                           <a:solidFill>
                             <a:srgbClr val="FFFFFF"/>
                           </a:solidFill>
                         </a:defRPr>
                       </a:pPr>
                       <a:r>
-                        <a:t>Best Heuristic</a:t>
+                        <a:t>Best Heur</a:t>
                       </a:r>
                     </a:p>
                   </a:txBody>
@@ -4780,7 +5973,7 @@
                     <a:lstStyle/>
                     <a:p>
                       <a:pPr algn="ctr">
-                        <a:defRPr b="1" sz="1200">
+                        <a:defRPr b="1" sz="1400">
                           <a:solidFill>
                             <a:srgbClr val="FFFFFF"/>
                           </a:solidFill>
@@ -4797,45 +5990,22 @@
                     </a:solidFill>
                   </a:tcPr>
                 </a:tc>
-                <a:tc>
-                  <a:txBody>
-                    <a:bodyPr/>
-                    <a:lstStyle/>
-                    <a:p>
-                      <a:pPr algn="ctr">
-                        <a:defRPr b="1" sz="1200">
-                          <a:solidFill>
-                            <a:srgbClr val="FFFFFF"/>
-                          </a:solidFill>
-                        </a:defRPr>
-                      </a:pPr>
-                      <a:r>
-                        <a:t>Runtime</a:t>
-                      </a:r>
-                    </a:p>
-                  </a:txBody>
-                  <a:tcPr>
-                    <a:solidFill>
-                      <a:srgbClr val="0D47A1"/>
-                    </a:solidFill>
-                  </a:tcPr>
-                </a:tc>
               </a:tr>
-              <a:tr h="365760">
+              <a:tr h="411480">
                 <a:tc>
                   <a:txBody>
                     <a:bodyPr/>
                     <a:lstStyle/>
                     <a:p>
                       <a:pPr algn="l">
-                        <a:defRPr sz="1100">
+                        <a:defRPr sz="1300">
                           <a:solidFill>
                             <a:srgbClr val="212121"/>
                           </a:solidFill>
                         </a:defRPr>
                       </a:pPr>
                       <a:r>
-                        <a:t>1. 4x4 Grid (300 m)</a:t>
+                        <a:t>4×4 Grid (300 m)</a:t>
                       </a:r>
                     </a:p>
                   </a:txBody>
@@ -4851,7 +6021,7 @@
                     <a:lstStyle/>
                     <a:p>
                       <a:pPr algn="ctr">
-                        <a:defRPr sz="1100">
+                        <a:defRPr sz="1300">
                           <a:solidFill>
                             <a:srgbClr val="212121"/>
                           </a:solidFill>
@@ -4874,76 +6044,7 @@
                     <a:lstStyle/>
                     <a:p>
                       <a:pPr algn="ctr">
-                        <a:defRPr sz="1100">
-                          <a:solidFill>
-                            <a:srgbClr val="212121"/>
-                          </a:solidFill>
-                        </a:defRPr>
-                      </a:pPr>
-                      <a:r>
-                        <a:t>42</a:t>
-                      </a:r>
-                    </a:p>
-                  </a:txBody>
-                  <a:tcPr>
-                    <a:solidFill>
-                      <a:srgbClr val="F5F7FA"/>
-                    </a:solidFill>
-                  </a:tcPr>
-                </a:tc>
-                <a:tc>
-                  <a:txBody>
-                    <a:bodyPr/>
-                    <a:lstStyle/>
-                    <a:p>
-                      <a:pPr algn="ctr">
-                        <a:defRPr sz="1100">
-                          <a:solidFill>
-                            <a:srgbClr val="212121"/>
-                          </a:solidFill>
-                        </a:defRPr>
-                      </a:pPr>
-                      <a:r>
-                        <a:t>90</a:t>
-                      </a:r>
-                    </a:p>
-                  </a:txBody>
-                  <a:tcPr>
-                    <a:solidFill>
-                      <a:srgbClr val="F5F7FA"/>
-                    </a:solidFill>
-                  </a:tcPr>
-                </a:tc>
-                <a:tc>
-                  <a:txBody>
-                    <a:bodyPr/>
-                    <a:lstStyle/>
-                    <a:p>
-                      <a:pPr algn="ctr">
-                        <a:defRPr sz="1100">
-                          <a:solidFill>
-                            <a:srgbClr val="212121"/>
-                          </a:solidFill>
-                        </a:defRPr>
-                      </a:pPr>
-                      <a:r>
-                        <a:t>15</a:t>
-                      </a:r>
-                    </a:p>
-                  </a:txBody>
-                  <a:tcPr>
-                    <a:solidFill>
-                      <a:srgbClr val="F5F7FA"/>
-                    </a:solidFill>
-                  </a:tcPr>
-                </a:tc>
-                <a:tc>
-                  <a:txBody>
-                    <a:bodyPr/>
-                    <a:lstStyle/>
-                    <a:p>
-                      <a:pPr algn="ctr">
-                        <a:defRPr sz="1100" b="1">
+                        <a:defRPr sz="1300" b="1">
                           <a:solidFill>
                             <a:srgbClr val="0D47A1"/>
                           </a:solidFill>
@@ -4966,7 +6067,7 @@
                     <a:lstStyle/>
                     <a:p>
                       <a:pPr algn="ctr">
-                        <a:defRPr sz="1100" b="1">
+                        <a:defRPr sz="1300" b="1">
                           <a:solidFill>
                             <a:srgbClr val="0D47A1"/>
                           </a:solidFill>
@@ -4989,37 +6090,14 @@
                     <a:lstStyle/>
                     <a:p>
                       <a:pPr algn="ctr">
-                        <a:defRPr sz="1100">
+                        <a:defRPr sz="1300">
                           <a:solidFill>
                             <a:srgbClr val="212121"/>
                           </a:solidFill>
                         </a:defRPr>
                       </a:pPr>
                       <a:r>
-                        <a:t>0 (Opt)</a:t>
-                      </a:r>
-                    </a:p>
-                  </a:txBody>
-                  <a:tcPr>
-                    <a:solidFill>
-                      <a:srgbClr val="F5F7FA"/>
-                    </a:solidFill>
-                  </a:tcPr>
-                </a:tc>
-                <a:tc>
-                  <a:txBody>
-                    <a:bodyPr/>
-                    <a:lstStyle/>
-                    <a:p>
-                      <a:pPr algn="ctr">
-                        <a:defRPr sz="1100">
-                          <a:solidFill>
-                            <a:srgbClr val="212121"/>
-                          </a:solidFill>
-                        </a:defRPr>
-                      </a:pPr>
-                      <a:r>
-                        <a:t>0.48 ms</a:t>
+                        <a:t>0</a:t>
                       </a:r>
                     </a:p>
                   </a:txBody>
@@ -5030,21 +6108,21 @@
                   </a:tcPr>
                 </a:tc>
               </a:tr>
-              <a:tr h="365760">
+              <a:tr h="411480">
                 <a:tc>
                   <a:txBody>
                     <a:bodyPr/>
                     <a:lstStyle/>
                     <a:p>
                       <a:pPr algn="l">
-                        <a:defRPr sz="1100">
+                        <a:defRPr sz="1300">
                           <a:solidFill>
                             <a:srgbClr val="212121"/>
                           </a:solidFill>
                         </a:defRPr>
                       </a:pPr>
                       <a:r>
-                        <a:t>2. Sparse Linear (350 m)</a:t>
+                        <a:t>Sparse Linear</a:t>
                       </a:r>
                     </a:p>
                   </a:txBody>
@@ -5060,7 +6138,7 @@
                     <a:lstStyle/>
                     <a:p>
                       <a:pPr algn="ctr">
-                        <a:defRPr sz="1100">
+                        <a:defRPr sz="1300">
                           <a:solidFill>
                             <a:srgbClr val="212121"/>
                           </a:solidFill>
@@ -5083,76 +6161,7 @@
                     <a:lstStyle/>
                     <a:p>
                       <a:pPr algn="ctr">
-                        <a:defRPr sz="1100">
-                          <a:solidFill>
-                            <a:srgbClr val="212121"/>
-                          </a:solidFill>
-                        </a:defRPr>
-                      </a:pPr>
-                      <a:r>
-                        <a:t>15</a:t>
-                      </a:r>
-                    </a:p>
-                  </a:txBody>
-                  <a:tcPr>
-                    <a:solidFill>
-                      <a:srgbClr val="FFFFFF"/>
-                    </a:solidFill>
-                  </a:tcPr>
-                </a:tc>
-                <a:tc>
-                  <a:txBody>
-                    <a:bodyPr/>
-                    <a:lstStyle/>
-                    <a:p>
-                      <a:pPr algn="ctr">
-                        <a:defRPr sz="1100">
-                          <a:solidFill>
-                            <a:srgbClr val="212121"/>
-                          </a:solidFill>
-                        </a:defRPr>
-                      </a:pPr>
-                      <a:r>
-                        <a:t>29</a:t>
-                      </a:r>
-                    </a:p>
-                  </a:txBody>
-                  <a:tcPr>
-                    <a:solidFill>
-                      <a:srgbClr val="FFFFFF"/>
-                    </a:solidFill>
-                  </a:tcPr>
-                </a:tc>
-                <a:tc>
-                  <a:txBody>
-                    <a:bodyPr/>
-                    <a:lstStyle/>
-                    <a:p>
-                      <a:pPr algn="ctr">
-                        <a:defRPr sz="1100">
-                          <a:solidFill>
-                            <a:srgbClr val="212121"/>
-                          </a:solidFill>
-                        </a:defRPr>
-                      </a:pPr>
-                      <a:r>
-                        <a:t>4</a:t>
-                      </a:r>
-                    </a:p>
-                  </a:txBody>
-                  <a:tcPr>
-                    <a:solidFill>
-                      <a:srgbClr val="FFFFFF"/>
-                    </a:solidFill>
-                  </a:tcPr>
-                </a:tc>
-                <a:tc>
-                  <a:txBody>
-                    <a:bodyPr/>
-                    <a:lstStyle/>
-                    <a:p>
-                      <a:pPr algn="ctr">
-                        <a:defRPr sz="1100" b="1">
+                        <a:defRPr sz="1300" b="1">
                           <a:solidFill>
                             <a:srgbClr val="0D47A1"/>
                           </a:solidFill>
@@ -5175,7 +6184,7 @@
                     <a:lstStyle/>
                     <a:p>
                       <a:pPr algn="ctr">
-                        <a:defRPr sz="1100" b="1">
+                        <a:defRPr sz="1300" b="1">
                           <a:solidFill>
                             <a:srgbClr val="0D47A1"/>
                           </a:solidFill>
@@ -5198,37 +6207,14 @@
                     <a:lstStyle/>
                     <a:p>
                       <a:pPr algn="ctr">
-                        <a:defRPr sz="1100">
+                        <a:defRPr sz="1300">
                           <a:solidFill>
                             <a:srgbClr val="212121"/>
                           </a:solidFill>
                         </a:defRPr>
                       </a:pPr>
                       <a:r>
-                        <a:t>0 (Opt)</a:t>
-                      </a:r>
-                    </a:p>
-                  </a:txBody>
-                  <a:tcPr>
-                    <a:solidFill>
-                      <a:srgbClr val="FFFFFF"/>
-                    </a:solidFill>
-                  </a:tcPr>
-                </a:tc>
-                <a:tc>
-                  <a:txBody>
-                    <a:bodyPr/>
-                    <a:lstStyle/>
-                    <a:p>
-                      <a:pPr algn="ctr">
-                        <a:defRPr sz="1100">
-                          <a:solidFill>
-                            <a:srgbClr val="212121"/>
-                          </a:solidFill>
-                        </a:defRPr>
-                      </a:pPr>
-                      <a:r>
-                        <a:t>0.17 ms</a:t>
+                        <a:t>0</a:t>
                       </a:r>
                     </a:p>
                   </a:txBody>
@@ -5239,21 +6225,21 @@
                   </a:tcPr>
                 </a:tc>
               </a:tr>
-              <a:tr h="365760">
+              <a:tr h="411480">
                 <a:tc>
                   <a:txBody>
                     <a:bodyPr/>
                     <a:lstStyle/>
                     <a:p>
                       <a:pPr algn="l">
-                        <a:defRPr sz="1100">
+                        <a:defRPr sz="1300">
                           <a:solidFill>
                             <a:srgbClr val="212121"/>
                           </a:solidFill>
                         </a:defRPr>
                       </a:pPr>
                       <a:r>
-                        <a:t>3. Dense Cluster (≤500 m)</a:t>
+                        <a:t>Dense Cluster</a:t>
                       </a:r>
                     </a:p>
                   </a:txBody>
@@ -5269,7 +6255,7 @@
                     <a:lstStyle/>
                     <a:p>
                       <a:pPr algn="ctr">
-                        <a:defRPr sz="1100">
+                        <a:defRPr sz="1300">
                           <a:solidFill>
                             <a:srgbClr val="212121"/>
                           </a:solidFill>
@@ -5292,76 +6278,7 @@
                     <a:lstStyle/>
                     <a:p>
                       <a:pPr algn="ctr">
-                        <a:defRPr sz="1100">
-                          <a:solidFill>
-                            <a:srgbClr val="212121"/>
-                          </a:solidFill>
-                        </a:defRPr>
-                      </a:pPr>
-                      <a:r>
-                        <a:t>120</a:t>
-                      </a:r>
-                    </a:p>
-                  </a:txBody>
-                  <a:tcPr>
-                    <a:solidFill>
-                      <a:srgbClr val="F5F7FA"/>
-                    </a:solidFill>
-                  </a:tcPr>
-                </a:tc>
-                <a:tc>
-                  <a:txBody>
-                    <a:bodyPr/>
-                    <a:lstStyle/>
-                    <a:p>
-                      <a:pPr algn="ctr">
-                        <a:defRPr sz="1100">
-                          <a:solidFill>
-                            <a:srgbClr val="212121"/>
-                          </a:solidFill>
-                        </a:defRPr>
-                      </a:pPr>
-                      <a:r>
-                        <a:t>120</a:t>
-                      </a:r>
-                    </a:p>
-                  </a:txBody>
-                  <a:tcPr>
-                    <a:solidFill>
-                      <a:srgbClr val="F5F7FA"/>
-                    </a:solidFill>
-                  </a:tcPr>
-                </a:tc>
-                <a:tc>
-                  <a:txBody>
-                    <a:bodyPr/>
-                    <a:lstStyle/>
-                    <a:p>
-                      <a:pPr algn="ctr">
-                        <a:defRPr sz="1100">
-                          <a:solidFill>
-                            <a:srgbClr val="212121"/>
-                          </a:solidFill>
-                        </a:defRPr>
-                      </a:pPr>
-                      <a:r>
-                        <a:t>15</a:t>
-                      </a:r>
-                    </a:p>
-                  </a:txBody>
-                  <a:tcPr>
-                    <a:solidFill>
-                      <a:srgbClr val="F5F7FA"/>
-                    </a:solidFill>
-                  </a:tcPr>
-                </a:tc>
-                <a:tc>
-                  <a:txBody>
-                    <a:bodyPr/>
-                    <a:lstStyle/>
-                    <a:p>
-                      <a:pPr algn="ctr">
-                        <a:defRPr sz="1100" b="1">
+                        <a:defRPr sz="1300" b="1">
                           <a:solidFill>
                             <a:srgbClr val="0D47A1"/>
                           </a:solidFill>
@@ -5384,7 +6301,7 @@
                     <a:lstStyle/>
                     <a:p>
                       <a:pPr algn="ctr">
-                        <a:defRPr sz="1100" b="1">
+                        <a:defRPr sz="1300" b="1">
                           <a:solidFill>
                             <a:srgbClr val="0D47A1"/>
                           </a:solidFill>
@@ -5407,37 +6324,14 @@
                     <a:lstStyle/>
                     <a:p>
                       <a:pPr algn="ctr">
-                        <a:defRPr sz="1100">
+                        <a:defRPr sz="1300">
                           <a:solidFill>
                             <a:srgbClr val="212121"/>
                           </a:solidFill>
                         </a:defRPr>
                       </a:pPr>
                       <a:r>
-                        <a:t>0 (Opt)</a:t>
-                      </a:r>
-                    </a:p>
-                  </a:txBody>
-                  <a:tcPr>
-                    <a:solidFill>
-                      <a:srgbClr val="F5F7FA"/>
-                    </a:solidFill>
-                  </a:tcPr>
-                </a:tc>
-                <a:tc>
-                  <a:txBody>
-                    <a:bodyPr/>
-                    <a:lstStyle/>
-                    <a:p>
-                      <a:pPr algn="ctr">
-                        <a:defRPr sz="1100">
-                          <a:solidFill>
-                            <a:srgbClr val="212121"/>
-                          </a:solidFill>
-                        </a:defRPr>
-                      </a:pPr>
-                      <a:r>
-                        <a:t>0.22 ms</a:t>
+                        <a:t>0</a:t>
                       </a:r>
                     </a:p>
                   </a:txBody>
@@ -5448,21 +6342,21 @@
                   </a:tcPr>
                 </a:tc>
               </a:tr>
-              <a:tr h="365760">
+              <a:tr h="411480">
                 <a:tc>
                   <a:txBody>
                     <a:bodyPr/>
                     <a:lstStyle/>
                     <a:p>
                       <a:pPr algn="l">
-                        <a:defRPr sz="1100">
+                        <a:defRPr sz="1300">
                           <a:solidFill>
                             <a:srgbClr val="212121"/>
                           </a:solidFill>
                         </a:defRPr>
                       </a:pPr>
                       <a:r>
-                        <a:t>4. Disconnected Clusters</a:t>
+                        <a:t>Disconnected</a:t>
                       </a:r>
                     </a:p>
                   </a:txBody>
@@ -5478,7 +6372,7 @@
                     <a:lstStyle/>
                     <a:p>
                       <a:pPr algn="ctr">
-                        <a:defRPr sz="1100">
+                        <a:defRPr sz="1300">
                           <a:solidFill>
                             <a:srgbClr val="212121"/>
                           </a:solidFill>
@@ -5501,76 +6395,7 @@
                     <a:lstStyle/>
                     <a:p>
                       <a:pPr algn="ctr">
-                        <a:defRPr sz="1100">
-                          <a:solidFill>
-                            <a:srgbClr val="212121"/>
-                          </a:solidFill>
-                        </a:defRPr>
-                      </a:pPr>
-                      <a:r>
-                        <a:t>56</a:t>
-                      </a:r>
-                    </a:p>
-                  </a:txBody>
-                  <a:tcPr>
-                    <a:solidFill>
-                      <a:srgbClr val="FFFFFF"/>
-                    </a:solidFill>
-                  </a:tcPr>
-                </a:tc>
-                <a:tc>
-                  <a:txBody>
-                    <a:bodyPr/>
-                    <a:lstStyle/>
-                    <a:p>
-                      <a:pPr algn="ctr">
-                        <a:defRPr sz="1100">
-                          <a:solidFill>
-                            <a:srgbClr val="212121"/>
-                          </a:solidFill>
-                        </a:defRPr>
-                      </a:pPr>
-                      <a:r>
-                        <a:t>56</a:t>
-                      </a:r>
-                    </a:p>
-                  </a:txBody>
-                  <a:tcPr>
-                    <a:solidFill>
-                      <a:srgbClr val="FFFFFF"/>
-                    </a:solidFill>
-                  </a:tcPr>
-                </a:tc>
-                <a:tc>
-                  <a:txBody>
-                    <a:bodyPr/>
-                    <a:lstStyle/>
-                    <a:p>
-                      <a:pPr algn="ctr">
-                        <a:defRPr sz="1100">
-                          <a:solidFill>
-                            <a:srgbClr val="212121"/>
-                          </a:solidFill>
-                        </a:defRPr>
-                      </a:pPr>
-                      <a:r>
-                        <a:t>7</a:t>
-                      </a:r>
-                    </a:p>
-                  </a:txBody>
-                  <a:tcPr>
-                    <a:solidFill>
-                      <a:srgbClr val="FFFFFF"/>
-                    </a:solidFill>
-                  </a:tcPr>
-                </a:tc>
-                <a:tc>
-                  <a:txBody>
-                    <a:bodyPr/>
-                    <a:lstStyle/>
-                    <a:p>
-                      <a:pPr algn="ctr">
-                        <a:defRPr sz="1100" b="1">
+                        <a:defRPr sz="1300" b="1">
                           <a:solidFill>
                             <a:srgbClr val="0D47A1"/>
                           </a:solidFill>
@@ -5593,7 +6418,7 @@
                     <a:lstStyle/>
                     <a:p>
                       <a:pPr algn="ctr">
-                        <a:defRPr sz="1100" b="1">
+                        <a:defRPr sz="1300" b="1">
                           <a:solidFill>
                             <a:srgbClr val="0D47A1"/>
                           </a:solidFill>
@@ -5616,37 +6441,14 @@
                     <a:lstStyle/>
                     <a:p>
                       <a:pPr algn="ctr">
-                        <a:defRPr sz="1100">
+                        <a:defRPr sz="1300">
                           <a:solidFill>
                             <a:srgbClr val="212121"/>
                           </a:solidFill>
                         </a:defRPr>
                       </a:pPr>
                       <a:r>
-                        <a:t>0 (Opt)</a:t>
-                      </a:r>
-                    </a:p>
-                  </a:txBody>
-                  <a:tcPr>
-                    <a:solidFill>
-                      <a:srgbClr val="FFFFFF"/>
-                    </a:solidFill>
-                  </a:tcPr>
-                </a:tc>
-                <a:tc>
-                  <a:txBody>
-                    <a:bodyPr/>
-                    <a:lstStyle/>
-                    <a:p>
-                      <a:pPr algn="ctr">
-                        <a:defRPr sz="1100">
-                          <a:solidFill>
-                            <a:srgbClr val="212121"/>
-                          </a:solidFill>
-                        </a:defRPr>
-                      </a:pPr>
-                      <a:r>
-                        <a:t>0.30 ms</a:t>
+                        <a:t>0</a:t>
                       </a:r>
                     </a:p>
                   </a:txBody>
@@ -5688,7 +6490,7 @@
         <p:spPr>
           <a:xfrm>
             <a:off x="0" y="0"/>
-            <a:ext cx="12191695" cy="1005840"/>
+            <a:ext cx="12191695" cy="1051560"/>
           </a:xfrm>
           <a:prstGeom prst="rect">
             <a:avLst/>
@@ -5697,9 +6499,7 @@
             <a:srgbClr val="0D47A1"/>
           </a:solidFill>
           <a:ln>
-            <a:solidFill>
-              <a:srgbClr val="0D47A1"/>
-            </a:solidFill>
+            <a:noFill/>
           </a:ln>
         </p:spPr>
         <p:style>
@@ -5732,8 +6532,8 @@
         </p:nvSpPr>
         <p:spPr>
           <a:xfrm>
-            <a:off x="731520" y="137160"/>
-            <a:ext cx="10698480" cy="731520"/>
+            <a:off x="731520" y="91440"/>
+            <a:ext cx="10698480" cy="868680"/>
           </a:xfrm>
           <a:prstGeom prst="rect">
             <a:avLst/>
@@ -5741,13 +6541,13 @@
           <a:noFill/>
         </p:spPr>
         <p:txBody>
-          <a:bodyPr wrap="square">
+          <a:bodyPr wrap="square" anchor="ctr">
             <a:spAutoFit/>
           </a:bodyPr>
           <a:lstStyle/>
           <a:p>
             <a:pPr>
-              <a:defRPr b="1" sz="2600">
+              <a:defRPr b="1" sz="3400">
                 <a:solidFill>
                   <a:srgbClr val="FFFFFF"/>
                 </a:solidFill>
@@ -5767,8 +6567,8 @@
         </p:nvSpPr>
         <p:spPr>
           <a:xfrm>
-            <a:off x="731520" y="1188720"/>
-            <a:ext cx="10698480" cy="411480"/>
+            <a:off x="731520" y="1280160"/>
+            <a:ext cx="5029200" cy="5212080"/>
           </a:xfrm>
           <a:prstGeom prst="rect">
             <a:avLst/>
@@ -5776,41 +6576,6 @@
           <a:noFill/>
         </p:spPr>
         <p:txBody>
-          <a:bodyPr wrap="none">
-            <a:spAutoFit/>
-          </a:bodyPr>
-          <a:lstStyle/>
-          <a:p>
-            <a:pPr>
-              <a:defRPr sz="1500" b="1">
-                <a:solidFill>
-                  <a:srgbClr val="263238"/>
-                </a:solidFill>
-              </a:defRPr>
-            </a:pPr>
-            <a:r>
-              <a:t>Strict Separation of Concerns &amp; BFS Topological Integrity Enforcement</a:t>
-            </a:r>
-          </a:p>
-        </p:txBody>
-      </p:sp>
-      <p:sp>
-        <p:nvSpPr>
-          <p:cNvPr id="5" name="TextBox 4"/>
-          <p:cNvSpPr txBox="1"/>
-          <p:nvPr/>
-        </p:nvSpPr>
-        <p:spPr>
-          <a:xfrm>
-            <a:off x="731520" y="1600200"/>
-            <a:ext cx="10698480" cy="4754880"/>
-          </a:xfrm>
-          <a:prstGeom prst="rect">
-            <a:avLst/>
-          </a:prstGeom>
-          <a:noFill/>
-        </p:spPr>
-        <p:txBody>
           <a:bodyPr wrap="square">
             <a:spAutoFit/>
           </a:bodyPr>
@@ -5818,80 +6583,74 @@
           <a:p>
             <a:pPr>
               <a:spcAft>
-                <a:spcPts val="1000"/>
+                <a:spcPts val="1200"/>
               </a:spcAft>
-              <a:defRPr sz="1400">
+              <a:defRPr sz="2100">
                 <a:solidFill>
                   <a:srgbClr val="212121"/>
                 </a:solidFill>
               </a:defRPr>
             </a:pPr>
             <a:r>
-              <a:t>• Zero Algorithmic Circularity: The verifier does NOT reuse graph coloring, G², or heuristics code.</a:t>
+              <a:t>• Zero shared code with coloring or G² logic</a:t>
             </a:r>
           </a:p>
           <a:p>
             <a:pPr>
               <a:spcAft>
-                <a:spcPts val="1000"/>
+                <a:spcPts val="1200"/>
               </a:spcAft>
-              <a:defRPr sz="1400">
+              <a:defRPr sz="2100">
                 <a:solidFill>
                   <a:srgbClr val="212121"/>
                 </a:solidFill>
               </a:defRPr>
             </a:pPr>
             <a:r>
-              <a:t>• BFS Shortest-Path Queries: Hop distances are computed directly on the physical connectivity graph G.</a:t>
+              <a:t>• BFS hop-distance queries on physical graph G</a:t>
             </a:r>
           </a:p>
           <a:p>
             <a:pPr>
               <a:spcAft>
-                <a:spcPts val="1000"/>
+                <a:spcPts val="1200"/>
               </a:spcAft>
-              <a:defRPr sz="1400">
+              <a:defRPr sz="2100">
                 <a:solidFill>
                   <a:srgbClr val="212121"/>
                 </a:solidFill>
               </a:defRPr>
             </a:pPr>
             <a:r>
-              <a:t>• Coverage Invariant: Verifies every node in V is assigned exactly one slot (detects unassigned and phantom nodes).</a:t>
-            </a:r>
-          </a:p>
-          <a:p>
-            <a:pPr>
-              <a:spcAft>
-                <a:spcPts val="1000"/>
-              </a:spcAft>
-              <a:defRPr sz="1400">
-                <a:solidFill>
-                  <a:srgbClr val="212121"/>
-                </a:solidFill>
-              </a:defRPr>
-            </a:pPr>
-            <a:r>
-              <a:t>• Contiguity Invariant: Asserts timeslot IDs span contiguous range 0..K-1 with zero orphaned gaps.</a:t>
-            </a:r>
-          </a:p>
-          <a:p>
-            <a:pPr>
-              <a:spcAft>
-                <a:spcPts val="1000"/>
-              </a:spcAft>
-              <a:defRPr sz="1400">
-                <a:solidFill>
-                  <a:srgbClr val="212121"/>
-                </a:solidFill>
-              </a:defRPr>
-            </a:pPr>
-            <a:r>
-              <a:t>• Conflict Freedom: Rigorously verifies that any pair sharing a slot has hop distance ≥ 3; flags all violations with exit code 1.</a:t>
-            </a:r>
-          </a:p>
-        </p:txBody>
-      </p:sp>
+              <a:t>• Checks: coverage, contiguity, conflict freedom</a:t>
+            </a:r>
+          </a:p>
+        </p:txBody>
+      </p:sp>
+      <p:pic>
+        <p:nvPicPr>
+          <p:cNvPr id="5" name="Picture 4" descr="grid_graph.png"/>
+          <p:cNvPicPr>
+            <a:picLocks noChangeAspect="1"/>
+          </p:cNvPicPr>
+          <p:nvPr/>
+        </p:nvPicPr>
+        <p:blipFill>
+          <a:blip r:embed="rId2"/>
+          <a:stretch>
+            <a:fillRect/>
+          </a:stretch>
+        </p:blipFill>
+        <p:spPr>
+          <a:xfrm>
+            <a:off x="5943600" y="1371600"/>
+            <a:ext cx="5486400" cy="5029200"/>
+          </a:xfrm>
+          <a:prstGeom prst="rect">
+            <a:avLst/>
+          </a:prstGeom>
+        </p:spPr>
+      </p:pic>
     </p:spTree>
   </p:cSld>
   <p:clrMapOvr>
@@ -5919,7 +6678,7 @@
         <p:spPr>
           <a:xfrm>
             <a:off x="0" y="0"/>
-            <a:ext cx="12191695" cy="1005840"/>
+            <a:ext cx="12191695" cy="1051560"/>
           </a:xfrm>
           <a:prstGeom prst="rect">
             <a:avLst/>
@@ -5928,9 +6687,7 @@
             <a:srgbClr val="0D47A1"/>
           </a:solidFill>
           <a:ln>
-            <a:solidFill>
-              <a:srgbClr val="0D47A1"/>
-            </a:solidFill>
+            <a:noFill/>
           </a:ln>
         </p:spPr>
         <p:style>
@@ -5963,8 +6720,8 @@
         </p:nvSpPr>
         <p:spPr>
           <a:xfrm>
-            <a:off x="731520" y="137160"/>
-            <a:ext cx="10698480" cy="731520"/>
+            <a:off x="731520" y="91440"/>
+            <a:ext cx="10698480" cy="868680"/>
           </a:xfrm>
           <a:prstGeom prst="rect">
             <a:avLst/>
@@ -5972,13 +6729,13 @@
           <a:noFill/>
         </p:spPr>
         <p:txBody>
-          <a:bodyPr wrap="square">
+          <a:bodyPr wrap="square" anchor="ctr">
             <a:spAutoFit/>
           </a:bodyPr>
           <a:lstStyle/>
           <a:p>
             <a:pPr>
-              <a:defRPr b="1" sz="2600">
+              <a:defRPr b="1" sz="3400">
                 <a:solidFill>
                   <a:srgbClr val="FFFFFF"/>
                 </a:solidFill>
@@ -5998,8 +6755,8 @@
         </p:nvSpPr>
         <p:spPr>
           <a:xfrm>
-            <a:off x="731520" y="1188720"/>
-            <a:ext cx="10698480" cy="411480"/>
+            <a:off x="731520" y="1280160"/>
+            <a:ext cx="10515600" cy="1783080"/>
           </a:xfrm>
           <a:prstGeom prst="rect">
             <a:avLst/>
@@ -6007,41 +6764,6 @@
           <a:noFill/>
         </p:spPr>
         <p:txBody>
-          <a:bodyPr wrap="none">
-            <a:spAutoFit/>
-          </a:bodyPr>
-          <a:lstStyle/>
-          <a:p>
-            <a:pPr>
-              <a:defRPr sz="1500" b="1">
-                <a:solidFill>
-                  <a:srgbClr val="263238"/>
-                </a:solidFill>
-              </a:defRPr>
-            </a:pPr>
-            <a:r>
-              <a:t>Bridging Mathematical Schedules to Real-Time Network Emulation</a:t>
-            </a:r>
-          </a:p>
-        </p:txBody>
-      </p:sp>
-      <p:sp>
-        <p:nvSpPr>
-          <p:cNvPr id="5" name="TextBox 4"/>
-          <p:cNvSpPr txBox="1"/>
-          <p:nvPr/>
-        </p:nvSpPr>
-        <p:spPr>
-          <a:xfrm>
-            <a:off x="731520" y="1600200"/>
-            <a:ext cx="10698480" cy="4754880"/>
-          </a:xfrm>
-          <a:prstGeom prst="rect">
-            <a:avLst/>
-          </a:prstGeom>
-          <a:noFill/>
-        </p:spPr>
-        <p:txBody>
           <a:bodyPr wrap="square">
             <a:spAutoFit/>
           </a:bodyPr>
@@ -6049,80 +6771,74 @@
           <a:p>
             <a:pPr>
               <a:spcAft>
-                <a:spcPts val="1000"/>
+                <a:spcPts val="1200"/>
               </a:spcAft>
-              <a:defRPr sz="1400">
+              <a:defRPr sz="2100">
                 <a:solidFill>
                   <a:srgbClr val="212121"/>
                 </a:solidFill>
               </a:defRPr>
             </a:pPr>
             <a:r>
-              <a:t>• High-Fidelity Radio Emulation: Integrates with EMANE tdmaeventschedulerradiomodel (1 ms slots, 50 µs guard time).</a:t>
+              <a:t>• Integrates with tdmaeventschedulerradiomodel</a:t>
             </a:r>
           </a:p>
           <a:p>
             <a:pPr>
               <a:spcAft>
-                <a:spcPts val="1000"/>
+                <a:spcPts val="1200"/>
               </a:spcAft>
-              <a:defRPr sz="1400">
+              <a:defRPr sz="2100">
                 <a:solidFill>
                   <a:srgbClr val="212121"/>
                 </a:solidFill>
               </a:defRPr>
             </a:pPr>
             <a:r>
-              <a:t>• Official Verification Log: 100% verified against Adjacent Link official documentation, XML schemas, and Python bindings.</a:t>
+              <a:t>• 1 ms slots, 50 µs guard, 2.4 GHz, 20 MHz BW</a:t>
             </a:r>
           </a:p>
           <a:p>
             <a:pPr>
               <a:spcAft>
-                <a:spcPts val="1000"/>
+                <a:spcPts val="1200"/>
               </a:spcAft>
-              <a:defRPr sz="1400">
+              <a:defRPr sz="2100">
                 <a:solidFill>
                   <a:srgbClr val="212121"/>
                 </a:solidFill>
               </a:defRPr>
             </a:pPr>
             <a:r>
-              <a:t>• Timing Architecture: Slot duration (1000 µs), overhead (50 µs), and bandwidth (20 MHz) defined in &lt;structure&gt; XML.</a:t>
-            </a:r>
-          </a:p>
-          <a:p>
-            <a:pPr>
-              <a:spcAft>
-                <a:spcPts val="1000"/>
-              </a:spcAft>
-              <a:defRPr sz="1400">
-                <a:solidFill>
-                  <a:srgbClr val="212121"/>
-                </a:solidFill>
-              </a:defRPr>
-            </a:pPr>
-            <a:r>
-              <a:t>• Range Modeling (Design Only): EMANE uses LocationEvent (ID 100) / PathlossEvent (ID 101) &amp; PCR curves to calibrate ~500 m range.</a:t>
-            </a:r>
-          </a:p>
-          <a:p>
-            <a:pPr>
-              <a:spcAft>
-                <a:spcPts val="1000"/>
-              </a:spcAft>
-              <a:defRPr sz="1400">
-                <a:solidFill>
-                  <a:srgbClr val="212121"/>
-                </a:solidFill>
-              </a:defRPr>
-            </a:pPr>
-            <a:r>
-              <a:t>• Tested vs Design-Only Boundary: Offline schema parsing and round-trip parity tested; live kernel RF execution documented.</a:t>
-            </a:r>
-          </a:p>
-        </p:txBody>
-      </p:sp>
+              <a:t>• 11/11 parameters verified against official docs</a:t>
+            </a:r>
+          </a:p>
+        </p:txBody>
+      </p:sp>
+      <p:pic>
+        <p:nvPicPr>
+          <p:cNvPr id="5" name="Picture 4" descr="architecture.png"/>
+          <p:cNvPicPr>
+            <a:picLocks noChangeAspect="1"/>
+          </p:cNvPicPr>
+          <p:nvPr/>
+        </p:nvPicPr>
+        <p:blipFill>
+          <a:blip r:embed="rId2"/>
+          <a:stretch>
+            <a:fillRect/>
+          </a:stretch>
+        </p:blipFill>
+        <p:spPr>
+          <a:xfrm>
+            <a:off x="457200" y="3200400"/>
+            <a:ext cx="11247120" cy="3200400"/>
+          </a:xfrm>
+          <a:prstGeom prst="rect">
+            <a:avLst/>
+          </a:prstGeom>
+        </p:spPr>
+      </p:pic>
     </p:spTree>
   </p:cSld>
   <p:clrMapOvr>
@@ -6150,7 +6866,7 @@
         <p:spPr>
           <a:xfrm>
             <a:off x="0" y="0"/>
-            <a:ext cx="12191695" cy="1005840"/>
+            <a:ext cx="12191695" cy="1051560"/>
           </a:xfrm>
           <a:prstGeom prst="rect">
             <a:avLst/>
@@ -6159,9 +6875,7 @@
             <a:srgbClr val="0D47A1"/>
           </a:solidFill>
           <a:ln>
-            <a:solidFill>
-              <a:srgbClr val="0D47A1"/>
-            </a:solidFill>
+            <a:noFill/>
           </a:ln>
         </p:spPr>
         <p:style>
@@ -6194,8 +6908,8 @@
         </p:nvSpPr>
         <p:spPr>
           <a:xfrm>
-            <a:off x="731520" y="137160"/>
-            <a:ext cx="10698480" cy="731520"/>
+            <a:off x="731520" y="91440"/>
+            <a:ext cx="10698480" cy="868680"/>
           </a:xfrm>
           <a:prstGeom prst="rect">
             <a:avLst/>
@@ -6203,20 +6917,20 @@
           <a:noFill/>
         </p:spPr>
         <p:txBody>
-          <a:bodyPr wrap="square">
+          <a:bodyPr wrap="square" anchor="ctr">
             <a:spAutoFit/>
           </a:bodyPr>
           <a:lstStyle/>
           <a:p>
             <a:pPr>
-              <a:defRPr b="1" sz="2600">
+              <a:defRPr b="1" sz="3400">
                 <a:solidFill>
                   <a:srgbClr val="FFFFFF"/>
                 </a:solidFill>
               </a:defRPr>
             </a:pPr>
             <a:r>
-              <a:t>Emulation Test Plan &amp; Engineering Decisions</a:t>
+              <a:t>Test Plan &amp; Engineering Decisions</a:t>
             </a:r>
           </a:p>
         </p:txBody>
@@ -6229,8 +6943,8 @@
         </p:nvSpPr>
         <p:spPr>
           <a:xfrm>
-            <a:off x="731520" y="1188720"/>
-            <a:ext cx="10698480" cy="411480"/>
+            <a:off x="731520" y="1280160"/>
+            <a:ext cx="5029200" cy="5212080"/>
           </a:xfrm>
           <a:prstGeom prst="rect">
             <a:avLst/>
@@ -6238,20 +6952,80 @@
           <a:noFill/>
         </p:spPr>
         <p:txBody>
-          <a:bodyPr wrap="none">
+          <a:bodyPr wrap="square">
             <a:spAutoFit/>
           </a:bodyPr>
           <a:lstStyle/>
           <a:p>
             <a:pPr>
-              <a:defRPr sz="1500" b="1">
+              <a:spcAft>
+                <a:spcPts val="1000"/>
+              </a:spcAft>
+              <a:defRPr sz="2000">
                 <a:solidFill>
-                  <a:srgbClr val="263238"/>
+                  <a:srgbClr val="212121"/>
                 </a:solidFill>
               </a:defRPr>
             </a:pPr>
             <a:r>
-              <a:t>Virtual Testbed Execution Plan and Critical Protocol Safeguards</a:t>
+              <a:t>EMULATION TEST PLAN:</a:t>
+            </a:r>
+          </a:p>
+          <a:p>
+            <a:pPr>
+              <a:spcAft>
+                <a:spcPts val="1000"/>
+              </a:spcAft>
+              <a:defRPr sz="2000">
+                <a:solidFill>
+                  <a:srgbClr val="212121"/>
+                </a:solidFill>
+              </a:defRPr>
+            </a:pPr>
+            <a:r>
+              <a:t>• Valid schedule: 0% loss at 9 ms</a:t>
+            </a:r>
+            <a:br/>
+            <a:r>
+              <a:t>  frame intervals</a:t>
+            </a:r>
+          </a:p>
+          <a:p>
+            <a:pPr>
+              <a:spcAft>
+                <a:spcPts val="1000"/>
+              </a:spcAft>
+              <a:defRPr sz="2000">
+                <a:solidFill>
+                  <a:srgbClr val="212121"/>
+                </a:solidFill>
+              </a:defRPr>
+            </a:pPr>
+            <a:r>
+              <a:t>• Conflicting schedule: deliberate</a:t>
+            </a:r>
+            <a:br/>
+            <a:r>
+              <a:t>  collision → &gt; 80% discards</a:t>
+            </a:r>
+          </a:p>
+          <a:p>
+            <a:pPr>
+              <a:spcAft>
+                <a:spcPts val="1000"/>
+              </a:spcAft>
+              <a:defRPr sz="2000">
+                <a:solidFill>
+                  <a:srgbClr val="212121"/>
+                </a:solidFill>
+              </a:defRPr>
+            </a:pPr>
+            <a:r>
+              <a:t>• Range calibration: freespace model</a:t>
+            </a:r>
+            <a:br/>
+            <a:r>
+              <a:t>  tuned for ~500 m cutoff</a:t>
             </a:r>
           </a:p>
         </p:txBody>
@@ -6264,8 +7038,8 @@
         </p:nvSpPr>
         <p:spPr>
           <a:xfrm>
-            <a:off x="731520" y="1600200"/>
-            <a:ext cx="10698480" cy="4754880"/>
+            <a:off x="6217920" y="1280160"/>
+            <a:ext cx="5029200" cy="5212080"/>
           </a:xfrm>
           <a:prstGeom prst="rect">
             <a:avLst/>
@@ -6282,14 +7056,14 @@
               <a:spcAft>
                 <a:spcPts val="1000"/>
               </a:spcAft>
-              <a:defRPr sz="1400">
+              <a:defRPr sz="2000">
                 <a:solidFill>
                   <a:srgbClr val="212121"/>
                 </a:solidFill>
               </a:defRPr>
             </a:pPr>
             <a:r>
-              <a:t>• Test Case 1 (Valid Schedule): Ping and iperf traffic pass with 0% loss; packets emit strictly at 9 ms frame intervals.</a:t>
+              <a:t>ENGINEERING DECISIONS:</a:t>
             </a:r>
           </a:p>
           <a:p>
@@ -6297,14 +7071,18 @@
               <a:spcAft>
                 <a:spcPts val="1000"/>
               </a:spcAft>
-              <a:defRPr sz="1400">
+              <a:defRPr sz="2000">
                 <a:solidFill>
                   <a:srgbClr val="212121"/>
                 </a:solidFill>
               </a:defRPr>
             </a:pPr>
             <a:r>
-              <a:t>• Test Case 2 (Conflicting Schedule): Deliberate collision forces SINR below PCR curve; triggers &gt; 80% packet discards.</a:t>
+              <a:t>• Float epsilon (10⁻⁹) for exact</a:t>
+            </a:r>
+            <a:br/>
+            <a:r>
+              <a:t>  500.0 m boundary inclusion</a:t>
             </a:r>
           </a:p>
           <a:p>
@@ -6312,14 +7090,18 @@
               <a:spcAft>
                 <a:spcPts val="1000"/>
               </a:spcAft>
-              <a:defRPr sz="1400">
+              <a:defRPr sz="2000">
                 <a:solidFill>
                   <a:srgbClr val="212121"/>
                 </a:solidFill>
               </a:defRPr>
             </a:pPr>
             <a:r>
-              <a:t>• Exact 500.0 m Boundary: Applied 10⁻⁹ m epsilon tolerance to guarantee exact 500.0 m coordinates are in direct range.</a:t>
+              <a:t>• Duplicate coordinate rejection</a:t>
+            </a:r>
+            <a:br/>
+            <a:r>
+              <a:t>  with explicit diagnostics</a:t>
             </a:r>
           </a:p>
           <a:p>
@@ -6327,29 +7109,18 @@
               <a:spcAft>
                 <a:spcPts val="1000"/>
               </a:spcAft>
-              <a:defRPr sz="1400">
+              <a:defRPr sz="2000">
                 <a:solidFill>
                   <a:srgbClr val="212121"/>
                 </a:solidFill>
               </a:defRPr>
             </a:pPr>
             <a:r>
-              <a:t>• Duplicate Coordinate Rejection: Detects physically impossible co-locations and terminates with explicit diagnostic errors.</a:t>
-            </a:r>
-          </a:p>
-          <a:p>
-            <a:pPr>
-              <a:spcAft>
-                <a:spcPts val="1000"/>
-              </a:spcAft>
-              <a:defRPr sz="1400">
-                <a:solidFill>
-                  <a:srgbClr val="212121"/>
-                </a:solidFill>
-              </a:defRPr>
-            </a:pPr>
-            <a:r>
-              <a:t>• Deterministic Reproducibility: Seeded random generators guarantee reproducible schedules across runs.</a:t>
+              <a:t>• Deterministic seeded RNG</a:t>
+            </a:r>
+            <a:br/>
+            <a:r>
+              <a:t>  for reproducible schedules</a:t>
             </a:r>
           </a:p>
         </p:txBody>
@@ -6680,4 +7451,324 @@
   </a:objectDefaults>
   <a:extraClrSchemeLst/>
 </a:theme>
+</file>
+
+<file path=ppt/theme/theme2.xml><?xml version="1.0" encoding="utf-8"?>
+<a:theme xmlns:a="http://schemas.openxmlformats.org/drawingml/2006/main" name="Office Theme">
+  <a:themeElements>
+    <a:clrScheme name="Office">
+      <a:dk1>
+        <a:sysClr val="windowText" lastClr="000000"/>
+      </a:dk1>
+      <a:lt1>
+        <a:sysClr val="window" lastClr="FFFFFF"/>
+      </a:lt1>
+      <a:dk2>
+        <a:srgbClr val="1F497D"/>
+      </a:dk2>
+      <a:lt2>
+        <a:srgbClr val="EEECE1"/>
+      </a:lt2>
+      <a:accent1>
+        <a:srgbClr val="4F81BD"/>
+      </a:accent1>
+      <a:accent2>
+        <a:srgbClr val="C0504D"/>
+      </a:accent2>
+      <a:accent3>
+        <a:srgbClr val="9BBB59"/>
+      </a:accent3>
+      <a:accent4>
+        <a:srgbClr val="8064A2"/>
+      </a:accent4>
+      <a:accent5>
+        <a:srgbClr val="4BACC6"/>
+      </a:accent5>
+      <a:accent6>
+        <a:srgbClr val="F79646"/>
+      </a:accent6>
+      <a:hlink>
+        <a:srgbClr val="0000FF"/>
+      </a:hlink>
+      <a:folHlink>
+        <a:srgbClr val="800080"/>
+      </a:folHlink>
+    </a:clrScheme>
+    <a:fontScheme name="Office">
+      <a:majorFont>
+        <a:latin typeface="Calibri"/>
+        <a:ea typeface=""/>
+        <a:cs typeface=""/>
+        <a:font script="Jpan" typeface="ＭＳ Ｐゴシック"/>
+        <a:font script="Hang" typeface="맑은 고딕"/>
+        <a:font script="Hans" typeface="宋体"/>
+        <a:font script="Hant" typeface="新細明體"/>
+        <a:font script="Arab" typeface="Times New Roman"/>
+        <a:font script="Hebr" typeface="Times New Roman"/>
+        <a:font script="Thai" typeface="Angsana New"/>
+        <a:font script="Ethi" typeface="Nyala"/>
+        <a:font script="Beng" typeface="Vrinda"/>
+        <a:font script="Gujr" typeface="Shruti"/>
+        <a:font script="Khmr" typeface="MoolBoran"/>
+        <a:font script="Knda" typeface="Tunga"/>
+        <a:font script="Guru" typeface="Raavi"/>
+        <a:font script="Cans" typeface="Euphemia"/>
+        <a:font script="Cher" typeface="Plantagenet Cherokee"/>
+        <a:font script="Yiii" typeface="Microsoft Yi Baiti"/>
+        <a:font script="Tibt" typeface="Microsoft Himalaya"/>
+        <a:font script="Thaa" typeface="MV Boli"/>
+        <a:font script="Deva" typeface="Mangal"/>
+        <a:font script="Telu" typeface="Gautami"/>
+        <a:font script="Taml" typeface="Latha"/>
+        <a:font script="Syrc" typeface="Estrangelo Edessa"/>
+        <a:font script="Orya" typeface="Kalinga"/>
+        <a:font script="Mlym" typeface="Kartika"/>
+        <a:font script="Laoo" typeface="DokChampa"/>
+        <a:font script="Sinh" typeface="Iskoola Pota"/>
+        <a:font script="Mong" typeface="Mongolian Baiti"/>
+        <a:font script="Viet" typeface="Times New Roman"/>
+        <a:font script="Uigh" typeface="Microsoft Uighur"/>
+        <a:font script="Geor" typeface="Sylfaen"/>
+      </a:majorFont>
+      <a:minorFont>
+        <a:latin typeface="Calibri"/>
+        <a:ea typeface=""/>
+        <a:cs typeface=""/>
+        <a:font script="Jpan" typeface="ＭＳ Ｐゴシック"/>
+        <a:font script="Hang" typeface="맑은 고딕"/>
+        <a:font script="Hans" typeface="宋体"/>
+        <a:font script="Hant" typeface="新細明體"/>
+        <a:font script="Arab" typeface="Arial"/>
+        <a:font script="Hebr" typeface="Arial"/>
+        <a:font script="Thai" typeface="Cordia New"/>
+        <a:font script="Ethi" typeface="Nyala"/>
+        <a:font script="Beng" typeface="Vrinda"/>
+        <a:font script="Gujr" typeface="Shruti"/>
+        <a:font script="Khmr" typeface="DaunPenh"/>
+        <a:font script="Knda" typeface="Tunga"/>
+        <a:font script="Guru" typeface="Raavi"/>
+        <a:font script="Cans" typeface="Euphemia"/>
+        <a:font script="Cher" typeface="Plantagenet Cherokee"/>
+        <a:font script="Yiii" typeface="Microsoft Yi Baiti"/>
+        <a:font script="Tibt" typeface="Microsoft Himalaya"/>
+        <a:font script="Thaa" typeface="MV Boli"/>
+        <a:font script="Deva" typeface="Mangal"/>
+        <a:font script="Telu" typeface="Gautami"/>
+        <a:font script="Taml" typeface="Latha"/>
+        <a:font script="Syrc" typeface="Estrangelo Edessa"/>
+        <a:font script="Orya" typeface="Kalinga"/>
+        <a:font script="Mlym" typeface="Kartika"/>
+        <a:font script="Laoo" typeface="DokChampa"/>
+        <a:font script="Sinh" typeface="Iskoola Pota"/>
+        <a:font script="Mong" typeface="Mongolian Baiti"/>
+        <a:font script="Viet" typeface="Arial"/>
+        <a:font script="Uigh" typeface="Microsoft Uighur"/>
+        <a:font script="Geor" typeface="Sylfaen"/>
+      </a:minorFont>
+    </a:fontScheme>
+    <a:fmtScheme name="Office">
+      <a:fillStyleLst>
+        <a:solidFill>
+          <a:schemeClr val="phClr"/>
+        </a:solidFill>
+        <a:gradFill rotWithShape="1">
+          <a:gsLst>
+            <a:gs pos="0">
+              <a:schemeClr val="phClr">
+                <a:tint val="50000"/>
+                <a:satMod val="300000"/>
+              </a:schemeClr>
+            </a:gs>
+            <a:gs pos="35000">
+              <a:schemeClr val="phClr">
+                <a:tint val="37000"/>
+                <a:satMod val="300000"/>
+              </a:schemeClr>
+            </a:gs>
+            <a:gs pos="100000">
+              <a:schemeClr val="phClr">
+                <a:tint val="15000"/>
+                <a:satMod val="350000"/>
+              </a:schemeClr>
+            </a:gs>
+          </a:gsLst>
+          <a:lin ang="16200000" scaled="1"/>
+        </a:gradFill>
+        <a:gradFill rotWithShape="1">
+          <a:gsLst>
+            <a:gs pos="0">
+              <a:schemeClr val="phClr">
+                <a:tint val="100000"/>
+                <a:shade val="100000"/>
+                <a:satMod val="130000"/>
+              </a:schemeClr>
+            </a:gs>
+            <a:gs pos="100000">
+              <a:schemeClr val="phClr">
+                <a:tint val="50000"/>
+                <a:shade val="100000"/>
+                <a:satMod val="350000"/>
+              </a:schemeClr>
+            </a:gs>
+          </a:gsLst>
+          <a:lin ang="16200000" scaled="0"/>
+        </a:gradFill>
+      </a:fillStyleLst>
+      <a:lnStyleLst>
+        <a:ln w="9525" cap="flat" cmpd="sng" algn="ctr">
+          <a:solidFill>
+            <a:schemeClr val="phClr">
+              <a:shade val="95000"/>
+              <a:satMod val="105000"/>
+            </a:schemeClr>
+          </a:solidFill>
+          <a:prstDash val="solid"/>
+        </a:ln>
+        <a:ln w="25400" cap="flat" cmpd="sng" algn="ctr">
+          <a:solidFill>
+            <a:schemeClr val="phClr"/>
+          </a:solidFill>
+          <a:prstDash val="solid"/>
+        </a:ln>
+        <a:ln w="38100" cap="flat" cmpd="sng" algn="ctr">
+          <a:solidFill>
+            <a:schemeClr val="phClr"/>
+          </a:solidFill>
+          <a:prstDash val="solid"/>
+        </a:ln>
+      </a:lnStyleLst>
+      <a:effectStyleLst>
+        <a:effectStyle>
+          <a:effectLst>
+            <a:outerShdw blurRad="40000" dist="20000" dir="5400000" rotWithShape="0">
+              <a:srgbClr val="000000">
+                <a:alpha val="38000"/>
+              </a:srgbClr>
+            </a:outerShdw>
+          </a:effectLst>
+        </a:effectStyle>
+        <a:effectStyle>
+          <a:effectLst>
+            <a:outerShdw blurRad="40000" dist="23000" dir="5400000" rotWithShape="0">
+              <a:srgbClr val="000000">
+                <a:alpha val="35000"/>
+              </a:srgbClr>
+            </a:outerShdw>
+          </a:effectLst>
+        </a:effectStyle>
+        <a:effectStyle>
+          <a:effectLst>
+            <a:outerShdw blurRad="40000" dist="23000" dir="5400000" rotWithShape="0">
+              <a:srgbClr val="000000">
+                <a:alpha val="35000"/>
+              </a:srgbClr>
+            </a:outerShdw>
+          </a:effectLst>
+          <a:scene3d>
+            <a:camera prst="orthographicFront">
+              <a:rot lat="0" lon="0" rev="0"/>
+            </a:camera>
+            <a:lightRig rig="threePt" dir="t">
+              <a:rot lat="0" lon="0" rev="1200000"/>
+            </a:lightRig>
+          </a:scene3d>
+          <a:sp3d>
+            <a:bevelT w="63500" h="25400"/>
+          </a:sp3d>
+        </a:effectStyle>
+      </a:effectStyleLst>
+      <a:bgFillStyleLst>
+        <a:solidFill>
+          <a:schemeClr val="phClr"/>
+        </a:solidFill>
+        <a:gradFill rotWithShape="1">
+          <a:gsLst>
+            <a:gs pos="0">
+              <a:schemeClr val="phClr">
+                <a:tint val="40000"/>
+                <a:satMod val="350000"/>
+              </a:schemeClr>
+            </a:gs>
+            <a:gs pos="40000">
+              <a:schemeClr val="phClr">
+                <a:tint val="45000"/>
+                <a:shade val="99000"/>
+                <a:satMod val="350000"/>
+              </a:schemeClr>
+            </a:gs>
+            <a:gs pos="100000">
+              <a:schemeClr val="phClr">
+                <a:shade val="20000"/>
+                <a:satMod val="255000"/>
+              </a:schemeClr>
+            </a:gs>
+          </a:gsLst>
+          <a:path path="circle">
+            <a:fillToRect l="50000" t="-80000" r="50000" b="180000"/>
+          </a:path>
+        </a:gradFill>
+        <a:gradFill rotWithShape="1">
+          <a:gsLst>
+            <a:gs pos="0">
+              <a:schemeClr val="phClr">
+                <a:tint val="80000"/>
+                <a:satMod val="300000"/>
+              </a:schemeClr>
+            </a:gs>
+            <a:gs pos="100000">
+              <a:schemeClr val="phClr">
+                <a:shade val="30000"/>
+                <a:satMod val="200000"/>
+              </a:schemeClr>
+            </a:gs>
+          </a:gsLst>
+          <a:path path="circle">
+            <a:fillToRect l="50000" t="50000" r="50000" b="50000"/>
+          </a:path>
+        </a:gradFill>
+      </a:bgFillStyleLst>
+    </a:fmtScheme>
+  </a:themeElements>
+  <a:objectDefaults>
+    <a:spDef>
+      <a:spPr/>
+      <a:bodyPr/>
+      <a:lstStyle/>
+      <a:style>
+        <a:lnRef idx="1">
+          <a:schemeClr val="accent1"/>
+        </a:lnRef>
+        <a:fillRef idx="3">
+          <a:schemeClr val="accent1"/>
+        </a:fillRef>
+        <a:effectRef idx="2">
+          <a:schemeClr val="accent1"/>
+        </a:effectRef>
+        <a:fontRef idx="minor">
+          <a:schemeClr val="lt1"/>
+        </a:fontRef>
+      </a:style>
+    </a:spDef>
+    <a:lnDef>
+      <a:spPr/>
+      <a:bodyPr/>
+      <a:lstStyle/>
+      <a:style>
+        <a:lnRef idx="2">
+          <a:schemeClr val="accent1"/>
+        </a:lnRef>
+        <a:fillRef idx="0">
+          <a:schemeClr val="accent1"/>
+        </a:fillRef>
+        <a:effectRef idx="1">
+          <a:schemeClr val="accent1"/>
+        </a:effectRef>
+        <a:fontRef idx="minor">
+          <a:schemeClr val="tx1"/>
+        </a:fontRef>
+      </a:style>
+    </a:lnDef>
+  </a:objectDefaults>
+  <a:extraClrSchemeLst/>
+</a:theme>
 </file>
</xml_diff>

<commit_message>
docs: regenerate Slide 7 verified grid diagram, fix aspect ratios, and refine planned test plan
</commit_message>
<xml_diff>
--- a/docs/presentation.pptx
+++ b/docs/presentation.pptx
@@ -596,7 +596,7 @@
           <a:lstStyle/>
           <a:p>
             <a:r>
-              <a:t>Summary: Complete, hardened TDMA schedule planner with 5 heuristics, 2 exact solvers, and independent BFS verifier.</a:t>
+              <a:t>Summary: Part 1 complete and verified; Part 2 designed and tested offline.</a:t>
             </a:r>
           </a:p>
           <a:p>
@@ -915,6 +915,11 @@
               <a:t>B. Pure-Python Branch-and-Bound: Zero-dependency fallback with DSATUR branching and clique pre-coloring.</a:t>
             </a:r>
           </a:p>
+          <a:p>
+            <a:r>
+              <a:t>Performance: about 1 ms or less on 16-node benchmark topologies.</a:t>
+            </a:r>
+          </a:p>
         </p:txBody>
       </p:sp>
       <p:sp>
@@ -1002,7 +1007,7 @@
           </a:p>
           <a:p>
             <a:r>
-              <a:t>Sub-Millisecond Speed: Both exact solvers compute the true global optimum for 16-node topologies in &lt; 0.5 ms.</a:t>
+              <a:t>Performance: about 1 ms or less on 16-node topologies.</a:t>
             </a:r>
           </a:p>
           <a:p>
@@ -1205,9 +1210,20 @@
               <a:t>Outcome: Catches deliberate collisions, missing nodes, and gaps; exits non-zero on failure.</a:t>
             </a:r>
           </a:p>
-          <a:p>
-            <a:r>
-              <a:t>The grid diagram shows the verified 9-slot assignment for the 4x4 topology.</a:t>
+          <a:p/>
+          <a:p>
+            <a:r>
+              <a:t>Verified 4x4 Grid node-to-slot list (matches CLI output):</a:t>
+            </a:r>
+          </a:p>
+          <a:p>
+            <a:r>
+              <a:t>Node_01: Slot 8, Node_02: Slot 4, Node_03: Slot 5, Node_04: Slot 8, Node_05: Slot 6, Node_06: Slot 0, Node_07: Slot 1, Node_08: Slot 6, Node_09: Slot 7, Node_10: Slot 2, Node_11: Slot 3, Node_12: Slot 7, Node_13: Slot 8, Node_14: Slot 4, Node_15: Slot 5, Node_16: Slot 8.</a:t>
+            </a:r>
+          </a:p>
+          <a:p>
+            <a:r>
+              <a:t>The four corners (Nodes 1, 4, 13, 16) are 3+ hops apart and safely reuse Slot 8.</a:t>
             </a:r>
           </a:p>
         </p:txBody>
@@ -1282,7 +1298,7 @@
           </a:p>
           <a:p>
             <a:r>
-              <a:t>Official Verification Log: 100% verified against Adjacent Link official documentation, XML schemas, and Python bindings.</a:t>
+              <a:t>Parameter names checked against official EMANE sources; live run not performed.</a:t>
             </a:r>
           </a:p>
           <a:p>
@@ -1372,12 +1388,28 @@
           <a:lstStyle/>
           <a:p>
             <a:r>
-              <a:t>Test Case 1 (Valid Schedule): Ping and iperf traffic pass with 0% loss; packets emit strictly at 9 ms frame intervals.</a:t>
-            </a:r>
-          </a:p>
-          <a:p>
-            <a:r>
-              <a:t>Test Case 2 (Conflicting Schedule): Deliberate collision forces SINR below PCR curve; triggers &gt; 80% packet discards.</a:t>
+              <a:t>Planned Test Plan (Not Yet Run):</a:t>
+            </a:r>
+          </a:p>
+          <a:p>
+            <a:r>
+              <a:t>1. Valid Schedule: expect delivery strictly inside scheduled slots (planned).</a:t>
+            </a:r>
+          </a:p>
+          <a:p>
+            <a:r>
+              <a:t>2. Deliberately Conflicting Schedule: expect collisions and packet drops at shared receivers (planned).</a:t>
+            </a:r>
+          </a:p>
+          <a:p>
+            <a:r>
+              <a:t>3. Range Calibration: pathloss tuned to ~500 m so that radios beyond 500 m do not collide (planned).</a:t>
+            </a:r>
+          </a:p>
+          <a:p/>
+          <a:p>
+            <a:r>
+              <a:t>Engineering Safeguards:</a:t>
             </a:r>
           </a:p>
           <a:p>
@@ -4700,7 +4732,7 @@
               </a:defRPr>
             </a:pPr>
             <a:r>
-              <a:t>Production-grade TDMA optimizer with proven correctness</a:t>
+              <a:t>Part 1 complete and verified; Part 2 designed and tested offline</a:t>
             </a:r>
           </a:p>
         </p:txBody>
@@ -4753,7 +4785,7 @@
               </a:defRPr>
             </a:pPr>
             <a:r>
-              <a:t>• Full EMANE bridge with Docker, configs, and publisher</a:t>
+              <a:t>• EMANE bridge: offline round-trip tested; live run pending</a:t>
             </a:r>
           </a:p>
           <a:p>
@@ -4965,8 +4997,8 @@
         </p:blipFill>
         <p:spPr>
           <a:xfrm>
-            <a:off x="5943600" y="1371600"/>
-            <a:ext cx="5669280" cy="4572000"/>
+            <a:off x="5943600" y="1645920"/>
+            <a:ext cx="5486400" cy="2541746"/>
           </a:xfrm>
           <a:prstGeom prst="rect">
             <a:avLst/>
@@ -5513,7 +5545,7 @@
               </a:defRPr>
             </a:pPr>
             <a:r>
-              <a:t>✓ &lt; 0.5 ms on 16-node topologies</a:t>
+              <a:t>✓ about 1 ms or less on 16-node topologies</a:t>
             </a:r>
           </a:p>
         </p:txBody>
@@ -5841,8 +5873,8 @@
         </p:blipFill>
         <p:spPr>
           <a:xfrm>
-            <a:off x="5943600" y="1371600"/>
-            <a:ext cx="5669280" cy="4572000"/>
+            <a:off x="6035040" y="1645920"/>
+            <a:ext cx="5394960" cy="2632928"/>
           </a:xfrm>
           <a:prstGeom prst="rect">
             <a:avLst/>
@@ -5859,7 +5891,7 @@
         </p:nvGraphicFramePr>
         <p:xfrm>
           <a:off x="731520" y="1371600"/>
-          <a:ext cx="4937760" cy="2057400"/>
+          <a:ext cx="4846320" cy="2057400"/>
         </p:xfrm>
         <a:graphic>
           <a:graphicData uri="http://schemas.openxmlformats.org/drawingml/2006/table">
@@ -5868,11 +5900,11 @@
                 <a:tableStyleId>{5C22544A-7EE6-4342-B048-85BDC9FD1C3A}</a:tableStyleId>
               </a:tblPr>
               <a:tblGrid>
-                <a:gridCol w="987552"/>
-                <a:gridCol w="987552"/>
-                <a:gridCol w="987552"/>
-                <a:gridCol w="987552"/>
-                <a:gridCol w="987552"/>
+                <a:gridCol w="1920240"/>
+                <a:gridCol w="640080"/>
+                <a:gridCol w="868680"/>
+                <a:gridCol w="868680"/>
+                <a:gridCol w="548640"/>
               </a:tblGrid>
               <a:tr h="411480">
                 <a:tc>
@@ -6644,7 +6676,7 @@
         <p:spPr>
           <a:xfrm>
             <a:off x="5943600" y="1371600"/>
-            <a:ext cx="5486400" cy="5029200"/>
+            <a:ext cx="5669280" cy="5088663"/>
           </a:xfrm>
           <a:prstGeom prst="rect">
             <a:avLst/>
@@ -6810,7 +6842,7 @@
               </a:defRPr>
             </a:pPr>
             <a:r>
-              <a:t>• 11/11 parameters verified against official docs</a:t>
+              <a:t>• Parameter names checked against official EMANE sources; live run not performed</a:t>
             </a:r>
           </a:p>
         </p:txBody>
@@ -6831,8 +6863,8 @@
         </p:blipFill>
         <p:spPr>
           <a:xfrm>
-            <a:off x="457200" y="3200400"/>
-            <a:ext cx="11247120" cy="3200400"/>
+            <a:off x="1371600" y="3200400"/>
+            <a:ext cx="9418320" cy="3277088"/>
           </a:xfrm>
           <a:prstGeom prst="rect">
             <a:avLst/>
@@ -6968,7 +7000,7 @@
               </a:defRPr>
             </a:pPr>
             <a:r>
-              <a:t>EMULATION TEST PLAN:</a:t>
+              <a:t>PLANNED TEST PLAN (not yet run):</a:t>
             </a:r>
           </a:p>
           <a:p>
@@ -6983,11 +7015,11 @@
               </a:defRPr>
             </a:pPr>
             <a:r>
-              <a:t>• Valid schedule: 0% loss at 9 ms</a:t>
+              <a:t>• Valid schedule: expect delivery only</a:t>
             </a:r>
             <a:br/>
             <a:r>
-              <a:t>  frame intervals</a:t>
+              <a:t>  in scheduled slots (planned)</a:t>
             </a:r>
           </a:p>
           <a:p>
@@ -7002,11 +7034,11 @@
               </a:defRPr>
             </a:pPr>
             <a:r>
-              <a:t>• Conflicting schedule: deliberate</a:t>
+              <a:t>• Deliberately conflicting schedule:</a:t>
             </a:r>
             <a:br/>
             <a:r>
-              <a:t>  collision → &gt; 80% discards</a:t>
+              <a:t>  expect collision/loss (planned)</a:t>
             </a:r>
           </a:p>
           <a:p>
@@ -7021,11 +7053,11 @@
               </a:defRPr>
             </a:pPr>
             <a:r>
-              <a:t>• Range calibration: freespace model</a:t>
+              <a:t>• Range calibration: pathloss tuned</a:t>
             </a:r>
             <a:br/>
             <a:r>
-              <a:t>  tuned for ~500 m cutoff</a:t>
+              <a:t>  to ~500 m (planned)</a:t>
             </a:r>
           </a:p>
         </p:txBody>

</xml_diff>

<commit_message>
docs: fix schedule injection claim, table header, repo URLs, 0% loss, and enlarge slide images
</commit_message>
<xml_diff>
--- a/docs/presentation.pptx
+++ b/docs/presentation.pptx
@@ -4997,8 +4997,8 @@
         </p:blipFill>
         <p:spPr>
           <a:xfrm>
-            <a:off x="5943600" y="1645920"/>
-            <a:ext cx="5486400" cy="2541746"/>
+            <a:off x="5943600" y="1371600"/>
+            <a:ext cx="5943600" cy="2753558"/>
           </a:xfrm>
           <a:prstGeom prst="rect">
             <a:avLst/>
@@ -5873,8 +5873,8 @@
         </p:blipFill>
         <p:spPr>
           <a:xfrm>
-            <a:off x="6035040" y="1645920"/>
-            <a:ext cx="5394960" cy="2632928"/>
+            <a:off x="6035040" y="1371600"/>
+            <a:ext cx="5760720" cy="2811432"/>
           </a:xfrm>
           <a:prstGeom prst="rect">
             <a:avLst/>
@@ -5891,7 +5891,7 @@
         </p:nvGraphicFramePr>
         <p:xfrm>
           <a:off x="731520" y="1371600"/>
-          <a:ext cx="4846320" cy="2057400"/>
+          <a:ext cx="4983480" cy="2057400"/>
         </p:xfrm>
         <a:graphic>
           <a:graphicData uri="http://schemas.openxmlformats.org/drawingml/2006/table">
@@ -5901,7 +5901,7 @@
               </a:tblPr>
               <a:tblGrid>
                 <a:gridCol w="1920240"/>
-                <a:gridCol w="640080"/>
+                <a:gridCol w="777240"/>
                 <a:gridCol w="868680"/>
                 <a:gridCol w="868680"/>
                 <a:gridCol w="548640"/>

</xml_diff>

<commit_message>
Redesign presentation deck layout and rewrite design notes with verified benchmarks
</commit_message>
<xml_diff>
--- a/docs/presentation.pptx
+++ b/docs/presentation.pptx
@@ -251,7 +251,7 @@
             <a:lstStyle/>
             <a:p>
               <a:pPr>
-                <a:defRPr sz="1300" b="1">
+                <a:defRPr sz="1400" b="1">
                   <a:latin typeface="Calibri"/>
                 </a:defRPr>
               </a:pPr>
@@ -308,7 +308,7 @@
         <a:lstStyle/>
         <a:p>
           <a:pPr>
-            <a:defRPr sz="1300">
+            <a:defRPr sz="1400">
               <a:latin typeface="Calibri"/>
             </a:defRPr>
           </a:pPr>
@@ -1148,7 +1148,7 @@
           <a:lstStyle/>
           <a:p>
             <a:r>
-              <a:t>I evaluated the optimizer across four benchmark topologies. For the 4x4 grid, we need 9 slots. For a 16-node linear chain spaced at 350 meters, the pattern repeats every 3 nodes, yielding 3 slots. For the dense cluster where all 16 nodes are within 500 meters of each other, G² forms a 16-clique, so zero spatial reuse is physically possible and 16 slots is strictly forced. For two clusters separated by 3000 meters, they are out of range of each other, so they reuse slots 0 through 7, halving the frame. The honest takeaway is that at 16 nodes, even basic greedy coloring reaches the exact optimum on all four topologies. The value of having the exact solver isn't that the heuristics were failing, but that the exact solver provides proof that no better schedule exists.</a:t>
+              <a:t>I evaluated the optimizer across four benchmark topologies. For the 4x4 grid, we need 9 slots. For a 16-node linear chain spaced at 350 meters, the pattern repeats every 3 nodes, yielding 3 slots. For the dense cluster where all 16 nodes are within 500 meters of each other, G² forms a 16-clique, forcing every node into a distinct slot for 16 total. Finally, for two disconnected 8-node clusters separated by 3000 meters, both clusters run simultaneously, yielding 8 slots. In every case, the heuristics found the optimum on all four topologies. The value of having the exact solver isn't that the heuristics were failing, but that the exact solver provides proof that no better schedule exists.</a:t>
             </a:r>
           </a:p>
         </p:txBody>
@@ -4303,8 +4303,8 @@
         </p:nvSpPr>
         <p:spPr>
           <a:xfrm>
-            <a:off x="1097280" y="1920240"/>
-            <a:ext cx="6583680" cy="1371600"/>
+            <a:off x="914400" y="1371600"/>
+            <a:ext cx="7315200" cy="1188720"/>
           </a:xfrm>
           <a:prstGeom prst="rect">
             <a:avLst/>
@@ -4318,7 +4318,7 @@
           <a:lstStyle/>
           <a:p>
             <a:pPr>
-              <a:defRPr sz="3800" b="1">
+              <a:defRPr sz="4000" b="1">
                 <a:solidFill>
                   <a:srgbClr val="FFFFFF"/>
                 </a:solidFill>
@@ -4339,8 +4339,8 @@
         </p:nvSpPr>
         <p:spPr>
           <a:xfrm>
-            <a:off x="1097280" y="3383280"/>
-            <a:ext cx="5486400" cy="19050"/>
+            <a:off x="914400" y="2926080"/>
+            <a:ext cx="6858000" cy="19050"/>
           </a:xfrm>
           <a:prstGeom prst="rect">
             <a:avLst/>
@@ -4382,8 +4382,8 @@
         </p:nvSpPr>
         <p:spPr>
           <a:xfrm>
-            <a:off x="1097280" y="3611880"/>
-            <a:ext cx="6400800" cy="457200"/>
+            <a:off x="914400" y="3291840"/>
+            <a:ext cx="6858000" cy="365760"/>
           </a:xfrm>
           <a:prstGeom prst="rect">
             <a:avLst/>
@@ -4418,8 +4418,8 @@
         </p:nvSpPr>
         <p:spPr>
           <a:xfrm>
-            <a:off x="1097280" y="4663440"/>
-            <a:ext cx="6400800" cy="731520"/>
+            <a:off x="914400" y="4114800"/>
+            <a:ext cx="6858000" cy="365760"/>
           </a:xfrm>
           <a:prstGeom prst="rect">
             <a:avLst/>
@@ -4444,11 +4444,31 @@
               <a:t>Athish M</a:t>
             </a:r>
           </a:p>
+        </p:txBody>
+      </p:sp>
+      <p:sp>
+        <p:nvSpPr>
+          <p:cNvPr id="7" name="TextBox 6"/>
+          <p:cNvSpPr txBox="1"/>
+          <p:nvPr/>
+        </p:nvSpPr>
+        <p:spPr>
+          <a:xfrm>
+            <a:off x="914400" y="4846320"/>
+            <a:ext cx="6858000" cy="365760"/>
+          </a:xfrm>
+          <a:prstGeom prst="rect">
+            <a:avLst/>
+          </a:prstGeom>
+          <a:noFill/>
+        </p:spPr>
+        <p:txBody>
+          <a:bodyPr wrap="none" lIns="0" tIns="0" rIns="0" bIns="0">
+            <a:spAutoFit/>
+          </a:bodyPr>
+          <a:lstStyle/>
           <a:p>
             <a:pPr>
-              <a:spcBef>
-                <a:spcPts val="400"/>
-              </a:spcBef>
               <a:defRPr sz="1600">
                 <a:solidFill>
                   <a:srgbClr val="94A3B8"/>
@@ -4464,13 +4484,13 @@
       </p:sp>
       <p:sp>
         <p:nvSpPr>
-          <p:cNvPr id="7" name="Oval 6"/>
+          <p:cNvPr id="8" name="Oval 7"/>
           <p:cNvSpPr/>
           <p:nvPr/>
         </p:nvSpPr>
         <p:spPr>
           <a:xfrm>
-            <a:off x="8412480" y="2011680"/>
+            <a:off x="8686800" y="1828800"/>
             <a:ext cx="457200" cy="457200"/>
           </a:xfrm>
           <a:prstGeom prst="ellipse">
@@ -4507,13 +4527,13 @@
       </p:sp>
       <p:sp>
         <p:nvSpPr>
-          <p:cNvPr id="8" name="Oval 7"/>
+          <p:cNvPr id="9" name="Oval 8"/>
           <p:cNvSpPr/>
           <p:nvPr/>
         </p:nvSpPr>
         <p:spPr>
           <a:xfrm>
-            <a:off x="9189720" y="2011680"/>
+            <a:off x="9464040" y="1828800"/>
             <a:ext cx="457200" cy="457200"/>
           </a:xfrm>
           <a:prstGeom prst="ellipse">
@@ -4550,13 +4570,13 @@
       </p:sp>
       <p:sp>
         <p:nvSpPr>
-          <p:cNvPr id="9" name="Oval 8"/>
+          <p:cNvPr id="10" name="Oval 9"/>
           <p:cNvSpPr/>
           <p:nvPr/>
         </p:nvSpPr>
         <p:spPr>
           <a:xfrm>
-            <a:off x="9966960" y="2011680"/>
+            <a:off x="10241280" y="1828800"/>
             <a:ext cx="457200" cy="457200"/>
           </a:xfrm>
           <a:prstGeom prst="ellipse">
@@ -4593,13 +4613,13 @@
       </p:sp>
       <p:sp>
         <p:nvSpPr>
-          <p:cNvPr id="10" name="Oval 9"/>
+          <p:cNvPr id="11" name="Oval 10"/>
           <p:cNvSpPr/>
           <p:nvPr/>
         </p:nvSpPr>
         <p:spPr>
           <a:xfrm>
-            <a:off x="10744200" y="2011680"/>
+            <a:off x="11018520" y="1828800"/>
             <a:ext cx="457200" cy="457200"/>
           </a:xfrm>
           <a:prstGeom prst="ellipse">
@@ -4636,13 +4656,13 @@
       </p:sp>
       <p:sp>
         <p:nvSpPr>
-          <p:cNvPr id="11" name="Oval 10"/>
+          <p:cNvPr id="12" name="Oval 11"/>
           <p:cNvSpPr/>
           <p:nvPr/>
         </p:nvSpPr>
         <p:spPr>
           <a:xfrm>
-            <a:off x="8412480" y="2788920"/>
+            <a:off x="8686800" y="2606040"/>
             <a:ext cx="457200" cy="457200"/>
           </a:xfrm>
           <a:prstGeom prst="ellipse">
@@ -4679,13 +4699,13 @@
       </p:sp>
       <p:sp>
         <p:nvSpPr>
-          <p:cNvPr id="12" name="Oval 11"/>
+          <p:cNvPr id="13" name="Oval 12"/>
           <p:cNvSpPr/>
           <p:nvPr/>
         </p:nvSpPr>
         <p:spPr>
           <a:xfrm>
-            <a:off x="9189720" y="2788920"/>
+            <a:off x="9464040" y="2606040"/>
             <a:ext cx="457200" cy="457200"/>
           </a:xfrm>
           <a:prstGeom prst="ellipse">
@@ -4722,13 +4742,13 @@
       </p:sp>
       <p:sp>
         <p:nvSpPr>
-          <p:cNvPr id="13" name="Oval 12"/>
+          <p:cNvPr id="14" name="Oval 13"/>
           <p:cNvSpPr/>
           <p:nvPr/>
         </p:nvSpPr>
         <p:spPr>
           <a:xfrm>
-            <a:off x="9966960" y="2788920"/>
+            <a:off x="10241280" y="2606040"/>
             <a:ext cx="457200" cy="457200"/>
           </a:xfrm>
           <a:prstGeom prst="ellipse">
@@ -4765,13 +4785,13 @@
       </p:sp>
       <p:sp>
         <p:nvSpPr>
-          <p:cNvPr id="14" name="Oval 13"/>
+          <p:cNvPr id="15" name="Oval 14"/>
           <p:cNvSpPr/>
           <p:nvPr/>
         </p:nvSpPr>
         <p:spPr>
           <a:xfrm>
-            <a:off x="10744200" y="2788920"/>
+            <a:off x="11018520" y="2606040"/>
             <a:ext cx="457200" cy="457200"/>
           </a:xfrm>
           <a:prstGeom prst="ellipse">
@@ -4808,13 +4828,13 @@
       </p:sp>
       <p:sp>
         <p:nvSpPr>
-          <p:cNvPr id="15" name="Oval 14"/>
+          <p:cNvPr id="16" name="Oval 15"/>
           <p:cNvSpPr/>
           <p:nvPr/>
         </p:nvSpPr>
         <p:spPr>
           <a:xfrm>
-            <a:off x="8412480" y="3566160"/>
+            <a:off x="8686800" y="3383280"/>
             <a:ext cx="457200" cy="457200"/>
           </a:xfrm>
           <a:prstGeom prst="ellipse">
@@ -4851,13 +4871,13 @@
       </p:sp>
       <p:sp>
         <p:nvSpPr>
-          <p:cNvPr id="16" name="Oval 15"/>
+          <p:cNvPr id="17" name="Oval 16"/>
           <p:cNvSpPr/>
           <p:nvPr/>
         </p:nvSpPr>
         <p:spPr>
           <a:xfrm>
-            <a:off x="9189720" y="3566160"/>
+            <a:off x="9464040" y="3383280"/>
             <a:ext cx="457200" cy="457200"/>
           </a:xfrm>
           <a:prstGeom prst="ellipse">
@@ -4894,13 +4914,13 @@
       </p:sp>
       <p:sp>
         <p:nvSpPr>
-          <p:cNvPr id="17" name="Oval 16"/>
+          <p:cNvPr id="18" name="Oval 17"/>
           <p:cNvSpPr/>
           <p:nvPr/>
         </p:nvSpPr>
         <p:spPr>
           <a:xfrm>
-            <a:off x="9966960" y="3566160"/>
+            <a:off x="10241280" y="3383280"/>
             <a:ext cx="457200" cy="457200"/>
           </a:xfrm>
           <a:prstGeom prst="ellipse">
@@ -4937,13 +4957,13 @@
       </p:sp>
       <p:sp>
         <p:nvSpPr>
-          <p:cNvPr id="18" name="Oval 17"/>
+          <p:cNvPr id="19" name="Oval 18"/>
           <p:cNvSpPr/>
           <p:nvPr/>
         </p:nvSpPr>
         <p:spPr>
           <a:xfrm>
-            <a:off x="10744200" y="3566160"/>
+            <a:off x="11018520" y="3383280"/>
             <a:ext cx="457200" cy="457200"/>
           </a:xfrm>
           <a:prstGeom prst="ellipse">
@@ -4980,13 +5000,13 @@
       </p:sp>
       <p:sp>
         <p:nvSpPr>
-          <p:cNvPr id="19" name="Oval 18"/>
+          <p:cNvPr id="20" name="Oval 19"/>
           <p:cNvSpPr/>
           <p:nvPr/>
         </p:nvSpPr>
         <p:spPr>
           <a:xfrm>
-            <a:off x="8412480" y="4343400"/>
+            <a:off x="8686800" y="4160520"/>
             <a:ext cx="457200" cy="457200"/>
           </a:xfrm>
           <a:prstGeom prst="ellipse">
@@ -5023,13 +5043,13 @@
       </p:sp>
       <p:sp>
         <p:nvSpPr>
-          <p:cNvPr id="20" name="Oval 19"/>
+          <p:cNvPr id="21" name="Oval 20"/>
           <p:cNvSpPr/>
           <p:nvPr/>
         </p:nvSpPr>
         <p:spPr>
           <a:xfrm>
-            <a:off x="9189720" y="4343400"/>
+            <a:off x="9464040" y="4160520"/>
             <a:ext cx="457200" cy="457200"/>
           </a:xfrm>
           <a:prstGeom prst="ellipse">
@@ -5066,13 +5086,13 @@
       </p:sp>
       <p:sp>
         <p:nvSpPr>
-          <p:cNvPr id="21" name="Oval 20"/>
+          <p:cNvPr id="22" name="Oval 21"/>
           <p:cNvSpPr/>
           <p:nvPr/>
         </p:nvSpPr>
         <p:spPr>
           <a:xfrm>
-            <a:off x="9966960" y="4343400"/>
+            <a:off x="10241280" y="4160520"/>
             <a:ext cx="457200" cy="457200"/>
           </a:xfrm>
           <a:prstGeom prst="ellipse">
@@ -5109,13 +5129,13 @@
       </p:sp>
       <p:sp>
         <p:nvSpPr>
-          <p:cNvPr id="22" name="Oval 21"/>
+          <p:cNvPr id="23" name="Oval 22"/>
           <p:cNvSpPr/>
           <p:nvPr/>
         </p:nvSpPr>
         <p:spPr>
           <a:xfrm>
-            <a:off x="10744200" y="4343400"/>
+            <a:off x="11018520" y="4160520"/>
             <a:ext cx="457200" cy="457200"/>
           </a:xfrm>
           <a:prstGeom prst="ellipse">
@@ -5152,13 +5172,13 @@
       </p:sp>
       <p:sp>
         <p:nvSpPr>
-          <p:cNvPr id="23" name="TextBox 22"/>
+          <p:cNvPr id="24" name="TextBox 23"/>
           <p:cNvSpPr txBox="1"/>
           <p:nvPr/>
         </p:nvSpPr>
         <p:spPr>
           <a:xfrm>
-            <a:off x="8046720" y="5303520"/>
+            <a:off x="8321040" y="5120640"/>
             <a:ext cx="3474720" cy="365760"/>
           </a:xfrm>
           <a:prstGeom prst="rect">
@@ -5334,8 +5354,8 @@
         </p:nvSpPr>
         <p:spPr>
           <a:xfrm>
-            <a:off x="914400" y="1417320"/>
-            <a:ext cx="10362895" cy="548640"/>
+            <a:off x="914400" y="1280160"/>
+            <a:ext cx="10362895" cy="411480"/>
           </a:xfrm>
           <a:prstGeom prst="rect">
             <a:avLst/>
@@ -5370,13 +5390,13 @@
         </p:nvCxnSpPr>
         <p:spPr>
           <a:xfrm>
-            <a:off x="3017520" y="3520440"/>
-            <a:ext cx="2560320" cy="0"/>
+            <a:off x="2880360" y="3726180"/>
+            <a:ext cx="2596896" cy="0"/>
           </a:xfrm>
           <a:prstGeom prst="line">
             <a:avLst/>
           </a:prstGeom>
-          <a:ln w="38100">
+          <a:ln w="44450">
             <a:solidFill>
               <a:srgbClr val="0F766E"/>
             </a:solidFill>
@@ -5405,13 +5425,13 @@
         </p:nvCxnSpPr>
         <p:spPr>
           <a:xfrm flipH="1">
-            <a:off x="6583680" y="3520440"/>
-            <a:ext cx="2560320" cy="0"/>
+            <a:off x="6711696" y="3726180"/>
+            <a:ext cx="2596896" cy="0"/>
           </a:xfrm>
           <a:prstGeom prst="line">
             <a:avLst/>
           </a:prstGeom>
-          <a:ln w="38100">
+          <a:ln w="44450">
             <a:solidFill>
               <a:srgbClr val="0F766E"/>
             </a:solidFill>
@@ -5440,8 +5460,8 @@
         </p:nvSpPr>
         <p:spPr>
           <a:xfrm>
-            <a:off x="3200400" y="2606040"/>
-            <a:ext cx="1463040" cy="320040"/>
+            <a:off x="2971800" y="2697480"/>
+            <a:ext cx="2011680" cy="365760"/>
           </a:xfrm>
           <a:prstGeom prst="rect">
             <a:avLst/>
@@ -5476,8 +5496,8 @@
         </p:nvSpPr>
         <p:spPr>
           <a:xfrm>
-            <a:off x="6766560" y="2606040"/>
-            <a:ext cx="1463040" cy="320040"/>
+            <a:off x="6803136" y="2697480"/>
+            <a:ext cx="2011680" cy="365760"/>
           </a:xfrm>
           <a:prstGeom prst="rect">
             <a:avLst/>
@@ -5512,13 +5532,13 @@
         </p:nvCxnSpPr>
         <p:spPr>
           <a:xfrm>
-            <a:off x="2514600" y="2331720"/>
-            <a:ext cx="7132320" cy="0"/>
+            <a:off x="2263140" y="2377440"/>
+            <a:ext cx="7662672" cy="0"/>
           </a:xfrm>
           <a:prstGeom prst="line">
             <a:avLst/>
           </a:prstGeom>
-          <a:ln w="25400">
+          <a:ln w="31750">
             <a:solidFill>
               <a:srgbClr val="D97706"/>
             </a:solidFill>
@@ -5547,8 +5567,8 @@
         </p:nvSpPr>
         <p:spPr>
           <a:xfrm>
-            <a:off x="4480560" y="1874520"/>
-            <a:ext cx="3200400" cy="365760"/>
+            <a:off x="4105656" y="1874519"/>
+            <a:ext cx="4114800" cy="411480"/>
           </a:xfrm>
           <a:prstGeom prst="rect">
             <a:avLst/>
@@ -5583,8 +5603,8 @@
         </p:nvSpPr>
         <p:spPr>
           <a:xfrm>
-            <a:off x="2011680" y="3017520"/>
-            <a:ext cx="1005840" cy="1005840"/>
+            <a:off x="1645920" y="3108960"/>
+            <a:ext cx="1234440" cy="1234440"/>
           </a:xfrm>
           <a:prstGeom prst="ellipse">
             <a:avLst/>
@@ -5615,7 +5635,7 @@
           <a:lstStyle/>
           <a:p>
             <a:pPr algn="ctr">
-              <a:defRPr sz="2600" b="1">
+              <a:defRPr sz="3000" b="1">
                 <a:solidFill>
                   <a:srgbClr val="FFFFFF"/>
                 </a:solidFill>
@@ -5636,8 +5656,8 @@
         </p:nvSpPr>
         <p:spPr>
           <a:xfrm>
-            <a:off x="1280160" y="4160520"/>
-            <a:ext cx="2468880" cy="411480"/>
+            <a:off x="731520" y="4526280"/>
+            <a:ext cx="3063240" cy="502920"/>
           </a:xfrm>
           <a:prstGeom prst="rect">
             <a:avLst/>
@@ -5672,8 +5692,8 @@
         </p:nvSpPr>
         <p:spPr>
           <a:xfrm>
-            <a:off x="5577840" y="3017520"/>
-            <a:ext cx="1005840" cy="1005840"/>
+            <a:off x="5477256" y="3108960"/>
+            <a:ext cx="1234440" cy="1234440"/>
           </a:xfrm>
           <a:prstGeom prst="ellipse">
             <a:avLst/>
@@ -5704,7 +5724,7 @@
           <a:lstStyle/>
           <a:p>
             <a:pPr algn="ctr">
-              <a:defRPr sz="2600" b="1">
+              <a:defRPr sz="3000" b="1">
                 <a:solidFill>
                   <a:srgbClr val="FFFFFF"/>
                 </a:solidFill>
@@ -5725,8 +5745,8 @@
         </p:nvSpPr>
         <p:spPr>
           <a:xfrm>
-            <a:off x="4846320" y="4160520"/>
-            <a:ext cx="2468880" cy="411480"/>
+            <a:off x="4562856" y="4526280"/>
+            <a:ext cx="3063240" cy="502920"/>
           </a:xfrm>
           <a:prstGeom prst="rect">
             <a:avLst/>
@@ -5761,8 +5781,8 @@
         </p:nvSpPr>
         <p:spPr>
           <a:xfrm>
-            <a:off x="9144000" y="3017520"/>
-            <a:ext cx="1005840" cy="1005840"/>
+            <a:off x="9308592" y="3108960"/>
+            <a:ext cx="1234440" cy="1234440"/>
           </a:xfrm>
           <a:prstGeom prst="ellipse">
             <a:avLst/>
@@ -5793,7 +5813,7 @@
           <a:lstStyle/>
           <a:p>
             <a:pPr algn="ctr">
-              <a:defRPr sz="2600" b="1">
+              <a:defRPr sz="3000" b="1">
                 <a:solidFill>
                   <a:srgbClr val="FFFFFF"/>
                 </a:solidFill>
@@ -5814,8 +5834,8 @@
         </p:nvSpPr>
         <p:spPr>
           <a:xfrm>
-            <a:off x="8412480" y="4160520"/>
-            <a:ext cx="2468880" cy="411480"/>
+            <a:off x="8394192" y="4526280"/>
+            <a:ext cx="3063240" cy="502920"/>
           </a:xfrm>
           <a:prstGeom prst="rect">
             <a:avLst/>
@@ -5850,7 +5870,7 @@
         </p:nvSpPr>
         <p:spPr>
           <a:xfrm>
-            <a:off x="914400" y="5120640"/>
+            <a:off x="914400" y="5532120"/>
             <a:ext cx="10362895" cy="548640"/>
           </a:xfrm>
           <a:prstGeom prst="rect">
@@ -6026,8 +6046,8 @@
         </p:nvSpPr>
         <p:spPr>
           <a:xfrm>
-            <a:off x="914400" y="1417320"/>
-            <a:ext cx="10362895" cy="548640"/>
+            <a:off x="914400" y="1325880"/>
+            <a:ext cx="10362895" cy="502920"/>
           </a:xfrm>
           <a:prstGeom prst="rect">
             <a:avLst/>
@@ -6062,8 +6082,8 @@
         </p:nvSpPr>
         <p:spPr>
           <a:xfrm>
-            <a:off x="914400" y="2194560"/>
-            <a:ext cx="4114800" cy="365760"/>
+            <a:off x="548640" y="2103120"/>
+            <a:ext cx="4114800" cy="411480"/>
           </a:xfrm>
           <a:prstGeom prst="rect">
             <a:avLst/>
@@ -6077,7 +6097,7 @@
           <a:lstStyle/>
           <a:p>
             <a:pPr>
-              <a:defRPr sz="2200" b="1">
+              <a:defRPr sz="2400" b="1">
                 <a:solidFill>
                   <a:srgbClr val="1B1F2A"/>
                 </a:solidFill>
@@ -6098,13 +6118,13 @@
         </p:nvCxnSpPr>
         <p:spPr>
           <a:xfrm>
-            <a:off x="1508760" y="3680460"/>
-            <a:ext cx="274320" cy="0"/>
+            <a:off x="1325880" y="4137659"/>
+            <a:ext cx="91440" cy="0"/>
           </a:xfrm>
           <a:prstGeom prst="line">
             <a:avLst/>
           </a:prstGeom>
-          <a:ln w="31750">
+          <a:ln w="38100">
             <a:solidFill>
               <a:srgbClr val="0F766E"/>
             </a:solidFill>
@@ -6133,13 +6153,13 @@
         </p:nvCxnSpPr>
         <p:spPr>
           <a:xfrm>
-            <a:off x="2377440" y="3680460"/>
-            <a:ext cx="274320" cy="0"/>
+            <a:off x="2194560" y="4137659"/>
+            <a:ext cx="91440" cy="0"/>
           </a:xfrm>
           <a:prstGeom prst="line">
             <a:avLst/>
           </a:prstGeom>
-          <a:ln w="31750">
+          <a:ln w="38100">
             <a:solidFill>
               <a:srgbClr val="0F766E"/>
             </a:solidFill>
@@ -6168,13 +6188,13 @@
         </p:nvCxnSpPr>
         <p:spPr>
           <a:xfrm>
-            <a:off x="3246120" y="3680460"/>
-            <a:ext cx="274320" cy="0"/>
+            <a:off x="3063240" y="4137659"/>
+            <a:ext cx="91440" cy="0"/>
           </a:xfrm>
           <a:prstGeom prst="line">
             <a:avLst/>
           </a:prstGeom>
-          <a:ln w="31750">
+          <a:ln w="38100">
             <a:solidFill>
               <a:srgbClr val="0F766E"/>
             </a:solidFill>
@@ -6203,13 +6223,13 @@
         </p:nvCxnSpPr>
         <p:spPr>
           <a:xfrm>
-            <a:off x="4114800" y="3680460"/>
-            <a:ext cx="274320" cy="0"/>
+            <a:off x="3931920" y="4137659"/>
+            <a:ext cx="91440" cy="0"/>
           </a:xfrm>
           <a:prstGeom prst="line">
             <a:avLst/>
           </a:prstGeom>
-          <a:ln w="31750">
+          <a:ln w="38100">
             <a:solidFill>
               <a:srgbClr val="0F766E"/>
             </a:solidFill>
@@ -6238,8 +6258,8 @@
         </p:nvSpPr>
         <p:spPr>
           <a:xfrm>
-            <a:off x="914400" y="3383280"/>
-            <a:ext cx="594360" cy="594360"/>
+            <a:off x="548640" y="3749039"/>
+            <a:ext cx="777240" cy="777240"/>
           </a:xfrm>
           <a:prstGeom prst="ellipse">
             <a:avLst/>
@@ -6270,7 +6290,7 @@
           <a:lstStyle/>
           <a:p>
             <a:pPr algn="ctr">
-              <a:defRPr sz="1600" b="1">
+              <a:defRPr sz="2000" b="1">
                 <a:solidFill>
                   <a:srgbClr val="FFFFFF"/>
                 </a:solidFill>
@@ -6291,8 +6311,8 @@
         </p:nvSpPr>
         <p:spPr>
           <a:xfrm>
-            <a:off x="1783080" y="3383280"/>
-            <a:ext cx="594360" cy="594360"/>
+            <a:off x="1417320" y="3749039"/>
+            <a:ext cx="777240" cy="777240"/>
           </a:xfrm>
           <a:prstGeom prst="ellipse">
             <a:avLst/>
@@ -6323,7 +6343,7 @@
           <a:lstStyle/>
           <a:p>
             <a:pPr algn="ctr">
-              <a:defRPr sz="1600" b="1">
+              <a:defRPr sz="2000" b="1">
                 <a:solidFill>
                   <a:srgbClr val="FFFFFF"/>
                 </a:solidFill>
@@ -6344,8 +6364,8 @@
         </p:nvSpPr>
         <p:spPr>
           <a:xfrm>
-            <a:off x="2651760" y="3383280"/>
-            <a:ext cx="594360" cy="594360"/>
+            <a:off x="2286000" y="3749039"/>
+            <a:ext cx="777240" cy="777240"/>
           </a:xfrm>
           <a:prstGeom prst="ellipse">
             <a:avLst/>
@@ -6376,7 +6396,7 @@
           <a:lstStyle/>
           <a:p>
             <a:pPr algn="ctr">
-              <a:defRPr sz="1600" b="1">
+              <a:defRPr sz="2000" b="1">
                 <a:solidFill>
                   <a:srgbClr val="FFFFFF"/>
                 </a:solidFill>
@@ -6397,8 +6417,8 @@
         </p:nvSpPr>
         <p:spPr>
           <a:xfrm>
-            <a:off x="3520440" y="3383280"/>
-            <a:ext cx="594360" cy="594360"/>
+            <a:off x="3154680" y="3749039"/>
+            <a:ext cx="777240" cy="777240"/>
           </a:xfrm>
           <a:prstGeom prst="ellipse">
             <a:avLst/>
@@ -6429,7 +6449,7 @@
           <a:lstStyle/>
           <a:p>
             <a:pPr algn="ctr">
-              <a:defRPr sz="1600" b="1">
+              <a:defRPr sz="2000" b="1">
                 <a:solidFill>
                   <a:srgbClr val="FFFFFF"/>
                 </a:solidFill>
@@ -6450,8 +6470,8 @@
         </p:nvSpPr>
         <p:spPr>
           <a:xfrm>
-            <a:off x="4389120" y="3383280"/>
-            <a:ext cx="594360" cy="594360"/>
+            <a:off x="4023360" y="3749039"/>
+            <a:ext cx="777240" cy="777240"/>
           </a:xfrm>
           <a:prstGeom prst="ellipse">
             <a:avLst/>
@@ -6482,7 +6502,7 @@
           <a:lstStyle/>
           <a:p>
             <a:pPr algn="ctr">
-              <a:defRPr sz="1600" b="1">
+              <a:defRPr sz="2000" b="1">
                 <a:solidFill>
                   <a:srgbClr val="FFFFFF"/>
                 </a:solidFill>
@@ -6503,8 +6523,8 @@
         </p:nvSpPr>
         <p:spPr>
           <a:xfrm>
-            <a:off x="914400" y="4160520"/>
-            <a:ext cx="4114800" cy="365760"/>
+            <a:off x="548640" y="4690871"/>
+            <a:ext cx="4114800" cy="411480"/>
           </a:xfrm>
           <a:prstGeom prst="rect">
             <a:avLst/>
@@ -6518,7 +6538,7 @@
           <a:lstStyle/>
           <a:p>
             <a:pPr>
-              <a:defRPr sz="2000">
+              <a:defRPr sz="1800">
                 <a:solidFill>
                   <a:srgbClr val="64748B"/>
                 </a:solidFill>
@@ -6539,8 +6559,8 @@
         </p:nvSpPr>
         <p:spPr>
           <a:xfrm>
-            <a:off x="5212080" y="2926080"/>
-            <a:ext cx="1645920" cy="731520"/>
+            <a:off x="4800600" y="3886200"/>
+            <a:ext cx="2423160" cy="457200"/>
           </a:xfrm>
           <a:prstGeom prst="rect">
             <a:avLst/>
@@ -6548,13 +6568,13 @@
           <a:noFill/>
         </p:spPr>
         <p:txBody>
-          <a:bodyPr wrap="square" lIns="0" tIns="0" rIns="0" bIns="0">
+          <a:bodyPr wrap="none" lIns="0" tIns="0" rIns="0" bIns="0">
             <a:spAutoFit/>
           </a:bodyPr>
           <a:lstStyle/>
           <a:p>
             <a:pPr algn="ctr">
-              <a:defRPr sz="2200" b="1">
+              <a:defRPr sz="2000" b="1">
                 <a:solidFill>
                   <a:srgbClr val="D97706"/>
                 </a:solidFill>
@@ -6562,11 +6582,7 @@
               </a:defRPr>
             </a:pPr>
             <a:r>
-              <a:t>→ Square it →</a:t>
-            </a:r>
-            <a:br/>
-            <a:r>
-              <a:t>G²</a:t>
+              <a:t>→ Square it → G²</a:t>
             </a:r>
           </a:p>
         </p:txBody>
@@ -6579,8 +6595,8 @@
         </p:nvSpPr>
         <p:spPr>
           <a:xfrm>
-            <a:off x="7132320" y="2194560"/>
-            <a:ext cx="4114800" cy="365760"/>
+            <a:off x="7315200" y="2103120"/>
+            <a:ext cx="4114800" cy="411480"/>
           </a:xfrm>
           <a:prstGeom prst="rect">
             <a:avLst/>
@@ -6594,7 +6610,7 @@
           <a:lstStyle/>
           <a:p>
             <a:pPr>
-              <a:defRPr sz="2200" b="1">
+              <a:defRPr sz="2400" b="1">
                 <a:solidFill>
                   <a:srgbClr val="1B1F2A"/>
                 </a:solidFill>
@@ -6615,13 +6631,13 @@
         </p:nvCxnSpPr>
         <p:spPr>
           <a:xfrm>
-            <a:off x="7726680" y="3680460"/>
-            <a:ext cx="274320" cy="0"/>
+            <a:off x="8092440" y="4137659"/>
+            <a:ext cx="91440" cy="0"/>
           </a:xfrm>
           <a:prstGeom prst="line">
             <a:avLst/>
           </a:prstGeom>
-          <a:ln w="31750">
+          <a:ln w="38100">
             <a:solidFill>
               <a:srgbClr val="0F766E"/>
             </a:solidFill>
@@ -6650,13 +6666,13 @@
         </p:nvCxnSpPr>
         <p:spPr>
           <a:xfrm>
-            <a:off x="8595360" y="3680460"/>
-            <a:ext cx="274320" cy="0"/>
+            <a:off x="8961120" y="4137659"/>
+            <a:ext cx="91440" cy="0"/>
           </a:xfrm>
           <a:prstGeom prst="line">
             <a:avLst/>
           </a:prstGeom>
-          <a:ln w="31750">
+          <a:ln w="38100">
             <a:solidFill>
               <a:srgbClr val="0F766E"/>
             </a:solidFill>
@@ -6685,13 +6701,13 @@
         </p:nvCxnSpPr>
         <p:spPr>
           <a:xfrm>
-            <a:off x="9464040" y="3680460"/>
-            <a:ext cx="274320" cy="0"/>
+            <a:off x="9829800" y="4137659"/>
+            <a:ext cx="91440" cy="0"/>
           </a:xfrm>
           <a:prstGeom prst="line">
             <a:avLst/>
           </a:prstGeom>
-          <a:ln w="31750">
+          <a:ln w="38100">
             <a:solidFill>
               <a:srgbClr val="0F766E"/>
             </a:solidFill>
@@ -6720,13 +6736,13 @@
         </p:nvCxnSpPr>
         <p:spPr>
           <a:xfrm>
-            <a:off x="10332720" y="3680460"/>
-            <a:ext cx="274320" cy="0"/>
+            <a:off x="10698480" y="4137659"/>
+            <a:ext cx="91440" cy="0"/>
           </a:xfrm>
           <a:prstGeom prst="line">
             <a:avLst/>
           </a:prstGeom>
-          <a:ln w="31750">
+          <a:ln w="38100">
             <a:solidFill>
               <a:srgbClr val="0F766E"/>
             </a:solidFill>
@@ -6755,13 +6771,13 @@
         </p:nvCxnSpPr>
         <p:spPr>
           <a:xfrm flipV="1">
-            <a:off x="7429500" y="3063240"/>
-            <a:ext cx="0" cy="320040"/>
+            <a:off x="7703820" y="3337559"/>
+            <a:ext cx="0" cy="411480"/>
           </a:xfrm>
           <a:prstGeom prst="line">
             <a:avLst/>
           </a:prstGeom>
-          <a:ln w="19050">
+          <a:ln w="25400">
             <a:solidFill>
               <a:srgbClr val="D97706"/>
             </a:solidFill>
@@ -6790,13 +6806,13 @@
         </p:nvCxnSpPr>
         <p:spPr>
           <a:xfrm>
-            <a:off x="7429500" y="3063240"/>
+            <a:off x="7703820" y="3337559"/>
             <a:ext cx="1737360" cy="0"/>
           </a:xfrm>
           <a:prstGeom prst="line">
             <a:avLst/>
           </a:prstGeom>
-          <a:ln w="19050">
+          <a:ln w="25400">
             <a:solidFill>
               <a:srgbClr val="D97706"/>
             </a:solidFill>
@@ -6825,13 +6841,13 @@
         </p:nvCxnSpPr>
         <p:spPr>
           <a:xfrm>
-            <a:off x="9166860" y="3063240"/>
-            <a:ext cx="0" cy="320040"/>
+            <a:off x="9441180" y="3337559"/>
+            <a:ext cx="0" cy="411480"/>
           </a:xfrm>
           <a:prstGeom prst="line">
             <a:avLst/>
           </a:prstGeom>
-          <a:ln w="19050">
+          <a:ln w="25400">
             <a:solidFill>
               <a:srgbClr val="D97706"/>
             </a:solidFill>
@@ -6860,13 +6876,13 @@
         </p:nvCxnSpPr>
         <p:spPr>
           <a:xfrm flipV="1">
-            <a:off x="8298180" y="2880360"/>
-            <a:ext cx="0" cy="502920"/>
+            <a:off x="8572500" y="3017519"/>
+            <a:ext cx="0" cy="731520"/>
           </a:xfrm>
           <a:prstGeom prst="line">
             <a:avLst/>
           </a:prstGeom>
-          <a:ln w="19050">
+          <a:ln w="25400">
             <a:solidFill>
               <a:srgbClr val="D97706"/>
             </a:solidFill>
@@ -6895,13 +6911,13 @@
         </p:nvCxnSpPr>
         <p:spPr>
           <a:xfrm>
-            <a:off x="8298180" y="2880360"/>
+            <a:off x="8572500" y="3017519"/>
             <a:ext cx="1737360" cy="0"/>
           </a:xfrm>
           <a:prstGeom prst="line">
             <a:avLst/>
           </a:prstGeom>
-          <a:ln w="19050">
+          <a:ln w="25400">
             <a:solidFill>
               <a:srgbClr val="D97706"/>
             </a:solidFill>
@@ -6930,13 +6946,13 @@
         </p:nvCxnSpPr>
         <p:spPr>
           <a:xfrm>
-            <a:off x="10035540" y="2880360"/>
-            <a:ext cx="0" cy="502920"/>
+            <a:off x="10309860" y="3017519"/>
+            <a:ext cx="0" cy="731520"/>
           </a:xfrm>
           <a:prstGeom prst="line">
             <a:avLst/>
           </a:prstGeom>
-          <a:ln w="19050">
+          <a:ln w="25400">
             <a:solidFill>
               <a:srgbClr val="D97706"/>
             </a:solidFill>
@@ -6965,13 +6981,13 @@
         </p:nvCxnSpPr>
         <p:spPr>
           <a:xfrm flipV="1">
-            <a:off x="9166860" y="3063240"/>
-            <a:ext cx="0" cy="320040"/>
+            <a:off x="9441180" y="3337559"/>
+            <a:ext cx="0" cy="411480"/>
           </a:xfrm>
           <a:prstGeom prst="line">
             <a:avLst/>
           </a:prstGeom>
-          <a:ln w="19050">
+          <a:ln w="25400">
             <a:solidFill>
               <a:srgbClr val="D97706"/>
             </a:solidFill>
@@ -7000,13 +7016,13 @@
         </p:nvCxnSpPr>
         <p:spPr>
           <a:xfrm>
-            <a:off x="9166860" y="3063240"/>
+            <a:off x="9441180" y="3337559"/>
             <a:ext cx="1737360" cy="0"/>
           </a:xfrm>
           <a:prstGeom prst="line">
             <a:avLst/>
           </a:prstGeom>
-          <a:ln w="19050">
+          <a:ln w="25400">
             <a:solidFill>
               <a:srgbClr val="D97706"/>
             </a:solidFill>
@@ -7035,13 +7051,13 @@
         </p:nvCxnSpPr>
         <p:spPr>
           <a:xfrm>
-            <a:off x="10904220" y="3063240"/>
-            <a:ext cx="0" cy="320040"/>
+            <a:off x="11178540" y="3337559"/>
+            <a:ext cx="0" cy="411480"/>
           </a:xfrm>
           <a:prstGeom prst="line">
             <a:avLst/>
           </a:prstGeom>
-          <a:ln w="19050">
+          <a:ln w="25400">
             <a:solidFill>
               <a:srgbClr val="D97706"/>
             </a:solidFill>
@@ -7070,8 +7086,8 @@
         </p:nvSpPr>
         <p:spPr>
           <a:xfrm>
-            <a:off x="7132320" y="3383280"/>
-            <a:ext cx="594360" cy="594360"/>
+            <a:off x="7315200" y="3749039"/>
+            <a:ext cx="777240" cy="777240"/>
           </a:xfrm>
           <a:prstGeom prst="ellipse">
             <a:avLst/>
@@ -7102,7 +7118,7 @@
           <a:lstStyle/>
           <a:p>
             <a:pPr algn="ctr">
-              <a:defRPr sz="1600" b="1">
+              <a:defRPr sz="2000" b="1">
                 <a:solidFill>
                   <a:srgbClr val="FFFFFF"/>
                 </a:solidFill>
@@ -7123,8 +7139,8 @@
         </p:nvSpPr>
         <p:spPr>
           <a:xfrm>
-            <a:off x="8001000" y="3383280"/>
-            <a:ext cx="594360" cy="594360"/>
+            <a:off x="8183880" y="3749039"/>
+            <a:ext cx="777240" cy="777240"/>
           </a:xfrm>
           <a:prstGeom prst="ellipse">
             <a:avLst/>
@@ -7155,7 +7171,7 @@
           <a:lstStyle/>
           <a:p>
             <a:pPr algn="ctr">
-              <a:defRPr sz="1600" b="1">
+              <a:defRPr sz="2000" b="1">
                 <a:solidFill>
                   <a:srgbClr val="FFFFFF"/>
                 </a:solidFill>
@@ -7176,8 +7192,8 @@
         </p:nvSpPr>
         <p:spPr>
           <a:xfrm>
-            <a:off x="8869680" y="3383280"/>
-            <a:ext cx="594360" cy="594360"/>
+            <a:off x="9052560" y="3749039"/>
+            <a:ext cx="777240" cy="777240"/>
           </a:xfrm>
           <a:prstGeom prst="ellipse">
             <a:avLst/>
@@ -7208,7 +7224,7 @@
           <a:lstStyle/>
           <a:p>
             <a:pPr algn="ctr">
-              <a:defRPr sz="1600" b="1">
+              <a:defRPr sz="2000" b="1">
                 <a:solidFill>
                   <a:srgbClr val="FFFFFF"/>
                 </a:solidFill>
@@ -7229,8 +7245,8 @@
         </p:nvSpPr>
         <p:spPr>
           <a:xfrm>
-            <a:off x="9738360" y="3383280"/>
-            <a:ext cx="594360" cy="594360"/>
+            <a:off x="9921240" y="3749039"/>
+            <a:ext cx="777240" cy="777240"/>
           </a:xfrm>
           <a:prstGeom prst="ellipse">
             <a:avLst/>
@@ -7261,7 +7277,7 @@
           <a:lstStyle/>
           <a:p>
             <a:pPr algn="ctr">
-              <a:defRPr sz="1600" b="1">
+              <a:defRPr sz="2000" b="1">
                 <a:solidFill>
                   <a:srgbClr val="FFFFFF"/>
                 </a:solidFill>
@@ -7282,8 +7298,8 @@
         </p:nvSpPr>
         <p:spPr>
           <a:xfrm>
-            <a:off x="10607040" y="3383280"/>
-            <a:ext cx="594360" cy="594360"/>
+            <a:off x="10789920" y="3749039"/>
+            <a:ext cx="777240" cy="777240"/>
           </a:xfrm>
           <a:prstGeom prst="ellipse">
             <a:avLst/>
@@ -7314,7 +7330,7 @@
           <a:lstStyle/>
           <a:p>
             <a:pPr algn="ctr">
-              <a:defRPr sz="1600" b="1">
+              <a:defRPr sz="2000" b="1">
                 <a:solidFill>
                   <a:srgbClr val="FFFFFF"/>
                 </a:solidFill>
@@ -7335,8 +7351,8 @@
         </p:nvSpPr>
         <p:spPr>
           <a:xfrm>
-            <a:off x="7132320" y="4160520"/>
-            <a:ext cx="4114800" cy="365760"/>
+            <a:off x="7315200" y="4690871"/>
+            <a:ext cx="4114800" cy="411480"/>
           </a:xfrm>
           <a:prstGeom prst="rect">
             <a:avLst/>
@@ -7350,7 +7366,7 @@
           <a:lstStyle/>
           <a:p>
             <a:pPr>
-              <a:defRPr sz="2000">
+              <a:defRPr sz="1800">
                 <a:solidFill>
                   <a:srgbClr val="64748B"/>
                 </a:solidFill>
@@ -7371,8 +7387,8 @@
         </p:nvSpPr>
         <p:spPr>
           <a:xfrm>
-            <a:off x="914400" y="5257800"/>
-            <a:ext cx="10362895" cy="548640"/>
+            <a:off x="914400" y="5532120"/>
+            <a:ext cx="10362895" cy="502920"/>
           </a:xfrm>
           <a:prstGeom prst="rect">
             <a:avLst/>
@@ -7548,8 +7564,8 @@
           <p:nvPr/>
         </p:nvGraphicFramePr>
         <p:xfrm>
-          <a:off x="914400" y="1554480"/>
-          <a:ext cx="10362895" cy="3291840"/>
+          <a:off x="914400" y="1508760"/>
+          <a:ext cx="10362895" cy="3840480"/>
         </p:xfrm>
         <a:graphic>
           <a:graphicData uri="http://schemas.openxmlformats.org/drawingml/2006/table">
@@ -7558,11 +7574,11 @@
                 <a:tableStyleId>{5C22544A-7EE6-4342-B048-85BDC9FD1C3A}</a:tableStyleId>
               </a:tblPr>
               <a:tblGrid>
-                <a:gridCol w="4572000"/>
-                <a:gridCol w="3047695"/>
+                <a:gridCol w="4876495"/>
+                <a:gridCol w="2743200"/>
                 <a:gridCol w="2743200"/>
               </a:tblGrid>
-              <a:tr h="470262">
+              <a:tr h="548640">
                 <a:tc>
                   <a:txBody>
                     <a:bodyPr/>
@@ -7630,14 +7646,14 @@
                   </a:tcPr>
                 </a:tc>
               </a:tr>
-              <a:tr h="470262">
+              <a:tr h="548640">
                 <a:tc>
                   <a:txBody>
                     <a:bodyPr/>
                     <a:lstStyle/>
                     <a:p>
                       <a:pPr algn="l">
-                        <a:defRPr sz="2000">
+                        <a:defRPr sz="1800">
                           <a:solidFill>
                             <a:srgbClr val="1B1F2A"/>
                           </a:solidFill>
@@ -7659,7 +7675,7 @@
                     <a:lstStyle/>
                     <a:p>
                       <a:pPr algn="ctr">
-                        <a:defRPr sz="2000" b="1">
+                        <a:defRPr sz="1800" b="1">
                           <a:solidFill>
                             <a:srgbClr val="1B1F2A"/>
                           </a:solidFill>
@@ -7681,7 +7697,7 @@
                     <a:lstStyle/>
                     <a:p>
                       <a:pPr algn="ctr">
-                        <a:defRPr sz="2000">
+                        <a:defRPr sz="1800">
                           <a:solidFill>
                             <a:srgbClr val="1B1F2A"/>
                           </a:solidFill>
@@ -7698,14 +7714,14 @@
                   </a:tcPr>
                 </a:tc>
               </a:tr>
-              <a:tr h="470262">
+              <a:tr h="548640">
                 <a:tc>
                   <a:txBody>
                     <a:bodyPr/>
                     <a:lstStyle/>
                     <a:p>
                       <a:pPr algn="l">
-                        <a:defRPr sz="2000">
+                        <a:defRPr sz="1800">
                           <a:solidFill>
                             <a:srgbClr val="1B1F2A"/>
                           </a:solidFill>
@@ -7727,7 +7743,7 @@
                     <a:lstStyle/>
                     <a:p>
                       <a:pPr algn="ctr">
-                        <a:defRPr sz="2000" b="1">
+                        <a:defRPr sz="1800" b="1">
                           <a:solidFill>
                             <a:srgbClr val="1B1F2A"/>
                           </a:solidFill>
@@ -7749,7 +7765,7 @@
                     <a:lstStyle/>
                     <a:p>
                       <a:pPr algn="ctr">
-                        <a:defRPr sz="2000">
+                        <a:defRPr sz="1800">
                           <a:solidFill>
                             <a:srgbClr val="1B1F2A"/>
                           </a:solidFill>
@@ -7766,14 +7782,14 @@
                   </a:tcPr>
                 </a:tc>
               </a:tr>
-              <a:tr h="470262">
+              <a:tr h="548640">
                 <a:tc>
                   <a:txBody>
                     <a:bodyPr/>
                     <a:lstStyle/>
                     <a:p>
                       <a:pPr algn="l">
-                        <a:defRPr sz="2000">
+                        <a:defRPr sz="1800">
                           <a:solidFill>
                             <a:srgbClr val="1B1F2A"/>
                           </a:solidFill>
@@ -7795,7 +7811,7 @@
                     <a:lstStyle/>
                     <a:p>
                       <a:pPr algn="ctr">
-                        <a:defRPr sz="2000" b="1">
+                        <a:defRPr sz="1800" b="1">
                           <a:solidFill>
                             <a:srgbClr val="1B1F2A"/>
                           </a:solidFill>
@@ -7817,7 +7833,7 @@
                     <a:lstStyle/>
                     <a:p>
                       <a:pPr algn="ctr">
-                        <a:defRPr sz="2000">
+                        <a:defRPr sz="1800">
                           <a:solidFill>
                             <a:srgbClr val="1B1F2A"/>
                           </a:solidFill>
@@ -7834,14 +7850,14 @@
                   </a:tcPr>
                 </a:tc>
               </a:tr>
-              <a:tr h="470262">
+              <a:tr h="548640">
                 <a:tc>
                   <a:txBody>
                     <a:bodyPr/>
                     <a:lstStyle/>
                     <a:p>
                       <a:pPr algn="l">
-                        <a:defRPr sz="2000">
+                        <a:defRPr sz="1800">
                           <a:solidFill>
                             <a:srgbClr val="1B1F2A"/>
                           </a:solidFill>
@@ -7863,7 +7879,7 @@
                     <a:lstStyle/>
                     <a:p>
                       <a:pPr algn="ctr">
-                        <a:defRPr sz="2000" b="1">
+                        <a:defRPr sz="1800" b="1">
                           <a:solidFill>
                             <a:srgbClr val="1B1F2A"/>
                           </a:solidFill>
@@ -7885,7 +7901,7 @@
                     <a:lstStyle/>
                     <a:p>
                       <a:pPr algn="ctr">
-                        <a:defRPr sz="2000">
+                        <a:defRPr sz="1800">
                           <a:solidFill>
                             <a:srgbClr val="1B1F2A"/>
                           </a:solidFill>
@@ -7902,14 +7918,14 @@
                   </a:tcPr>
                 </a:tc>
               </a:tr>
-              <a:tr h="470262">
+              <a:tr h="548640">
                 <a:tc>
                   <a:txBody>
                     <a:bodyPr/>
                     <a:lstStyle/>
                     <a:p>
                       <a:pPr algn="l">
-                        <a:defRPr sz="2000">
+                        <a:defRPr sz="1800">
                           <a:solidFill>
                             <a:srgbClr val="1B1F2A"/>
                           </a:solidFill>
@@ -7931,7 +7947,7 @@
                     <a:lstStyle/>
                     <a:p>
                       <a:pPr algn="ctr">
-                        <a:defRPr sz="2000" b="1">
+                        <a:defRPr sz="1800" b="1">
                           <a:solidFill>
                             <a:srgbClr val="1B1F2A"/>
                           </a:solidFill>
@@ -7953,7 +7969,7 @@
                     <a:lstStyle/>
                     <a:p>
                       <a:pPr algn="ctr">
-                        <a:defRPr sz="2000">
+                        <a:defRPr sz="1800">
                           <a:solidFill>
                             <a:srgbClr val="1B1F2A"/>
                           </a:solidFill>
@@ -7970,14 +7986,14 @@
                   </a:tcPr>
                 </a:tc>
               </a:tr>
-              <a:tr h="470268">
+              <a:tr h="548640">
                 <a:tc>
                   <a:txBody>
                     <a:bodyPr/>
                     <a:lstStyle/>
                     <a:p>
                       <a:pPr algn="l">
-                        <a:defRPr sz="2000">
+                        <a:defRPr sz="1800">
                           <a:solidFill>
                             <a:srgbClr val="1B1F2A"/>
                           </a:solidFill>
@@ -7999,7 +8015,7 @@
                     <a:lstStyle/>
                     <a:p>
                       <a:pPr algn="ctr">
-                        <a:defRPr sz="2000" b="1">
+                        <a:defRPr sz="1800" b="1">
                           <a:solidFill>
                             <a:srgbClr val="1B1F2A"/>
                           </a:solidFill>
@@ -8021,7 +8037,7 @@
                     <a:lstStyle/>
                     <a:p>
                       <a:pPr algn="ctr">
-                        <a:defRPr sz="2000">
+                        <a:defRPr sz="1800">
                           <a:solidFill>
                             <a:srgbClr val="1B1F2A"/>
                           </a:solidFill>
@@ -8050,8 +8066,8 @@
         </p:nvSpPr>
         <p:spPr>
           <a:xfrm>
-            <a:off x="914400" y="5166360"/>
-            <a:ext cx="10362895" cy="548640"/>
+            <a:off x="914400" y="5623560"/>
+            <a:ext cx="10362895" cy="502920"/>
           </a:xfrm>
           <a:prstGeom prst="rect">
             <a:avLst/>
@@ -8226,14 +8242,14 @@
         </p:nvSpPr>
         <p:spPr>
           <a:xfrm>
-            <a:off x="914400" y="1463040"/>
-            <a:ext cx="5120640" cy="4480560"/>
+            <a:off x="640080" y="1325880"/>
+            <a:ext cx="5943600" cy="4800600"/>
           </a:xfrm>
           <a:prstGeom prst="rect">
             <a:avLst/>
           </a:prstGeom>
           <a:solidFill>
-            <a:srgbClr val="1B1F2A"/>
+            <a:srgbClr val="1A1F2C"/>
           </a:solidFill>
           <a:ln>
             <a:noFill/>
@@ -8269,8 +8285,8 @@
         </p:nvSpPr>
         <p:spPr>
           <a:xfrm>
-            <a:off x="1097280" y="1600200"/>
-            <a:ext cx="4754880" cy="4206240"/>
+            <a:off x="804672" y="1417320"/>
+            <a:ext cx="5614416" cy="4617720"/>
           </a:xfrm>
           <a:prstGeom prst="rect">
             <a:avLst/>
@@ -8278,15 +8294,18 @@
           <a:noFill/>
         </p:spPr>
         <p:txBody>
-          <a:bodyPr wrap="square" lIns="0" tIns="0" rIns="0" bIns="0">
+          <a:bodyPr wrap="none" lIns="0" tIns="0" rIns="0" bIns="0">
             <a:spAutoFit/>
           </a:bodyPr>
           <a:lstStyle/>
           <a:p>
             <a:pPr>
-              <a:defRPr sz="1300">
+              <a:lnSpc>
+                <a:spcPts val="1550"/>
+              </a:lnSpc>
+              <a:defRPr sz="1400" b="0">
                 <a:solidFill>
-                  <a:srgbClr val="D97706"/>
+                  <a:srgbClr val="F59E0B"/>
                 </a:solidFill>
                 <a:latin typeface="Consolas"/>
               </a:defRPr>
@@ -8297,184 +8316,338 @@
           </a:p>
           <a:p>
             <a:pPr>
-              <a:defRPr sz="1300">
+              <a:lnSpc>
+                <a:spcPts val="1550"/>
+              </a:lnSpc>
+              <a:defRPr sz="1400" b="1">
                 <a:solidFill>
-                  <a:srgbClr val="FFFFFF"/>
+                  <a:srgbClr val="F8FAFC"/>
                 </a:solidFill>
                 <a:latin typeface="Consolas"/>
               </a:defRPr>
             </a:pPr>
             <a:r>
-              <a:t>Optimized Frame Length : 9 slots (Proven Opt)</a:t>
+              <a:t>Optimized Frame Length: 9 slots (Proven Optimum)</a:t>
             </a:r>
           </a:p>
           <a:p>
             <a:pPr>
-              <a:defRPr sz="1300">
+              <a:lnSpc>
+                <a:spcPts val="1550"/>
+              </a:lnSpc>
+              <a:defRPr sz="1400" b="0">
                 <a:solidFill>
-                  <a:srgbClr val="64748B"/>
+                  <a:srgbClr val="475569"/>
                 </a:solidFill>
                 <a:latin typeface="Consolas"/>
               </a:defRPr>
             </a:pPr>
             <a:r>
-              <a:t>-------------------------------------------------</a:t>
+              <a:t>--------------------------------------------------</a:t>
             </a:r>
           </a:p>
           <a:p>
             <a:pPr>
-              <a:defRPr sz="1300">
+              <a:lnSpc>
+                <a:spcPts val="1550"/>
+              </a:lnSpc>
+              <a:defRPr sz="1400" b="0">
                 <a:solidFill>
-                  <a:srgbClr val="FFFFFF"/>
+                  <a:srgbClr val="E2E8F0"/>
                 </a:solidFill>
                 <a:latin typeface="Consolas"/>
               </a:defRPr>
             </a:pPr>
             <a:r>
-              <a:t>Node_01: Slot 8    Node_09: Slot 7</a:t>
+              <a:t>Node_01: Slot 8       Node_09: Slot 7</a:t>
             </a:r>
           </a:p>
           <a:p>
             <a:pPr>
-              <a:defRPr sz="1300">
+              <a:lnSpc>
+                <a:spcPts val="1550"/>
+              </a:lnSpc>
+              <a:defRPr sz="1400" b="0">
                 <a:solidFill>
-                  <a:srgbClr val="FFFFFF"/>
+                  <a:srgbClr val="E2E8F0"/>
                 </a:solidFill>
                 <a:latin typeface="Consolas"/>
               </a:defRPr>
             </a:pPr>
             <a:r>
-              <a:t>Node_02: Slot 4    Node_10: Slot 2</a:t>
+              <a:t>Node_02: Slot 4       Node_10: Slot 2</a:t>
             </a:r>
           </a:p>
           <a:p>
             <a:pPr>
-              <a:defRPr sz="1300">
+              <a:lnSpc>
+                <a:spcPts val="1550"/>
+              </a:lnSpc>
+              <a:defRPr sz="1400" b="0">
                 <a:solidFill>
-                  <a:srgbClr val="FFFFFF"/>
+                  <a:srgbClr val="E2E8F0"/>
                 </a:solidFill>
                 <a:latin typeface="Consolas"/>
               </a:defRPr>
             </a:pPr>
             <a:r>
-              <a:t>Node_03: Slot 5    Node_11: Slot 3</a:t>
+              <a:t>Node_03: Slot 5       Node_11: Slot 3</a:t>
             </a:r>
           </a:p>
           <a:p>
             <a:pPr>
-              <a:defRPr sz="1300">
+              <a:lnSpc>
+                <a:spcPts val="1550"/>
+              </a:lnSpc>
+              <a:defRPr sz="1400" b="0">
                 <a:solidFill>
-                  <a:srgbClr val="FFFFFF"/>
+                  <a:srgbClr val="E2E8F0"/>
                 </a:solidFill>
                 <a:latin typeface="Consolas"/>
               </a:defRPr>
             </a:pPr>
             <a:r>
-              <a:t>Node_04: Slot 8    Node_12: Slot 7</a:t>
+              <a:t>Node_04: Slot 8       Node_12: Slot 7</a:t>
             </a:r>
           </a:p>
           <a:p>
             <a:pPr>
-              <a:defRPr sz="1300">
+              <a:lnSpc>
+                <a:spcPts val="1550"/>
+              </a:lnSpc>
+              <a:defRPr sz="1400" b="0">
                 <a:solidFill>
-                  <a:srgbClr val="FFFFFF"/>
+                  <a:srgbClr val="E2E8F0"/>
                 </a:solidFill>
                 <a:latin typeface="Consolas"/>
               </a:defRPr>
             </a:pPr>
             <a:r>
-              <a:t>Node_05: Slot 6    Node_13: Slot 8</a:t>
+              <a:t>Node_05: Slot 6       Node_13: Slot 8</a:t>
             </a:r>
           </a:p>
           <a:p>
             <a:pPr>
-              <a:defRPr sz="1300">
+              <a:lnSpc>
+                <a:spcPts val="1550"/>
+              </a:lnSpc>
+              <a:defRPr sz="1400" b="0">
                 <a:solidFill>
-                  <a:srgbClr val="FFFFFF"/>
+                  <a:srgbClr val="E2E8F0"/>
                 </a:solidFill>
                 <a:latin typeface="Consolas"/>
               </a:defRPr>
             </a:pPr>
             <a:r>
-              <a:t>Node_06: Slot 0    Node_14: Slot 4</a:t>
+              <a:t>Node_06: Slot 0       Node_14: Slot 4</a:t>
             </a:r>
           </a:p>
           <a:p>
             <a:pPr>
-              <a:defRPr sz="1300">
+              <a:lnSpc>
+                <a:spcPts val="1550"/>
+              </a:lnSpc>
+              <a:defRPr sz="1400" b="0">
                 <a:solidFill>
-                  <a:srgbClr val="FFFFFF"/>
+                  <a:srgbClr val="E2E8F0"/>
                 </a:solidFill>
                 <a:latin typeface="Consolas"/>
               </a:defRPr>
             </a:pPr>
             <a:r>
-              <a:t>Node_07: Slot 1    Node_15: Slot 5</a:t>
+              <a:t>Node_07: Slot 1       Node_15: Slot 5</a:t>
             </a:r>
           </a:p>
           <a:p>
             <a:pPr>
-              <a:defRPr sz="1300">
+              <a:lnSpc>
+                <a:spcPts val="1550"/>
+              </a:lnSpc>
+              <a:defRPr sz="1400" b="0">
                 <a:solidFill>
-                  <a:srgbClr val="FFFFFF"/>
+                  <a:srgbClr val="E2E8F0"/>
                 </a:solidFill>
                 <a:latin typeface="Consolas"/>
               </a:defRPr>
             </a:pPr>
             <a:r>
-              <a:t>Node_08: Slot 6    Node_16: Slot 8</a:t>
+              <a:t>Node_08: Slot 6       Node_16: Slot 8</a:t>
             </a:r>
           </a:p>
           <a:p>
             <a:pPr>
-              <a:defRPr sz="1300">
+              <a:lnSpc>
+                <a:spcPts val="1550"/>
+              </a:lnSpc>
+              <a:defRPr sz="1400" b="0">
                 <a:solidFill>
-                  <a:srgbClr val="64748B"/>
+                  <a:srgbClr val="475569"/>
                 </a:solidFill>
                 <a:latin typeface="Consolas"/>
               </a:defRPr>
             </a:pPr>
             <a:r>
-              <a:t>-------------------------------------------------</a:t>
+              <a:t>--------------------------------------------------</a:t>
             </a:r>
           </a:p>
           <a:p>
             <a:pPr>
-              <a:defRPr sz="1300">
+              <a:lnSpc>
+                <a:spcPts val="1550"/>
+              </a:lnSpc>
+              <a:defRPr sz="1400" b="1">
                 <a:solidFill>
-                  <a:srgbClr val="64748B"/>
+                  <a:srgbClr val="94A3B8"/>
                 </a:solidFill>
                 <a:latin typeface="Consolas"/>
               </a:defRPr>
             </a:pPr>
             <a:r>
-              <a:t>Slot 00 | ..1.............</a:t>
+              <a:t>Slot   01 02 03 04 05 06 07 08 09 10 11 12 13 14 15 16</a:t>
             </a:r>
           </a:p>
           <a:p>
             <a:pPr>
-              <a:defRPr sz="1300">
+              <a:lnSpc>
+                <a:spcPts val="1550"/>
+              </a:lnSpc>
+              <a:defRPr sz="1400" b="0">
                 <a:solidFill>
-                  <a:srgbClr val="64748B"/>
+                  <a:srgbClr val="94A3B8"/>
                 </a:solidFill>
                 <a:latin typeface="Consolas"/>
               </a:defRPr>
             </a:pPr>
             <a:r>
-              <a:t>Slot 04 | .1.........1....</a:t>
+              <a:t>Slot 0  .  .  .  .  .  1  .  .  .  .  .  .  .  .  .  .</a:t>
             </a:r>
           </a:p>
           <a:p>
             <a:pPr>
-              <a:defRPr sz="1300">
+              <a:lnSpc>
+                <a:spcPts val="1550"/>
+              </a:lnSpc>
+              <a:defRPr sz="1400" b="0">
                 <a:solidFill>
-                  <a:srgbClr val="D97706"/>
+                  <a:srgbClr val="94A3B8"/>
                 </a:solidFill>
                 <a:latin typeface="Consolas"/>
               </a:defRPr>
             </a:pPr>
             <a:r>
-              <a:t>Slot 08 | 1..1........1..1 (Four corners!)</a:t>
+              <a:t>Slot 1  .  .  .  .  .  .  1  .  .  .  .  .  .  .  .  .</a:t>
+            </a:r>
+          </a:p>
+          <a:p>
+            <a:pPr>
+              <a:lnSpc>
+                <a:spcPts val="1550"/>
+              </a:lnSpc>
+              <a:defRPr sz="1400" b="0">
+                <a:solidFill>
+                  <a:srgbClr val="94A3B8"/>
+                </a:solidFill>
+                <a:latin typeface="Consolas"/>
+              </a:defRPr>
+            </a:pPr>
+            <a:r>
+              <a:t>Slot 2  .  .  .  .  .  .  .  .  .  1  .  .  .  .  .  .</a:t>
+            </a:r>
+          </a:p>
+          <a:p>
+            <a:pPr>
+              <a:lnSpc>
+                <a:spcPts val="1550"/>
+              </a:lnSpc>
+              <a:defRPr sz="1400" b="0">
+                <a:solidFill>
+                  <a:srgbClr val="94A3B8"/>
+                </a:solidFill>
+                <a:latin typeface="Consolas"/>
+              </a:defRPr>
+            </a:pPr>
+            <a:r>
+              <a:t>Slot 3  .  .  .  .  .  .  .  .  .  .  1  .  .  .  .  .</a:t>
+            </a:r>
+          </a:p>
+          <a:p>
+            <a:pPr>
+              <a:lnSpc>
+                <a:spcPts val="1550"/>
+              </a:lnSpc>
+              <a:defRPr sz="1400" b="0">
+                <a:solidFill>
+                  <a:srgbClr val="94A3B8"/>
+                </a:solidFill>
+                <a:latin typeface="Consolas"/>
+              </a:defRPr>
+            </a:pPr>
+            <a:r>
+              <a:t>Slot 4  .  1  .  .  .  .  .  .  .  .  .  .  .  1  .  .</a:t>
+            </a:r>
+          </a:p>
+          <a:p>
+            <a:pPr>
+              <a:lnSpc>
+                <a:spcPts val="1550"/>
+              </a:lnSpc>
+              <a:defRPr sz="1400" b="0">
+                <a:solidFill>
+                  <a:srgbClr val="94A3B8"/>
+                </a:solidFill>
+                <a:latin typeface="Consolas"/>
+              </a:defRPr>
+            </a:pPr>
+            <a:r>
+              <a:t>Slot 5  .  .  1  .  .  .  .  .  .  .  .  .  .  .  1  .</a:t>
+            </a:r>
+          </a:p>
+          <a:p>
+            <a:pPr>
+              <a:lnSpc>
+                <a:spcPts val="1550"/>
+              </a:lnSpc>
+              <a:defRPr sz="1400" b="0">
+                <a:solidFill>
+                  <a:srgbClr val="94A3B8"/>
+                </a:solidFill>
+                <a:latin typeface="Consolas"/>
+              </a:defRPr>
+            </a:pPr>
+            <a:r>
+              <a:t>Slot 6  .  .  .  .  1  .  .  1  .  .  .  .  .  .  .  .</a:t>
+            </a:r>
+          </a:p>
+          <a:p>
+            <a:pPr>
+              <a:lnSpc>
+                <a:spcPts val="1550"/>
+              </a:lnSpc>
+              <a:defRPr sz="1400" b="0">
+                <a:solidFill>
+                  <a:srgbClr val="94A3B8"/>
+                </a:solidFill>
+                <a:latin typeface="Consolas"/>
+              </a:defRPr>
+            </a:pPr>
+            <a:r>
+              <a:t>Slot 7  .  .  .  .  .  .  .  .  1  .  .  1  .  .  .  .</a:t>
+            </a:r>
+          </a:p>
+          <a:p>
+            <a:pPr>
+              <a:lnSpc>
+                <a:spcPts val="1550"/>
+              </a:lnSpc>
+              <a:defRPr sz="1400" b="1">
+                <a:solidFill>
+                  <a:srgbClr val="F59E0B"/>
+                </a:solidFill>
+                <a:latin typeface="Consolas"/>
+              </a:defRPr>
+            </a:pPr>
+            <a:r>
+              <a:t>Slot 8  1  .  .  1  .  .  .  .  .  .  .  .  1  .  .  1</a:t>
             </a:r>
           </a:p>
         </p:txBody>
@@ -8487,8 +8660,8 @@
         </p:nvCxnSpPr>
         <p:spPr>
           <a:xfrm>
-            <a:off x="7022592" y="1810512"/>
-            <a:ext cx="1005840" cy="0"/>
+            <a:off x="7269480" y="1645920"/>
+            <a:ext cx="1143000" cy="0"/>
           </a:xfrm>
           <a:prstGeom prst="line">
             <a:avLst/>
@@ -8522,8 +8695,8 @@
         </p:nvCxnSpPr>
         <p:spPr>
           <a:xfrm>
-            <a:off x="7022592" y="1810512"/>
-            <a:ext cx="0" cy="1005840"/>
+            <a:off x="7269480" y="1645920"/>
+            <a:ext cx="0" cy="1143000"/>
           </a:xfrm>
           <a:prstGeom prst="line">
             <a:avLst/>
@@ -8557,8 +8730,8 @@
         </p:nvCxnSpPr>
         <p:spPr>
           <a:xfrm>
-            <a:off x="7022592" y="1810512"/>
-            <a:ext cx="1005840" cy="1005840"/>
+            <a:off x="7269480" y="1645920"/>
+            <a:ext cx="1143000" cy="1143000"/>
           </a:xfrm>
           <a:prstGeom prst="line">
             <a:avLst/>
@@ -8592,8 +8765,8 @@
         </p:nvCxnSpPr>
         <p:spPr>
           <a:xfrm>
-            <a:off x="8028432" y="1810512"/>
-            <a:ext cx="1005840" cy="0"/>
+            <a:off x="8412480" y="1645920"/>
+            <a:ext cx="1143000" cy="0"/>
           </a:xfrm>
           <a:prstGeom prst="line">
             <a:avLst/>
@@ -8627,8 +8800,8 @@
         </p:nvCxnSpPr>
         <p:spPr>
           <a:xfrm flipH="1">
-            <a:off x="7022592" y="1810512"/>
-            <a:ext cx="1005840" cy="1005840"/>
+            <a:off x="7269480" y="1645920"/>
+            <a:ext cx="1143000" cy="1143000"/>
           </a:xfrm>
           <a:prstGeom prst="line">
             <a:avLst/>
@@ -8662,8 +8835,8 @@
         </p:nvCxnSpPr>
         <p:spPr>
           <a:xfrm>
-            <a:off x="8028432" y="1810512"/>
-            <a:ext cx="0" cy="1005840"/>
+            <a:off x="8412480" y="1645920"/>
+            <a:ext cx="0" cy="1143000"/>
           </a:xfrm>
           <a:prstGeom prst="line">
             <a:avLst/>
@@ -8697,8 +8870,8 @@
         </p:nvCxnSpPr>
         <p:spPr>
           <a:xfrm>
-            <a:off x="8028432" y="1810512"/>
-            <a:ext cx="1005840" cy="1005840"/>
+            <a:off x="8412480" y="1645920"/>
+            <a:ext cx="1143000" cy="1143000"/>
           </a:xfrm>
           <a:prstGeom prst="line">
             <a:avLst/>
@@ -8732,8 +8905,8 @@
         </p:nvCxnSpPr>
         <p:spPr>
           <a:xfrm>
-            <a:off x="9034272" y="1810512"/>
-            <a:ext cx="1005840" cy="0"/>
+            <a:off x="9555480" y="1645920"/>
+            <a:ext cx="1143000" cy="0"/>
           </a:xfrm>
           <a:prstGeom prst="line">
             <a:avLst/>
@@ -8767,8 +8940,8 @@
         </p:nvCxnSpPr>
         <p:spPr>
           <a:xfrm flipH="1">
-            <a:off x="8028432" y="1810512"/>
-            <a:ext cx="1005840" cy="1005840"/>
+            <a:off x="8412480" y="1645920"/>
+            <a:ext cx="1143000" cy="1143000"/>
           </a:xfrm>
           <a:prstGeom prst="line">
             <a:avLst/>
@@ -8802,8 +8975,8 @@
         </p:nvCxnSpPr>
         <p:spPr>
           <a:xfrm>
-            <a:off x="9034272" y="1810512"/>
-            <a:ext cx="0" cy="1005840"/>
+            <a:off x="9555480" y="1645920"/>
+            <a:ext cx="0" cy="1143000"/>
           </a:xfrm>
           <a:prstGeom prst="line">
             <a:avLst/>
@@ -8837,8 +9010,8 @@
         </p:nvCxnSpPr>
         <p:spPr>
           <a:xfrm>
-            <a:off x="9034272" y="1810512"/>
-            <a:ext cx="1005840" cy="1005840"/>
+            <a:off x="9555480" y="1645920"/>
+            <a:ext cx="1143000" cy="1143000"/>
           </a:xfrm>
           <a:prstGeom prst="line">
             <a:avLst/>
@@ -8872,8 +9045,8 @@
         </p:nvCxnSpPr>
         <p:spPr>
           <a:xfrm flipH="1">
-            <a:off x="9034272" y="1810512"/>
-            <a:ext cx="1005840" cy="1005840"/>
+            <a:off x="9555480" y="1645920"/>
+            <a:ext cx="1143000" cy="1143000"/>
           </a:xfrm>
           <a:prstGeom prst="line">
             <a:avLst/>
@@ -8907,8 +9080,8 @@
         </p:nvCxnSpPr>
         <p:spPr>
           <a:xfrm>
-            <a:off x="10040112" y="1810512"/>
-            <a:ext cx="0" cy="1005840"/>
+            <a:off x="10698480" y="1645920"/>
+            <a:ext cx="0" cy="1143000"/>
           </a:xfrm>
           <a:prstGeom prst="line">
             <a:avLst/>
@@ -8942,8 +9115,8 @@
         </p:nvCxnSpPr>
         <p:spPr>
           <a:xfrm>
-            <a:off x="7022592" y="2816352"/>
-            <a:ext cx="1005840" cy="0"/>
+            <a:off x="7269480" y="2788920"/>
+            <a:ext cx="1143000" cy="0"/>
           </a:xfrm>
           <a:prstGeom prst="line">
             <a:avLst/>
@@ -8977,8 +9150,8 @@
         </p:nvCxnSpPr>
         <p:spPr>
           <a:xfrm>
-            <a:off x="7022592" y="2816352"/>
-            <a:ext cx="0" cy="1005840"/>
+            <a:off x="7269480" y="2788920"/>
+            <a:ext cx="0" cy="1143000"/>
           </a:xfrm>
           <a:prstGeom prst="line">
             <a:avLst/>
@@ -9012,8 +9185,8 @@
         </p:nvCxnSpPr>
         <p:spPr>
           <a:xfrm>
-            <a:off x="7022592" y="2816352"/>
-            <a:ext cx="1005840" cy="1005840"/>
+            <a:off x="7269480" y="2788920"/>
+            <a:ext cx="1143000" cy="1143000"/>
           </a:xfrm>
           <a:prstGeom prst="line">
             <a:avLst/>
@@ -9047,8 +9220,8 @@
         </p:nvCxnSpPr>
         <p:spPr>
           <a:xfrm>
-            <a:off x="8028432" y="2816352"/>
-            <a:ext cx="1005840" cy="0"/>
+            <a:off x="8412480" y="2788920"/>
+            <a:ext cx="1143000" cy="0"/>
           </a:xfrm>
           <a:prstGeom prst="line">
             <a:avLst/>
@@ -9082,8 +9255,8 @@
         </p:nvCxnSpPr>
         <p:spPr>
           <a:xfrm flipH="1">
-            <a:off x="7022592" y="2816352"/>
-            <a:ext cx="1005840" cy="1005840"/>
+            <a:off x="7269480" y="2788920"/>
+            <a:ext cx="1143000" cy="1143000"/>
           </a:xfrm>
           <a:prstGeom prst="line">
             <a:avLst/>
@@ -9117,8 +9290,8 @@
         </p:nvCxnSpPr>
         <p:spPr>
           <a:xfrm>
-            <a:off x="8028432" y="2816352"/>
-            <a:ext cx="0" cy="1005840"/>
+            <a:off x="8412480" y="2788920"/>
+            <a:ext cx="0" cy="1143000"/>
           </a:xfrm>
           <a:prstGeom prst="line">
             <a:avLst/>
@@ -9152,8 +9325,8 @@
         </p:nvCxnSpPr>
         <p:spPr>
           <a:xfrm>
-            <a:off x="8028432" y="2816352"/>
-            <a:ext cx="1005840" cy="1005840"/>
+            <a:off x="8412480" y="2788920"/>
+            <a:ext cx="1143000" cy="1143000"/>
           </a:xfrm>
           <a:prstGeom prst="line">
             <a:avLst/>
@@ -9187,8 +9360,8 @@
         </p:nvCxnSpPr>
         <p:spPr>
           <a:xfrm>
-            <a:off x="9034272" y="2816352"/>
-            <a:ext cx="1005840" cy="0"/>
+            <a:off x="9555480" y="2788920"/>
+            <a:ext cx="1143000" cy="0"/>
           </a:xfrm>
           <a:prstGeom prst="line">
             <a:avLst/>
@@ -9222,8 +9395,8 @@
         </p:nvCxnSpPr>
         <p:spPr>
           <a:xfrm flipH="1">
-            <a:off x="8028432" y="2816352"/>
-            <a:ext cx="1005840" cy="1005840"/>
+            <a:off x="8412480" y="2788920"/>
+            <a:ext cx="1143000" cy="1143000"/>
           </a:xfrm>
           <a:prstGeom prst="line">
             <a:avLst/>
@@ -9257,8 +9430,8 @@
         </p:nvCxnSpPr>
         <p:spPr>
           <a:xfrm>
-            <a:off x="9034272" y="2816352"/>
-            <a:ext cx="0" cy="1005840"/>
+            <a:off x="9555480" y="2788920"/>
+            <a:ext cx="0" cy="1143000"/>
           </a:xfrm>
           <a:prstGeom prst="line">
             <a:avLst/>
@@ -9292,8 +9465,8 @@
         </p:nvCxnSpPr>
         <p:spPr>
           <a:xfrm>
-            <a:off x="9034272" y="2816352"/>
-            <a:ext cx="1005840" cy="1005840"/>
+            <a:off x="9555480" y="2788920"/>
+            <a:ext cx="1143000" cy="1143000"/>
           </a:xfrm>
           <a:prstGeom prst="line">
             <a:avLst/>
@@ -9327,8 +9500,8 @@
         </p:nvCxnSpPr>
         <p:spPr>
           <a:xfrm flipH="1">
-            <a:off x="9034272" y="2816352"/>
-            <a:ext cx="1005840" cy="1005840"/>
+            <a:off x="9555480" y="2788920"/>
+            <a:ext cx="1143000" cy="1143000"/>
           </a:xfrm>
           <a:prstGeom prst="line">
             <a:avLst/>
@@ -9362,8 +9535,8 @@
         </p:nvCxnSpPr>
         <p:spPr>
           <a:xfrm>
-            <a:off x="10040112" y="2816352"/>
-            <a:ext cx="0" cy="1005840"/>
+            <a:off x="10698480" y="2788920"/>
+            <a:ext cx="0" cy="1143000"/>
           </a:xfrm>
           <a:prstGeom prst="line">
             <a:avLst/>
@@ -9397,8 +9570,8 @@
         </p:nvCxnSpPr>
         <p:spPr>
           <a:xfrm>
-            <a:off x="7022592" y="3822192"/>
-            <a:ext cx="1005840" cy="0"/>
+            <a:off x="7269480" y="3931920"/>
+            <a:ext cx="1143000" cy="0"/>
           </a:xfrm>
           <a:prstGeom prst="line">
             <a:avLst/>
@@ -9432,8 +9605,8 @@
         </p:nvCxnSpPr>
         <p:spPr>
           <a:xfrm>
-            <a:off x="7022592" y="3822192"/>
-            <a:ext cx="0" cy="1005840"/>
+            <a:off x="7269480" y="3931920"/>
+            <a:ext cx="0" cy="1143000"/>
           </a:xfrm>
           <a:prstGeom prst="line">
             <a:avLst/>
@@ -9467,8 +9640,8 @@
         </p:nvCxnSpPr>
         <p:spPr>
           <a:xfrm>
-            <a:off x="7022592" y="3822192"/>
-            <a:ext cx="1005840" cy="1005840"/>
+            <a:off x="7269480" y="3931920"/>
+            <a:ext cx="1143000" cy="1143000"/>
           </a:xfrm>
           <a:prstGeom prst="line">
             <a:avLst/>
@@ -9502,8 +9675,8 @@
         </p:nvCxnSpPr>
         <p:spPr>
           <a:xfrm>
-            <a:off x="8028432" y="3822192"/>
-            <a:ext cx="1005840" cy="0"/>
+            <a:off x="8412480" y="3931920"/>
+            <a:ext cx="1143000" cy="0"/>
           </a:xfrm>
           <a:prstGeom prst="line">
             <a:avLst/>
@@ -9537,8 +9710,8 @@
         </p:nvCxnSpPr>
         <p:spPr>
           <a:xfrm flipH="1">
-            <a:off x="7022592" y="3822192"/>
-            <a:ext cx="1005840" cy="1005840"/>
+            <a:off x="7269480" y="3931920"/>
+            <a:ext cx="1143000" cy="1143000"/>
           </a:xfrm>
           <a:prstGeom prst="line">
             <a:avLst/>
@@ -9572,8 +9745,8 @@
         </p:nvCxnSpPr>
         <p:spPr>
           <a:xfrm>
-            <a:off x="8028432" y="3822192"/>
-            <a:ext cx="0" cy="1005840"/>
+            <a:off x="8412480" y="3931920"/>
+            <a:ext cx="0" cy="1143000"/>
           </a:xfrm>
           <a:prstGeom prst="line">
             <a:avLst/>
@@ -9607,8 +9780,8 @@
         </p:nvCxnSpPr>
         <p:spPr>
           <a:xfrm>
-            <a:off x="8028432" y="3822192"/>
-            <a:ext cx="1005840" cy="1005840"/>
+            <a:off x="8412480" y="3931920"/>
+            <a:ext cx="1143000" cy="1143000"/>
           </a:xfrm>
           <a:prstGeom prst="line">
             <a:avLst/>
@@ -9642,8 +9815,8 @@
         </p:nvCxnSpPr>
         <p:spPr>
           <a:xfrm>
-            <a:off x="9034272" y="3822192"/>
-            <a:ext cx="1005840" cy="0"/>
+            <a:off x="9555480" y="3931920"/>
+            <a:ext cx="1143000" cy="0"/>
           </a:xfrm>
           <a:prstGeom prst="line">
             <a:avLst/>
@@ -9677,8 +9850,8 @@
         </p:nvCxnSpPr>
         <p:spPr>
           <a:xfrm flipH="1">
-            <a:off x="8028432" y="3822192"/>
-            <a:ext cx="1005840" cy="1005840"/>
+            <a:off x="8412480" y="3931920"/>
+            <a:ext cx="1143000" cy="1143000"/>
           </a:xfrm>
           <a:prstGeom prst="line">
             <a:avLst/>
@@ -9712,8 +9885,8 @@
         </p:nvCxnSpPr>
         <p:spPr>
           <a:xfrm>
-            <a:off x="9034272" y="3822192"/>
-            <a:ext cx="0" cy="1005840"/>
+            <a:off x="9555480" y="3931920"/>
+            <a:ext cx="0" cy="1143000"/>
           </a:xfrm>
           <a:prstGeom prst="line">
             <a:avLst/>
@@ -9747,8 +9920,8 @@
         </p:nvCxnSpPr>
         <p:spPr>
           <a:xfrm>
-            <a:off x="9034272" y="3822192"/>
-            <a:ext cx="1005840" cy="1005840"/>
+            <a:off x="9555480" y="3931920"/>
+            <a:ext cx="1143000" cy="1143000"/>
           </a:xfrm>
           <a:prstGeom prst="line">
             <a:avLst/>
@@ -9782,8 +9955,8 @@
         </p:nvCxnSpPr>
         <p:spPr>
           <a:xfrm flipH="1">
-            <a:off x="9034272" y="3822192"/>
-            <a:ext cx="1005840" cy="1005840"/>
+            <a:off x="9555480" y="3931920"/>
+            <a:ext cx="1143000" cy="1143000"/>
           </a:xfrm>
           <a:prstGeom prst="line">
             <a:avLst/>
@@ -9817,8 +9990,8 @@
         </p:nvCxnSpPr>
         <p:spPr>
           <a:xfrm>
-            <a:off x="10040112" y="3822192"/>
-            <a:ext cx="0" cy="1005840"/>
+            <a:off x="10698480" y="3931920"/>
+            <a:ext cx="0" cy="1143000"/>
           </a:xfrm>
           <a:prstGeom prst="line">
             <a:avLst/>
@@ -9852,8 +10025,8 @@
         </p:nvCxnSpPr>
         <p:spPr>
           <a:xfrm>
-            <a:off x="7022592" y="4828032"/>
-            <a:ext cx="1005840" cy="0"/>
+            <a:off x="7269480" y="5074920"/>
+            <a:ext cx="1143000" cy="0"/>
           </a:xfrm>
           <a:prstGeom prst="line">
             <a:avLst/>
@@ -9887,8 +10060,8 @@
         </p:nvCxnSpPr>
         <p:spPr>
           <a:xfrm>
-            <a:off x="8028432" y="4828032"/>
-            <a:ext cx="1005840" cy="0"/>
+            <a:off x="8412480" y="5074920"/>
+            <a:ext cx="1143000" cy="0"/>
           </a:xfrm>
           <a:prstGeom prst="line">
             <a:avLst/>
@@ -9922,8 +10095,8 @@
         </p:nvCxnSpPr>
         <p:spPr>
           <a:xfrm>
-            <a:off x="9034272" y="4828032"/>
-            <a:ext cx="1005840" cy="0"/>
+            <a:off x="9555480" y="5074920"/>
+            <a:ext cx="1143000" cy="0"/>
           </a:xfrm>
           <a:prstGeom prst="line">
             <a:avLst/>
@@ -9957,8 +10130,8 @@
         </p:nvSpPr>
         <p:spPr>
           <a:xfrm>
-            <a:off x="6675120" y="1463040"/>
-            <a:ext cx="694944" cy="694944"/>
+            <a:off x="6858000" y="1234440"/>
+            <a:ext cx="822960" cy="822960"/>
           </a:xfrm>
           <a:prstGeom prst="ellipse">
             <a:avLst/>
@@ -10000,8 +10173,8 @@
         </p:nvSpPr>
         <p:spPr>
           <a:xfrm>
-            <a:off x="6766560" y="1554480"/>
-            <a:ext cx="512064" cy="512064"/>
+            <a:off x="6949440" y="1325880"/>
+            <a:ext cx="640080" cy="640080"/>
           </a:xfrm>
           <a:prstGeom prst="ellipse">
             <a:avLst/>
@@ -10032,7 +10205,7 @@
           <a:lstStyle/>
           <a:p>
             <a:pPr algn="ctr">
-              <a:defRPr sz="1300" b="1">
+              <a:defRPr sz="1400" b="1">
                 <a:solidFill>
                   <a:srgbClr val="FFFFFF"/>
                 </a:solidFill>
@@ -10053,8 +10226,8 @@
         </p:nvSpPr>
         <p:spPr>
           <a:xfrm>
-            <a:off x="7772400" y="1554480"/>
-            <a:ext cx="512064" cy="512064"/>
+            <a:off x="8092440" y="1325880"/>
+            <a:ext cx="640080" cy="640080"/>
           </a:xfrm>
           <a:prstGeom prst="ellipse">
             <a:avLst/>
@@ -10085,7 +10258,7 @@
           <a:lstStyle/>
           <a:p>
             <a:pPr algn="ctr">
-              <a:defRPr sz="1300" b="1">
+              <a:defRPr sz="1400" b="1">
                 <a:solidFill>
                   <a:srgbClr val="FFFFFF"/>
                 </a:solidFill>
@@ -10106,8 +10279,8 @@
         </p:nvSpPr>
         <p:spPr>
           <a:xfrm>
-            <a:off x="8778240" y="1554480"/>
-            <a:ext cx="512064" cy="512064"/>
+            <a:off x="9235440" y="1325880"/>
+            <a:ext cx="640080" cy="640080"/>
           </a:xfrm>
           <a:prstGeom prst="ellipse">
             <a:avLst/>
@@ -10138,7 +10311,7 @@
           <a:lstStyle/>
           <a:p>
             <a:pPr algn="ctr">
-              <a:defRPr sz="1300" b="1">
+              <a:defRPr sz="1400" b="1">
                 <a:solidFill>
                   <a:srgbClr val="FFFFFF"/>
                 </a:solidFill>
@@ -10159,8 +10332,8 @@
         </p:nvSpPr>
         <p:spPr>
           <a:xfrm>
-            <a:off x="9692640" y="1463040"/>
-            <a:ext cx="694944" cy="694944"/>
+            <a:off x="10287000" y="1234440"/>
+            <a:ext cx="822960" cy="822960"/>
           </a:xfrm>
           <a:prstGeom prst="ellipse">
             <a:avLst/>
@@ -10202,8 +10375,8 @@
         </p:nvSpPr>
         <p:spPr>
           <a:xfrm>
-            <a:off x="9784080" y="1554480"/>
-            <a:ext cx="512064" cy="512064"/>
+            <a:off x="10378440" y="1325880"/>
+            <a:ext cx="640080" cy="640080"/>
           </a:xfrm>
           <a:prstGeom prst="ellipse">
             <a:avLst/>
@@ -10234,7 +10407,7 @@
           <a:lstStyle/>
           <a:p>
             <a:pPr algn="ctr">
-              <a:defRPr sz="1300" b="1">
+              <a:defRPr sz="1400" b="1">
                 <a:solidFill>
                   <a:srgbClr val="FFFFFF"/>
                 </a:solidFill>
@@ -10255,8 +10428,8 @@
         </p:nvSpPr>
         <p:spPr>
           <a:xfrm>
-            <a:off x="6766560" y="2560320"/>
-            <a:ext cx="512064" cy="512064"/>
+            <a:off x="6949440" y="2468880"/>
+            <a:ext cx="640080" cy="640080"/>
           </a:xfrm>
           <a:prstGeom prst="ellipse">
             <a:avLst/>
@@ -10287,7 +10460,7 @@
           <a:lstStyle/>
           <a:p>
             <a:pPr algn="ctr">
-              <a:defRPr sz="1300" b="1">
+              <a:defRPr sz="1400" b="1">
                 <a:solidFill>
                   <a:srgbClr val="FFFFFF"/>
                 </a:solidFill>
@@ -10308,8 +10481,8 @@
         </p:nvSpPr>
         <p:spPr>
           <a:xfrm>
-            <a:off x="7772400" y="2560320"/>
-            <a:ext cx="512064" cy="512064"/>
+            <a:off x="8092440" y="2468880"/>
+            <a:ext cx="640080" cy="640080"/>
           </a:xfrm>
           <a:prstGeom prst="ellipse">
             <a:avLst/>
@@ -10340,7 +10513,7 @@
           <a:lstStyle/>
           <a:p>
             <a:pPr algn="ctr">
-              <a:defRPr sz="1300" b="1">
+              <a:defRPr sz="1400" b="1">
                 <a:solidFill>
                   <a:srgbClr val="FFFFFF"/>
                 </a:solidFill>
@@ -10361,8 +10534,8 @@
         </p:nvSpPr>
         <p:spPr>
           <a:xfrm>
-            <a:off x="8778240" y="2560320"/>
-            <a:ext cx="512064" cy="512064"/>
+            <a:off x="9235440" y="2468880"/>
+            <a:ext cx="640080" cy="640080"/>
           </a:xfrm>
           <a:prstGeom prst="ellipse">
             <a:avLst/>
@@ -10393,7 +10566,7 @@
           <a:lstStyle/>
           <a:p>
             <a:pPr algn="ctr">
-              <a:defRPr sz="1300" b="1">
+              <a:defRPr sz="1400" b="1">
                 <a:solidFill>
                   <a:srgbClr val="FFFFFF"/>
                 </a:solidFill>
@@ -10414,8 +10587,8 @@
         </p:nvSpPr>
         <p:spPr>
           <a:xfrm>
-            <a:off x="9784080" y="2560320"/>
-            <a:ext cx="512064" cy="512064"/>
+            <a:off x="10378440" y="2468880"/>
+            <a:ext cx="640080" cy="640080"/>
           </a:xfrm>
           <a:prstGeom prst="ellipse">
             <a:avLst/>
@@ -10446,7 +10619,7 @@
           <a:lstStyle/>
           <a:p>
             <a:pPr algn="ctr">
-              <a:defRPr sz="1300" b="1">
+              <a:defRPr sz="1400" b="1">
                 <a:solidFill>
                   <a:srgbClr val="FFFFFF"/>
                 </a:solidFill>
@@ -10467,8 +10640,8 @@
         </p:nvSpPr>
         <p:spPr>
           <a:xfrm>
-            <a:off x="6766560" y="3566160"/>
-            <a:ext cx="512064" cy="512064"/>
+            <a:off x="6949440" y="3611880"/>
+            <a:ext cx="640080" cy="640080"/>
           </a:xfrm>
           <a:prstGeom prst="ellipse">
             <a:avLst/>
@@ -10499,7 +10672,7 @@
           <a:lstStyle/>
           <a:p>
             <a:pPr algn="ctr">
-              <a:defRPr sz="1300" b="1">
+              <a:defRPr sz="1400" b="1">
                 <a:solidFill>
                   <a:srgbClr val="FFFFFF"/>
                 </a:solidFill>
@@ -10520,8 +10693,8 @@
         </p:nvSpPr>
         <p:spPr>
           <a:xfrm>
-            <a:off x="7772400" y="3566160"/>
-            <a:ext cx="512064" cy="512064"/>
+            <a:off x="8092440" y="3611880"/>
+            <a:ext cx="640080" cy="640080"/>
           </a:xfrm>
           <a:prstGeom prst="ellipse">
             <a:avLst/>
@@ -10552,7 +10725,7 @@
           <a:lstStyle/>
           <a:p>
             <a:pPr algn="ctr">
-              <a:defRPr sz="1300" b="1">
+              <a:defRPr sz="1400" b="1">
                 <a:solidFill>
                   <a:srgbClr val="FFFFFF"/>
                 </a:solidFill>
@@ -10573,8 +10746,8 @@
         </p:nvSpPr>
         <p:spPr>
           <a:xfrm>
-            <a:off x="8778240" y="3566160"/>
-            <a:ext cx="512064" cy="512064"/>
+            <a:off x="9235440" y="3611880"/>
+            <a:ext cx="640080" cy="640080"/>
           </a:xfrm>
           <a:prstGeom prst="ellipse">
             <a:avLst/>
@@ -10605,7 +10778,7 @@
           <a:lstStyle/>
           <a:p>
             <a:pPr algn="ctr">
-              <a:defRPr sz="1300" b="1">
+              <a:defRPr sz="1400" b="1">
                 <a:solidFill>
                   <a:srgbClr val="FFFFFF"/>
                 </a:solidFill>
@@ -10626,8 +10799,8 @@
         </p:nvSpPr>
         <p:spPr>
           <a:xfrm>
-            <a:off x="9784080" y="3566160"/>
-            <a:ext cx="512064" cy="512064"/>
+            <a:off x="10378440" y="3611880"/>
+            <a:ext cx="640080" cy="640080"/>
           </a:xfrm>
           <a:prstGeom prst="ellipse">
             <a:avLst/>
@@ -10658,7 +10831,7 @@
           <a:lstStyle/>
           <a:p>
             <a:pPr algn="ctr">
-              <a:defRPr sz="1300" b="1">
+              <a:defRPr sz="1400" b="1">
                 <a:solidFill>
                   <a:srgbClr val="FFFFFF"/>
                 </a:solidFill>
@@ -10679,8 +10852,8 @@
         </p:nvSpPr>
         <p:spPr>
           <a:xfrm>
-            <a:off x="6675120" y="4480560"/>
-            <a:ext cx="694944" cy="694944"/>
+            <a:off x="6858000" y="4663440"/>
+            <a:ext cx="822960" cy="822960"/>
           </a:xfrm>
           <a:prstGeom prst="ellipse">
             <a:avLst/>
@@ -10722,8 +10895,8 @@
         </p:nvSpPr>
         <p:spPr>
           <a:xfrm>
-            <a:off x="6766560" y="4572000"/>
-            <a:ext cx="512064" cy="512064"/>
+            <a:off x="6949440" y="4754880"/>
+            <a:ext cx="640080" cy="640080"/>
           </a:xfrm>
           <a:prstGeom prst="ellipse">
             <a:avLst/>
@@ -10754,7 +10927,7 @@
           <a:lstStyle/>
           <a:p>
             <a:pPr algn="ctr">
-              <a:defRPr sz="1300" b="1">
+              <a:defRPr sz="1400" b="1">
                 <a:solidFill>
                   <a:srgbClr val="FFFFFF"/>
                 </a:solidFill>
@@ -10775,8 +10948,8 @@
         </p:nvSpPr>
         <p:spPr>
           <a:xfrm>
-            <a:off x="7772400" y="4572000"/>
-            <a:ext cx="512064" cy="512064"/>
+            <a:off x="8092440" y="4754880"/>
+            <a:ext cx="640080" cy="640080"/>
           </a:xfrm>
           <a:prstGeom prst="ellipse">
             <a:avLst/>
@@ -10807,7 +10980,7 @@
           <a:lstStyle/>
           <a:p>
             <a:pPr algn="ctr">
-              <a:defRPr sz="1300" b="1">
+              <a:defRPr sz="1400" b="1">
                 <a:solidFill>
                   <a:srgbClr val="FFFFFF"/>
                 </a:solidFill>
@@ -10828,8 +11001,8 @@
         </p:nvSpPr>
         <p:spPr>
           <a:xfrm>
-            <a:off x="8778240" y="4572000"/>
-            <a:ext cx="512064" cy="512064"/>
+            <a:off x="9235440" y="4754880"/>
+            <a:ext cx="640080" cy="640080"/>
           </a:xfrm>
           <a:prstGeom prst="ellipse">
             <a:avLst/>
@@ -10860,7 +11033,7 @@
           <a:lstStyle/>
           <a:p>
             <a:pPr algn="ctr">
-              <a:defRPr sz="1300" b="1">
+              <a:defRPr sz="1400" b="1">
                 <a:solidFill>
                   <a:srgbClr val="FFFFFF"/>
                 </a:solidFill>
@@ -10881,8 +11054,8 @@
         </p:nvSpPr>
         <p:spPr>
           <a:xfrm>
-            <a:off x="9692640" y="4480560"/>
-            <a:ext cx="694944" cy="694944"/>
+            <a:off x="10287000" y="4663440"/>
+            <a:ext cx="822960" cy="822960"/>
           </a:xfrm>
           <a:prstGeom prst="ellipse">
             <a:avLst/>
@@ -10924,8 +11097,8 @@
         </p:nvSpPr>
         <p:spPr>
           <a:xfrm>
-            <a:off x="9784080" y="4572000"/>
-            <a:ext cx="512064" cy="512064"/>
+            <a:off x="10378440" y="4754880"/>
+            <a:ext cx="640080" cy="640080"/>
           </a:xfrm>
           <a:prstGeom prst="ellipse">
             <a:avLst/>
@@ -10956,7 +11129,7 @@
           <a:lstStyle/>
           <a:p>
             <a:pPr algn="ctr">
-              <a:defRPr sz="1300" b="1">
+              <a:defRPr sz="1400" b="1">
                 <a:solidFill>
                   <a:srgbClr val="FFFFFF"/>
                 </a:solidFill>
@@ -10977,8 +11150,8 @@
         </p:nvSpPr>
         <p:spPr>
           <a:xfrm>
-            <a:off x="6400800" y="5532120"/>
-            <a:ext cx="4114800" cy="457200"/>
+            <a:off x="6675120" y="5715000"/>
+            <a:ext cx="4114800" cy="411480"/>
           </a:xfrm>
           <a:prstGeom prst="rect">
             <a:avLst/>
@@ -11153,8 +11326,8 @@
         </p:nvSpPr>
         <p:spPr>
           <a:xfrm>
-            <a:off x="914400" y="1417320"/>
-            <a:ext cx="1371600" cy="914400"/>
+            <a:off x="914400" y="1371600"/>
+            <a:ext cx="2743200" cy="1280160"/>
           </a:xfrm>
           <a:prstGeom prst="rect">
             <a:avLst/>
@@ -11168,7 +11341,7 @@
           <a:lstStyle/>
           <a:p>
             <a:pPr>
-              <a:defRPr sz="6400" b="1">
+              <a:defRPr sz="11000" b="1">
                 <a:solidFill>
                   <a:srgbClr val="D97706"/>
                 </a:solidFill>
@@ -11189,8 +11362,8 @@
         </p:nvSpPr>
         <p:spPr>
           <a:xfrm>
-            <a:off x="1920240" y="1600200"/>
-            <a:ext cx="4114800" cy="457200"/>
+            <a:off x="914400" y="3017520"/>
+            <a:ext cx="5303520" cy="411480"/>
           </a:xfrm>
           <a:prstGeom prst="rect">
             <a:avLst/>
@@ -11198,7 +11371,7 @@
           <a:noFill/>
         </p:spPr>
         <p:txBody>
-          <a:bodyPr wrap="none">
+          <a:bodyPr wrap="square" lIns="0" tIns="0" rIns="0" bIns="0">
             <a:spAutoFit/>
           </a:bodyPr>
           <a:lstStyle/>
@@ -11225,8 +11398,8 @@
         </p:nvSpPr>
         <p:spPr>
           <a:xfrm>
-            <a:off x="914400" y="2514600"/>
-            <a:ext cx="5120640" cy="1645920"/>
+            <a:off x="914400" y="3566160"/>
+            <a:ext cx="5303520" cy="1417320"/>
           </a:xfrm>
           <a:prstGeom prst="rect">
             <a:avLst/>
@@ -11248,7 +11421,7 @@
               </a:defRPr>
             </a:pPr>
             <a:r>
-              <a:t>• In range at 424 m diagonal (300√2 m ≤ 500 m).</a:t>
+              <a:t>• Diagonal neighbors reach each other (424 m ≤ 500 m).</a:t>
             </a:r>
           </a:p>
           <a:p>
@@ -11287,14 +11460,50 @@
       </p:sp>
       <p:sp>
         <p:nvSpPr>
-          <p:cNvPr id="8" name="Rectangle 7"/>
+          <p:cNvPr id="8" name="TextBox 7"/>
+          <p:cNvSpPr txBox="1"/>
+          <p:nvPr/>
+        </p:nvSpPr>
+        <p:spPr>
+          <a:xfrm>
+            <a:off x="914400" y="5166360"/>
+            <a:ext cx="5303520" cy="1005840"/>
+          </a:xfrm>
+          <a:prstGeom prst="rect">
+            <a:avLst/>
+          </a:prstGeom>
+          <a:noFill/>
+        </p:spPr>
+        <p:txBody>
+          <a:bodyPr wrap="square" lIns="0" tIns="0" rIns="0" bIns="0">
+            <a:spAutoFit/>
+          </a:bodyPr>
+          <a:lstStyle/>
+          <a:p>
+            <a:pPr>
+              <a:defRPr sz="2000">
+                <a:solidFill>
+                  <a:srgbClr val="D97706"/>
+                </a:solidFill>
+                <a:latin typeface="Calibri"/>
+              </a:defRPr>
+            </a:pPr>
+            <a:r>
+              <a:t>The brief's sample shows 5 slots. Node_01 and Node_03 are 600 m apart, but Node_02 hears both, so distance-2 forbids sharing.</a:t>
+            </a:r>
+          </a:p>
+        </p:txBody>
+      </p:sp>
+      <p:sp>
+        <p:nvSpPr>
+          <p:cNvPr id="9" name="Rectangle 8"/>
           <p:cNvSpPr/>
           <p:nvPr/>
         </p:nvSpPr>
         <p:spPr>
           <a:xfrm>
-            <a:off x="6601968" y="2395728"/>
-            <a:ext cx="2852928" cy="2852928"/>
+            <a:off x="6784848" y="2304288"/>
+            <a:ext cx="3255264" cy="3255264"/>
           </a:xfrm>
           <a:prstGeom prst="rect">
             <a:avLst/>
@@ -11332,49 +11541,14 @@
       </p:sp>
       <p:cxnSp>
         <p:nvCxnSpPr>
-          <p:cNvPr id="9" name="Connector 8"/>
-          <p:cNvCxnSpPr/>
-          <p:nvPr/>
-        </p:nvCxnSpPr>
-        <p:spPr>
-          <a:xfrm>
-            <a:off x="7022592" y="1810512"/>
-            <a:ext cx="1005840" cy="0"/>
-          </a:xfrm>
-          <a:prstGeom prst="line">
-            <a:avLst/>
-          </a:prstGeom>
-          <a:ln w="12700">
-            <a:solidFill>
-              <a:srgbClr val="CBD5E1"/>
-            </a:solidFill>
-          </a:ln>
-        </p:spPr>
-        <p:style>
-          <a:lnRef idx="2">
-            <a:schemeClr val="accent1"/>
-          </a:lnRef>
-          <a:fillRef idx="0">
-            <a:schemeClr val="accent1"/>
-          </a:fillRef>
-          <a:effectRef idx="1">
-            <a:schemeClr val="accent1"/>
-          </a:effectRef>
-          <a:fontRef idx="minor">
-            <a:schemeClr val="tx1"/>
-          </a:fontRef>
-        </p:style>
-      </p:cxnSp>
-      <p:cxnSp>
-        <p:nvCxnSpPr>
           <p:cNvPr id="10" name="Connector 9"/>
           <p:cNvCxnSpPr/>
           <p:nvPr/>
         </p:nvCxnSpPr>
         <p:spPr>
           <a:xfrm>
-            <a:off x="7022592" y="1810512"/>
-            <a:ext cx="0" cy="1005840"/>
+            <a:off x="7269480" y="1645920"/>
+            <a:ext cx="1143000" cy="0"/>
           </a:xfrm>
           <a:prstGeom prst="line">
             <a:avLst/>
@@ -11408,8 +11582,8 @@
         </p:nvCxnSpPr>
         <p:spPr>
           <a:xfrm>
-            <a:off x="7022592" y="1810512"/>
-            <a:ext cx="1005840" cy="1005840"/>
+            <a:off x="7269480" y="1645920"/>
+            <a:ext cx="0" cy="1143000"/>
           </a:xfrm>
           <a:prstGeom prst="line">
             <a:avLst/>
@@ -11443,8 +11617,8 @@
         </p:nvCxnSpPr>
         <p:spPr>
           <a:xfrm>
-            <a:off x="8028432" y="1810512"/>
-            <a:ext cx="1005840" cy="0"/>
+            <a:off x="7269480" y="1645920"/>
+            <a:ext cx="1143000" cy="1143000"/>
           </a:xfrm>
           <a:prstGeom prst="line">
             <a:avLst/>
@@ -11477,9 +11651,9 @@
           <p:nvPr/>
         </p:nvCxnSpPr>
         <p:spPr>
-          <a:xfrm flipH="1">
-            <a:off x="7022592" y="1810512"/>
-            <a:ext cx="1005840" cy="1005840"/>
+          <a:xfrm>
+            <a:off x="8412480" y="1645920"/>
+            <a:ext cx="1143000" cy="0"/>
           </a:xfrm>
           <a:prstGeom prst="line">
             <a:avLst/>
@@ -11512,9 +11686,9 @@
           <p:nvPr/>
         </p:nvCxnSpPr>
         <p:spPr>
-          <a:xfrm>
-            <a:off x="8028432" y="1810512"/>
-            <a:ext cx="0" cy="1005840"/>
+          <a:xfrm flipH="1">
+            <a:off x="7269480" y="1645920"/>
+            <a:ext cx="1143000" cy="1143000"/>
           </a:xfrm>
           <a:prstGeom prst="line">
             <a:avLst/>
@@ -11548,8 +11722,8 @@
         </p:nvCxnSpPr>
         <p:spPr>
           <a:xfrm>
-            <a:off x="8028432" y="1810512"/>
-            <a:ext cx="1005840" cy="1005840"/>
+            <a:off x="8412480" y="1645920"/>
+            <a:ext cx="0" cy="1143000"/>
           </a:xfrm>
           <a:prstGeom prst="line">
             <a:avLst/>
@@ -11583,8 +11757,8 @@
         </p:nvCxnSpPr>
         <p:spPr>
           <a:xfrm>
-            <a:off x="9034272" y="1810512"/>
-            <a:ext cx="1005840" cy="0"/>
+            <a:off x="8412480" y="1645920"/>
+            <a:ext cx="1143000" cy="1143000"/>
           </a:xfrm>
           <a:prstGeom prst="line">
             <a:avLst/>
@@ -11617,9 +11791,9 @@
           <p:nvPr/>
         </p:nvCxnSpPr>
         <p:spPr>
-          <a:xfrm flipH="1">
-            <a:off x="8028432" y="1810512"/>
-            <a:ext cx="1005840" cy="1005840"/>
+          <a:xfrm>
+            <a:off x="9555480" y="1645920"/>
+            <a:ext cx="1143000" cy="0"/>
           </a:xfrm>
           <a:prstGeom prst="line">
             <a:avLst/>
@@ -11652,9 +11826,9 @@
           <p:nvPr/>
         </p:nvCxnSpPr>
         <p:spPr>
-          <a:xfrm>
-            <a:off x="9034272" y="1810512"/>
-            <a:ext cx="0" cy="1005840"/>
+          <a:xfrm flipH="1">
+            <a:off x="8412480" y="1645920"/>
+            <a:ext cx="1143000" cy="1143000"/>
           </a:xfrm>
           <a:prstGeom prst="line">
             <a:avLst/>
@@ -11688,8 +11862,8 @@
         </p:nvCxnSpPr>
         <p:spPr>
           <a:xfrm>
-            <a:off x="9034272" y="1810512"/>
-            <a:ext cx="1005840" cy="1005840"/>
+            <a:off x="9555480" y="1645920"/>
+            <a:ext cx="0" cy="1143000"/>
           </a:xfrm>
           <a:prstGeom prst="line">
             <a:avLst/>
@@ -11722,9 +11896,9 @@
           <p:nvPr/>
         </p:nvCxnSpPr>
         <p:spPr>
-          <a:xfrm flipH="1">
-            <a:off x="9034272" y="1810512"/>
-            <a:ext cx="1005840" cy="1005840"/>
+          <a:xfrm>
+            <a:off x="9555480" y="1645920"/>
+            <a:ext cx="1143000" cy="1143000"/>
           </a:xfrm>
           <a:prstGeom prst="line">
             <a:avLst/>
@@ -11757,9 +11931,9 @@
           <p:nvPr/>
         </p:nvCxnSpPr>
         <p:spPr>
-          <a:xfrm>
-            <a:off x="10040112" y="1810512"/>
-            <a:ext cx="0" cy="1005840"/>
+          <a:xfrm flipH="1">
+            <a:off x="9555480" y="1645920"/>
+            <a:ext cx="1143000" cy="1143000"/>
           </a:xfrm>
           <a:prstGeom prst="line">
             <a:avLst/>
@@ -11793,8 +11967,8 @@
         </p:nvCxnSpPr>
         <p:spPr>
           <a:xfrm>
-            <a:off x="7022592" y="2816352"/>
-            <a:ext cx="1005840" cy="0"/>
+            <a:off x="10698480" y="1645920"/>
+            <a:ext cx="0" cy="1143000"/>
           </a:xfrm>
           <a:prstGeom prst="line">
             <a:avLst/>
@@ -11828,8 +12002,8 @@
         </p:nvCxnSpPr>
         <p:spPr>
           <a:xfrm>
-            <a:off x="7022592" y="2816352"/>
-            <a:ext cx="0" cy="1005840"/>
+            <a:off x="7269480" y="2788920"/>
+            <a:ext cx="1143000" cy="0"/>
           </a:xfrm>
           <a:prstGeom prst="line">
             <a:avLst/>
@@ -11863,8 +12037,8 @@
         </p:nvCxnSpPr>
         <p:spPr>
           <a:xfrm>
-            <a:off x="7022592" y="2816352"/>
-            <a:ext cx="1005840" cy="1005840"/>
+            <a:off x="7269480" y="2788920"/>
+            <a:ext cx="0" cy="1143000"/>
           </a:xfrm>
           <a:prstGeom prst="line">
             <a:avLst/>
@@ -11898,8 +12072,8 @@
         </p:nvCxnSpPr>
         <p:spPr>
           <a:xfrm>
-            <a:off x="8028432" y="2816352"/>
-            <a:ext cx="1005840" cy="0"/>
+            <a:off x="7269480" y="2788920"/>
+            <a:ext cx="1143000" cy="1143000"/>
           </a:xfrm>
           <a:prstGeom prst="line">
             <a:avLst/>
@@ -11932,9 +12106,9 @@
           <p:nvPr/>
         </p:nvCxnSpPr>
         <p:spPr>
-          <a:xfrm flipH="1">
-            <a:off x="7022592" y="2816352"/>
-            <a:ext cx="1005840" cy="1005840"/>
+          <a:xfrm>
+            <a:off x="8412480" y="2788920"/>
+            <a:ext cx="1143000" cy="0"/>
           </a:xfrm>
           <a:prstGeom prst="line">
             <a:avLst/>
@@ -11967,9 +12141,9 @@
           <p:nvPr/>
         </p:nvCxnSpPr>
         <p:spPr>
-          <a:xfrm>
-            <a:off x="8028432" y="2816352"/>
-            <a:ext cx="0" cy="1005840"/>
+          <a:xfrm flipH="1">
+            <a:off x="7269480" y="2788920"/>
+            <a:ext cx="1143000" cy="1143000"/>
           </a:xfrm>
           <a:prstGeom prst="line">
             <a:avLst/>
@@ -12003,8 +12177,8 @@
         </p:nvCxnSpPr>
         <p:spPr>
           <a:xfrm>
-            <a:off x="8028432" y="2816352"/>
-            <a:ext cx="1005840" cy="1005840"/>
+            <a:off x="8412480" y="2788920"/>
+            <a:ext cx="0" cy="1143000"/>
           </a:xfrm>
           <a:prstGeom prst="line">
             <a:avLst/>
@@ -12038,8 +12212,8 @@
         </p:nvCxnSpPr>
         <p:spPr>
           <a:xfrm>
-            <a:off x="9034272" y="2816352"/>
-            <a:ext cx="1005840" cy="0"/>
+            <a:off x="8412480" y="2788920"/>
+            <a:ext cx="1143000" cy="1143000"/>
           </a:xfrm>
           <a:prstGeom prst="line">
             <a:avLst/>
@@ -12072,9 +12246,9 @@
           <p:nvPr/>
         </p:nvCxnSpPr>
         <p:spPr>
-          <a:xfrm flipH="1">
-            <a:off x="8028432" y="2816352"/>
-            <a:ext cx="1005840" cy="1005840"/>
+          <a:xfrm>
+            <a:off x="9555480" y="2788920"/>
+            <a:ext cx="1143000" cy="0"/>
           </a:xfrm>
           <a:prstGeom prst="line">
             <a:avLst/>
@@ -12107,9 +12281,9 @@
           <p:nvPr/>
         </p:nvCxnSpPr>
         <p:spPr>
-          <a:xfrm>
-            <a:off x="9034272" y="2816352"/>
-            <a:ext cx="0" cy="1005840"/>
+          <a:xfrm flipH="1">
+            <a:off x="8412480" y="2788920"/>
+            <a:ext cx="1143000" cy="1143000"/>
           </a:xfrm>
           <a:prstGeom prst="line">
             <a:avLst/>
@@ -12143,8 +12317,8 @@
         </p:nvCxnSpPr>
         <p:spPr>
           <a:xfrm>
-            <a:off x="9034272" y="2816352"/>
-            <a:ext cx="1005840" cy="1005840"/>
+            <a:off x="9555480" y="2788920"/>
+            <a:ext cx="0" cy="1143000"/>
           </a:xfrm>
           <a:prstGeom prst="line">
             <a:avLst/>
@@ -12177,9 +12351,9 @@
           <p:nvPr/>
         </p:nvCxnSpPr>
         <p:spPr>
-          <a:xfrm flipH="1">
-            <a:off x="9034272" y="2816352"/>
-            <a:ext cx="1005840" cy="1005840"/>
+          <a:xfrm>
+            <a:off x="9555480" y="2788920"/>
+            <a:ext cx="1143000" cy="1143000"/>
           </a:xfrm>
           <a:prstGeom prst="line">
             <a:avLst/>
@@ -12212,9 +12386,9 @@
           <p:nvPr/>
         </p:nvCxnSpPr>
         <p:spPr>
-          <a:xfrm>
-            <a:off x="10040112" y="2816352"/>
-            <a:ext cx="0" cy="1005840"/>
+          <a:xfrm flipH="1">
+            <a:off x="9555480" y="2788920"/>
+            <a:ext cx="1143000" cy="1143000"/>
           </a:xfrm>
           <a:prstGeom prst="line">
             <a:avLst/>
@@ -12248,8 +12422,8 @@
         </p:nvCxnSpPr>
         <p:spPr>
           <a:xfrm>
-            <a:off x="7022592" y="3822192"/>
-            <a:ext cx="1005840" cy="0"/>
+            <a:off x="10698480" y="2788920"/>
+            <a:ext cx="0" cy="1143000"/>
           </a:xfrm>
           <a:prstGeom prst="line">
             <a:avLst/>
@@ -12283,8 +12457,8 @@
         </p:nvCxnSpPr>
         <p:spPr>
           <a:xfrm>
-            <a:off x="7022592" y="3822192"/>
-            <a:ext cx="0" cy="1005840"/>
+            <a:off x="7269480" y="3931920"/>
+            <a:ext cx="1143000" cy="0"/>
           </a:xfrm>
           <a:prstGeom prst="line">
             <a:avLst/>
@@ -12318,8 +12492,8 @@
         </p:nvCxnSpPr>
         <p:spPr>
           <a:xfrm>
-            <a:off x="7022592" y="3822192"/>
-            <a:ext cx="1005840" cy="1005840"/>
+            <a:off x="7269480" y="3931920"/>
+            <a:ext cx="0" cy="1143000"/>
           </a:xfrm>
           <a:prstGeom prst="line">
             <a:avLst/>
@@ -12353,8 +12527,8 @@
         </p:nvCxnSpPr>
         <p:spPr>
           <a:xfrm>
-            <a:off x="8028432" y="3822192"/>
-            <a:ext cx="1005840" cy="0"/>
+            <a:off x="7269480" y="3931920"/>
+            <a:ext cx="1143000" cy="1143000"/>
           </a:xfrm>
           <a:prstGeom prst="line">
             <a:avLst/>
@@ -12387,9 +12561,9 @@
           <p:nvPr/>
         </p:nvCxnSpPr>
         <p:spPr>
-          <a:xfrm flipH="1">
-            <a:off x="7022592" y="3822192"/>
-            <a:ext cx="1005840" cy="1005840"/>
+          <a:xfrm>
+            <a:off x="8412480" y="3931920"/>
+            <a:ext cx="1143000" cy="0"/>
           </a:xfrm>
           <a:prstGeom prst="line">
             <a:avLst/>
@@ -12422,9 +12596,9 @@
           <p:nvPr/>
         </p:nvCxnSpPr>
         <p:spPr>
-          <a:xfrm>
-            <a:off x="8028432" y="3822192"/>
-            <a:ext cx="0" cy="1005840"/>
+          <a:xfrm flipH="1">
+            <a:off x="7269480" y="3931920"/>
+            <a:ext cx="1143000" cy="1143000"/>
           </a:xfrm>
           <a:prstGeom prst="line">
             <a:avLst/>
@@ -12458,8 +12632,8 @@
         </p:nvCxnSpPr>
         <p:spPr>
           <a:xfrm>
-            <a:off x="8028432" y="3822192"/>
-            <a:ext cx="1005840" cy="1005840"/>
+            <a:off x="8412480" y="3931920"/>
+            <a:ext cx="0" cy="1143000"/>
           </a:xfrm>
           <a:prstGeom prst="line">
             <a:avLst/>
@@ -12493,8 +12667,8 @@
         </p:nvCxnSpPr>
         <p:spPr>
           <a:xfrm>
-            <a:off x="9034272" y="3822192"/>
-            <a:ext cx="1005840" cy="0"/>
+            <a:off x="8412480" y="3931920"/>
+            <a:ext cx="1143000" cy="1143000"/>
           </a:xfrm>
           <a:prstGeom prst="line">
             <a:avLst/>
@@ -12527,9 +12701,9 @@
           <p:nvPr/>
         </p:nvCxnSpPr>
         <p:spPr>
-          <a:xfrm flipH="1">
-            <a:off x="8028432" y="3822192"/>
-            <a:ext cx="1005840" cy="1005840"/>
+          <a:xfrm>
+            <a:off x="9555480" y="3931920"/>
+            <a:ext cx="1143000" cy="0"/>
           </a:xfrm>
           <a:prstGeom prst="line">
             <a:avLst/>
@@ -12562,9 +12736,9 @@
           <p:nvPr/>
         </p:nvCxnSpPr>
         <p:spPr>
-          <a:xfrm>
-            <a:off x="9034272" y="3822192"/>
-            <a:ext cx="0" cy="1005840"/>
+          <a:xfrm flipH="1">
+            <a:off x="8412480" y="3931920"/>
+            <a:ext cx="1143000" cy="1143000"/>
           </a:xfrm>
           <a:prstGeom prst="line">
             <a:avLst/>
@@ -12598,8 +12772,8 @@
         </p:nvCxnSpPr>
         <p:spPr>
           <a:xfrm>
-            <a:off x="9034272" y="3822192"/>
-            <a:ext cx="1005840" cy="1005840"/>
+            <a:off x="9555480" y="3931920"/>
+            <a:ext cx="0" cy="1143000"/>
           </a:xfrm>
           <a:prstGeom prst="line">
             <a:avLst/>
@@ -12632,9 +12806,9 @@
           <p:nvPr/>
         </p:nvCxnSpPr>
         <p:spPr>
-          <a:xfrm flipH="1">
-            <a:off x="9034272" y="3822192"/>
-            <a:ext cx="1005840" cy="1005840"/>
+          <a:xfrm>
+            <a:off x="9555480" y="3931920"/>
+            <a:ext cx="1143000" cy="1143000"/>
           </a:xfrm>
           <a:prstGeom prst="line">
             <a:avLst/>
@@ -12667,9 +12841,9 @@
           <p:nvPr/>
         </p:nvCxnSpPr>
         <p:spPr>
-          <a:xfrm>
-            <a:off x="10040112" y="3822192"/>
-            <a:ext cx="0" cy="1005840"/>
+          <a:xfrm flipH="1">
+            <a:off x="9555480" y="3931920"/>
+            <a:ext cx="1143000" cy="1143000"/>
           </a:xfrm>
           <a:prstGeom prst="line">
             <a:avLst/>
@@ -12703,8 +12877,8 @@
         </p:nvCxnSpPr>
         <p:spPr>
           <a:xfrm>
-            <a:off x="7022592" y="4828032"/>
-            <a:ext cx="1005840" cy="0"/>
+            <a:off x="10698480" y="3931920"/>
+            <a:ext cx="0" cy="1143000"/>
           </a:xfrm>
           <a:prstGeom prst="line">
             <a:avLst/>
@@ -12738,8 +12912,8 @@
         </p:nvCxnSpPr>
         <p:spPr>
           <a:xfrm>
-            <a:off x="8028432" y="4828032"/>
-            <a:ext cx="1005840" cy="0"/>
+            <a:off x="7269480" y="5074920"/>
+            <a:ext cx="1143000" cy="0"/>
           </a:xfrm>
           <a:prstGeom prst="line">
             <a:avLst/>
@@ -12773,8 +12947,8 @@
         </p:nvCxnSpPr>
         <p:spPr>
           <a:xfrm>
-            <a:off x="9034272" y="4828032"/>
-            <a:ext cx="1005840" cy="0"/>
+            <a:off x="8412480" y="5074920"/>
+            <a:ext cx="1143000" cy="0"/>
           </a:xfrm>
           <a:prstGeom prst="line">
             <a:avLst/>
@@ -12800,16 +12974,51 @@
           </a:fontRef>
         </p:style>
       </p:cxnSp>
-      <p:sp>
-        <p:nvSpPr>
-          <p:cNvPr id="51" name="Oval 50"/>
+      <p:cxnSp>
+        <p:nvCxnSpPr>
+          <p:cNvPr id="51" name="Connector 50"/>
+          <p:cNvCxnSpPr/>
+          <p:nvPr/>
+        </p:nvCxnSpPr>
+        <p:spPr>
+          <a:xfrm>
+            <a:off x="9555480" y="5074920"/>
+            <a:ext cx="1143000" cy="0"/>
+          </a:xfrm>
+          <a:prstGeom prst="line">
+            <a:avLst/>
+          </a:prstGeom>
+          <a:ln w="12700">
+            <a:solidFill>
+              <a:srgbClr val="CBD5E1"/>
+            </a:solidFill>
+          </a:ln>
+        </p:spPr>
+        <p:style>
+          <a:lnRef idx="2">
+            <a:schemeClr val="accent1"/>
+          </a:lnRef>
+          <a:fillRef idx="0">
+            <a:schemeClr val="accent1"/>
+          </a:fillRef>
+          <a:effectRef idx="1">
+            <a:schemeClr val="accent1"/>
+          </a:effectRef>
+          <a:fontRef idx="minor">
+            <a:schemeClr val="tx1"/>
+          </a:fontRef>
+        </p:style>
+      </p:cxnSp>
+      <p:sp>
+        <p:nvSpPr>
+          <p:cNvPr id="52" name="Oval 51"/>
           <p:cNvSpPr/>
           <p:nvPr/>
         </p:nvSpPr>
         <p:spPr>
           <a:xfrm>
-            <a:off x="6766560" y="1554480"/>
-            <a:ext cx="512064" cy="512064"/>
+            <a:off x="6949440" y="1325880"/>
+            <a:ext cx="640080" cy="640080"/>
           </a:xfrm>
           <a:prstGeom prst="ellipse">
             <a:avLst/>
@@ -12840,7 +13049,7 @@
           <a:lstStyle/>
           <a:p>
             <a:pPr algn="ctr">
-              <a:defRPr sz="1300" b="1">
+              <a:defRPr sz="1400" b="1">
                 <a:solidFill>
                   <a:srgbClr val="FFFFFF"/>
                 </a:solidFill>
@@ -12855,14 +13064,14 @@
       </p:sp>
       <p:sp>
         <p:nvSpPr>
-          <p:cNvPr id="52" name="Oval 51"/>
+          <p:cNvPr id="53" name="Oval 52"/>
           <p:cNvSpPr/>
           <p:nvPr/>
         </p:nvSpPr>
         <p:spPr>
           <a:xfrm>
-            <a:off x="7772400" y="1554480"/>
-            <a:ext cx="512064" cy="512064"/>
+            <a:off x="8092440" y="1325880"/>
+            <a:ext cx="640080" cy="640080"/>
           </a:xfrm>
           <a:prstGeom prst="ellipse">
             <a:avLst/>
@@ -12893,7 +13102,7 @@
           <a:lstStyle/>
           <a:p>
             <a:pPr algn="ctr">
-              <a:defRPr sz="1300" b="1">
+              <a:defRPr sz="1400" b="1">
                 <a:solidFill>
                   <a:srgbClr val="FFFFFF"/>
                 </a:solidFill>
@@ -12908,14 +13117,14 @@
       </p:sp>
       <p:sp>
         <p:nvSpPr>
-          <p:cNvPr id="53" name="Oval 52"/>
+          <p:cNvPr id="54" name="Oval 53"/>
           <p:cNvSpPr/>
           <p:nvPr/>
         </p:nvSpPr>
         <p:spPr>
           <a:xfrm>
-            <a:off x="8778240" y="1554480"/>
-            <a:ext cx="512064" cy="512064"/>
+            <a:off x="9235440" y="1325880"/>
+            <a:ext cx="640080" cy="640080"/>
           </a:xfrm>
           <a:prstGeom prst="ellipse">
             <a:avLst/>
@@ -12946,7 +13155,7 @@
           <a:lstStyle/>
           <a:p>
             <a:pPr algn="ctr">
-              <a:defRPr sz="1300" b="1">
+              <a:defRPr sz="1400" b="1">
                 <a:solidFill>
                   <a:srgbClr val="FFFFFF"/>
                 </a:solidFill>
@@ -12961,14 +13170,14 @@
       </p:sp>
       <p:sp>
         <p:nvSpPr>
-          <p:cNvPr id="54" name="Oval 53"/>
+          <p:cNvPr id="55" name="Oval 54"/>
           <p:cNvSpPr/>
           <p:nvPr/>
         </p:nvSpPr>
         <p:spPr>
           <a:xfrm>
-            <a:off x="9784080" y="1554480"/>
-            <a:ext cx="512064" cy="512064"/>
+            <a:off x="10378440" y="1325880"/>
+            <a:ext cx="640080" cy="640080"/>
           </a:xfrm>
           <a:prstGeom prst="ellipse">
             <a:avLst/>
@@ -12999,7 +13208,7 @@
           <a:lstStyle/>
           <a:p>
             <a:pPr algn="ctr">
-              <a:defRPr sz="1300" b="1">
+              <a:defRPr sz="1400" b="1">
                 <a:solidFill>
                   <a:srgbClr val="FFFFFF"/>
                 </a:solidFill>
@@ -13014,14 +13223,14 @@
       </p:sp>
       <p:sp>
         <p:nvSpPr>
-          <p:cNvPr id="55" name="Oval 54"/>
+          <p:cNvPr id="56" name="Oval 55"/>
           <p:cNvSpPr/>
           <p:nvPr/>
         </p:nvSpPr>
         <p:spPr>
           <a:xfrm>
-            <a:off x="6766560" y="2560320"/>
-            <a:ext cx="512064" cy="512064"/>
+            <a:off x="6949440" y="2468880"/>
+            <a:ext cx="640080" cy="640080"/>
           </a:xfrm>
           <a:prstGeom prst="ellipse">
             <a:avLst/>
@@ -13052,7 +13261,7 @@
           <a:lstStyle/>
           <a:p>
             <a:pPr algn="ctr">
-              <a:defRPr sz="1300" b="1">
+              <a:defRPr sz="1400" b="1">
                 <a:solidFill>
                   <a:srgbClr val="FFFFFF"/>
                 </a:solidFill>
@@ -13067,14 +13276,14 @@
       </p:sp>
       <p:sp>
         <p:nvSpPr>
-          <p:cNvPr id="56" name="Oval 55"/>
+          <p:cNvPr id="57" name="Oval 56"/>
           <p:cNvSpPr/>
           <p:nvPr/>
         </p:nvSpPr>
         <p:spPr>
           <a:xfrm>
-            <a:off x="7772400" y="2560320"/>
-            <a:ext cx="512064" cy="512064"/>
+            <a:off x="8092440" y="2468880"/>
+            <a:ext cx="640080" cy="640080"/>
           </a:xfrm>
           <a:prstGeom prst="ellipse">
             <a:avLst/>
@@ -13105,7 +13314,7 @@
           <a:lstStyle/>
           <a:p>
             <a:pPr algn="ctr">
-              <a:defRPr sz="1300" b="1">
+              <a:defRPr sz="1400" b="1">
                 <a:solidFill>
                   <a:srgbClr val="FFFFFF"/>
                 </a:solidFill>
@@ -13120,14 +13329,14 @@
       </p:sp>
       <p:sp>
         <p:nvSpPr>
-          <p:cNvPr id="57" name="Oval 56"/>
+          <p:cNvPr id="58" name="Oval 57"/>
           <p:cNvSpPr/>
           <p:nvPr/>
         </p:nvSpPr>
         <p:spPr>
           <a:xfrm>
-            <a:off x="8778240" y="2560320"/>
-            <a:ext cx="512064" cy="512064"/>
+            <a:off x="9235440" y="2468880"/>
+            <a:ext cx="640080" cy="640080"/>
           </a:xfrm>
           <a:prstGeom prst="ellipse">
             <a:avLst/>
@@ -13158,7 +13367,7 @@
           <a:lstStyle/>
           <a:p>
             <a:pPr algn="ctr">
-              <a:defRPr sz="1300" b="1">
+              <a:defRPr sz="1400" b="1">
                 <a:solidFill>
                   <a:srgbClr val="FFFFFF"/>
                 </a:solidFill>
@@ -13173,14 +13382,14 @@
       </p:sp>
       <p:sp>
         <p:nvSpPr>
-          <p:cNvPr id="58" name="Oval 57"/>
+          <p:cNvPr id="59" name="Oval 58"/>
           <p:cNvSpPr/>
           <p:nvPr/>
         </p:nvSpPr>
         <p:spPr>
           <a:xfrm>
-            <a:off x="9784080" y="2560320"/>
-            <a:ext cx="512064" cy="512064"/>
+            <a:off x="10378440" y="2468880"/>
+            <a:ext cx="640080" cy="640080"/>
           </a:xfrm>
           <a:prstGeom prst="ellipse">
             <a:avLst/>
@@ -13211,7 +13420,7 @@
           <a:lstStyle/>
           <a:p>
             <a:pPr algn="ctr">
-              <a:defRPr sz="1300" b="1">
+              <a:defRPr sz="1400" b="1">
                 <a:solidFill>
                   <a:srgbClr val="FFFFFF"/>
                 </a:solidFill>
@@ -13226,14 +13435,14 @@
       </p:sp>
       <p:sp>
         <p:nvSpPr>
-          <p:cNvPr id="59" name="Oval 58"/>
+          <p:cNvPr id="60" name="Oval 59"/>
           <p:cNvSpPr/>
           <p:nvPr/>
         </p:nvSpPr>
         <p:spPr>
           <a:xfrm>
-            <a:off x="6766560" y="3566160"/>
-            <a:ext cx="512064" cy="512064"/>
+            <a:off x="6949440" y="3611880"/>
+            <a:ext cx="640080" cy="640080"/>
           </a:xfrm>
           <a:prstGeom prst="ellipse">
             <a:avLst/>
@@ -13264,7 +13473,7 @@
           <a:lstStyle/>
           <a:p>
             <a:pPr algn="ctr">
-              <a:defRPr sz="1300" b="1">
+              <a:defRPr sz="1400" b="1">
                 <a:solidFill>
                   <a:srgbClr val="FFFFFF"/>
                 </a:solidFill>
@@ -13279,14 +13488,14 @@
       </p:sp>
       <p:sp>
         <p:nvSpPr>
-          <p:cNvPr id="60" name="Oval 59"/>
+          <p:cNvPr id="61" name="Oval 60"/>
           <p:cNvSpPr/>
           <p:nvPr/>
         </p:nvSpPr>
         <p:spPr>
           <a:xfrm>
-            <a:off x="7772400" y="3566160"/>
-            <a:ext cx="512064" cy="512064"/>
+            <a:off x="8092440" y="3611880"/>
+            <a:ext cx="640080" cy="640080"/>
           </a:xfrm>
           <a:prstGeom prst="ellipse">
             <a:avLst/>
@@ -13317,7 +13526,7 @@
           <a:lstStyle/>
           <a:p>
             <a:pPr algn="ctr">
-              <a:defRPr sz="1300" b="1">
+              <a:defRPr sz="1400" b="1">
                 <a:solidFill>
                   <a:srgbClr val="FFFFFF"/>
                 </a:solidFill>
@@ -13332,14 +13541,14 @@
       </p:sp>
       <p:sp>
         <p:nvSpPr>
-          <p:cNvPr id="61" name="Oval 60"/>
+          <p:cNvPr id="62" name="Oval 61"/>
           <p:cNvSpPr/>
           <p:nvPr/>
         </p:nvSpPr>
         <p:spPr>
           <a:xfrm>
-            <a:off x="8778240" y="3566160"/>
-            <a:ext cx="512064" cy="512064"/>
+            <a:off x="9235440" y="3611880"/>
+            <a:ext cx="640080" cy="640080"/>
           </a:xfrm>
           <a:prstGeom prst="ellipse">
             <a:avLst/>
@@ -13370,7 +13579,7 @@
           <a:lstStyle/>
           <a:p>
             <a:pPr algn="ctr">
-              <a:defRPr sz="1300" b="1">
+              <a:defRPr sz="1400" b="1">
                 <a:solidFill>
                   <a:srgbClr val="FFFFFF"/>
                 </a:solidFill>
@@ -13385,14 +13594,14 @@
       </p:sp>
       <p:sp>
         <p:nvSpPr>
-          <p:cNvPr id="62" name="Oval 61"/>
+          <p:cNvPr id="63" name="Oval 62"/>
           <p:cNvSpPr/>
           <p:nvPr/>
         </p:nvSpPr>
         <p:spPr>
           <a:xfrm>
-            <a:off x="9784080" y="3566160"/>
-            <a:ext cx="512064" cy="512064"/>
+            <a:off x="10378440" y="3611880"/>
+            <a:ext cx="640080" cy="640080"/>
           </a:xfrm>
           <a:prstGeom prst="ellipse">
             <a:avLst/>
@@ -13423,7 +13632,7 @@
           <a:lstStyle/>
           <a:p>
             <a:pPr algn="ctr">
-              <a:defRPr sz="1300" b="1">
+              <a:defRPr sz="1400" b="1">
                 <a:solidFill>
                   <a:srgbClr val="FFFFFF"/>
                 </a:solidFill>
@@ -13438,14 +13647,14 @@
       </p:sp>
       <p:sp>
         <p:nvSpPr>
-          <p:cNvPr id="63" name="Oval 62"/>
+          <p:cNvPr id="64" name="Oval 63"/>
           <p:cNvSpPr/>
           <p:nvPr/>
         </p:nvSpPr>
         <p:spPr>
           <a:xfrm>
-            <a:off x="6766560" y="4572000"/>
-            <a:ext cx="512064" cy="512064"/>
+            <a:off x="6949440" y="4754880"/>
+            <a:ext cx="640080" cy="640080"/>
           </a:xfrm>
           <a:prstGeom prst="ellipse">
             <a:avLst/>
@@ -13476,7 +13685,7 @@
           <a:lstStyle/>
           <a:p>
             <a:pPr algn="ctr">
-              <a:defRPr sz="1300" b="1">
+              <a:defRPr sz="1400" b="1">
                 <a:solidFill>
                   <a:srgbClr val="FFFFFF"/>
                 </a:solidFill>
@@ -13491,14 +13700,14 @@
       </p:sp>
       <p:sp>
         <p:nvSpPr>
-          <p:cNvPr id="64" name="Oval 63"/>
+          <p:cNvPr id="65" name="Oval 64"/>
           <p:cNvSpPr/>
           <p:nvPr/>
         </p:nvSpPr>
         <p:spPr>
           <a:xfrm>
-            <a:off x="7772400" y="4572000"/>
-            <a:ext cx="512064" cy="512064"/>
+            <a:off x="8092440" y="4754880"/>
+            <a:ext cx="640080" cy="640080"/>
           </a:xfrm>
           <a:prstGeom prst="ellipse">
             <a:avLst/>
@@ -13529,7 +13738,7 @@
           <a:lstStyle/>
           <a:p>
             <a:pPr algn="ctr">
-              <a:defRPr sz="1300" b="1">
+              <a:defRPr sz="1400" b="1">
                 <a:solidFill>
                   <a:srgbClr val="FFFFFF"/>
                 </a:solidFill>
@@ -13544,14 +13753,14 @@
       </p:sp>
       <p:sp>
         <p:nvSpPr>
-          <p:cNvPr id="65" name="Oval 64"/>
+          <p:cNvPr id="66" name="Oval 65"/>
           <p:cNvSpPr/>
           <p:nvPr/>
         </p:nvSpPr>
         <p:spPr>
           <a:xfrm>
-            <a:off x="8778240" y="4572000"/>
-            <a:ext cx="512064" cy="512064"/>
+            <a:off x="9235440" y="4754880"/>
+            <a:ext cx="640080" cy="640080"/>
           </a:xfrm>
           <a:prstGeom prst="ellipse">
             <a:avLst/>
@@ -13582,7 +13791,7 @@
           <a:lstStyle/>
           <a:p>
             <a:pPr algn="ctr">
-              <a:defRPr sz="1300" b="1">
+              <a:defRPr sz="1400" b="1">
                 <a:solidFill>
                   <a:srgbClr val="FFFFFF"/>
                 </a:solidFill>
@@ -13597,14 +13806,14 @@
       </p:sp>
       <p:sp>
         <p:nvSpPr>
-          <p:cNvPr id="66" name="Oval 65"/>
+          <p:cNvPr id="67" name="Oval 66"/>
           <p:cNvSpPr/>
           <p:nvPr/>
         </p:nvSpPr>
         <p:spPr>
           <a:xfrm>
-            <a:off x="9784080" y="4572000"/>
-            <a:ext cx="512064" cy="512064"/>
+            <a:off x="10378440" y="4754880"/>
+            <a:ext cx="640080" cy="640080"/>
           </a:xfrm>
           <a:prstGeom prst="ellipse">
             <a:avLst/>
@@ -13635,7 +13844,7 @@
           <a:lstStyle/>
           <a:p>
             <a:pPr algn="ctr">
-              <a:defRPr sz="1300" b="1">
+              <a:defRPr sz="1400" b="1">
                 <a:solidFill>
                   <a:srgbClr val="FFFFFF"/>
                 </a:solidFill>
@@ -13650,14 +13859,14 @@
       </p:sp>
       <p:sp>
         <p:nvSpPr>
-          <p:cNvPr id="67" name="TextBox 66"/>
+          <p:cNvPr id="68" name="TextBox 67"/>
           <p:cNvSpPr txBox="1"/>
           <p:nvPr/>
         </p:nvSpPr>
         <p:spPr>
           <a:xfrm>
-            <a:off x="6400800" y="5532120"/>
-            <a:ext cx="4114800" cy="457200"/>
+            <a:off x="6675120" y="5715000"/>
+            <a:ext cx="4114800" cy="411480"/>
           </a:xfrm>
           <a:prstGeom prst="rect">
             <a:avLst/>
@@ -13680,42 +13889,6 @@
             </a:pPr>
             <a:r>
               <a:t>Any 3×3 subgrid forms a 9-clique in G²</a:t>
-            </a:r>
-          </a:p>
-        </p:txBody>
-      </p:sp>
-      <p:sp>
-        <p:nvSpPr>
-          <p:cNvPr id="68" name="TextBox 67"/>
-          <p:cNvSpPr txBox="1"/>
-          <p:nvPr/>
-        </p:nvSpPr>
-        <p:spPr>
-          <a:xfrm>
-            <a:off x="914400" y="4663440"/>
-            <a:ext cx="5303520" cy="1280160"/>
-          </a:xfrm>
-          <a:prstGeom prst="rect">
-            <a:avLst/>
-          </a:prstGeom>
-          <a:noFill/>
-        </p:spPr>
-        <p:txBody>
-          <a:bodyPr wrap="square" lIns="0" tIns="0" rIns="0" bIns="0">
-            <a:spAutoFit/>
-          </a:bodyPr>
-          <a:lstStyle/>
-          <a:p>
-            <a:pPr>
-              <a:defRPr sz="2000">
-                <a:solidFill>
-                  <a:srgbClr val="D97706"/>
-                </a:solidFill>
-                <a:latin typeface="Calibri"/>
-              </a:defRPr>
-            </a:pPr>
-            <a:r>
-              <a:t>The brief's sample shows 5 slots. Node_01 and Node_03 are 600 m apart, but Node_02 hears both, so distance-2 forbids sharing.</a:t>
             </a:r>
           </a:p>
         </p:txBody>
@@ -13869,8 +14042,8 @@
           <p:nvPr/>
         </p:nvGraphicFramePr>
         <p:xfrm>
-          <a:off x="914400" y="1463040"/>
-          <a:ext cx="4937760" cy="3931920"/>
+          <a:off x="640080" y="1508760"/>
+          <a:ext cx="5120640" cy="4389120"/>
         </p:xfrm>
         <a:graphic>
           <a:graphicData uri="http://schemas.openxmlformats.org/drawingml/2006/chart">
@@ -13887,8 +14060,8 @@
           <p:nvPr/>
         </p:nvGraphicFramePr>
         <p:xfrm>
-          <a:off x="6217920" y="1554480"/>
-          <a:ext cx="5029200" cy="2377440"/>
+          <a:off x="6126480" y="1508760"/>
+          <a:ext cx="5303520" cy="3108960"/>
         </p:xfrm>
         <a:graphic>
           <a:graphicData uri="http://schemas.openxmlformats.org/drawingml/2006/table">
@@ -13897,19 +14070,19 @@
                 <a:tableStyleId>{5C22544A-7EE6-4342-B048-85BDC9FD1C3A}</a:tableStyleId>
               </a:tblPr>
               <a:tblGrid>
-                <a:gridCol w="1828800"/>
-                <a:gridCol w="914400"/>
-                <a:gridCol w="914400"/>
-                <a:gridCol w="1371600"/>
+                <a:gridCol w="2011680"/>
+                <a:gridCol w="1005840"/>
+                <a:gridCol w="1005840"/>
+                <a:gridCol w="1280160"/>
               </a:tblGrid>
-              <a:tr h="475488">
+              <a:tr h="621792">
                 <a:tc>
                   <a:txBody>
                     <a:bodyPr/>
                     <a:lstStyle/>
                     <a:p>
                       <a:pPr algn="l">
-                        <a:defRPr sz="1800" b="1">
+                        <a:defRPr sz="2000" b="1">
                           <a:solidFill>
                             <a:srgbClr val="1B1F2A"/>
                           </a:solidFill>
@@ -13931,7 +14104,7 @@
                     <a:lstStyle/>
                     <a:p>
                       <a:pPr algn="ctr">
-                        <a:defRPr sz="1800" b="1">
+                        <a:defRPr sz="2000" b="1">
                           <a:solidFill>
                             <a:srgbClr val="1B1F2A"/>
                           </a:solidFill>
@@ -13953,7 +14126,7 @@
                     <a:lstStyle/>
                     <a:p>
                       <a:pPr algn="ctr">
-                        <a:defRPr sz="1800" b="1">
+                        <a:defRPr sz="2000" b="1">
                           <a:solidFill>
                             <a:srgbClr val="1B1F2A"/>
                           </a:solidFill>
@@ -13975,7 +14148,7 @@
                     <a:lstStyle/>
                     <a:p>
                       <a:pPr algn="ctr">
-                        <a:defRPr sz="1800" b="1">
+                        <a:defRPr sz="2000" b="1">
                           <a:solidFill>
                             <a:srgbClr val="1B1F2A"/>
                           </a:solidFill>
@@ -13992,14 +14165,14 @@
                   </a:tcPr>
                 </a:tc>
               </a:tr>
-              <a:tr h="475488">
+              <a:tr h="621792">
                 <a:tc>
                   <a:txBody>
                     <a:bodyPr/>
                     <a:lstStyle/>
                     <a:p>
                       <a:pPr algn="l">
-                        <a:defRPr sz="2000">
+                        <a:defRPr sz="1800">
                           <a:solidFill>
                             <a:srgbClr val="1B1F2A"/>
                           </a:solidFill>
@@ -14021,7 +14194,7 @@
                     <a:lstStyle/>
                     <a:p>
                       <a:pPr algn="ctr">
-                        <a:defRPr sz="2000">
+                        <a:defRPr sz="1800">
                           <a:solidFill>
                             <a:srgbClr val="1B1F2A"/>
                           </a:solidFill>
@@ -14043,7 +14216,7 @@
                     <a:lstStyle/>
                     <a:p>
                       <a:pPr algn="ctr">
-                        <a:defRPr sz="2000">
+                        <a:defRPr sz="1800">
                           <a:solidFill>
                             <a:srgbClr val="1B1F2A"/>
                           </a:solidFill>
@@ -14065,7 +14238,7 @@
                     <a:lstStyle/>
                     <a:p>
                       <a:pPr algn="ctr">
-                        <a:defRPr sz="2000" b="1">
+                        <a:defRPr sz="1800" b="1">
                           <a:solidFill>
                             <a:srgbClr val="1B1F2A"/>
                           </a:solidFill>
@@ -14082,14 +14255,14 @@
                   </a:tcPr>
                 </a:tc>
               </a:tr>
-              <a:tr h="475488">
+              <a:tr h="621792">
                 <a:tc>
                   <a:txBody>
                     <a:bodyPr/>
                     <a:lstStyle/>
                     <a:p>
                       <a:pPr algn="l">
-                        <a:defRPr sz="2000">
+                        <a:defRPr sz="1800">
                           <a:solidFill>
                             <a:srgbClr val="1B1F2A"/>
                           </a:solidFill>
@@ -14111,7 +14284,7 @@
                     <a:lstStyle/>
                     <a:p>
                       <a:pPr algn="ctr">
-                        <a:defRPr sz="2000">
+                        <a:defRPr sz="1800">
                           <a:solidFill>
                             <a:srgbClr val="1B1F2A"/>
                           </a:solidFill>
@@ -14133,7 +14306,7 @@
                     <a:lstStyle/>
                     <a:p>
                       <a:pPr algn="ctr">
-                        <a:defRPr sz="2000">
+                        <a:defRPr sz="1800">
                           <a:solidFill>
                             <a:srgbClr val="1B1F2A"/>
                           </a:solidFill>
@@ -14155,7 +14328,7 @@
                     <a:lstStyle/>
                     <a:p>
                       <a:pPr algn="ctr">
-                        <a:defRPr sz="2000" b="1">
+                        <a:defRPr sz="1800" b="1">
                           <a:solidFill>
                             <a:srgbClr val="1B1F2A"/>
                           </a:solidFill>
@@ -14172,14 +14345,14 @@
                   </a:tcPr>
                 </a:tc>
               </a:tr>
-              <a:tr h="475488">
+              <a:tr h="621792">
                 <a:tc>
                   <a:txBody>
                     <a:bodyPr/>
                     <a:lstStyle/>
                     <a:p>
                       <a:pPr algn="l">
-                        <a:defRPr sz="2000">
+                        <a:defRPr sz="1800">
                           <a:solidFill>
                             <a:srgbClr val="1B1F2A"/>
                           </a:solidFill>
@@ -14201,7 +14374,7 @@
                     <a:lstStyle/>
                     <a:p>
                       <a:pPr algn="ctr">
-                        <a:defRPr sz="2000">
+                        <a:defRPr sz="1800">
                           <a:solidFill>
                             <a:srgbClr val="1B1F2A"/>
                           </a:solidFill>
@@ -14223,7 +14396,7 @@
                     <a:lstStyle/>
                     <a:p>
                       <a:pPr algn="ctr">
-                        <a:defRPr sz="2000">
+                        <a:defRPr sz="1800">
                           <a:solidFill>
                             <a:srgbClr val="1B1F2A"/>
                           </a:solidFill>
@@ -14245,7 +14418,7 @@
                     <a:lstStyle/>
                     <a:p>
                       <a:pPr algn="ctr">
-                        <a:defRPr sz="2000" b="1">
+                        <a:defRPr sz="1800" b="1">
                           <a:solidFill>
                             <a:srgbClr val="1B1F2A"/>
                           </a:solidFill>
@@ -14262,14 +14435,14 @@
                   </a:tcPr>
                 </a:tc>
               </a:tr>
-              <a:tr h="475488">
+              <a:tr h="621792">
                 <a:tc>
                   <a:txBody>
                     <a:bodyPr/>
                     <a:lstStyle/>
                     <a:p>
                       <a:pPr algn="l">
-                        <a:defRPr sz="2000">
+                        <a:defRPr sz="1800">
                           <a:solidFill>
                             <a:srgbClr val="1B1F2A"/>
                           </a:solidFill>
@@ -14291,7 +14464,7 @@
                     <a:lstStyle/>
                     <a:p>
                       <a:pPr algn="ctr">
-                        <a:defRPr sz="2000">
+                        <a:defRPr sz="1800">
                           <a:solidFill>
                             <a:srgbClr val="1B1F2A"/>
                           </a:solidFill>
@@ -14313,7 +14486,7 @@
                     <a:lstStyle/>
                     <a:p>
                       <a:pPr algn="ctr">
-                        <a:defRPr sz="2000">
+                        <a:defRPr sz="1800">
                           <a:solidFill>
                             <a:srgbClr val="1B1F2A"/>
                           </a:solidFill>
@@ -14335,7 +14508,7 @@
                     <a:lstStyle/>
                     <a:p>
                       <a:pPr algn="ctr">
-                        <a:defRPr sz="2000" b="1">
+                        <a:defRPr sz="1800" b="1">
                           <a:solidFill>
                             <a:srgbClr val="1B1F2A"/>
                           </a:solidFill>
@@ -14364,8 +14537,8 @@
         </p:nvSpPr>
         <p:spPr>
           <a:xfrm>
-            <a:off x="6217920" y="4297680"/>
-            <a:ext cx="5029200" cy="1097280"/>
+            <a:off x="6126480" y="4892040"/>
+            <a:ext cx="5303520" cy="1005840"/>
           </a:xfrm>
           <a:prstGeom prst="rect">
             <a:avLst/>
@@ -14540,8 +14713,8 @@
         </p:nvSpPr>
         <p:spPr>
           <a:xfrm>
-            <a:off x="914400" y="1554480"/>
-            <a:ext cx="1645920" cy="731520"/>
+            <a:off x="640080" y="1737360"/>
+            <a:ext cx="1874519" cy="1005840"/>
           </a:xfrm>
           <a:prstGeom prst="roundRect">
             <a:avLst/>
@@ -14572,7 +14745,7 @@
           <a:lstStyle/>
           <a:p>
             <a:pPr algn="ctr">
-              <a:defRPr sz="2000" b="1">
+              <a:defRPr sz="2200" b="1">
                 <a:solidFill>
                   <a:srgbClr val="FFFFFF"/>
                 </a:solidFill>
@@ -14593,8 +14766,8 @@
         </p:nvSpPr>
         <p:spPr>
           <a:xfrm>
-            <a:off x="731520" y="2377440"/>
-            <a:ext cx="2011680" cy="320040"/>
+            <a:off x="457200" y="2880360"/>
+            <a:ext cx="2240279" cy="411480"/>
           </a:xfrm>
           <a:prstGeom prst="rect">
             <a:avLst/>
@@ -14602,13 +14775,13 @@
           <a:noFill/>
         </p:spPr>
         <p:txBody>
-          <a:bodyPr wrap="none">
+          <a:bodyPr wrap="none" lIns="0" tIns="0" rIns="0" bIns="0">
             <a:spAutoFit/>
           </a:bodyPr>
           <a:lstStyle/>
           <a:p>
             <a:pPr algn="ctr">
-              <a:defRPr sz="2000" b="1">
+              <a:defRPr sz="1800" b="1">
                 <a:solidFill>
                   <a:srgbClr val="0F766E"/>
                 </a:solidFill>
@@ -14629,8 +14802,8 @@
         </p:nvCxnSpPr>
         <p:spPr>
           <a:xfrm>
-            <a:off x="2560320" y="1920240"/>
-            <a:ext cx="530352" cy="0"/>
+            <a:off x="2514599" y="2240280"/>
+            <a:ext cx="365760" cy="0"/>
           </a:xfrm>
           <a:prstGeom prst="line">
             <a:avLst/>
@@ -14664,8 +14837,8 @@
         </p:nvSpPr>
         <p:spPr>
           <a:xfrm>
-            <a:off x="3090672" y="1554480"/>
-            <a:ext cx="1645920" cy="731520"/>
+            <a:off x="2880359" y="1737360"/>
+            <a:ext cx="1874519" cy="1005840"/>
           </a:xfrm>
           <a:prstGeom prst="roundRect">
             <a:avLst/>
@@ -14696,7 +14869,7 @@
           <a:lstStyle/>
           <a:p>
             <a:pPr algn="ctr">
-              <a:defRPr sz="2000" b="1">
+              <a:defRPr sz="2200" b="1">
                 <a:solidFill>
                   <a:srgbClr val="FFFFFF"/>
                 </a:solidFill>
@@ -14717,8 +14890,8 @@
         </p:nvSpPr>
         <p:spPr>
           <a:xfrm>
-            <a:off x="2907792" y="2377440"/>
-            <a:ext cx="2011680" cy="320040"/>
+            <a:off x="2697479" y="2880360"/>
+            <a:ext cx="2240279" cy="411480"/>
           </a:xfrm>
           <a:prstGeom prst="rect">
             <a:avLst/>
@@ -14726,13 +14899,13 @@
           <a:noFill/>
         </p:spPr>
         <p:txBody>
-          <a:bodyPr wrap="none">
+          <a:bodyPr wrap="none" lIns="0" tIns="0" rIns="0" bIns="0">
             <a:spAutoFit/>
           </a:bodyPr>
           <a:lstStyle/>
           <a:p>
             <a:pPr algn="ctr">
-              <a:defRPr sz="2000" b="1">
+              <a:defRPr sz="1800" b="1">
                 <a:solidFill>
                   <a:srgbClr val="0F766E"/>
                 </a:solidFill>
@@ -14753,8 +14926,8 @@
         </p:nvCxnSpPr>
         <p:spPr>
           <a:xfrm>
-            <a:off x="4736592" y="1920240"/>
-            <a:ext cx="530352" cy="0"/>
+            <a:off x="4754878" y="2240280"/>
+            <a:ext cx="365760" cy="0"/>
           </a:xfrm>
           <a:prstGeom prst="line">
             <a:avLst/>
@@ -14788,8 +14961,8 @@
         </p:nvSpPr>
         <p:spPr>
           <a:xfrm>
-            <a:off x="5266944" y="1554480"/>
-            <a:ext cx="1645920" cy="731520"/>
+            <a:off x="5120638" y="1737360"/>
+            <a:ext cx="1874519" cy="1005840"/>
           </a:xfrm>
           <a:prstGeom prst="roundRect">
             <a:avLst/>
@@ -14820,7 +14993,7 @@
           <a:lstStyle/>
           <a:p>
             <a:pPr algn="ctr">
-              <a:defRPr sz="2000" b="1">
+              <a:defRPr sz="2200" b="1">
                 <a:solidFill>
                   <a:srgbClr val="FFFFFF"/>
                 </a:solidFill>
@@ -14841,8 +15014,8 @@
         </p:nvSpPr>
         <p:spPr>
           <a:xfrm>
-            <a:off x="5084064" y="2377440"/>
-            <a:ext cx="2011680" cy="320040"/>
+            <a:off x="4937758" y="2880360"/>
+            <a:ext cx="2240279" cy="411480"/>
           </a:xfrm>
           <a:prstGeom prst="rect">
             <a:avLst/>
@@ -14850,13 +15023,13 @@
           <a:noFill/>
         </p:spPr>
         <p:txBody>
-          <a:bodyPr wrap="none">
+          <a:bodyPr wrap="none" lIns="0" tIns="0" rIns="0" bIns="0">
             <a:spAutoFit/>
           </a:bodyPr>
           <a:lstStyle/>
           <a:p>
             <a:pPr algn="ctr">
-              <a:defRPr sz="2000" b="1">
+              <a:defRPr sz="1800" b="1">
                 <a:solidFill>
                   <a:srgbClr val="0F766E"/>
                 </a:solidFill>
@@ -14877,8 +15050,8 @@
         </p:nvCxnSpPr>
         <p:spPr>
           <a:xfrm>
-            <a:off x="6912864" y="1920240"/>
-            <a:ext cx="530352" cy="0"/>
+            <a:off x="6995157" y="2240280"/>
+            <a:ext cx="365760" cy="0"/>
           </a:xfrm>
           <a:prstGeom prst="line">
             <a:avLst/>
@@ -14912,8 +15085,8 @@
         </p:nvSpPr>
         <p:spPr>
           <a:xfrm>
-            <a:off x="7443216" y="1554480"/>
-            <a:ext cx="1645920" cy="731520"/>
+            <a:off x="7360917" y="1737360"/>
+            <a:ext cx="1874519" cy="1005840"/>
           </a:xfrm>
           <a:prstGeom prst="roundRect">
             <a:avLst/>
@@ -14944,7 +15117,7 @@
           <a:lstStyle/>
           <a:p>
             <a:pPr algn="ctr">
-              <a:defRPr sz="2000" b="1">
+              <a:defRPr sz="2200" b="1">
                 <a:solidFill>
                   <a:srgbClr val="FFFFFF"/>
                 </a:solidFill>
@@ -14965,8 +15138,8 @@
         </p:nvSpPr>
         <p:spPr>
           <a:xfrm>
-            <a:off x="7260336" y="2377440"/>
-            <a:ext cx="2011680" cy="320040"/>
+            <a:off x="7178037" y="2880360"/>
+            <a:ext cx="2240279" cy="411480"/>
           </a:xfrm>
           <a:prstGeom prst="rect">
             <a:avLst/>
@@ -14974,13 +15147,13 @@
           <a:noFill/>
         </p:spPr>
         <p:txBody>
-          <a:bodyPr wrap="none">
+          <a:bodyPr wrap="none" lIns="0" tIns="0" rIns="0" bIns="0">
             <a:spAutoFit/>
           </a:bodyPr>
           <a:lstStyle/>
           <a:p>
             <a:pPr algn="ctr">
-              <a:defRPr sz="2000" b="1">
+              <a:defRPr sz="1800" b="1">
                 <a:solidFill>
                   <a:srgbClr val="0F766E"/>
                 </a:solidFill>
@@ -15001,8 +15174,8 @@
         </p:nvCxnSpPr>
         <p:spPr>
           <a:xfrm>
-            <a:off x="9089136" y="1920240"/>
-            <a:ext cx="530352" cy="0"/>
+            <a:off x="9235436" y="2240280"/>
+            <a:ext cx="365760" cy="0"/>
           </a:xfrm>
           <a:prstGeom prst="line">
             <a:avLst/>
@@ -15036,8 +15209,8 @@
         </p:nvSpPr>
         <p:spPr>
           <a:xfrm>
-            <a:off x="9619488" y="1554480"/>
-            <a:ext cx="1645920" cy="731520"/>
+            <a:off x="9601196" y="1737360"/>
+            <a:ext cx="1874519" cy="1005840"/>
           </a:xfrm>
           <a:prstGeom prst="roundRect">
             <a:avLst/>
@@ -15068,7 +15241,7 @@
           <a:lstStyle/>
           <a:p>
             <a:pPr algn="ctr">
-              <a:defRPr sz="2000" b="1">
+              <a:defRPr sz="2200" b="1">
                 <a:solidFill>
                   <a:srgbClr val="FFFFFF"/>
                 </a:solidFill>
@@ -15089,8 +15262,8 @@
         </p:nvSpPr>
         <p:spPr>
           <a:xfrm>
-            <a:off x="9436608" y="2377440"/>
-            <a:ext cx="2011680" cy="320040"/>
+            <a:off x="9418316" y="2880360"/>
+            <a:ext cx="2240279" cy="411480"/>
           </a:xfrm>
           <a:prstGeom prst="rect">
             <a:avLst/>
@@ -15098,13 +15271,13 @@
           <a:noFill/>
         </p:spPr>
         <p:txBody>
-          <a:bodyPr wrap="none">
+          <a:bodyPr wrap="none" lIns="0" tIns="0" rIns="0" bIns="0">
             <a:spAutoFit/>
           </a:bodyPr>
           <a:lstStyle/>
           <a:p>
             <a:pPr algn="ctr">
-              <a:defRPr sz="2000" b="1">
+              <a:defRPr sz="1800" b="1">
                 <a:solidFill>
                   <a:srgbClr val="D97706"/>
                 </a:solidFill>
@@ -15125,8 +15298,8 @@
         </p:nvSpPr>
         <p:spPr>
           <a:xfrm>
-            <a:off x="914400" y="3383280"/>
-            <a:ext cx="10362895" cy="2560320"/>
+            <a:off x="731520" y="3794760"/>
+            <a:ext cx="10515600" cy="2194560"/>
           </a:xfrm>
           <a:prstGeom prst="rect">
             <a:avLst/>

</xml_diff>

<commit_message>
Align benchmark runtimes and clarify partial coordinates in design notes and deck
</commit_message>
<xml_diff>
--- a/docs/presentation.pptx
+++ b/docs/presentation.pptx
@@ -938,7 +938,7 @@
           <a:lstStyle/>
           <a:p>
             <a:r>
-              <a:t>I wanted to evaluate several coloring algorithms to see which one gave the tightest schedule. I started with greedy coloring ordered by degree, which took 0.06 milliseconds and found 9 slots. Then I tried DSATUR, which dynamically chooses the node with the most colored neighbors; that also took under a millisecond and found 9 slots. Smallest-last ordering based on graph degeneracy gave the same 9 slots. To test whether random orders could shake loose an 8-slot schedule, I ran 1000 seeded random restarts; that took 24 milliseconds, but the best schedule remained 9 slots. Finally, I built a local search routine with Kempe-chain swaps and tabu search to try to eliminate the ninth color; after 2000 swaps it still couldn't reach 8. Because all five heuristics stalled at 9, I couldn't tell if 9 was an algorithmic limitation or a physical lower bound. That's why I added an exact solver using Google OR-Tools CP-SAT with maximum-clique pre-coloring.</a:t>
+              <a:t>I wanted to evaluate several coloring algorithms to see which one gave the tightest schedule. I started with greedy coloring ordered by degree, which took 0.06 milliseconds and found 9 slots. Then I tried DSATUR, which dynamically chooses the node with the most colored neighbors; that took 0.16 milliseconds and found 9 slots. Smallest-last ordering based on graph degeneracy took 0.12 milliseconds and gave the same 9 slots. To test whether random orders could shake loose an 8-slot schedule, I ran 1000 seeded random restarts; that took 26.3 milliseconds, but the best schedule remained 9 slots. Finally, I built a local search routine with Kempe-chain swaps and tabu search to try to eliminate the ninth color; after 60.2 milliseconds it still couldn't reach 8. Because all five heuristics stalled at 9, I couldn't tell if 9 was an algorithmic limitation or a physical lower bound. That's why I added an exact solver using Google OR-Tools CP-SAT with maximum-clique pre-coloring, solving in 0.57 milliseconds.</a:t>
             </a:r>
           </a:p>
         </p:txBody>
@@ -4272,6 +4272,7 @@
           <a:ln>
             <a:noFill/>
           </a:ln>
+          <a:effectLst/>
         </p:spPr>
         <p:style>
           <a:lnRef idx="1">
@@ -4310,6 +4311,7 @@
             <a:avLst/>
           </a:prstGeom>
           <a:noFill/>
+          <a:effectLst/>
         </p:spPr>
         <p:txBody>
           <a:bodyPr wrap="square" lIns="0" tIns="0" rIns="0" bIns="0">
@@ -4351,6 +4353,7 @@
           <a:ln>
             <a:noFill/>
           </a:ln>
+          <a:effectLst/>
         </p:spPr>
         <p:style>
           <a:lnRef idx="1">
@@ -4389,6 +4392,7 @@
             <a:avLst/>
           </a:prstGeom>
           <a:noFill/>
+          <a:effectLst/>
         </p:spPr>
         <p:txBody>
           <a:bodyPr wrap="square" lIns="0" tIns="0" rIns="0" bIns="0">
@@ -4425,6 +4429,7 @@
             <a:avLst/>
           </a:prstGeom>
           <a:noFill/>
+          <a:effectLst/>
         </p:spPr>
         <p:txBody>
           <a:bodyPr wrap="none" lIns="0" tIns="0" rIns="0" bIns="0">
@@ -4461,6 +4466,7 @@
             <a:avLst/>
           </a:prstGeom>
           <a:noFill/>
+          <a:effectLst/>
         </p:spPr>
         <p:txBody>
           <a:bodyPr wrap="none" lIns="0" tIns="0" rIns="0" bIns="0">
@@ -4502,6 +4508,7 @@
           <a:ln>
             <a:noFill/>
           </a:ln>
+          <a:effectLst/>
         </p:spPr>
         <p:style>
           <a:lnRef idx="1">
@@ -4545,6 +4552,7 @@
           <a:ln>
             <a:noFill/>
           </a:ln>
+          <a:effectLst/>
         </p:spPr>
         <p:style>
           <a:lnRef idx="1">
@@ -4588,6 +4596,7 @@
           <a:ln>
             <a:noFill/>
           </a:ln>
+          <a:effectLst/>
         </p:spPr>
         <p:style>
           <a:lnRef idx="1">
@@ -4631,6 +4640,7 @@
           <a:ln>
             <a:noFill/>
           </a:ln>
+          <a:effectLst/>
         </p:spPr>
         <p:style>
           <a:lnRef idx="1">
@@ -4674,6 +4684,7 @@
           <a:ln>
             <a:noFill/>
           </a:ln>
+          <a:effectLst/>
         </p:spPr>
         <p:style>
           <a:lnRef idx="1">
@@ -4717,6 +4728,7 @@
           <a:ln>
             <a:noFill/>
           </a:ln>
+          <a:effectLst/>
         </p:spPr>
         <p:style>
           <a:lnRef idx="1">
@@ -4760,6 +4772,7 @@
           <a:ln>
             <a:noFill/>
           </a:ln>
+          <a:effectLst/>
         </p:spPr>
         <p:style>
           <a:lnRef idx="1">
@@ -4803,6 +4816,7 @@
           <a:ln>
             <a:noFill/>
           </a:ln>
+          <a:effectLst/>
         </p:spPr>
         <p:style>
           <a:lnRef idx="1">
@@ -4846,6 +4860,7 @@
           <a:ln>
             <a:noFill/>
           </a:ln>
+          <a:effectLst/>
         </p:spPr>
         <p:style>
           <a:lnRef idx="1">
@@ -4889,6 +4904,7 @@
           <a:ln>
             <a:noFill/>
           </a:ln>
+          <a:effectLst/>
         </p:spPr>
         <p:style>
           <a:lnRef idx="1">
@@ -4932,6 +4948,7 @@
           <a:ln>
             <a:noFill/>
           </a:ln>
+          <a:effectLst/>
         </p:spPr>
         <p:style>
           <a:lnRef idx="1">
@@ -4975,6 +4992,7 @@
           <a:ln>
             <a:noFill/>
           </a:ln>
+          <a:effectLst/>
         </p:spPr>
         <p:style>
           <a:lnRef idx="1">
@@ -5018,6 +5036,7 @@
           <a:ln>
             <a:noFill/>
           </a:ln>
+          <a:effectLst/>
         </p:spPr>
         <p:style>
           <a:lnRef idx="1">
@@ -5061,6 +5080,7 @@
           <a:ln>
             <a:noFill/>
           </a:ln>
+          <a:effectLst/>
         </p:spPr>
         <p:style>
           <a:lnRef idx="1">
@@ -5104,6 +5124,7 @@
           <a:ln>
             <a:noFill/>
           </a:ln>
+          <a:effectLst/>
         </p:spPr>
         <p:style>
           <a:lnRef idx="1">
@@ -5147,6 +5168,7 @@
           <a:ln>
             <a:noFill/>
           </a:ln>
+          <a:effectLst/>
         </p:spPr>
         <p:style>
           <a:lnRef idx="1">
@@ -5185,6 +5207,7 @@
             <a:avLst/>
           </a:prstGeom>
           <a:noFill/>
+          <a:effectLst/>
         </p:spPr>
         <p:txBody>
           <a:bodyPr wrap="none" lIns="0" tIns="0" rIns="0" bIns="0">
@@ -5244,6 +5267,7 @@
           <a:ln>
             <a:noFill/>
           </a:ln>
+          <a:effectLst/>
         </p:spPr>
         <p:style>
           <a:lnRef idx="1">
@@ -5282,6 +5306,7 @@
             <a:avLst/>
           </a:prstGeom>
           <a:noFill/>
+          <a:effectLst/>
         </p:spPr>
         <p:txBody>
           <a:bodyPr wrap="square" lIns="0" tIns="0" rIns="0" bIns="0">
@@ -5323,6 +5348,7 @@
           <a:ln>
             <a:noFill/>
           </a:ln>
+          <a:effectLst/>
         </p:spPr>
         <p:style>
           <a:lnRef idx="1">
@@ -5361,6 +5387,7 @@
             <a:avLst/>
           </a:prstGeom>
           <a:noFill/>
+          <a:effectLst/>
         </p:spPr>
         <p:txBody>
           <a:bodyPr wrap="square" lIns="0" tIns="0" rIns="0" bIns="0">
@@ -5401,6 +5428,7 @@
               <a:srgbClr val="0F766E"/>
             </a:solidFill>
           </a:ln>
+          <a:effectLst/>
         </p:spPr>
         <p:style>
           <a:lnRef idx="2">
@@ -5436,6 +5464,7 @@
               <a:srgbClr val="0F766E"/>
             </a:solidFill>
           </a:ln>
+          <a:effectLst/>
         </p:spPr>
         <p:style>
           <a:lnRef idx="2">
@@ -5467,6 +5496,7 @@
             <a:avLst/>
           </a:prstGeom>
           <a:noFill/>
+          <a:effectLst/>
         </p:spPr>
         <p:txBody>
           <a:bodyPr wrap="none">
@@ -5503,6 +5533,7 @@
             <a:avLst/>
           </a:prstGeom>
           <a:noFill/>
+          <a:effectLst/>
         </p:spPr>
         <p:txBody>
           <a:bodyPr wrap="none">
@@ -5543,6 +5574,7 @@
               <a:srgbClr val="D97706"/>
             </a:solidFill>
           </a:ln>
+          <a:effectLst/>
         </p:spPr>
         <p:style>
           <a:lnRef idx="2">
@@ -5574,6 +5606,7 @@
             <a:avLst/>
           </a:prstGeom>
           <a:noFill/>
+          <a:effectLst/>
         </p:spPr>
         <p:txBody>
           <a:bodyPr wrap="none">
@@ -5615,6 +5648,7 @@
           <a:ln>
             <a:noFill/>
           </a:ln>
+          <a:effectLst/>
         </p:spPr>
         <p:style>
           <a:lnRef idx="1">
@@ -5663,6 +5697,7 @@
             <a:avLst/>
           </a:prstGeom>
           <a:noFill/>
+          <a:effectLst/>
         </p:spPr>
         <p:txBody>
           <a:bodyPr wrap="square" lIns="0" tIns="0" rIns="0" bIns="0">
@@ -5704,6 +5739,7 @@
           <a:ln>
             <a:noFill/>
           </a:ln>
+          <a:effectLst/>
         </p:spPr>
         <p:style>
           <a:lnRef idx="1">
@@ -5752,6 +5788,7 @@
             <a:avLst/>
           </a:prstGeom>
           <a:noFill/>
+          <a:effectLst/>
         </p:spPr>
         <p:txBody>
           <a:bodyPr wrap="square" lIns="0" tIns="0" rIns="0" bIns="0">
@@ -5793,6 +5830,7 @@
           <a:ln>
             <a:noFill/>
           </a:ln>
+          <a:effectLst/>
         </p:spPr>
         <p:style>
           <a:lnRef idx="1">
@@ -5841,6 +5879,7 @@
             <a:avLst/>
           </a:prstGeom>
           <a:noFill/>
+          <a:effectLst/>
         </p:spPr>
         <p:txBody>
           <a:bodyPr wrap="square" lIns="0" tIns="0" rIns="0" bIns="0">
@@ -5877,6 +5916,7 @@
             <a:avLst/>
           </a:prstGeom>
           <a:noFill/>
+          <a:effectLst/>
         </p:spPr>
         <p:txBody>
           <a:bodyPr wrap="square" lIns="0" tIns="0" rIns="0" bIns="0">
@@ -5936,6 +5976,7 @@
           <a:ln>
             <a:noFill/>
           </a:ln>
+          <a:effectLst/>
         </p:spPr>
         <p:style>
           <a:lnRef idx="1">
@@ -5974,6 +6015,7 @@
             <a:avLst/>
           </a:prstGeom>
           <a:noFill/>
+          <a:effectLst/>
         </p:spPr>
         <p:txBody>
           <a:bodyPr wrap="square" lIns="0" tIns="0" rIns="0" bIns="0">
@@ -6015,6 +6057,7 @@
           <a:ln>
             <a:noFill/>
           </a:ln>
+          <a:effectLst/>
         </p:spPr>
         <p:style>
           <a:lnRef idx="1">
@@ -6053,6 +6096,7 @@
             <a:avLst/>
           </a:prstGeom>
           <a:noFill/>
+          <a:effectLst/>
         </p:spPr>
         <p:txBody>
           <a:bodyPr wrap="square" lIns="0" tIns="0" rIns="0" bIns="0">
@@ -6089,6 +6133,7 @@
             <a:avLst/>
           </a:prstGeom>
           <a:noFill/>
+          <a:effectLst/>
         </p:spPr>
         <p:txBody>
           <a:bodyPr wrap="none">
@@ -6129,6 +6174,7 @@
               <a:srgbClr val="0F766E"/>
             </a:solidFill>
           </a:ln>
+          <a:effectLst/>
         </p:spPr>
         <p:style>
           <a:lnRef idx="2">
@@ -6164,6 +6210,7 @@
               <a:srgbClr val="0F766E"/>
             </a:solidFill>
           </a:ln>
+          <a:effectLst/>
         </p:spPr>
         <p:style>
           <a:lnRef idx="2">
@@ -6199,6 +6246,7 @@
               <a:srgbClr val="0F766E"/>
             </a:solidFill>
           </a:ln>
+          <a:effectLst/>
         </p:spPr>
         <p:style>
           <a:lnRef idx="2">
@@ -6234,6 +6282,7 @@
               <a:srgbClr val="0F766E"/>
             </a:solidFill>
           </a:ln>
+          <a:effectLst/>
         </p:spPr>
         <p:style>
           <a:lnRef idx="2">
@@ -6270,6 +6319,7 @@
           <a:ln>
             <a:noFill/>
           </a:ln>
+          <a:effectLst/>
         </p:spPr>
         <p:style>
           <a:lnRef idx="1">
@@ -6323,6 +6373,7 @@
           <a:ln>
             <a:noFill/>
           </a:ln>
+          <a:effectLst/>
         </p:spPr>
         <p:style>
           <a:lnRef idx="1">
@@ -6376,6 +6427,7 @@
           <a:ln>
             <a:noFill/>
           </a:ln>
+          <a:effectLst/>
         </p:spPr>
         <p:style>
           <a:lnRef idx="1">
@@ -6429,6 +6481,7 @@
           <a:ln>
             <a:noFill/>
           </a:ln>
+          <a:effectLst/>
         </p:spPr>
         <p:style>
           <a:lnRef idx="1">
@@ -6482,6 +6535,7 @@
           <a:ln>
             <a:noFill/>
           </a:ln>
+          <a:effectLst/>
         </p:spPr>
         <p:style>
           <a:lnRef idx="1">
@@ -6530,6 +6584,7 @@
             <a:avLst/>
           </a:prstGeom>
           <a:noFill/>
+          <a:effectLst/>
         </p:spPr>
         <p:txBody>
           <a:bodyPr wrap="none">
@@ -6566,6 +6621,7 @@
             <a:avLst/>
           </a:prstGeom>
           <a:noFill/>
+          <a:effectLst/>
         </p:spPr>
         <p:txBody>
           <a:bodyPr wrap="none" lIns="0" tIns="0" rIns="0" bIns="0">
@@ -6602,6 +6658,7 @@
             <a:avLst/>
           </a:prstGeom>
           <a:noFill/>
+          <a:effectLst/>
         </p:spPr>
         <p:txBody>
           <a:bodyPr wrap="none">
@@ -6642,6 +6699,7 @@
               <a:srgbClr val="0F766E"/>
             </a:solidFill>
           </a:ln>
+          <a:effectLst/>
         </p:spPr>
         <p:style>
           <a:lnRef idx="2">
@@ -6677,6 +6735,7 @@
               <a:srgbClr val="0F766E"/>
             </a:solidFill>
           </a:ln>
+          <a:effectLst/>
         </p:spPr>
         <p:style>
           <a:lnRef idx="2">
@@ -6712,6 +6771,7 @@
               <a:srgbClr val="0F766E"/>
             </a:solidFill>
           </a:ln>
+          <a:effectLst/>
         </p:spPr>
         <p:style>
           <a:lnRef idx="2">
@@ -6747,6 +6807,7 @@
               <a:srgbClr val="0F766E"/>
             </a:solidFill>
           </a:ln>
+          <a:effectLst/>
         </p:spPr>
         <p:style>
           <a:lnRef idx="2">
@@ -6782,6 +6843,7 @@
               <a:srgbClr val="D97706"/>
             </a:solidFill>
           </a:ln>
+          <a:effectLst/>
         </p:spPr>
         <p:style>
           <a:lnRef idx="2">
@@ -6817,6 +6879,7 @@
               <a:srgbClr val="D97706"/>
             </a:solidFill>
           </a:ln>
+          <a:effectLst/>
         </p:spPr>
         <p:style>
           <a:lnRef idx="2">
@@ -6852,6 +6915,7 @@
               <a:srgbClr val="D97706"/>
             </a:solidFill>
           </a:ln>
+          <a:effectLst/>
         </p:spPr>
         <p:style>
           <a:lnRef idx="2">
@@ -6887,6 +6951,7 @@
               <a:srgbClr val="D97706"/>
             </a:solidFill>
           </a:ln>
+          <a:effectLst/>
         </p:spPr>
         <p:style>
           <a:lnRef idx="2">
@@ -6922,6 +6987,7 @@
               <a:srgbClr val="D97706"/>
             </a:solidFill>
           </a:ln>
+          <a:effectLst/>
         </p:spPr>
         <p:style>
           <a:lnRef idx="2">
@@ -6957,6 +7023,7 @@
               <a:srgbClr val="D97706"/>
             </a:solidFill>
           </a:ln>
+          <a:effectLst/>
         </p:spPr>
         <p:style>
           <a:lnRef idx="2">
@@ -6992,6 +7059,7 @@
               <a:srgbClr val="D97706"/>
             </a:solidFill>
           </a:ln>
+          <a:effectLst/>
         </p:spPr>
         <p:style>
           <a:lnRef idx="2">
@@ -7027,6 +7095,7 @@
               <a:srgbClr val="D97706"/>
             </a:solidFill>
           </a:ln>
+          <a:effectLst/>
         </p:spPr>
         <p:style>
           <a:lnRef idx="2">
@@ -7062,6 +7131,7 @@
               <a:srgbClr val="D97706"/>
             </a:solidFill>
           </a:ln>
+          <a:effectLst/>
         </p:spPr>
         <p:style>
           <a:lnRef idx="2">
@@ -7098,6 +7168,7 @@
           <a:ln>
             <a:noFill/>
           </a:ln>
+          <a:effectLst/>
         </p:spPr>
         <p:style>
           <a:lnRef idx="1">
@@ -7151,6 +7222,7 @@
           <a:ln>
             <a:noFill/>
           </a:ln>
+          <a:effectLst/>
         </p:spPr>
         <p:style>
           <a:lnRef idx="1">
@@ -7204,6 +7276,7 @@
           <a:ln>
             <a:noFill/>
           </a:ln>
+          <a:effectLst/>
         </p:spPr>
         <p:style>
           <a:lnRef idx="1">
@@ -7257,6 +7330,7 @@
           <a:ln>
             <a:noFill/>
           </a:ln>
+          <a:effectLst/>
         </p:spPr>
         <p:style>
           <a:lnRef idx="1">
@@ -7310,6 +7384,7 @@
           <a:ln>
             <a:noFill/>
           </a:ln>
+          <a:effectLst/>
         </p:spPr>
         <p:style>
           <a:lnRef idx="1">
@@ -7358,6 +7433,7 @@
             <a:avLst/>
           </a:prstGeom>
           <a:noFill/>
+          <a:effectLst/>
         </p:spPr>
         <p:txBody>
           <a:bodyPr wrap="none">
@@ -7394,6 +7470,7 @@
             <a:avLst/>
           </a:prstGeom>
           <a:noFill/>
+          <a:effectLst/>
         </p:spPr>
         <p:txBody>
           <a:bodyPr wrap="square" lIns="0" tIns="0" rIns="0" bIns="0">
@@ -7453,6 +7530,7 @@
           <a:ln>
             <a:noFill/>
           </a:ln>
+          <a:effectLst/>
         </p:spPr>
         <p:style>
           <a:lnRef idx="1">
@@ -7491,6 +7569,7 @@
             <a:avLst/>
           </a:prstGeom>
           <a:noFill/>
+          <a:effectLst/>
         </p:spPr>
         <p:txBody>
           <a:bodyPr wrap="square" lIns="0" tIns="0" rIns="0" bIns="0">
@@ -7532,6 +7611,7 @@
           <a:ln>
             <a:noFill/>
           </a:ln>
+          <a:effectLst/>
         </p:spPr>
         <p:style>
           <a:lnRef idx="1">
@@ -7773,7 +7853,7 @@
                         </a:defRPr>
                       </a:pPr>
                       <a:r>
-                        <a:t>0.15 ms</a:t>
+                        <a:t>0.16 ms</a:t>
                       </a:r>
                     </a:p>
                   </a:txBody>
@@ -7841,7 +7921,7 @@
                         </a:defRPr>
                       </a:pPr>
                       <a:r>
-                        <a:t>0.20 ms</a:t>
+                        <a:t>0.12 ms</a:t>
                       </a:r>
                     </a:p>
                   </a:txBody>
@@ -7909,7 +7989,7 @@
                         </a:defRPr>
                       </a:pPr>
                       <a:r>
-                        <a:t>24.2 ms</a:t>
+                        <a:t>26.3 ms</a:t>
                       </a:r>
                     </a:p>
                   </a:txBody>
@@ -7977,7 +8057,7 @@
                         </a:defRPr>
                       </a:pPr>
                       <a:r>
-                        <a:t>60.8 ms</a:t>
+                        <a:t>60.2 ms</a:t>
                       </a:r>
                     </a:p>
                   </a:txBody>
@@ -8045,7 +8125,7 @@
                         </a:defRPr>
                       </a:pPr>
                       <a:r>
-                        <a:t>0.60 ms</a:t>
+                        <a:t>0.57 ms</a:t>
                       </a:r>
                     </a:p>
                   </a:txBody>
@@ -8073,6 +8153,7 @@
             <a:avLst/>
           </a:prstGeom>
           <a:noFill/>
+          <a:effectLst/>
         </p:spPr>
         <p:txBody>
           <a:bodyPr wrap="square" lIns="0" tIns="0" rIns="0" bIns="0">
@@ -8132,6 +8213,7 @@
           <a:ln>
             <a:noFill/>
           </a:ln>
+          <a:effectLst/>
         </p:spPr>
         <p:style>
           <a:lnRef idx="1">
@@ -8170,6 +8252,7 @@
             <a:avLst/>
           </a:prstGeom>
           <a:noFill/>
+          <a:effectLst/>
         </p:spPr>
         <p:txBody>
           <a:bodyPr wrap="square" lIns="0" tIns="0" rIns="0" bIns="0">
@@ -8211,6 +8294,7 @@
           <a:ln>
             <a:noFill/>
           </a:ln>
+          <a:effectLst/>
         </p:spPr>
         <p:style>
           <a:lnRef idx="1">
@@ -8242,8 +8326,8 @@
         </p:nvSpPr>
         <p:spPr>
           <a:xfrm>
-            <a:off x="640080" y="1325880"/>
-            <a:ext cx="5943600" cy="4800600"/>
+            <a:off x="640080" y="1280160"/>
+            <a:ext cx="5989320" cy="4892040"/>
           </a:xfrm>
           <a:prstGeom prst="rect">
             <a:avLst/>
@@ -8254,6 +8338,7 @@
           <a:ln>
             <a:noFill/>
           </a:ln>
+          <a:effectLst/>
         </p:spPr>
         <p:style>
           <a:lnRef idx="1">
@@ -8285,13 +8370,14 @@
         </p:nvSpPr>
         <p:spPr>
           <a:xfrm>
-            <a:off x="804672" y="1417320"/>
-            <a:ext cx="5614416" cy="4617720"/>
+            <a:off x="804672" y="1353312"/>
+            <a:ext cx="5660136" cy="4745736"/>
           </a:xfrm>
           <a:prstGeom prst="rect">
             <a:avLst/>
           </a:prstGeom>
           <a:noFill/>
+          <a:effectLst/>
         </p:spPr>
         <p:txBody>
           <a:bodyPr wrap="none" lIns="0" tIns="0" rIns="0" bIns="0">
@@ -8660,7 +8746,7 @@
         </p:nvCxnSpPr>
         <p:spPr>
           <a:xfrm>
-            <a:off x="7269480" y="1645920"/>
+            <a:off x="7269480" y="1600200"/>
             <a:ext cx="1143000" cy="0"/>
           </a:xfrm>
           <a:prstGeom prst="line">
@@ -8671,6 +8757,7 @@
               <a:srgbClr val="CBD5E1"/>
             </a:solidFill>
           </a:ln>
+          <a:effectLst/>
         </p:spPr>
         <p:style>
           <a:lnRef idx="2">
@@ -8695,7 +8782,7 @@
         </p:nvCxnSpPr>
         <p:spPr>
           <a:xfrm>
-            <a:off x="7269480" y="1645920"/>
+            <a:off x="7269480" y="1600200"/>
             <a:ext cx="0" cy="1143000"/>
           </a:xfrm>
           <a:prstGeom prst="line">
@@ -8706,6 +8793,7 @@
               <a:srgbClr val="CBD5E1"/>
             </a:solidFill>
           </a:ln>
+          <a:effectLst/>
         </p:spPr>
         <p:style>
           <a:lnRef idx="2">
@@ -8730,7 +8818,7 @@
         </p:nvCxnSpPr>
         <p:spPr>
           <a:xfrm>
-            <a:off x="7269480" y="1645920"/>
+            <a:off x="7269480" y="1600200"/>
             <a:ext cx="1143000" cy="1143000"/>
           </a:xfrm>
           <a:prstGeom prst="line">
@@ -8741,6 +8829,7 @@
               <a:srgbClr val="CBD5E1"/>
             </a:solidFill>
           </a:ln>
+          <a:effectLst/>
         </p:spPr>
         <p:style>
           <a:lnRef idx="2">
@@ -8765,7 +8854,7 @@
         </p:nvCxnSpPr>
         <p:spPr>
           <a:xfrm>
-            <a:off x="8412480" y="1645920"/>
+            <a:off x="8412480" y="1600200"/>
             <a:ext cx="1143000" cy="0"/>
           </a:xfrm>
           <a:prstGeom prst="line">
@@ -8776,6 +8865,7 @@
               <a:srgbClr val="CBD5E1"/>
             </a:solidFill>
           </a:ln>
+          <a:effectLst/>
         </p:spPr>
         <p:style>
           <a:lnRef idx="2">
@@ -8800,7 +8890,7 @@
         </p:nvCxnSpPr>
         <p:spPr>
           <a:xfrm flipH="1">
-            <a:off x="7269480" y="1645920"/>
+            <a:off x="7269480" y="1600200"/>
             <a:ext cx="1143000" cy="1143000"/>
           </a:xfrm>
           <a:prstGeom prst="line">
@@ -8811,6 +8901,7 @@
               <a:srgbClr val="CBD5E1"/>
             </a:solidFill>
           </a:ln>
+          <a:effectLst/>
         </p:spPr>
         <p:style>
           <a:lnRef idx="2">
@@ -8835,7 +8926,7 @@
         </p:nvCxnSpPr>
         <p:spPr>
           <a:xfrm>
-            <a:off x="8412480" y="1645920"/>
+            <a:off x="8412480" y="1600200"/>
             <a:ext cx="0" cy="1143000"/>
           </a:xfrm>
           <a:prstGeom prst="line">
@@ -8846,6 +8937,7 @@
               <a:srgbClr val="CBD5E1"/>
             </a:solidFill>
           </a:ln>
+          <a:effectLst/>
         </p:spPr>
         <p:style>
           <a:lnRef idx="2">
@@ -8870,7 +8962,7 @@
         </p:nvCxnSpPr>
         <p:spPr>
           <a:xfrm>
-            <a:off x="8412480" y="1645920"/>
+            <a:off x="8412480" y="1600200"/>
             <a:ext cx="1143000" cy="1143000"/>
           </a:xfrm>
           <a:prstGeom prst="line">
@@ -8881,6 +8973,7 @@
               <a:srgbClr val="CBD5E1"/>
             </a:solidFill>
           </a:ln>
+          <a:effectLst/>
         </p:spPr>
         <p:style>
           <a:lnRef idx="2">
@@ -8905,7 +8998,7 @@
         </p:nvCxnSpPr>
         <p:spPr>
           <a:xfrm>
-            <a:off x="9555480" y="1645920"/>
+            <a:off x="9555480" y="1600200"/>
             <a:ext cx="1143000" cy="0"/>
           </a:xfrm>
           <a:prstGeom prst="line">
@@ -8916,6 +9009,7 @@
               <a:srgbClr val="CBD5E1"/>
             </a:solidFill>
           </a:ln>
+          <a:effectLst/>
         </p:spPr>
         <p:style>
           <a:lnRef idx="2">
@@ -8940,7 +9034,7 @@
         </p:nvCxnSpPr>
         <p:spPr>
           <a:xfrm flipH="1">
-            <a:off x="8412480" y="1645920"/>
+            <a:off x="8412480" y="1600200"/>
             <a:ext cx="1143000" cy="1143000"/>
           </a:xfrm>
           <a:prstGeom prst="line">
@@ -8951,6 +9045,7 @@
               <a:srgbClr val="CBD5E1"/>
             </a:solidFill>
           </a:ln>
+          <a:effectLst/>
         </p:spPr>
         <p:style>
           <a:lnRef idx="2">
@@ -8975,7 +9070,7 @@
         </p:nvCxnSpPr>
         <p:spPr>
           <a:xfrm>
-            <a:off x="9555480" y="1645920"/>
+            <a:off x="9555480" y="1600200"/>
             <a:ext cx="0" cy="1143000"/>
           </a:xfrm>
           <a:prstGeom prst="line">
@@ -8986,6 +9081,7 @@
               <a:srgbClr val="CBD5E1"/>
             </a:solidFill>
           </a:ln>
+          <a:effectLst/>
         </p:spPr>
         <p:style>
           <a:lnRef idx="2">
@@ -9010,7 +9106,7 @@
         </p:nvCxnSpPr>
         <p:spPr>
           <a:xfrm>
-            <a:off x="9555480" y="1645920"/>
+            <a:off x="9555480" y="1600200"/>
             <a:ext cx="1143000" cy="1143000"/>
           </a:xfrm>
           <a:prstGeom prst="line">
@@ -9021,6 +9117,7 @@
               <a:srgbClr val="CBD5E1"/>
             </a:solidFill>
           </a:ln>
+          <a:effectLst/>
         </p:spPr>
         <p:style>
           <a:lnRef idx="2">
@@ -9045,7 +9142,7 @@
         </p:nvCxnSpPr>
         <p:spPr>
           <a:xfrm flipH="1">
-            <a:off x="9555480" y="1645920"/>
+            <a:off x="9555480" y="1600200"/>
             <a:ext cx="1143000" cy="1143000"/>
           </a:xfrm>
           <a:prstGeom prst="line">
@@ -9056,6 +9153,7 @@
               <a:srgbClr val="CBD5E1"/>
             </a:solidFill>
           </a:ln>
+          <a:effectLst/>
         </p:spPr>
         <p:style>
           <a:lnRef idx="2">
@@ -9080,7 +9178,7 @@
         </p:nvCxnSpPr>
         <p:spPr>
           <a:xfrm>
-            <a:off x="10698480" y="1645920"/>
+            <a:off x="10698480" y="1600200"/>
             <a:ext cx="0" cy="1143000"/>
           </a:xfrm>
           <a:prstGeom prst="line">
@@ -9091,6 +9189,7 @@
               <a:srgbClr val="CBD5E1"/>
             </a:solidFill>
           </a:ln>
+          <a:effectLst/>
         </p:spPr>
         <p:style>
           <a:lnRef idx="2">
@@ -9115,7 +9214,7 @@
         </p:nvCxnSpPr>
         <p:spPr>
           <a:xfrm>
-            <a:off x="7269480" y="2788920"/>
+            <a:off x="7269480" y="2743200"/>
             <a:ext cx="1143000" cy="0"/>
           </a:xfrm>
           <a:prstGeom prst="line">
@@ -9126,6 +9225,7 @@
               <a:srgbClr val="CBD5E1"/>
             </a:solidFill>
           </a:ln>
+          <a:effectLst/>
         </p:spPr>
         <p:style>
           <a:lnRef idx="2">
@@ -9150,7 +9250,7 @@
         </p:nvCxnSpPr>
         <p:spPr>
           <a:xfrm>
-            <a:off x="7269480" y="2788920"/>
+            <a:off x="7269480" y="2743200"/>
             <a:ext cx="0" cy="1143000"/>
           </a:xfrm>
           <a:prstGeom prst="line">
@@ -9161,6 +9261,7 @@
               <a:srgbClr val="CBD5E1"/>
             </a:solidFill>
           </a:ln>
+          <a:effectLst/>
         </p:spPr>
         <p:style>
           <a:lnRef idx="2">
@@ -9185,7 +9286,7 @@
         </p:nvCxnSpPr>
         <p:spPr>
           <a:xfrm>
-            <a:off x="7269480" y="2788920"/>
+            <a:off x="7269480" y="2743200"/>
             <a:ext cx="1143000" cy="1143000"/>
           </a:xfrm>
           <a:prstGeom prst="line">
@@ -9196,6 +9297,7 @@
               <a:srgbClr val="CBD5E1"/>
             </a:solidFill>
           </a:ln>
+          <a:effectLst/>
         </p:spPr>
         <p:style>
           <a:lnRef idx="2">
@@ -9220,7 +9322,7 @@
         </p:nvCxnSpPr>
         <p:spPr>
           <a:xfrm>
-            <a:off x="8412480" y="2788920"/>
+            <a:off x="8412480" y="2743200"/>
             <a:ext cx="1143000" cy="0"/>
           </a:xfrm>
           <a:prstGeom prst="line">
@@ -9231,6 +9333,7 @@
               <a:srgbClr val="CBD5E1"/>
             </a:solidFill>
           </a:ln>
+          <a:effectLst/>
         </p:spPr>
         <p:style>
           <a:lnRef idx="2">
@@ -9255,7 +9358,7 @@
         </p:nvCxnSpPr>
         <p:spPr>
           <a:xfrm flipH="1">
-            <a:off x="7269480" y="2788920"/>
+            <a:off x="7269480" y="2743200"/>
             <a:ext cx="1143000" cy="1143000"/>
           </a:xfrm>
           <a:prstGeom prst="line">
@@ -9266,6 +9369,7 @@
               <a:srgbClr val="CBD5E1"/>
             </a:solidFill>
           </a:ln>
+          <a:effectLst/>
         </p:spPr>
         <p:style>
           <a:lnRef idx="2">
@@ -9290,7 +9394,7 @@
         </p:nvCxnSpPr>
         <p:spPr>
           <a:xfrm>
-            <a:off x="8412480" y="2788920"/>
+            <a:off x="8412480" y="2743200"/>
             <a:ext cx="0" cy="1143000"/>
           </a:xfrm>
           <a:prstGeom prst="line">
@@ -9301,6 +9405,7 @@
               <a:srgbClr val="CBD5E1"/>
             </a:solidFill>
           </a:ln>
+          <a:effectLst/>
         </p:spPr>
         <p:style>
           <a:lnRef idx="2">
@@ -9325,7 +9430,7 @@
         </p:nvCxnSpPr>
         <p:spPr>
           <a:xfrm>
-            <a:off x="8412480" y="2788920"/>
+            <a:off x="8412480" y="2743200"/>
             <a:ext cx="1143000" cy="1143000"/>
           </a:xfrm>
           <a:prstGeom prst="line">
@@ -9336,6 +9441,7 @@
               <a:srgbClr val="CBD5E1"/>
             </a:solidFill>
           </a:ln>
+          <a:effectLst/>
         </p:spPr>
         <p:style>
           <a:lnRef idx="2">
@@ -9360,7 +9466,7 @@
         </p:nvCxnSpPr>
         <p:spPr>
           <a:xfrm>
-            <a:off x="9555480" y="2788920"/>
+            <a:off x="9555480" y="2743200"/>
             <a:ext cx="1143000" cy="0"/>
           </a:xfrm>
           <a:prstGeom prst="line">
@@ -9371,6 +9477,7 @@
               <a:srgbClr val="CBD5E1"/>
             </a:solidFill>
           </a:ln>
+          <a:effectLst/>
         </p:spPr>
         <p:style>
           <a:lnRef idx="2">
@@ -9395,7 +9502,7 @@
         </p:nvCxnSpPr>
         <p:spPr>
           <a:xfrm flipH="1">
-            <a:off x="8412480" y="2788920"/>
+            <a:off x="8412480" y="2743200"/>
             <a:ext cx="1143000" cy="1143000"/>
           </a:xfrm>
           <a:prstGeom prst="line">
@@ -9406,6 +9513,7 @@
               <a:srgbClr val="CBD5E1"/>
             </a:solidFill>
           </a:ln>
+          <a:effectLst/>
         </p:spPr>
         <p:style>
           <a:lnRef idx="2">
@@ -9430,7 +9538,7 @@
         </p:nvCxnSpPr>
         <p:spPr>
           <a:xfrm>
-            <a:off x="9555480" y="2788920"/>
+            <a:off x="9555480" y="2743200"/>
             <a:ext cx="0" cy="1143000"/>
           </a:xfrm>
           <a:prstGeom prst="line">
@@ -9441,6 +9549,7 @@
               <a:srgbClr val="CBD5E1"/>
             </a:solidFill>
           </a:ln>
+          <a:effectLst/>
         </p:spPr>
         <p:style>
           <a:lnRef idx="2">
@@ -9465,7 +9574,7 @@
         </p:nvCxnSpPr>
         <p:spPr>
           <a:xfrm>
-            <a:off x="9555480" y="2788920"/>
+            <a:off x="9555480" y="2743200"/>
             <a:ext cx="1143000" cy="1143000"/>
           </a:xfrm>
           <a:prstGeom prst="line">
@@ -9476,6 +9585,7 @@
               <a:srgbClr val="CBD5E1"/>
             </a:solidFill>
           </a:ln>
+          <a:effectLst/>
         </p:spPr>
         <p:style>
           <a:lnRef idx="2">
@@ -9500,7 +9610,7 @@
         </p:nvCxnSpPr>
         <p:spPr>
           <a:xfrm flipH="1">
-            <a:off x="9555480" y="2788920"/>
+            <a:off x="9555480" y="2743200"/>
             <a:ext cx="1143000" cy="1143000"/>
           </a:xfrm>
           <a:prstGeom prst="line">
@@ -9511,6 +9621,7 @@
               <a:srgbClr val="CBD5E1"/>
             </a:solidFill>
           </a:ln>
+          <a:effectLst/>
         </p:spPr>
         <p:style>
           <a:lnRef idx="2">
@@ -9535,7 +9646,7 @@
         </p:nvCxnSpPr>
         <p:spPr>
           <a:xfrm>
-            <a:off x="10698480" y="2788920"/>
+            <a:off x="10698480" y="2743200"/>
             <a:ext cx="0" cy="1143000"/>
           </a:xfrm>
           <a:prstGeom prst="line">
@@ -9546,6 +9657,7 @@
               <a:srgbClr val="CBD5E1"/>
             </a:solidFill>
           </a:ln>
+          <a:effectLst/>
         </p:spPr>
         <p:style>
           <a:lnRef idx="2">
@@ -9570,7 +9682,7 @@
         </p:nvCxnSpPr>
         <p:spPr>
           <a:xfrm>
-            <a:off x="7269480" y="3931920"/>
+            <a:off x="7269480" y="3886200"/>
             <a:ext cx="1143000" cy="0"/>
           </a:xfrm>
           <a:prstGeom prst="line">
@@ -9581,6 +9693,7 @@
               <a:srgbClr val="CBD5E1"/>
             </a:solidFill>
           </a:ln>
+          <a:effectLst/>
         </p:spPr>
         <p:style>
           <a:lnRef idx="2">
@@ -9605,7 +9718,7 @@
         </p:nvCxnSpPr>
         <p:spPr>
           <a:xfrm>
-            <a:off x="7269480" y="3931920"/>
+            <a:off x="7269480" y="3886200"/>
             <a:ext cx="0" cy="1143000"/>
           </a:xfrm>
           <a:prstGeom prst="line">
@@ -9616,6 +9729,7 @@
               <a:srgbClr val="CBD5E1"/>
             </a:solidFill>
           </a:ln>
+          <a:effectLst/>
         </p:spPr>
         <p:style>
           <a:lnRef idx="2">
@@ -9640,7 +9754,7 @@
         </p:nvCxnSpPr>
         <p:spPr>
           <a:xfrm>
-            <a:off x="7269480" y="3931920"/>
+            <a:off x="7269480" y="3886200"/>
             <a:ext cx="1143000" cy="1143000"/>
           </a:xfrm>
           <a:prstGeom prst="line">
@@ -9651,6 +9765,7 @@
               <a:srgbClr val="CBD5E1"/>
             </a:solidFill>
           </a:ln>
+          <a:effectLst/>
         </p:spPr>
         <p:style>
           <a:lnRef idx="2">
@@ -9675,7 +9790,7 @@
         </p:nvCxnSpPr>
         <p:spPr>
           <a:xfrm>
-            <a:off x="8412480" y="3931920"/>
+            <a:off x="8412480" y="3886200"/>
             <a:ext cx="1143000" cy="0"/>
           </a:xfrm>
           <a:prstGeom prst="line">
@@ -9686,6 +9801,7 @@
               <a:srgbClr val="CBD5E1"/>
             </a:solidFill>
           </a:ln>
+          <a:effectLst/>
         </p:spPr>
         <p:style>
           <a:lnRef idx="2">
@@ -9710,7 +9826,7 @@
         </p:nvCxnSpPr>
         <p:spPr>
           <a:xfrm flipH="1">
-            <a:off x="7269480" y="3931920"/>
+            <a:off x="7269480" y="3886200"/>
             <a:ext cx="1143000" cy="1143000"/>
           </a:xfrm>
           <a:prstGeom prst="line">
@@ -9721,6 +9837,7 @@
               <a:srgbClr val="CBD5E1"/>
             </a:solidFill>
           </a:ln>
+          <a:effectLst/>
         </p:spPr>
         <p:style>
           <a:lnRef idx="2">
@@ -9745,7 +9862,7 @@
         </p:nvCxnSpPr>
         <p:spPr>
           <a:xfrm>
-            <a:off x="8412480" y="3931920"/>
+            <a:off x="8412480" y="3886200"/>
             <a:ext cx="0" cy="1143000"/>
           </a:xfrm>
           <a:prstGeom prst="line">
@@ -9756,6 +9873,7 @@
               <a:srgbClr val="CBD5E1"/>
             </a:solidFill>
           </a:ln>
+          <a:effectLst/>
         </p:spPr>
         <p:style>
           <a:lnRef idx="2">
@@ -9780,7 +9898,7 @@
         </p:nvCxnSpPr>
         <p:spPr>
           <a:xfrm>
-            <a:off x="8412480" y="3931920"/>
+            <a:off x="8412480" y="3886200"/>
             <a:ext cx="1143000" cy="1143000"/>
           </a:xfrm>
           <a:prstGeom prst="line">
@@ -9791,6 +9909,7 @@
               <a:srgbClr val="CBD5E1"/>
             </a:solidFill>
           </a:ln>
+          <a:effectLst/>
         </p:spPr>
         <p:style>
           <a:lnRef idx="2">
@@ -9815,7 +9934,7 @@
         </p:nvCxnSpPr>
         <p:spPr>
           <a:xfrm>
-            <a:off x="9555480" y="3931920"/>
+            <a:off x="9555480" y="3886200"/>
             <a:ext cx="1143000" cy="0"/>
           </a:xfrm>
           <a:prstGeom prst="line">
@@ -9826,6 +9945,7 @@
               <a:srgbClr val="CBD5E1"/>
             </a:solidFill>
           </a:ln>
+          <a:effectLst/>
         </p:spPr>
         <p:style>
           <a:lnRef idx="2">
@@ -9850,7 +9970,7 @@
         </p:nvCxnSpPr>
         <p:spPr>
           <a:xfrm flipH="1">
-            <a:off x="8412480" y="3931920"/>
+            <a:off x="8412480" y="3886200"/>
             <a:ext cx="1143000" cy="1143000"/>
           </a:xfrm>
           <a:prstGeom prst="line">
@@ -9861,6 +9981,7 @@
               <a:srgbClr val="CBD5E1"/>
             </a:solidFill>
           </a:ln>
+          <a:effectLst/>
         </p:spPr>
         <p:style>
           <a:lnRef idx="2">
@@ -9885,7 +10006,7 @@
         </p:nvCxnSpPr>
         <p:spPr>
           <a:xfrm>
-            <a:off x="9555480" y="3931920"/>
+            <a:off x="9555480" y="3886200"/>
             <a:ext cx="0" cy="1143000"/>
           </a:xfrm>
           <a:prstGeom prst="line">
@@ -9896,6 +10017,7 @@
               <a:srgbClr val="CBD5E1"/>
             </a:solidFill>
           </a:ln>
+          <a:effectLst/>
         </p:spPr>
         <p:style>
           <a:lnRef idx="2">
@@ -9920,7 +10042,7 @@
         </p:nvCxnSpPr>
         <p:spPr>
           <a:xfrm>
-            <a:off x="9555480" y="3931920"/>
+            <a:off x="9555480" y="3886200"/>
             <a:ext cx="1143000" cy="1143000"/>
           </a:xfrm>
           <a:prstGeom prst="line">
@@ -9931,6 +10053,7 @@
               <a:srgbClr val="CBD5E1"/>
             </a:solidFill>
           </a:ln>
+          <a:effectLst/>
         </p:spPr>
         <p:style>
           <a:lnRef idx="2">
@@ -9955,7 +10078,7 @@
         </p:nvCxnSpPr>
         <p:spPr>
           <a:xfrm flipH="1">
-            <a:off x="9555480" y="3931920"/>
+            <a:off x="9555480" y="3886200"/>
             <a:ext cx="1143000" cy="1143000"/>
           </a:xfrm>
           <a:prstGeom prst="line">
@@ -9966,6 +10089,7 @@
               <a:srgbClr val="CBD5E1"/>
             </a:solidFill>
           </a:ln>
+          <a:effectLst/>
         </p:spPr>
         <p:style>
           <a:lnRef idx="2">
@@ -9990,7 +10114,7 @@
         </p:nvCxnSpPr>
         <p:spPr>
           <a:xfrm>
-            <a:off x="10698480" y="3931920"/>
+            <a:off x="10698480" y="3886200"/>
             <a:ext cx="0" cy="1143000"/>
           </a:xfrm>
           <a:prstGeom prst="line">
@@ -10001,6 +10125,7 @@
               <a:srgbClr val="CBD5E1"/>
             </a:solidFill>
           </a:ln>
+          <a:effectLst/>
         </p:spPr>
         <p:style>
           <a:lnRef idx="2">
@@ -10025,7 +10150,7 @@
         </p:nvCxnSpPr>
         <p:spPr>
           <a:xfrm>
-            <a:off x="7269480" y="5074920"/>
+            <a:off x="7269480" y="5029200"/>
             <a:ext cx="1143000" cy="0"/>
           </a:xfrm>
           <a:prstGeom prst="line">
@@ -10036,6 +10161,7 @@
               <a:srgbClr val="CBD5E1"/>
             </a:solidFill>
           </a:ln>
+          <a:effectLst/>
         </p:spPr>
         <p:style>
           <a:lnRef idx="2">
@@ -10060,7 +10186,7 @@
         </p:nvCxnSpPr>
         <p:spPr>
           <a:xfrm>
-            <a:off x="8412480" y="5074920"/>
+            <a:off x="8412480" y="5029200"/>
             <a:ext cx="1143000" cy="0"/>
           </a:xfrm>
           <a:prstGeom prst="line">
@@ -10071,6 +10197,7 @@
               <a:srgbClr val="CBD5E1"/>
             </a:solidFill>
           </a:ln>
+          <a:effectLst/>
         </p:spPr>
         <p:style>
           <a:lnRef idx="2">
@@ -10095,7 +10222,7 @@
         </p:nvCxnSpPr>
         <p:spPr>
           <a:xfrm>
-            <a:off x="9555480" y="5074920"/>
+            <a:off x="9555480" y="5029200"/>
             <a:ext cx="1143000" cy="0"/>
           </a:xfrm>
           <a:prstGeom prst="line">
@@ -10106,6 +10233,7 @@
               <a:srgbClr val="CBD5E1"/>
             </a:solidFill>
           </a:ln>
+          <a:effectLst/>
         </p:spPr>
         <p:style>
           <a:lnRef idx="2">
@@ -10130,7 +10258,7 @@
         </p:nvSpPr>
         <p:spPr>
           <a:xfrm>
-            <a:off x="6858000" y="1234440"/>
+            <a:off x="6858000" y="1188720"/>
             <a:ext cx="822960" cy="822960"/>
           </a:xfrm>
           <a:prstGeom prst="ellipse">
@@ -10142,6 +10270,7 @@
               <a:srgbClr val="D97706"/>
             </a:solidFill>
           </a:ln>
+          <a:effectLst/>
         </p:spPr>
         <p:style>
           <a:lnRef idx="1">
@@ -10173,7 +10302,7 @@
         </p:nvSpPr>
         <p:spPr>
           <a:xfrm>
-            <a:off x="6949440" y="1325880"/>
+            <a:off x="6949440" y="1280160"/>
             <a:ext cx="640080" cy="640080"/>
           </a:xfrm>
           <a:prstGeom prst="ellipse">
@@ -10185,6 +10314,7 @@
           <a:ln>
             <a:noFill/>
           </a:ln>
+          <a:effectLst/>
         </p:spPr>
         <p:style>
           <a:lnRef idx="1">
@@ -10226,7 +10356,7 @@
         </p:nvSpPr>
         <p:spPr>
           <a:xfrm>
-            <a:off x="8092440" y="1325880"/>
+            <a:off x="8092440" y="1280160"/>
             <a:ext cx="640080" cy="640080"/>
           </a:xfrm>
           <a:prstGeom prst="ellipse">
@@ -10238,6 +10368,7 @@
           <a:ln>
             <a:noFill/>
           </a:ln>
+          <a:effectLst/>
         </p:spPr>
         <p:style>
           <a:lnRef idx="1">
@@ -10279,7 +10410,7 @@
         </p:nvSpPr>
         <p:spPr>
           <a:xfrm>
-            <a:off x="9235440" y="1325880"/>
+            <a:off x="9235440" y="1280160"/>
             <a:ext cx="640080" cy="640080"/>
           </a:xfrm>
           <a:prstGeom prst="ellipse">
@@ -10291,6 +10422,7 @@
           <a:ln>
             <a:noFill/>
           </a:ln>
+          <a:effectLst/>
         </p:spPr>
         <p:style>
           <a:lnRef idx="1">
@@ -10332,7 +10464,7 @@
         </p:nvSpPr>
         <p:spPr>
           <a:xfrm>
-            <a:off x="10287000" y="1234440"/>
+            <a:off x="10287000" y="1188720"/>
             <a:ext cx="822960" cy="822960"/>
           </a:xfrm>
           <a:prstGeom prst="ellipse">
@@ -10344,6 +10476,7 @@
               <a:srgbClr val="D97706"/>
             </a:solidFill>
           </a:ln>
+          <a:effectLst/>
         </p:spPr>
         <p:style>
           <a:lnRef idx="1">
@@ -10375,7 +10508,7 @@
         </p:nvSpPr>
         <p:spPr>
           <a:xfrm>
-            <a:off x="10378440" y="1325880"/>
+            <a:off x="10378440" y="1280160"/>
             <a:ext cx="640080" cy="640080"/>
           </a:xfrm>
           <a:prstGeom prst="ellipse">
@@ -10387,6 +10520,7 @@
           <a:ln>
             <a:noFill/>
           </a:ln>
+          <a:effectLst/>
         </p:spPr>
         <p:style>
           <a:lnRef idx="1">
@@ -10428,7 +10562,7 @@
         </p:nvSpPr>
         <p:spPr>
           <a:xfrm>
-            <a:off x="6949440" y="2468880"/>
+            <a:off x="6949440" y="2423160"/>
             <a:ext cx="640080" cy="640080"/>
           </a:xfrm>
           <a:prstGeom prst="ellipse">
@@ -10440,6 +10574,7 @@
           <a:ln>
             <a:noFill/>
           </a:ln>
+          <a:effectLst/>
         </p:spPr>
         <p:style>
           <a:lnRef idx="1">
@@ -10481,7 +10616,7 @@
         </p:nvSpPr>
         <p:spPr>
           <a:xfrm>
-            <a:off x="8092440" y="2468880"/>
+            <a:off x="8092440" y="2423160"/>
             <a:ext cx="640080" cy="640080"/>
           </a:xfrm>
           <a:prstGeom prst="ellipse">
@@ -10493,6 +10628,7 @@
           <a:ln>
             <a:noFill/>
           </a:ln>
+          <a:effectLst/>
         </p:spPr>
         <p:style>
           <a:lnRef idx="1">
@@ -10534,7 +10670,7 @@
         </p:nvSpPr>
         <p:spPr>
           <a:xfrm>
-            <a:off x="9235440" y="2468880"/>
+            <a:off x="9235440" y="2423160"/>
             <a:ext cx="640080" cy="640080"/>
           </a:xfrm>
           <a:prstGeom prst="ellipse">
@@ -10546,6 +10682,7 @@
           <a:ln>
             <a:noFill/>
           </a:ln>
+          <a:effectLst/>
         </p:spPr>
         <p:style>
           <a:lnRef idx="1">
@@ -10587,7 +10724,7 @@
         </p:nvSpPr>
         <p:spPr>
           <a:xfrm>
-            <a:off x="10378440" y="2468880"/>
+            <a:off x="10378440" y="2423160"/>
             <a:ext cx="640080" cy="640080"/>
           </a:xfrm>
           <a:prstGeom prst="ellipse">
@@ -10599,6 +10736,7 @@
           <a:ln>
             <a:noFill/>
           </a:ln>
+          <a:effectLst/>
         </p:spPr>
         <p:style>
           <a:lnRef idx="1">
@@ -10640,7 +10778,7 @@
         </p:nvSpPr>
         <p:spPr>
           <a:xfrm>
-            <a:off x="6949440" y="3611880"/>
+            <a:off x="6949440" y="3566160"/>
             <a:ext cx="640080" cy="640080"/>
           </a:xfrm>
           <a:prstGeom prst="ellipse">
@@ -10652,6 +10790,7 @@
           <a:ln>
             <a:noFill/>
           </a:ln>
+          <a:effectLst/>
         </p:spPr>
         <p:style>
           <a:lnRef idx="1">
@@ -10693,7 +10832,7 @@
         </p:nvSpPr>
         <p:spPr>
           <a:xfrm>
-            <a:off x="8092440" y="3611880"/>
+            <a:off x="8092440" y="3566160"/>
             <a:ext cx="640080" cy="640080"/>
           </a:xfrm>
           <a:prstGeom prst="ellipse">
@@ -10705,6 +10844,7 @@
           <a:ln>
             <a:noFill/>
           </a:ln>
+          <a:effectLst/>
         </p:spPr>
         <p:style>
           <a:lnRef idx="1">
@@ -10746,7 +10886,7 @@
         </p:nvSpPr>
         <p:spPr>
           <a:xfrm>
-            <a:off x="9235440" y="3611880"/>
+            <a:off x="9235440" y="3566160"/>
             <a:ext cx="640080" cy="640080"/>
           </a:xfrm>
           <a:prstGeom prst="ellipse">
@@ -10758,6 +10898,7 @@
           <a:ln>
             <a:noFill/>
           </a:ln>
+          <a:effectLst/>
         </p:spPr>
         <p:style>
           <a:lnRef idx="1">
@@ -10799,7 +10940,7 @@
         </p:nvSpPr>
         <p:spPr>
           <a:xfrm>
-            <a:off x="10378440" y="3611880"/>
+            <a:off x="10378440" y="3566160"/>
             <a:ext cx="640080" cy="640080"/>
           </a:xfrm>
           <a:prstGeom prst="ellipse">
@@ -10811,6 +10952,7 @@
           <a:ln>
             <a:noFill/>
           </a:ln>
+          <a:effectLst/>
         </p:spPr>
         <p:style>
           <a:lnRef idx="1">
@@ -10852,7 +10994,7 @@
         </p:nvSpPr>
         <p:spPr>
           <a:xfrm>
-            <a:off x="6858000" y="4663440"/>
+            <a:off x="6858000" y="4617720"/>
             <a:ext cx="822960" cy="822960"/>
           </a:xfrm>
           <a:prstGeom prst="ellipse">
@@ -10864,6 +11006,7 @@
               <a:srgbClr val="D97706"/>
             </a:solidFill>
           </a:ln>
+          <a:effectLst/>
         </p:spPr>
         <p:style>
           <a:lnRef idx="1">
@@ -10895,7 +11038,7 @@
         </p:nvSpPr>
         <p:spPr>
           <a:xfrm>
-            <a:off x="6949440" y="4754880"/>
+            <a:off x="6949440" y="4709160"/>
             <a:ext cx="640080" cy="640080"/>
           </a:xfrm>
           <a:prstGeom prst="ellipse">
@@ -10907,6 +11050,7 @@
           <a:ln>
             <a:noFill/>
           </a:ln>
+          <a:effectLst/>
         </p:spPr>
         <p:style>
           <a:lnRef idx="1">
@@ -10948,7 +11092,7 @@
         </p:nvSpPr>
         <p:spPr>
           <a:xfrm>
-            <a:off x="8092440" y="4754880"/>
+            <a:off x="8092440" y="4709160"/>
             <a:ext cx="640080" cy="640080"/>
           </a:xfrm>
           <a:prstGeom prst="ellipse">
@@ -10960,6 +11104,7 @@
           <a:ln>
             <a:noFill/>
           </a:ln>
+          <a:effectLst/>
         </p:spPr>
         <p:style>
           <a:lnRef idx="1">
@@ -11001,7 +11146,7 @@
         </p:nvSpPr>
         <p:spPr>
           <a:xfrm>
-            <a:off x="9235440" y="4754880"/>
+            <a:off x="9235440" y="4709160"/>
             <a:ext cx="640080" cy="640080"/>
           </a:xfrm>
           <a:prstGeom prst="ellipse">
@@ -11013,6 +11158,7 @@
           <a:ln>
             <a:noFill/>
           </a:ln>
+          <a:effectLst/>
         </p:spPr>
         <p:style>
           <a:lnRef idx="1">
@@ -11054,7 +11200,7 @@
         </p:nvSpPr>
         <p:spPr>
           <a:xfrm>
-            <a:off x="10287000" y="4663440"/>
+            <a:off x="10287000" y="4617720"/>
             <a:ext cx="822960" cy="822960"/>
           </a:xfrm>
           <a:prstGeom prst="ellipse">
@@ -11066,6 +11212,7 @@
               <a:srgbClr val="D97706"/>
             </a:solidFill>
           </a:ln>
+          <a:effectLst/>
         </p:spPr>
         <p:style>
           <a:lnRef idx="1">
@@ -11097,7 +11244,7 @@
         </p:nvSpPr>
         <p:spPr>
           <a:xfrm>
-            <a:off x="10378440" y="4754880"/>
+            <a:off x="10378440" y="4709160"/>
             <a:ext cx="640080" cy="640080"/>
           </a:xfrm>
           <a:prstGeom prst="ellipse">
@@ -11109,6 +11256,7 @@
           <a:ln>
             <a:noFill/>
           </a:ln>
+          <a:effectLst/>
         </p:spPr>
         <p:style>
           <a:lnRef idx="1">
@@ -11157,6 +11305,7 @@
             <a:avLst/>
           </a:prstGeom>
           <a:noFill/>
+          <a:effectLst/>
         </p:spPr>
         <p:txBody>
           <a:bodyPr wrap="none">
@@ -11216,6 +11365,7 @@
           <a:ln>
             <a:noFill/>
           </a:ln>
+          <a:effectLst/>
         </p:spPr>
         <p:style>
           <a:lnRef idx="1">
@@ -11254,6 +11404,7 @@
             <a:avLst/>
           </a:prstGeom>
           <a:noFill/>
+          <a:effectLst/>
         </p:spPr>
         <p:txBody>
           <a:bodyPr wrap="square" lIns="0" tIns="0" rIns="0" bIns="0">
@@ -11295,6 +11446,7 @@
           <a:ln>
             <a:noFill/>
           </a:ln>
+          <a:effectLst/>
         </p:spPr>
         <p:style>
           <a:lnRef idx="1">
@@ -11333,6 +11485,7 @@
             <a:avLst/>
           </a:prstGeom>
           <a:noFill/>
+          <a:effectLst/>
         </p:spPr>
         <p:txBody>
           <a:bodyPr wrap="none" lIns="0" tIns="0" rIns="0" bIns="0">
@@ -11369,6 +11522,7 @@
             <a:avLst/>
           </a:prstGeom>
           <a:noFill/>
+          <a:effectLst/>
         </p:spPr>
         <p:txBody>
           <a:bodyPr wrap="square" lIns="0" tIns="0" rIns="0" bIns="0">
@@ -11398,13 +11552,14 @@
         </p:nvSpPr>
         <p:spPr>
           <a:xfrm>
-            <a:off x="914400" y="3566160"/>
-            <a:ext cx="5303520" cy="1417320"/>
+            <a:off x="914400" y="3474720"/>
+            <a:ext cx="5303520" cy="1051560"/>
           </a:xfrm>
           <a:prstGeom prst="rect">
             <a:avLst/>
           </a:prstGeom>
           <a:noFill/>
+          <a:effectLst/>
         </p:spPr>
         <p:txBody>
           <a:bodyPr wrap="square" lIns="0" tIns="0" rIns="0" bIns="0">
@@ -11427,7 +11582,7 @@
           <a:p>
             <a:pPr>
               <a:spcBef>
-                <a:spcPts val="600"/>
+                <a:spcPts val="400"/>
               </a:spcBef>
               <a:defRPr sz="2000">
                 <a:solidFill>
@@ -11443,7 +11598,7 @@
           <a:p>
             <a:pPr>
               <a:spcBef>
-                <a:spcPts val="600"/>
+                <a:spcPts val="400"/>
               </a:spcBef>
               <a:defRPr sz="2000">
                 <a:solidFill>
@@ -11473,6 +11628,7 @@
             <a:avLst/>
           </a:prstGeom>
           <a:noFill/>
+          <a:effectLst/>
         </p:spPr>
         <p:txBody>
           <a:bodyPr wrap="square" lIns="0" tIns="0" rIns="0" bIns="0">
@@ -11481,7 +11637,7 @@
           <a:lstStyle/>
           <a:p>
             <a:pPr>
-              <a:defRPr sz="2000">
+              <a:defRPr sz="1900">
                 <a:solidFill>
                   <a:srgbClr val="D97706"/>
                 </a:solidFill>
@@ -11489,7 +11645,7 @@
               </a:defRPr>
             </a:pPr>
             <a:r>
-              <a:t>The brief's sample shows 5 slots. Node_01 and Node_03 are 600 m apart, but Node_02 hears both, so distance-2 forbids sharing.</a:t>
+              <a:t>The brief's sample shows 5 slots with partial coordinates. Node_01 and Node_03 share slot 0, but both neighbor Node_02, so distance-2 forbids sharing.</a:t>
             </a:r>
           </a:p>
         </p:txBody>
@@ -11516,6 +11672,7 @@
               <a:srgbClr val="D97706"/>
             </a:solidFill>
           </a:ln>
+          <a:effectLst/>
         </p:spPr>
         <p:style>
           <a:lnRef idx="1">
@@ -11547,7 +11704,7 @@
         </p:nvCxnSpPr>
         <p:spPr>
           <a:xfrm>
-            <a:off x="7269480" y="1645920"/>
+            <a:off x="7269480" y="1600200"/>
             <a:ext cx="1143000" cy="0"/>
           </a:xfrm>
           <a:prstGeom prst="line">
@@ -11558,6 +11715,7 @@
               <a:srgbClr val="CBD5E1"/>
             </a:solidFill>
           </a:ln>
+          <a:effectLst/>
         </p:spPr>
         <p:style>
           <a:lnRef idx="2">
@@ -11582,7 +11740,7 @@
         </p:nvCxnSpPr>
         <p:spPr>
           <a:xfrm>
-            <a:off x="7269480" y="1645920"/>
+            <a:off x="7269480" y="1600200"/>
             <a:ext cx="0" cy="1143000"/>
           </a:xfrm>
           <a:prstGeom prst="line">
@@ -11593,6 +11751,7 @@
               <a:srgbClr val="CBD5E1"/>
             </a:solidFill>
           </a:ln>
+          <a:effectLst/>
         </p:spPr>
         <p:style>
           <a:lnRef idx="2">
@@ -11617,7 +11776,7 @@
         </p:nvCxnSpPr>
         <p:spPr>
           <a:xfrm>
-            <a:off x="7269480" y="1645920"/>
+            <a:off x="7269480" y="1600200"/>
             <a:ext cx="1143000" cy="1143000"/>
           </a:xfrm>
           <a:prstGeom prst="line">
@@ -11628,6 +11787,7 @@
               <a:srgbClr val="CBD5E1"/>
             </a:solidFill>
           </a:ln>
+          <a:effectLst/>
         </p:spPr>
         <p:style>
           <a:lnRef idx="2">
@@ -11652,7 +11812,7 @@
         </p:nvCxnSpPr>
         <p:spPr>
           <a:xfrm>
-            <a:off x="8412480" y="1645920"/>
+            <a:off x="8412480" y="1600200"/>
             <a:ext cx="1143000" cy="0"/>
           </a:xfrm>
           <a:prstGeom prst="line">
@@ -11663,6 +11823,7 @@
               <a:srgbClr val="CBD5E1"/>
             </a:solidFill>
           </a:ln>
+          <a:effectLst/>
         </p:spPr>
         <p:style>
           <a:lnRef idx="2">
@@ -11687,7 +11848,7 @@
         </p:nvCxnSpPr>
         <p:spPr>
           <a:xfrm flipH="1">
-            <a:off x="7269480" y="1645920"/>
+            <a:off x="7269480" y="1600200"/>
             <a:ext cx="1143000" cy="1143000"/>
           </a:xfrm>
           <a:prstGeom prst="line">
@@ -11698,6 +11859,7 @@
               <a:srgbClr val="CBD5E1"/>
             </a:solidFill>
           </a:ln>
+          <a:effectLst/>
         </p:spPr>
         <p:style>
           <a:lnRef idx="2">
@@ -11722,7 +11884,7 @@
         </p:nvCxnSpPr>
         <p:spPr>
           <a:xfrm>
-            <a:off x="8412480" y="1645920"/>
+            <a:off x="8412480" y="1600200"/>
             <a:ext cx="0" cy="1143000"/>
           </a:xfrm>
           <a:prstGeom prst="line">
@@ -11733,6 +11895,7 @@
               <a:srgbClr val="CBD5E1"/>
             </a:solidFill>
           </a:ln>
+          <a:effectLst/>
         </p:spPr>
         <p:style>
           <a:lnRef idx="2">
@@ -11757,7 +11920,7 @@
         </p:nvCxnSpPr>
         <p:spPr>
           <a:xfrm>
-            <a:off x="8412480" y="1645920"/>
+            <a:off x="8412480" y="1600200"/>
             <a:ext cx="1143000" cy="1143000"/>
           </a:xfrm>
           <a:prstGeom prst="line">
@@ -11768,6 +11931,7 @@
               <a:srgbClr val="CBD5E1"/>
             </a:solidFill>
           </a:ln>
+          <a:effectLst/>
         </p:spPr>
         <p:style>
           <a:lnRef idx="2">
@@ -11792,7 +11956,7 @@
         </p:nvCxnSpPr>
         <p:spPr>
           <a:xfrm>
-            <a:off x="9555480" y="1645920"/>
+            <a:off x="9555480" y="1600200"/>
             <a:ext cx="1143000" cy="0"/>
           </a:xfrm>
           <a:prstGeom prst="line">
@@ -11803,6 +11967,7 @@
               <a:srgbClr val="CBD5E1"/>
             </a:solidFill>
           </a:ln>
+          <a:effectLst/>
         </p:spPr>
         <p:style>
           <a:lnRef idx="2">
@@ -11827,7 +11992,7 @@
         </p:nvCxnSpPr>
         <p:spPr>
           <a:xfrm flipH="1">
-            <a:off x="8412480" y="1645920"/>
+            <a:off x="8412480" y="1600200"/>
             <a:ext cx="1143000" cy="1143000"/>
           </a:xfrm>
           <a:prstGeom prst="line">
@@ -11838,6 +12003,7 @@
               <a:srgbClr val="CBD5E1"/>
             </a:solidFill>
           </a:ln>
+          <a:effectLst/>
         </p:spPr>
         <p:style>
           <a:lnRef idx="2">
@@ -11862,7 +12028,7 @@
         </p:nvCxnSpPr>
         <p:spPr>
           <a:xfrm>
-            <a:off x="9555480" y="1645920"/>
+            <a:off x="9555480" y="1600200"/>
             <a:ext cx="0" cy="1143000"/>
           </a:xfrm>
           <a:prstGeom prst="line">
@@ -11873,6 +12039,7 @@
               <a:srgbClr val="CBD5E1"/>
             </a:solidFill>
           </a:ln>
+          <a:effectLst/>
         </p:spPr>
         <p:style>
           <a:lnRef idx="2">
@@ -11897,7 +12064,7 @@
         </p:nvCxnSpPr>
         <p:spPr>
           <a:xfrm>
-            <a:off x="9555480" y="1645920"/>
+            <a:off x="9555480" y="1600200"/>
             <a:ext cx="1143000" cy="1143000"/>
           </a:xfrm>
           <a:prstGeom prst="line">
@@ -11908,6 +12075,7 @@
               <a:srgbClr val="CBD5E1"/>
             </a:solidFill>
           </a:ln>
+          <a:effectLst/>
         </p:spPr>
         <p:style>
           <a:lnRef idx="2">
@@ -11932,7 +12100,7 @@
         </p:nvCxnSpPr>
         <p:spPr>
           <a:xfrm flipH="1">
-            <a:off x="9555480" y="1645920"/>
+            <a:off x="9555480" y="1600200"/>
             <a:ext cx="1143000" cy="1143000"/>
           </a:xfrm>
           <a:prstGeom prst="line">
@@ -11943,6 +12111,7 @@
               <a:srgbClr val="CBD5E1"/>
             </a:solidFill>
           </a:ln>
+          <a:effectLst/>
         </p:spPr>
         <p:style>
           <a:lnRef idx="2">
@@ -11967,7 +12136,7 @@
         </p:nvCxnSpPr>
         <p:spPr>
           <a:xfrm>
-            <a:off x="10698480" y="1645920"/>
+            <a:off x="10698480" y="1600200"/>
             <a:ext cx="0" cy="1143000"/>
           </a:xfrm>
           <a:prstGeom prst="line">
@@ -11978,6 +12147,7 @@
               <a:srgbClr val="CBD5E1"/>
             </a:solidFill>
           </a:ln>
+          <a:effectLst/>
         </p:spPr>
         <p:style>
           <a:lnRef idx="2">
@@ -12002,7 +12172,7 @@
         </p:nvCxnSpPr>
         <p:spPr>
           <a:xfrm>
-            <a:off x="7269480" y="2788920"/>
+            <a:off x="7269480" y="2743200"/>
             <a:ext cx="1143000" cy="0"/>
           </a:xfrm>
           <a:prstGeom prst="line">
@@ -12013,6 +12183,7 @@
               <a:srgbClr val="CBD5E1"/>
             </a:solidFill>
           </a:ln>
+          <a:effectLst/>
         </p:spPr>
         <p:style>
           <a:lnRef idx="2">
@@ -12037,7 +12208,7 @@
         </p:nvCxnSpPr>
         <p:spPr>
           <a:xfrm>
-            <a:off x="7269480" y="2788920"/>
+            <a:off x="7269480" y="2743200"/>
             <a:ext cx="0" cy="1143000"/>
           </a:xfrm>
           <a:prstGeom prst="line">
@@ -12048,6 +12219,7 @@
               <a:srgbClr val="CBD5E1"/>
             </a:solidFill>
           </a:ln>
+          <a:effectLst/>
         </p:spPr>
         <p:style>
           <a:lnRef idx="2">
@@ -12072,7 +12244,7 @@
         </p:nvCxnSpPr>
         <p:spPr>
           <a:xfrm>
-            <a:off x="7269480" y="2788920"/>
+            <a:off x="7269480" y="2743200"/>
             <a:ext cx="1143000" cy="1143000"/>
           </a:xfrm>
           <a:prstGeom prst="line">
@@ -12083,6 +12255,7 @@
               <a:srgbClr val="CBD5E1"/>
             </a:solidFill>
           </a:ln>
+          <a:effectLst/>
         </p:spPr>
         <p:style>
           <a:lnRef idx="2">
@@ -12107,7 +12280,7 @@
         </p:nvCxnSpPr>
         <p:spPr>
           <a:xfrm>
-            <a:off x="8412480" y="2788920"/>
+            <a:off x="8412480" y="2743200"/>
             <a:ext cx="1143000" cy="0"/>
           </a:xfrm>
           <a:prstGeom prst="line">
@@ -12118,6 +12291,7 @@
               <a:srgbClr val="CBD5E1"/>
             </a:solidFill>
           </a:ln>
+          <a:effectLst/>
         </p:spPr>
         <p:style>
           <a:lnRef idx="2">
@@ -12142,7 +12316,7 @@
         </p:nvCxnSpPr>
         <p:spPr>
           <a:xfrm flipH="1">
-            <a:off x="7269480" y="2788920"/>
+            <a:off x="7269480" y="2743200"/>
             <a:ext cx="1143000" cy="1143000"/>
           </a:xfrm>
           <a:prstGeom prst="line">
@@ -12153,6 +12327,7 @@
               <a:srgbClr val="CBD5E1"/>
             </a:solidFill>
           </a:ln>
+          <a:effectLst/>
         </p:spPr>
         <p:style>
           <a:lnRef idx="2">
@@ -12177,7 +12352,7 @@
         </p:nvCxnSpPr>
         <p:spPr>
           <a:xfrm>
-            <a:off x="8412480" y="2788920"/>
+            <a:off x="8412480" y="2743200"/>
             <a:ext cx="0" cy="1143000"/>
           </a:xfrm>
           <a:prstGeom prst="line">
@@ -12188,6 +12363,7 @@
               <a:srgbClr val="CBD5E1"/>
             </a:solidFill>
           </a:ln>
+          <a:effectLst/>
         </p:spPr>
         <p:style>
           <a:lnRef idx="2">
@@ -12212,7 +12388,7 @@
         </p:nvCxnSpPr>
         <p:spPr>
           <a:xfrm>
-            <a:off x="8412480" y="2788920"/>
+            <a:off x="8412480" y="2743200"/>
             <a:ext cx="1143000" cy="1143000"/>
           </a:xfrm>
           <a:prstGeom prst="line">
@@ -12223,6 +12399,7 @@
               <a:srgbClr val="CBD5E1"/>
             </a:solidFill>
           </a:ln>
+          <a:effectLst/>
         </p:spPr>
         <p:style>
           <a:lnRef idx="2">
@@ -12247,7 +12424,7 @@
         </p:nvCxnSpPr>
         <p:spPr>
           <a:xfrm>
-            <a:off x="9555480" y="2788920"/>
+            <a:off x="9555480" y="2743200"/>
             <a:ext cx="1143000" cy="0"/>
           </a:xfrm>
           <a:prstGeom prst="line">
@@ -12258,6 +12435,7 @@
               <a:srgbClr val="CBD5E1"/>
             </a:solidFill>
           </a:ln>
+          <a:effectLst/>
         </p:spPr>
         <p:style>
           <a:lnRef idx="2">
@@ -12282,7 +12460,7 @@
         </p:nvCxnSpPr>
         <p:spPr>
           <a:xfrm flipH="1">
-            <a:off x="8412480" y="2788920"/>
+            <a:off x="8412480" y="2743200"/>
             <a:ext cx="1143000" cy="1143000"/>
           </a:xfrm>
           <a:prstGeom prst="line">
@@ -12293,6 +12471,7 @@
               <a:srgbClr val="CBD5E1"/>
             </a:solidFill>
           </a:ln>
+          <a:effectLst/>
         </p:spPr>
         <p:style>
           <a:lnRef idx="2">
@@ -12317,7 +12496,7 @@
         </p:nvCxnSpPr>
         <p:spPr>
           <a:xfrm>
-            <a:off x="9555480" y="2788920"/>
+            <a:off x="9555480" y="2743200"/>
             <a:ext cx="0" cy="1143000"/>
           </a:xfrm>
           <a:prstGeom prst="line">
@@ -12328,6 +12507,7 @@
               <a:srgbClr val="CBD5E1"/>
             </a:solidFill>
           </a:ln>
+          <a:effectLst/>
         </p:spPr>
         <p:style>
           <a:lnRef idx="2">
@@ -12352,7 +12532,7 @@
         </p:nvCxnSpPr>
         <p:spPr>
           <a:xfrm>
-            <a:off x="9555480" y="2788920"/>
+            <a:off x="9555480" y="2743200"/>
             <a:ext cx="1143000" cy="1143000"/>
           </a:xfrm>
           <a:prstGeom prst="line">
@@ -12363,6 +12543,7 @@
               <a:srgbClr val="CBD5E1"/>
             </a:solidFill>
           </a:ln>
+          <a:effectLst/>
         </p:spPr>
         <p:style>
           <a:lnRef idx="2">
@@ -12387,7 +12568,7 @@
         </p:nvCxnSpPr>
         <p:spPr>
           <a:xfrm flipH="1">
-            <a:off x="9555480" y="2788920"/>
+            <a:off x="9555480" y="2743200"/>
             <a:ext cx="1143000" cy="1143000"/>
           </a:xfrm>
           <a:prstGeom prst="line">
@@ -12398,6 +12579,7 @@
               <a:srgbClr val="CBD5E1"/>
             </a:solidFill>
           </a:ln>
+          <a:effectLst/>
         </p:spPr>
         <p:style>
           <a:lnRef idx="2">
@@ -12422,7 +12604,7 @@
         </p:nvCxnSpPr>
         <p:spPr>
           <a:xfrm>
-            <a:off x="10698480" y="2788920"/>
+            <a:off x="10698480" y="2743200"/>
             <a:ext cx="0" cy="1143000"/>
           </a:xfrm>
           <a:prstGeom prst="line">
@@ -12433,6 +12615,7 @@
               <a:srgbClr val="CBD5E1"/>
             </a:solidFill>
           </a:ln>
+          <a:effectLst/>
         </p:spPr>
         <p:style>
           <a:lnRef idx="2">
@@ -12457,7 +12640,7 @@
         </p:nvCxnSpPr>
         <p:spPr>
           <a:xfrm>
-            <a:off x="7269480" y="3931920"/>
+            <a:off x="7269480" y="3886200"/>
             <a:ext cx="1143000" cy="0"/>
           </a:xfrm>
           <a:prstGeom prst="line">
@@ -12468,6 +12651,7 @@
               <a:srgbClr val="CBD5E1"/>
             </a:solidFill>
           </a:ln>
+          <a:effectLst/>
         </p:spPr>
         <p:style>
           <a:lnRef idx="2">
@@ -12492,7 +12676,7 @@
         </p:nvCxnSpPr>
         <p:spPr>
           <a:xfrm>
-            <a:off x="7269480" y="3931920"/>
+            <a:off x="7269480" y="3886200"/>
             <a:ext cx="0" cy="1143000"/>
           </a:xfrm>
           <a:prstGeom prst="line">
@@ -12503,6 +12687,7 @@
               <a:srgbClr val="CBD5E1"/>
             </a:solidFill>
           </a:ln>
+          <a:effectLst/>
         </p:spPr>
         <p:style>
           <a:lnRef idx="2">
@@ -12527,7 +12712,7 @@
         </p:nvCxnSpPr>
         <p:spPr>
           <a:xfrm>
-            <a:off x="7269480" y="3931920"/>
+            <a:off x="7269480" y="3886200"/>
             <a:ext cx="1143000" cy="1143000"/>
           </a:xfrm>
           <a:prstGeom prst="line">
@@ -12538,6 +12723,7 @@
               <a:srgbClr val="CBD5E1"/>
             </a:solidFill>
           </a:ln>
+          <a:effectLst/>
         </p:spPr>
         <p:style>
           <a:lnRef idx="2">
@@ -12562,7 +12748,7 @@
         </p:nvCxnSpPr>
         <p:spPr>
           <a:xfrm>
-            <a:off x="8412480" y="3931920"/>
+            <a:off x="8412480" y="3886200"/>
             <a:ext cx="1143000" cy="0"/>
           </a:xfrm>
           <a:prstGeom prst="line">
@@ -12573,6 +12759,7 @@
               <a:srgbClr val="CBD5E1"/>
             </a:solidFill>
           </a:ln>
+          <a:effectLst/>
         </p:spPr>
         <p:style>
           <a:lnRef idx="2">
@@ -12597,7 +12784,7 @@
         </p:nvCxnSpPr>
         <p:spPr>
           <a:xfrm flipH="1">
-            <a:off x="7269480" y="3931920"/>
+            <a:off x="7269480" y="3886200"/>
             <a:ext cx="1143000" cy="1143000"/>
           </a:xfrm>
           <a:prstGeom prst="line">
@@ -12608,6 +12795,7 @@
               <a:srgbClr val="CBD5E1"/>
             </a:solidFill>
           </a:ln>
+          <a:effectLst/>
         </p:spPr>
         <p:style>
           <a:lnRef idx="2">
@@ -12632,7 +12820,7 @@
         </p:nvCxnSpPr>
         <p:spPr>
           <a:xfrm>
-            <a:off x="8412480" y="3931920"/>
+            <a:off x="8412480" y="3886200"/>
             <a:ext cx="0" cy="1143000"/>
           </a:xfrm>
           <a:prstGeom prst="line">
@@ -12643,6 +12831,7 @@
               <a:srgbClr val="CBD5E1"/>
             </a:solidFill>
           </a:ln>
+          <a:effectLst/>
         </p:spPr>
         <p:style>
           <a:lnRef idx="2">
@@ -12667,7 +12856,7 @@
         </p:nvCxnSpPr>
         <p:spPr>
           <a:xfrm>
-            <a:off x="8412480" y="3931920"/>
+            <a:off x="8412480" y="3886200"/>
             <a:ext cx="1143000" cy="1143000"/>
           </a:xfrm>
           <a:prstGeom prst="line">
@@ -12678,6 +12867,7 @@
               <a:srgbClr val="CBD5E1"/>
             </a:solidFill>
           </a:ln>
+          <a:effectLst/>
         </p:spPr>
         <p:style>
           <a:lnRef idx="2">
@@ -12702,7 +12892,7 @@
         </p:nvCxnSpPr>
         <p:spPr>
           <a:xfrm>
-            <a:off x="9555480" y="3931920"/>
+            <a:off x="9555480" y="3886200"/>
             <a:ext cx="1143000" cy="0"/>
           </a:xfrm>
           <a:prstGeom prst="line">
@@ -12713,6 +12903,7 @@
               <a:srgbClr val="CBD5E1"/>
             </a:solidFill>
           </a:ln>
+          <a:effectLst/>
         </p:spPr>
         <p:style>
           <a:lnRef idx="2">
@@ -12737,7 +12928,7 @@
         </p:nvCxnSpPr>
         <p:spPr>
           <a:xfrm flipH="1">
-            <a:off x="8412480" y="3931920"/>
+            <a:off x="8412480" y="3886200"/>
             <a:ext cx="1143000" cy="1143000"/>
           </a:xfrm>
           <a:prstGeom prst="line">
@@ -12748,6 +12939,7 @@
               <a:srgbClr val="CBD5E1"/>
             </a:solidFill>
           </a:ln>
+          <a:effectLst/>
         </p:spPr>
         <p:style>
           <a:lnRef idx="2">
@@ -12772,7 +12964,7 @@
         </p:nvCxnSpPr>
         <p:spPr>
           <a:xfrm>
-            <a:off x="9555480" y="3931920"/>
+            <a:off x="9555480" y="3886200"/>
             <a:ext cx="0" cy="1143000"/>
           </a:xfrm>
           <a:prstGeom prst="line">
@@ -12783,6 +12975,7 @@
               <a:srgbClr val="CBD5E1"/>
             </a:solidFill>
           </a:ln>
+          <a:effectLst/>
         </p:spPr>
         <p:style>
           <a:lnRef idx="2">
@@ -12807,7 +13000,7 @@
         </p:nvCxnSpPr>
         <p:spPr>
           <a:xfrm>
-            <a:off x="9555480" y="3931920"/>
+            <a:off x="9555480" y="3886200"/>
             <a:ext cx="1143000" cy="1143000"/>
           </a:xfrm>
           <a:prstGeom prst="line">
@@ -12818,6 +13011,7 @@
               <a:srgbClr val="CBD5E1"/>
             </a:solidFill>
           </a:ln>
+          <a:effectLst/>
         </p:spPr>
         <p:style>
           <a:lnRef idx="2">
@@ -12842,7 +13036,7 @@
         </p:nvCxnSpPr>
         <p:spPr>
           <a:xfrm flipH="1">
-            <a:off x="9555480" y="3931920"/>
+            <a:off x="9555480" y="3886200"/>
             <a:ext cx="1143000" cy="1143000"/>
           </a:xfrm>
           <a:prstGeom prst="line">
@@ -12853,6 +13047,7 @@
               <a:srgbClr val="CBD5E1"/>
             </a:solidFill>
           </a:ln>
+          <a:effectLst/>
         </p:spPr>
         <p:style>
           <a:lnRef idx="2">
@@ -12877,7 +13072,7 @@
         </p:nvCxnSpPr>
         <p:spPr>
           <a:xfrm>
-            <a:off x="10698480" y="3931920"/>
+            <a:off x="10698480" y="3886200"/>
             <a:ext cx="0" cy="1143000"/>
           </a:xfrm>
           <a:prstGeom prst="line">
@@ -12888,6 +13083,7 @@
               <a:srgbClr val="CBD5E1"/>
             </a:solidFill>
           </a:ln>
+          <a:effectLst/>
         </p:spPr>
         <p:style>
           <a:lnRef idx="2">
@@ -12912,7 +13108,7 @@
         </p:nvCxnSpPr>
         <p:spPr>
           <a:xfrm>
-            <a:off x="7269480" y="5074920"/>
+            <a:off x="7269480" y="5029200"/>
             <a:ext cx="1143000" cy="0"/>
           </a:xfrm>
           <a:prstGeom prst="line">
@@ -12923,6 +13119,7 @@
               <a:srgbClr val="CBD5E1"/>
             </a:solidFill>
           </a:ln>
+          <a:effectLst/>
         </p:spPr>
         <p:style>
           <a:lnRef idx="2">
@@ -12947,7 +13144,7 @@
         </p:nvCxnSpPr>
         <p:spPr>
           <a:xfrm>
-            <a:off x="8412480" y="5074920"/>
+            <a:off x="8412480" y="5029200"/>
             <a:ext cx="1143000" cy="0"/>
           </a:xfrm>
           <a:prstGeom prst="line">
@@ -12958,6 +13155,7 @@
               <a:srgbClr val="CBD5E1"/>
             </a:solidFill>
           </a:ln>
+          <a:effectLst/>
         </p:spPr>
         <p:style>
           <a:lnRef idx="2">
@@ -12982,7 +13180,7 @@
         </p:nvCxnSpPr>
         <p:spPr>
           <a:xfrm>
-            <a:off x="9555480" y="5074920"/>
+            <a:off x="9555480" y="5029200"/>
             <a:ext cx="1143000" cy="0"/>
           </a:xfrm>
           <a:prstGeom prst="line">
@@ -12993,6 +13191,7 @@
               <a:srgbClr val="CBD5E1"/>
             </a:solidFill>
           </a:ln>
+          <a:effectLst/>
         </p:spPr>
         <p:style>
           <a:lnRef idx="2">
@@ -13017,7 +13216,7 @@
         </p:nvSpPr>
         <p:spPr>
           <a:xfrm>
-            <a:off x="6949440" y="1325880"/>
+            <a:off x="6949440" y="1280160"/>
             <a:ext cx="640080" cy="640080"/>
           </a:xfrm>
           <a:prstGeom prst="ellipse">
@@ -13029,6 +13228,7 @@
           <a:ln>
             <a:noFill/>
           </a:ln>
+          <a:effectLst/>
         </p:spPr>
         <p:style>
           <a:lnRef idx="1">
@@ -13070,7 +13270,7 @@
         </p:nvSpPr>
         <p:spPr>
           <a:xfrm>
-            <a:off x="8092440" y="1325880"/>
+            <a:off x="8092440" y="1280160"/>
             <a:ext cx="640080" cy="640080"/>
           </a:xfrm>
           <a:prstGeom prst="ellipse">
@@ -13082,6 +13282,7 @@
           <a:ln>
             <a:noFill/>
           </a:ln>
+          <a:effectLst/>
         </p:spPr>
         <p:style>
           <a:lnRef idx="1">
@@ -13123,7 +13324,7 @@
         </p:nvSpPr>
         <p:spPr>
           <a:xfrm>
-            <a:off x="9235440" y="1325880"/>
+            <a:off x="9235440" y="1280160"/>
             <a:ext cx="640080" cy="640080"/>
           </a:xfrm>
           <a:prstGeom prst="ellipse">
@@ -13135,6 +13336,7 @@
           <a:ln>
             <a:noFill/>
           </a:ln>
+          <a:effectLst/>
         </p:spPr>
         <p:style>
           <a:lnRef idx="1">
@@ -13176,7 +13378,7 @@
         </p:nvSpPr>
         <p:spPr>
           <a:xfrm>
-            <a:off x="10378440" y="1325880"/>
+            <a:off x="10378440" y="1280160"/>
             <a:ext cx="640080" cy="640080"/>
           </a:xfrm>
           <a:prstGeom prst="ellipse">
@@ -13188,6 +13390,7 @@
           <a:ln>
             <a:noFill/>
           </a:ln>
+          <a:effectLst/>
         </p:spPr>
         <p:style>
           <a:lnRef idx="1">
@@ -13229,7 +13432,7 @@
         </p:nvSpPr>
         <p:spPr>
           <a:xfrm>
-            <a:off x="6949440" y="2468880"/>
+            <a:off x="6949440" y="2423160"/>
             <a:ext cx="640080" cy="640080"/>
           </a:xfrm>
           <a:prstGeom prst="ellipse">
@@ -13241,6 +13444,7 @@
           <a:ln>
             <a:noFill/>
           </a:ln>
+          <a:effectLst/>
         </p:spPr>
         <p:style>
           <a:lnRef idx="1">
@@ -13282,7 +13486,7 @@
         </p:nvSpPr>
         <p:spPr>
           <a:xfrm>
-            <a:off x="8092440" y="2468880"/>
+            <a:off x="8092440" y="2423160"/>
             <a:ext cx="640080" cy="640080"/>
           </a:xfrm>
           <a:prstGeom prst="ellipse">
@@ -13294,6 +13498,7 @@
           <a:ln>
             <a:noFill/>
           </a:ln>
+          <a:effectLst/>
         </p:spPr>
         <p:style>
           <a:lnRef idx="1">
@@ -13335,7 +13540,7 @@
         </p:nvSpPr>
         <p:spPr>
           <a:xfrm>
-            <a:off x="9235440" y="2468880"/>
+            <a:off x="9235440" y="2423160"/>
             <a:ext cx="640080" cy="640080"/>
           </a:xfrm>
           <a:prstGeom prst="ellipse">
@@ -13347,6 +13552,7 @@
           <a:ln>
             <a:noFill/>
           </a:ln>
+          <a:effectLst/>
         </p:spPr>
         <p:style>
           <a:lnRef idx="1">
@@ -13388,7 +13594,7 @@
         </p:nvSpPr>
         <p:spPr>
           <a:xfrm>
-            <a:off x="10378440" y="2468880"/>
+            <a:off x="10378440" y="2423160"/>
             <a:ext cx="640080" cy="640080"/>
           </a:xfrm>
           <a:prstGeom prst="ellipse">
@@ -13400,6 +13606,7 @@
           <a:ln>
             <a:noFill/>
           </a:ln>
+          <a:effectLst/>
         </p:spPr>
         <p:style>
           <a:lnRef idx="1">
@@ -13441,7 +13648,7 @@
         </p:nvSpPr>
         <p:spPr>
           <a:xfrm>
-            <a:off x="6949440" y="3611880"/>
+            <a:off x="6949440" y="3566160"/>
             <a:ext cx="640080" cy="640080"/>
           </a:xfrm>
           <a:prstGeom prst="ellipse">
@@ -13453,6 +13660,7 @@
           <a:ln>
             <a:noFill/>
           </a:ln>
+          <a:effectLst/>
         </p:spPr>
         <p:style>
           <a:lnRef idx="1">
@@ -13494,7 +13702,7 @@
         </p:nvSpPr>
         <p:spPr>
           <a:xfrm>
-            <a:off x="8092440" y="3611880"/>
+            <a:off x="8092440" y="3566160"/>
             <a:ext cx="640080" cy="640080"/>
           </a:xfrm>
           <a:prstGeom prst="ellipse">
@@ -13506,6 +13714,7 @@
           <a:ln>
             <a:noFill/>
           </a:ln>
+          <a:effectLst/>
         </p:spPr>
         <p:style>
           <a:lnRef idx="1">
@@ -13547,7 +13756,7 @@
         </p:nvSpPr>
         <p:spPr>
           <a:xfrm>
-            <a:off x="9235440" y="3611880"/>
+            <a:off x="9235440" y="3566160"/>
             <a:ext cx="640080" cy="640080"/>
           </a:xfrm>
           <a:prstGeom prst="ellipse">
@@ -13559,6 +13768,7 @@
           <a:ln>
             <a:noFill/>
           </a:ln>
+          <a:effectLst/>
         </p:spPr>
         <p:style>
           <a:lnRef idx="1">
@@ -13600,7 +13810,7 @@
         </p:nvSpPr>
         <p:spPr>
           <a:xfrm>
-            <a:off x="10378440" y="3611880"/>
+            <a:off x="10378440" y="3566160"/>
             <a:ext cx="640080" cy="640080"/>
           </a:xfrm>
           <a:prstGeom prst="ellipse">
@@ -13612,6 +13822,7 @@
           <a:ln>
             <a:noFill/>
           </a:ln>
+          <a:effectLst/>
         </p:spPr>
         <p:style>
           <a:lnRef idx="1">
@@ -13653,7 +13864,7 @@
         </p:nvSpPr>
         <p:spPr>
           <a:xfrm>
-            <a:off x="6949440" y="4754880"/>
+            <a:off x="6949440" y="4709160"/>
             <a:ext cx="640080" cy="640080"/>
           </a:xfrm>
           <a:prstGeom prst="ellipse">
@@ -13665,6 +13876,7 @@
           <a:ln>
             <a:noFill/>
           </a:ln>
+          <a:effectLst/>
         </p:spPr>
         <p:style>
           <a:lnRef idx="1">
@@ -13706,7 +13918,7 @@
         </p:nvSpPr>
         <p:spPr>
           <a:xfrm>
-            <a:off x="8092440" y="4754880"/>
+            <a:off x="8092440" y="4709160"/>
             <a:ext cx="640080" cy="640080"/>
           </a:xfrm>
           <a:prstGeom prst="ellipse">
@@ -13718,6 +13930,7 @@
           <a:ln>
             <a:noFill/>
           </a:ln>
+          <a:effectLst/>
         </p:spPr>
         <p:style>
           <a:lnRef idx="1">
@@ -13759,7 +13972,7 @@
         </p:nvSpPr>
         <p:spPr>
           <a:xfrm>
-            <a:off x="9235440" y="4754880"/>
+            <a:off x="9235440" y="4709160"/>
             <a:ext cx="640080" cy="640080"/>
           </a:xfrm>
           <a:prstGeom prst="ellipse">
@@ -13771,6 +13984,7 @@
           <a:ln>
             <a:noFill/>
           </a:ln>
+          <a:effectLst/>
         </p:spPr>
         <p:style>
           <a:lnRef idx="1">
@@ -13812,7 +14026,7 @@
         </p:nvSpPr>
         <p:spPr>
           <a:xfrm>
-            <a:off x="10378440" y="4754880"/>
+            <a:off x="10378440" y="4709160"/>
             <a:ext cx="640080" cy="640080"/>
           </a:xfrm>
           <a:prstGeom prst="ellipse">
@@ -13824,6 +14038,7 @@
           <a:ln>
             <a:noFill/>
           </a:ln>
+          <a:effectLst/>
         </p:spPr>
         <p:style>
           <a:lnRef idx="1">
@@ -13872,6 +14087,7 @@
             <a:avLst/>
           </a:prstGeom>
           <a:noFill/>
+          <a:effectLst/>
         </p:spPr>
         <p:txBody>
           <a:bodyPr wrap="none">
@@ -13931,6 +14147,7 @@
           <a:ln>
             <a:noFill/>
           </a:ln>
+          <a:effectLst/>
         </p:spPr>
         <p:style>
           <a:lnRef idx="1">
@@ -13969,6 +14186,7 @@
             <a:avLst/>
           </a:prstGeom>
           <a:noFill/>
+          <a:effectLst/>
         </p:spPr>
         <p:txBody>
           <a:bodyPr wrap="square" lIns="0" tIns="0" rIns="0" bIns="0">
@@ -14010,6 +14228,7 @@
           <a:ln>
             <a:noFill/>
           </a:ln>
+          <a:effectLst/>
         </p:spPr>
         <p:style>
           <a:lnRef idx="1">
@@ -14544,6 +14763,7 @@
             <a:avLst/>
           </a:prstGeom>
           <a:noFill/>
+          <a:effectLst/>
         </p:spPr>
         <p:txBody>
           <a:bodyPr wrap="square" lIns="0" tIns="0" rIns="0" bIns="0">
@@ -14603,6 +14823,7 @@
           <a:ln>
             <a:noFill/>
           </a:ln>
+          <a:effectLst/>
         </p:spPr>
         <p:style>
           <a:lnRef idx="1">
@@ -14641,6 +14862,7 @@
             <a:avLst/>
           </a:prstGeom>
           <a:noFill/>
+          <a:effectLst/>
         </p:spPr>
         <p:txBody>
           <a:bodyPr wrap="square" lIns="0" tIns="0" rIns="0" bIns="0">
@@ -14682,6 +14904,7 @@
           <a:ln>
             <a:noFill/>
           </a:ln>
+          <a:effectLst/>
         </p:spPr>
         <p:style>
           <a:lnRef idx="1">
@@ -14725,6 +14948,7 @@
           <a:ln>
             <a:noFill/>
           </a:ln>
+          <a:effectLst/>
         </p:spPr>
         <p:style>
           <a:lnRef idx="1">
@@ -14773,6 +14997,7 @@
             <a:avLst/>
           </a:prstGeom>
           <a:noFill/>
+          <a:effectLst/>
         </p:spPr>
         <p:txBody>
           <a:bodyPr wrap="none" lIns="0" tIns="0" rIns="0" bIns="0">
@@ -14813,6 +15038,7 @@
               <a:srgbClr val="0F766E"/>
             </a:solidFill>
           </a:ln>
+          <a:effectLst/>
         </p:spPr>
         <p:style>
           <a:lnRef idx="2">
@@ -14849,6 +15075,7 @@
           <a:ln>
             <a:noFill/>
           </a:ln>
+          <a:effectLst/>
         </p:spPr>
         <p:style>
           <a:lnRef idx="1">
@@ -14897,6 +15124,7 @@
             <a:avLst/>
           </a:prstGeom>
           <a:noFill/>
+          <a:effectLst/>
         </p:spPr>
         <p:txBody>
           <a:bodyPr wrap="none" lIns="0" tIns="0" rIns="0" bIns="0">
@@ -14937,6 +15165,7 @@
               <a:srgbClr val="0F766E"/>
             </a:solidFill>
           </a:ln>
+          <a:effectLst/>
         </p:spPr>
         <p:style>
           <a:lnRef idx="2">
@@ -14973,6 +15202,7 @@
           <a:ln>
             <a:noFill/>
           </a:ln>
+          <a:effectLst/>
         </p:spPr>
         <p:style>
           <a:lnRef idx="1">
@@ -15021,6 +15251,7 @@
             <a:avLst/>
           </a:prstGeom>
           <a:noFill/>
+          <a:effectLst/>
         </p:spPr>
         <p:txBody>
           <a:bodyPr wrap="none" lIns="0" tIns="0" rIns="0" bIns="0">
@@ -15061,6 +15292,7 @@
               <a:srgbClr val="0F766E"/>
             </a:solidFill>
           </a:ln>
+          <a:effectLst/>
         </p:spPr>
         <p:style>
           <a:lnRef idx="2">
@@ -15097,6 +15329,7 @@
           <a:ln>
             <a:noFill/>
           </a:ln>
+          <a:effectLst/>
         </p:spPr>
         <p:style>
           <a:lnRef idx="1">
@@ -15145,6 +15378,7 @@
             <a:avLst/>
           </a:prstGeom>
           <a:noFill/>
+          <a:effectLst/>
         </p:spPr>
         <p:txBody>
           <a:bodyPr wrap="none" lIns="0" tIns="0" rIns="0" bIns="0">
@@ -15185,6 +15419,7 @@
               <a:srgbClr val="D97706"/>
             </a:solidFill>
           </a:ln>
+          <a:effectLst/>
         </p:spPr>
         <p:style>
           <a:lnRef idx="2">
@@ -15221,6 +15456,7 @@
           <a:ln>
             <a:noFill/>
           </a:ln>
+          <a:effectLst/>
         </p:spPr>
         <p:style>
           <a:lnRef idx="1">
@@ -15269,6 +15505,7 @@
             <a:avLst/>
           </a:prstGeom>
           <a:noFill/>
+          <a:effectLst/>
         </p:spPr>
         <p:txBody>
           <a:bodyPr wrap="none" lIns="0" tIns="0" rIns="0" bIns="0">
@@ -15305,6 +15542,7 @@
             <a:avLst/>
           </a:prstGeom>
           <a:noFill/>
+          <a:effectLst/>
         </p:spPr>
         <p:txBody>
           <a:bodyPr wrap="square" lIns="0" tIns="0" rIns="0" bIns="0">

</xml_diff>

<commit_message>
Fix slide 3 circle spacing and slide 4 caption gap, and verify official EMANE event IDs
</commit_message>
<xml_diff>
--- a/docs/presentation.pptx
+++ b/docs/presentation.pptx
@@ -5771,8 +5771,8 @@
         </p:nvCxnSpPr>
         <p:spPr>
           <a:xfrm>
-            <a:off x="1371600" y="3954780"/>
-            <a:ext cx="0" cy="0"/>
+            <a:off x="868680" y="3977640"/>
+            <a:ext cx="1188720" cy="0"/>
           </a:xfrm>
           <a:prstGeom prst="line">
             <a:avLst/>
@@ -5793,8 +5793,8 @@
         </p:nvCxnSpPr>
         <p:spPr>
           <a:xfrm>
-            <a:off x="2240280" y="3954780"/>
-            <a:ext cx="0" cy="0"/>
+            <a:off x="2057400" y="3977640"/>
+            <a:ext cx="1188720" cy="0"/>
           </a:xfrm>
           <a:prstGeom prst="line">
             <a:avLst/>
@@ -5815,8 +5815,8 @@
         </p:nvCxnSpPr>
         <p:spPr>
           <a:xfrm>
-            <a:off x="3108960" y="3954780"/>
-            <a:ext cx="0" cy="0"/>
+            <a:off x="3246120" y="3977640"/>
+            <a:ext cx="1188720" cy="0"/>
           </a:xfrm>
           <a:prstGeom prst="line">
             <a:avLst/>
@@ -5837,8 +5837,8 @@
         </p:nvCxnSpPr>
         <p:spPr>
           <a:xfrm>
-            <a:off x="3977640" y="3954780"/>
-            <a:ext cx="0" cy="0"/>
+            <a:off x="4434840" y="3977640"/>
+            <a:ext cx="1188720" cy="0"/>
           </a:xfrm>
           <a:prstGeom prst="line">
             <a:avLst/>
@@ -5859,8 +5859,8 @@
         </p:nvSpPr>
         <p:spPr>
           <a:xfrm>
-            <a:off x="502920" y="3520440"/>
-            <a:ext cx="868680" cy="868680"/>
+            <a:off x="502920" y="3611880"/>
+            <a:ext cx="731520" cy="731520"/>
           </a:xfrm>
           <a:prstGeom prst="ellipse">
             <a:avLst/>
@@ -5878,7 +5878,7 @@
           <a:lstStyle/>
           <a:p>
             <a:pPr algn="ctr">
-              <a:defRPr sz="2200" b="1">
+              <a:defRPr sz="2000" b="1">
                 <a:solidFill>
                   <a:srgbClr val="FFFFFF"/>
                 </a:solidFill>
@@ -5899,8 +5899,8 @@
         </p:nvSpPr>
         <p:spPr>
           <a:xfrm>
-            <a:off x="1371600" y="3520440"/>
-            <a:ext cx="868680" cy="868680"/>
+            <a:off x="1691640" y="3611880"/>
+            <a:ext cx="731520" cy="731520"/>
           </a:xfrm>
           <a:prstGeom prst="ellipse">
             <a:avLst/>
@@ -5918,7 +5918,7 @@
           <a:lstStyle/>
           <a:p>
             <a:pPr algn="ctr">
-              <a:defRPr sz="2200" b="1">
+              <a:defRPr sz="2000" b="1">
                 <a:solidFill>
                   <a:srgbClr val="FFFFFF"/>
                 </a:solidFill>
@@ -5939,8 +5939,8 @@
         </p:nvSpPr>
         <p:spPr>
           <a:xfrm>
-            <a:off x="2240280" y="3520440"/>
-            <a:ext cx="868680" cy="868680"/>
+            <a:off x="2880360" y="3611880"/>
+            <a:ext cx="731520" cy="731520"/>
           </a:xfrm>
           <a:prstGeom prst="ellipse">
             <a:avLst/>
@@ -5958,7 +5958,7 @@
           <a:lstStyle/>
           <a:p>
             <a:pPr algn="ctr">
-              <a:defRPr sz="2200" b="1">
+              <a:defRPr sz="2000" b="1">
                 <a:solidFill>
                   <a:srgbClr val="FFFFFF"/>
                 </a:solidFill>
@@ -5979,8 +5979,8 @@
         </p:nvSpPr>
         <p:spPr>
           <a:xfrm>
-            <a:off x="3108960" y="3520440"/>
-            <a:ext cx="868680" cy="868680"/>
+            <a:off x="4069080" y="3611880"/>
+            <a:ext cx="731520" cy="731520"/>
           </a:xfrm>
           <a:prstGeom prst="ellipse">
             <a:avLst/>
@@ -5998,7 +5998,7 @@
           <a:lstStyle/>
           <a:p>
             <a:pPr algn="ctr">
-              <a:defRPr sz="2200" b="1">
+              <a:defRPr sz="2000" b="1">
                 <a:solidFill>
                   <a:srgbClr val="FFFFFF"/>
                 </a:solidFill>
@@ -6019,8 +6019,8 @@
         </p:nvSpPr>
         <p:spPr>
           <a:xfrm>
-            <a:off x="3977640" y="3520440"/>
-            <a:ext cx="868680" cy="868680"/>
+            <a:off x="5257800" y="3611880"/>
+            <a:ext cx="731520" cy="731520"/>
           </a:xfrm>
           <a:prstGeom prst="ellipse">
             <a:avLst/>
@@ -6038,7 +6038,7 @@
           <a:lstStyle/>
           <a:p>
             <a:pPr algn="ctr">
-              <a:defRPr sz="2200" b="1">
+              <a:defRPr sz="2000" b="1">
                 <a:solidFill>
                   <a:srgbClr val="FFFFFF"/>
                 </a:solidFill>
@@ -6060,7 +6060,7 @@
         <p:spPr>
           <a:xfrm>
             <a:off x="502920" y="4572000"/>
-            <a:ext cx="4114800" cy="411480"/>
+            <a:ext cx="5029200" cy="411480"/>
           </a:xfrm>
           <a:prstGeom prst="rect">
             <a:avLst/>
@@ -6096,8 +6096,8 @@
         </p:nvSpPr>
         <p:spPr>
           <a:xfrm>
-            <a:off x="4937760" y="3749039"/>
-            <a:ext cx="2377440" cy="457200"/>
+            <a:off x="4434840" y="2423160"/>
+            <a:ext cx="3291840" cy="457200"/>
           </a:xfrm>
           <a:prstGeom prst="rect">
             <a:avLst/>
@@ -6112,7 +6112,7 @@
           <a:lstStyle/>
           <a:p>
             <a:pPr algn="ctr">
-              <a:defRPr sz="2000" b="1">
+              <a:defRPr sz="2200" b="1">
                 <a:solidFill>
                   <a:srgbClr val="D97706"/>
                 </a:solidFill>
@@ -6133,7 +6133,7 @@
         </p:nvSpPr>
         <p:spPr>
           <a:xfrm>
-            <a:off x="7406640" y="1965960"/>
+            <a:off x="6172200" y="1965960"/>
             <a:ext cx="4114800" cy="411480"/>
           </a:xfrm>
           <a:prstGeom prst="rect">
@@ -6170,8 +6170,8 @@
         </p:nvCxnSpPr>
         <p:spPr>
           <a:xfrm>
-            <a:off x="8275320" y="3954780"/>
-            <a:ext cx="0" cy="0"/>
+            <a:off x="6537960" y="3977640"/>
+            <a:ext cx="1188720" cy="0"/>
           </a:xfrm>
           <a:prstGeom prst="line">
             <a:avLst/>
@@ -6192,8 +6192,8 @@
         </p:nvCxnSpPr>
         <p:spPr>
           <a:xfrm>
-            <a:off x="9144000" y="3954780"/>
-            <a:ext cx="0" cy="0"/>
+            <a:off x="7726680" y="3977640"/>
+            <a:ext cx="1188720" cy="0"/>
           </a:xfrm>
           <a:prstGeom prst="line">
             <a:avLst/>
@@ -6214,8 +6214,8 @@
         </p:nvCxnSpPr>
         <p:spPr>
           <a:xfrm>
-            <a:off x="10012680" y="3954780"/>
-            <a:ext cx="0" cy="0"/>
+            <a:off x="8915400" y="3977640"/>
+            <a:ext cx="1188720" cy="0"/>
           </a:xfrm>
           <a:prstGeom prst="line">
             <a:avLst/>
@@ -6236,8 +6236,8 @@
         </p:nvCxnSpPr>
         <p:spPr>
           <a:xfrm>
-            <a:off x="10881360" y="3954780"/>
-            <a:ext cx="0" cy="0"/>
+            <a:off x="10104120" y="3977640"/>
+            <a:ext cx="1188720" cy="0"/>
           </a:xfrm>
           <a:prstGeom prst="line">
             <a:avLst/>
@@ -6258,7 +6258,7 @@
         </p:nvCxnSpPr>
         <p:spPr>
           <a:xfrm flipV="1">
-            <a:off x="7840980" y="3017520"/>
+            <a:off x="6537960" y="3108960"/>
             <a:ext cx="0" cy="502920"/>
           </a:xfrm>
           <a:prstGeom prst="line">
@@ -6280,8 +6280,8 @@
         </p:nvCxnSpPr>
         <p:spPr>
           <a:xfrm>
-            <a:off x="7840980" y="3017520"/>
-            <a:ext cx="1737360" cy="0"/>
+            <a:off x="6537960" y="3108960"/>
+            <a:ext cx="2377440" cy="0"/>
           </a:xfrm>
           <a:prstGeom prst="line">
             <a:avLst/>
@@ -6302,7 +6302,7 @@
         </p:nvCxnSpPr>
         <p:spPr>
           <a:xfrm>
-            <a:off x="9578340" y="3017520"/>
+            <a:off x="8915400" y="3108960"/>
             <a:ext cx="0" cy="502920"/>
           </a:xfrm>
           <a:prstGeom prst="line">
@@ -6324,7 +6324,7 @@
         </p:nvCxnSpPr>
         <p:spPr>
           <a:xfrm flipV="1">
-            <a:off x="8709660" y="2651760"/>
+            <a:off x="7726680" y="2743200"/>
             <a:ext cx="0" cy="868680"/>
           </a:xfrm>
           <a:prstGeom prst="line">
@@ -6346,8 +6346,8 @@
         </p:nvCxnSpPr>
         <p:spPr>
           <a:xfrm>
-            <a:off x="8709660" y="2651760"/>
-            <a:ext cx="1737360" cy="0"/>
+            <a:off x="7726680" y="2743200"/>
+            <a:ext cx="2377440" cy="0"/>
           </a:xfrm>
           <a:prstGeom prst="line">
             <a:avLst/>
@@ -6368,7 +6368,7 @@
         </p:nvCxnSpPr>
         <p:spPr>
           <a:xfrm>
-            <a:off x="10447020" y="2651760"/>
+            <a:off x="10104120" y="2743200"/>
             <a:ext cx="0" cy="868680"/>
           </a:xfrm>
           <a:prstGeom prst="line">
@@ -6390,7 +6390,7 @@
         </p:nvCxnSpPr>
         <p:spPr>
           <a:xfrm flipV="1">
-            <a:off x="9578340" y="3017520"/>
+            <a:off x="8915400" y="3108960"/>
             <a:ext cx="0" cy="502920"/>
           </a:xfrm>
           <a:prstGeom prst="line">
@@ -6412,8 +6412,8 @@
         </p:nvCxnSpPr>
         <p:spPr>
           <a:xfrm>
-            <a:off x="9578340" y="3017520"/>
-            <a:ext cx="1737360" cy="0"/>
+            <a:off x="8915400" y="3108960"/>
+            <a:ext cx="2377440" cy="0"/>
           </a:xfrm>
           <a:prstGeom prst="line">
             <a:avLst/>
@@ -6434,7 +6434,7 @@
         </p:nvCxnSpPr>
         <p:spPr>
           <a:xfrm>
-            <a:off x="11315700" y="3017520"/>
+            <a:off x="11292840" y="3108960"/>
             <a:ext cx="0" cy="502920"/>
           </a:xfrm>
           <a:prstGeom prst="line">
@@ -6456,8 +6456,8 @@
         </p:nvSpPr>
         <p:spPr>
           <a:xfrm>
-            <a:off x="7406640" y="3520440"/>
-            <a:ext cx="868680" cy="868680"/>
+            <a:off x="6172200" y="3611880"/>
+            <a:ext cx="731520" cy="731520"/>
           </a:xfrm>
           <a:prstGeom prst="ellipse">
             <a:avLst/>
@@ -6475,7 +6475,7 @@
           <a:lstStyle/>
           <a:p>
             <a:pPr algn="ctr">
-              <a:defRPr sz="2200" b="1">
+              <a:defRPr sz="2000" b="1">
                 <a:solidFill>
                   <a:srgbClr val="FFFFFF"/>
                 </a:solidFill>
@@ -6496,8 +6496,8 @@
         </p:nvSpPr>
         <p:spPr>
           <a:xfrm>
-            <a:off x="8275320" y="3520440"/>
-            <a:ext cx="868680" cy="868680"/>
+            <a:off x="7360920" y="3611880"/>
+            <a:ext cx="731520" cy="731520"/>
           </a:xfrm>
           <a:prstGeom prst="ellipse">
             <a:avLst/>
@@ -6515,7 +6515,7 @@
           <a:lstStyle/>
           <a:p>
             <a:pPr algn="ctr">
-              <a:defRPr sz="2200" b="1">
+              <a:defRPr sz="2000" b="1">
                 <a:solidFill>
                   <a:srgbClr val="FFFFFF"/>
                 </a:solidFill>
@@ -6536,8 +6536,8 @@
         </p:nvSpPr>
         <p:spPr>
           <a:xfrm>
-            <a:off x="9144000" y="3520440"/>
-            <a:ext cx="868680" cy="868680"/>
+            <a:off x="8549640" y="3611880"/>
+            <a:ext cx="731520" cy="731520"/>
           </a:xfrm>
           <a:prstGeom prst="ellipse">
             <a:avLst/>
@@ -6555,7 +6555,7 @@
           <a:lstStyle/>
           <a:p>
             <a:pPr algn="ctr">
-              <a:defRPr sz="2200" b="1">
+              <a:defRPr sz="2000" b="1">
                 <a:solidFill>
                   <a:srgbClr val="FFFFFF"/>
                 </a:solidFill>
@@ -6576,8 +6576,8 @@
         </p:nvSpPr>
         <p:spPr>
           <a:xfrm>
-            <a:off x="10012680" y="3520440"/>
-            <a:ext cx="868680" cy="868680"/>
+            <a:off x="9738360" y="3611880"/>
+            <a:ext cx="731520" cy="731520"/>
           </a:xfrm>
           <a:prstGeom prst="ellipse">
             <a:avLst/>
@@ -6595,7 +6595,7 @@
           <a:lstStyle/>
           <a:p>
             <a:pPr algn="ctr">
-              <a:defRPr sz="2200" b="1">
+              <a:defRPr sz="2000" b="1">
                 <a:solidFill>
                   <a:srgbClr val="FFFFFF"/>
                 </a:solidFill>
@@ -6616,8 +6616,8 @@
         </p:nvSpPr>
         <p:spPr>
           <a:xfrm>
-            <a:off x="10881360" y="3520440"/>
-            <a:ext cx="868680" cy="868680"/>
+            <a:off x="10927080" y="3611880"/>
+            <a:ext cx="731520" cy="731520"/>
           </a:xfrm>
           <a:prstGeom prst="ellipse">
             <a:avLst/>
@@ -6635,7 +6635,7 @@
           <a:lstStyle/>
           <a:p>
             <a:pPr algn="ctr">
-              <a:defRPr sz="2200" b="1">
+              <a:defRPr sz="2000" b="1">
                 <a:solidFill>
                   <a:srgbClr val="FFFFFF"/>
                 </a:solidFill>
@@ -6656,8 +6656,8 @@
         </p:nvSpPr>
         <p:spPr>
           <a:xfrm>
-            <a:off x="7406640" y="4572000"/>
-            <a:ext cx="4114800" cy="411480"/>
+            <a:off x="6172200" y="4572000"/>
+            <a:ext cx="5029200" cy="411480"/>
           </a:xfrm>
           <a:prstGeom prst="rect">
             <a:avLst/>
@@ -6847,7 +6847,7 @@
         </p:nvGraphicFramePr>
         <p:xfrm>
           <a:off x="914400" y="1508760"/>
-          <a:ext cx="10362895" cy="4160520"/>
+          <a:ext cx="10362895" cy="3840480"/>
         </p:xfrm>
         <a:graphic>
           <a:graphicData uri="http://schemas.openxmlformats.org/drawingml/2006/table">
@@ -6861,14 +6861,14 @@
                 <a:gridCol w="2743200"/>
                 <a:gridCol w="2743200"/>
               </a:tblGrid>
-              <a:tr h="594360">
+              <a:tr h="548640">
                 <a:tc>
                   <a:txBody>
                     <a:bodyPr/>
                     <a:lstStyle/>
                     <a:p>
                       <a:pPr algn="l">
-                        <a:defRPr sz="2100" b="1">
+                        <a:defRPr sz="2000" b="1">
                           <a:solidFill>
                             <a:srgbClr val="1B1F2A"/>
                           </a:solidFill>
@@ -6890,7 +6890,7 @@
                     <a:lstStyle/>
                     <a:p>
                       <a:pPr algn="ctr">
-                        <a:defRPr sz="2100" b="1">
+                        <a:defRPr sz="2000" b="1">
                           <a:solidFill>
                             <a:srgbClr val="1B1F2A"/>
                           </a:solidFill>
@@ -6912,7 +6912,7 @@
                     <a:lstStyle/>
                     <a:p>
                       <a:pPr algn="ctr">
-                        <a:defRPr sz="2100" b="1">
+                        <a:defRPr sz="2000" b="1">
                           <a:solidFill>
                             <a:srgbClr val="1B1F2A"/>
                           </a:solidFill>
@@ -6929,14 +6929,14 @@
                   </a:tcPr>
                 </a:tc>
               </a:tr>
-              <a:tr h="594360">
+              <a:tr h="548640">
                 <a:tc>
                   <a:txBody>
                     <a:bodyPr/>
                     <a:lstStyle/>
                     <a:p>
                       <a:pPr algn="l">
-                        <a:defRPr sz="1900">
+                        <a:defRPr sz="1800">
                           <a:solidFill>
                             <a:srgbClr val="1B1F2A"/>
                           </a:solidFill>
@@ -6958,7 +6958,7 @@
                     <a:lstStyle/>
                     <a:p>
                       <a:pPr algn="ctr">
-                        <a:defRPr sz="1900" b="1">
+                        <a:defRPr sz="1800" b="1">
                           <a:solidFill>
                             <a:srgbClr val="1B1F2A"/>
                           </a:solidFill>
@@ -6980,7 +6980,7 @@
                     <a:lstStyle/>
                     <a:p>
                       <a:pPr algn="ctr">
-                        <a:defRPr sz="1900">
+                        <a:defRPr sz="1800">
                           <a:solidFill>
                             <a:srgbClr val="1B1F2A"/>
                           </a:solidFill>
@@ -6997,14 +6997,14 @@
                   </a:tcPr>
                 </a:tc>
               </a:tr>
-              <a:tr h="594360">
+              <a:tr h="548640">
                 <a:tc>
                   <a:txBody>
                     <a:bodyPr/>
                     <a:lstStyle/>
                     <a:p>
                       <a:pPr algn="l">
-                        <a:defRPr sz="1900">
+                        <a:defRPr sz="1800">
                           <a:solidFill>
                             <a:srgbClr val="1B1F2A"/>
                           </a:solidFill>
@@ -7026,7 +7026,7 @@
                     <a:lstStyle/>
                     <a:p>
                       <a:pPr algn="ctr">
-                        <a:defRPr sz="1900" b="1">
+                        <a:defRPr sz="1800" b="1">
                           <a:solidFill>
                             <a:srgbClr val="1B1F2A"/>
                           </a:solidFill>
@@ -7048,7 +7048,7 @@
                     <a:lstStyle/>
                     <a:p>
                       <a:pPr algn="ctr">
-                        <a:defRPr sz="1900">
+                        <a:defRPr sz="1800">
                           <a:solidFill>
                             <a:srgbClr val="1B1F2A"/>
                           </a:solidFill>
@@ -7065,14 +7065,14 @@
                   </a:tcPr>
                 </a:tc>
               </a:tr>
-              <a:tr h="594360">
+              <a:tr h="548640">
                 <a:tc>
                   <a:txBody>
                     <a:bodyPr/>
                     <a:lstStyle/>
                     <a:p>
                       <a:pPr algn="l">
-                        <a:defRPr sz="1900">
+                        <a:defRPr sz="1800">
                           <a:solidFill>
                             <a:srgbClr val="1B1F2A"/>
                           </a:solidFill>
@@ -7094,7 +7094,7 @@
                     <a:lstStyle/>
                     <a:p>
                       <a:pPr algn="ctr">
-                        <a:defRPr sz="1900" b="1">
+                        <a:defRPr sz="1800" b="1">
                           <a:solidFill>
                             <a:srgbClr val="1B1F2A"/>
                           </a:solidFill>
@@ -7116,7 +7116,7 @@
                     <a:lstStyle/>
                     <a:p>
                       <a:pPr algn="ctr">
-                        <a:defRPr sz="1900">
+                        <a:defRPr sz="1800">
                           <a:solidFill>
                             <a:srgbClr val="1B1F2A"/>
                           </a:solidFill>
@@ -7133,14 +7133,14 @@
                   </a:tcPr>
                 </a:tc>
               </a:tr>
-              <a:tr h="594360">
+              <a:tr h="548640">
                 <a:tc>
                   <a:txBody>
                     <a:bodyPr/>
                     <a:lstStyle/>
                     <a:p>
                       <a:pPr algn="l">
-                        <a:defRPr sz="1900">
+                        <a:defRPr sz="1800">
                           <a:solidFill>
                             <a:srgbClr val="1B1F2A"/>
                           </a:solidFill>
@@ -7162,7 +7162,7 @@
                     <a:lstStyle/>
                     <a:p>
                       <a:pPr algn="ctr">
-                        <a:defRPr sz="1900" b="1">
+                        <a:defRPr sz="1800" b="1">
                           <a:solidFill>
                             <a:srgbClr val="1B1F2A"/>
                           </a:solidFill>
@@ -7184,7 +7184,7 @@
                     <a:lstStyle/>
                     <a:p>
                       <a:pPr algn="ctr">
-                        <a:defRPr sz="1900">
+                        <a:defRPr sz="1800">
                           <a:solidFill>
                             <a:srgbClr val="1B1F2A"/>
                           </a:solidFill>
@@ -7201,14 +7201,14 @@
                   </a:tcPr>
                 </a:tc>
               </a:tr>
-              <a:tr h="594360">
+              <a:tr h="548640">
                 <a:tc>
                   <a:txBody>
                     <a:bodyPr/>
                     <a:lstStyle/>
                     <a:p>
                       <a:pPr algn="l">
-                        <a:defRPr sz="1900">
+                        <a:defRPr sz="1800">
                           <a:solidFill>
                             <a:srgbClr val="1B1F2A"/>
                           </a:solidFill>
@@ -7230,7 +7230,7 @@
                     <a:lstStyle/>
                     <a:p>
                       <a:pPr algn="ctr">
-                        <a:defRPr sz="1900" b="1">
+                        <a:defRPr sz="1800" b="1">
                           <a:solidFill>
                             <a:srgbClr val="1B1F2A"/>
                           </a:solidFill>
@@ -7252,7 +7252,7 @@
                     <a:lstStyle/>
                     <a:p>
                       <a:pPr algn="ctr">
-                        <a:defRPr sz="1900">
+                        <a:defRPr sz="1800">
                           <a:solidFill>
                             <a:srgbClr val="1B1F2A"/>
                           </a:solidFill>
@@ -7269,14 +7269,14 @@
                   </a:tcPr>
                 </a:tc>
               </a:tr>
-              <a:tr h="594360">
+              <a:tr h="548640">
                 <a:tc>
                   <a:txBody>
                     <a:bodyPr/>
                     <a:lstStyle/>
                     <a:p>
                       <a:pPr algn="l">
-                        <a:defRPr sz="1900">
+                        <a:defRPr sz="1800">
                           <a:solidFill>
                             <a:srgbClr val="1B1F2A"/>
                           </a:solidFill>
@@ -7298,7 +7298,7 @@
                     <a:lstStyle/>
                     <a:p>
                       <a:pPr algn="ctr">
-                        <a:defRPr sz="1900" b="1">
+                        <a:defRPr sz="1800" b="1">
                           <a:solidFill>
                             <a:srgbClr val="1B1F2A"/>
                           </a:solidFill>
@@ -7320,7 +7320,7 @@
                     <a:lstStyle/>
                     <a:p>
                       <a:pPr algn="ctr">
-                        <a:defRPr sz="1900">
+                        <a:defRPr sz="1800">
                           <a:solidFill>
                             <a:srgbClr val="1B1F2A"/>
                           </a:solidFill>
@@ -7349,7 +7349,7 @@
         </p:nvSpPr>
         <p:spPr>
           <a:xfrm>
-            <a:off x="914400" y="5852160"/>
+            <a:off x="914400" y="5760720"/>
             <a:ext cx="10362895" cy="411480"/>
           </a:xfrm>
           <a:prstGeom prst="rect">

</xml_diff>

<commit_message>
Stack slide 3 physical and conflict graphs vertically with distinct arcs
</commit_message>
<xml_diff>
--- a/docs/presentation.pptx
+++ b/docs/presentation.pptx
@@ -5697,8 +5697,8 @@
         </p:nvSpPr>
         <p:spPr>
           <a:xfrm>
-            <a:off x="914400" y="1325880"/>
-            <a:ext cx="10362895" cy="502920"/>
+            <a:off x="914400" y="1371600"/>
+            <a:ext cx="10362895" cy="411480"/>
           </a:xfrm>
           <a:prstGeom prst="rect">
             <a:avLst/>
@@ -5734,8 +5734,8 @@
         </p:nvSpPr>
         <p:spPr>
           <a:xfrm>
-            <a:off x="502920" y="1965960"/>
-            <a:ext cx="4114800" cy="411480"/>
+            <a:off x="594360" y="2121408"/>
+            <a:ext cx="2606040" cy="411480"/>
           </a:xfrm>
           <a:prstGeom prst="rect">
             <a:avLst/>
@@ -5744,13 +5744,13 @@
           <a:effectLst/>
         </p:spPr>
         <p:txBody>
-          <a:bodyPr wrap="none">
+          <a:bodyPr wrap="none" lIns="0" tIns="0" rIns="0" bIns="0">
             <a:spAutoFit/>
           </a:bodyPr>
           <a:lstStyle/>
           <a:p>
             <a:pPr>
-              <a:defRPr sz="2400" b="1">
+              <a:defRPr sz="2000" b="1">
                 <a:solidFill>
                   <a:srgbClr val="1B1F2A"/>
                 </a:solidFill>
@@ -5771,7 +5771,7 @@
         </p:nvCxnSpPr>
         <p:spPr>
           <a:xfrm>
-            <a:off x="868680" y="3977640"/>
+            <a:off x="3718407" y="2331720"/>
             <a:ext cx="1188720" cy="0"/>
           </a:xfrm>
           <a:prstGeom prst="line">
@@ -5793,7 +5793,7 @@
         </p:nvCxnSpPr>
         <p:spPr>
           <a:xfrm>
-            <a:off x="2057400" y="3977640"/>
+            <a:off x="4907127" y="2331720"/>
             <a:ext cx="1188720" cy="0"/>
           </a:xfrm>
           <a:prstGeom prst="line">
@@ -5815,7 +5815,7 @@
         </p:nvCxnSpPr>
         <p:spPr>
           <a:xfrm>
-            <a:off x="3246120" y="3977640"/>
+            <a:off x="6095847" y="2331720"/>
             <a:ext cx="1188720" cy="0"/>
           </a:xfrm>
           <a:prstGeom prst="line">
@@ -5837,7 +5837,7 @@
         </p:nvCxnSpPr>
         <p:spPr>
           <a:xfrm>
-            <a:off x="4434840" y="3977640"/>
+            <a:off x="7284567" y="2331720"/>
             <a:ext cx="1188720" cy="0"/>
           </a:xfrm>
           <a:prstGeom prst="line">
@@ -5859,7 +5859,7 @@
         </p:nvSpPr>
         <p:spPr>
           <a:xfrm>
-            <a:off x="502920" y="3611880"/>
+            <a:off x="3352647" y="1965960"/>
             <a:ext cx="731520" cy="731520"/>
           </a:xfrm>
           <a:prstGeom prst="ellipse">
@@ -5899,7 +5899,7 @@
         </p:nvSpPr>
         <p:spPr>
           <a:xfrm>
-            <a:off x="1691640" y="3611880"/>
+            <a:off x="4541367" y="1965960"/>
             <a:ext cx="731520" cy="731520"/>
           </a:xfrm>
           <a:prstGeom prst="ellipse">
@@ -5939,7 +5939,7 @@
         </p:nvSpPr>
         <p:spPr>
           <a:xfrm>
-            <a:off x="2880360" y="3611880"/>
+            <a:off x="5730087" y="1965960"/>
             <a:ext cx="731520" cy="731520"/>
           </a:xfrm>
           <a:prstGeom prst="ellipse">
@@ -5979,7 +5979,7 @@
         </p:nvSpPr>
         <p:spPr>
           <a:xfrm>
-            <a:off x="4069080" y="3611880"/>
+            <a:off x="6918807" y="1965960"/>
             <a:ext cx="731520" cy="731520"/>
           </a:xfrm>
           <a:prstGeom prst="ellipse">
@@ -6019,7 +6019,7 @@
         </p:nvSpPr>
         <p:spPr>
           <a:xfrm>
-            <a:off x="5257800" y="3611880"/>
+            <a:off x="8107527" y="1965960"/>
             <a:ext cx="731520" cy="731520"/>
           </a:xfrm>
           <a:prstGeom prst="ellipse">
@@ -6059,45 +6059,8 @@
         </p:nvSpPr>
         <p:spPr>
           <a:xfrm>
-            <a:off x="502920" y="4572000"/>
-            <a:ext cx="5029200" cy="411480"/>
-          </a:xfrm>
-          <a:prstGeom prst="rect">
-            <a:avLst/>
-          </a:prstGeom>
-          <a:noFill/>
-          <a:effectLst/>
-        </p:spPr>
-        <p:txBody>
-          <a:bodyPr wrap="none">
-            <a:spAutoFit/>
-          </a:bodyPr>
-          <a:lstStyle/>
-          <a:p>
-            <a:pPr>
-              <a:defRPr sz="1900">
-                <a:solidFill>
-                  <a:srgbClr val="64748B"/>
-                </a:solidFill>
-                <a:latin typeface="Calibri"/>
-              </a:defRPr>
-            </a:pPr>
-            <a:r>
-              <a:t>Edges where distance ≤ 500 m</a:t>
-            </a:r>
-          </a:p>
-        </p:txBody>
-      </p:sp>
-      <p:sp>
-        <p:nvSpPr>
-          <p:cNvPr id="17" name="TextBox 16"/>
-          <p:cNvSpPr txBox="1"/>
-          <p:nvPr/>
-        </p:nvSpPr>
-        <p:spPr>
-          <a:xfrm>
-            <a:off x="4434840" y="2423160"/>
-            <a:ext cx="3291840" cy="457200"/>
+            <a:off x="3352647" y="2770632"/>
+            <a:ext cx="5486400" cy="320040"/>
           </a:xfrm>
           <a:prstGeom prst="rect">
             <a:avLst/>
@@ -6112,6 +6075,43 @@
           <a:lstStyle/>
           <a:p>
             <a:pPr algn="ctr">
+              <a:defRPr sz="1800">
+                <a:solidFill>
+                  <a:srgbClr val="64748B"/>
+                </a:solidFill>
+                <a:latin typeface="Calibri"/>
+              </a:defRPr>
+            </a:pPr>
+            <a:r>
+              <a:t>Edges where distance ≤ 500 m</a:t>
+            </a:r>
+          </a:p>
+        </p:txBody>
+      </p:sp>
+      <p:sp>
+        <p:nvSpPr>
+          <p:cNvPr id="17" name="TextBox 16"/>
+          <p:cNvSpPr txBox="1"/>
+          <p:nvPr/>
+        </p:nvSpPr>
+        <p:spPr>
+          <a:xfrm>
+            <a:off x="3352647" y="3200400"/>
+            <a:ext cx="5486400" cy="411480"/>
+          </a:xfrm>
+          <a:prstGeom prst="rect">
+            <a:avLst/>
+          </a:prstGeom>
+          <a:noFill/>
+          <a:effectLst/>
+        </p:spPr>
+        <p:txBody>
+          <a:bodyPr wrap="none" lIns="0" tIns="0" rIns="0" bIns="0">
+            <a:spAutoFit/>
+          </a:bodyPr>
+          <a:lstStyle/>
+          <a:p>
+            <a:pPr algn="ctr">
               <a:defRPr sz="2200" b="1">
                 <a:solidFill>
                   <a:srgbClr val="D97706"/>
@@ -6120,7 +6120,7 @@
               </a:defRPr>
             </a:pPr>
             <a:r>
-              <a:t>→ Square it → G²</a:t>
+              <a:t>↓   Square it</a:t>
             </a:r>
           </a:p>
         </p:txBody>
@@ -6133,8 +6133,8 @@
         </p:nvSpPr>
         <p:spPr>
           <a:xfrm>
-            <a:off x="6172200" y="1965960"/>
-            <a:ext cx="4114800" cy="411480"/>
+            <a:off x="594360" y="4590288"/>
+            <a:ext cx="2606040" cy="411480"/>
           </a:xfrm>
           <a:prstGeom prst="rect">
             <a:avLst/>
@@ -6143,13 +6143,13 @@
           <a:effectLst/>
         </p:spPr>
         <p:txBody>
-          <a:bodyPr wrap="none">
+          <a:bodyPr wrap="none" lIns="0" tIns="0" rIns="0" bIns="0">
             <a:spAutoFit/>
           </a:bodyPr>
           <a:lstStyle/>
           <a:p>
             <a:pPr>
-              <a:defRPr sz="2400" b="1">
+              <a:defRPr sz="2000" b="1">
                 <a:solidFill>
                   <a:srgbClr val="1B1F2A"/>
                 </a:solidFill>
@@ -6170,7 +6170,7 @@
         </p:nvCxnSpPr>
         <p:spPr>
           <a:xfrm>
-            <a:off x="6537960" y="3977640"/>
+            <a:off x="3718407" y="4800600"/>
             <a:ext cx="1188720" cy="0"/>
           </a:xfrm>
           <a:prstGeom prst="line">
@@ -6192,7 +6192,7 @@
         </p:nvCxnSpPr>
         <p:spPr>
           <a:xfrm>
-            <a:off x="7726680" y="3977640"/>
+            <a:off x="4907127" y="4800600"/>
             <a:ext cx="1188720" cy="0"/>
           </a:xfrm>
           <a:prstGeom prst="line">
@@ -6214,7 +6214,7 @@
         </p:nvCxnSpPr>
         <p:spPr>
           <a:xfrm>
-            <a:off x="8915400" y="3977640"/>
+            <a:off x="6095847" y="4800600"/>
             <a:ext cx="1188720" cy="0"/>
           </a:xfrm>
           <a:prstGeom prst="line">
@@ -6236,7 +6236,7 @@
         </p:nvCxnSpPr>
         <p:spPr>
           <a:xfrm>
-            <a:off x="10104120" y="3977640"/>
+            <a:off x="7284567" y="4800600"/>
             <a:ext cx="1188720" cy="0"/>
           </a:xfrm>
           <a:prstGeom prst="line">
@@ -6258,8 +6258,8 @@
         </p:nvCxnSpPr>
         <p:spPr>
           <a:xfrm flipV="1">
-            <a:off x="6537960" y="3108960"/>
-            <a:ext cx="0" cy="502920"/>
+            <a:off x="3663543" y="4114800"/>
+            <a:ext cx="0" cy="685800"/>
           </a:xfrm>
           <a:prstGeom prst="line">
             <a:avLst/>
@@ -6280,7 +6280,7 @@
         </p:nvCxnSpPr>
         <p:spPr>
           <a:xfrm>
-            <a:off x="6537960" y="3108960"/>
+            <a:off x="3663543" y="4114800"/>
             <a:ext cx="2377440" cy="0"/>
           </a:xfrm>
           <a:prstGeom prst="line">
@@ -6302,8 +6302,8 @@
         </p:nvCxnSpPr>
         <p:spPr>
           <a:xfrm>
-            <a:off x="8915400" y="3108960"/>
-            <a:ext cx="0" cy="502920"/>
+            <a:off x="6040983" y="4114800"/>
+            <a:ext cx="0" cy="685800"/>
           </a:xfrm>
           <a:prstGeom prst="line">
             <a:avLst/>
@@ -6324,8 +6324,8 @@
         </p:nvCxnSpPr>
         <p:spPr>
           <a:xfrm flipV="1">
-            <a:off x="7726680" y="2743200"/>
-            <a:ext cx="0" cy="868680"/>
+            <a:off x="6150711" y="3977640"/>
+            <a:ext cx="0" cy="822960"/>
           </a:xfrm>
           <a:prstGeom prst="line">
             <a:avLst/>
@@ -6346,7 +6346,7 @@
         </p:nvCxnSpPr>
         <p:spPr>
           <a:xfrm>
-            <a:off x="7726680" y="2743200"/>
+            <a:off x="6150711" y="3977640"/>
             <a:ext cx="2377440" cy="0"/>
           </a:xfrm>
           <a:prstGeom prst="line">
@@ -6368,8 +6368,8 @@
         </p:nvCxnSpPr>
         <p:spPr>
           <a:xfrm>
-            <a:off x="10104120" y="2743200"/>
-            <a:ext cx="0" cy="868680"/>
+            <a:off x="8528151" y="3977640"/>
+            <a:ext cx="0" cy="822960"/>
           </a:xfrm>
           <a:prstGeom prst="line">
             <a:avLst/>
@@ -6390,8 +6390,8 @@
         </p:nvCxnSpPr>
         <p:spPr>
           <a:xfrm flipV="1">
-            <a:off x="8915400" y="3108960"/>
-            <a:ext cx="0" cy="502920"/>
+            <a:off x="4907127" y="3813048"/>
+            <a:ext cx="0" cy="987552"/>
           </a:xfrm>
           <a:prstGeom prst="line">
             <a:avLst/>
@@ -6412,7 +6412,7 @@
         </p:nvCxnSpPr>
         <p:spPr>
           <a:xfrm>
-            <a:off x="8915400" y="3108960"/>
+            <a:off x="4907127" y="3813048"/>
             <a:ext cx="2377440" cy="0"/>
           </a:xfrm>
           <a:prstGeom prst="line">
@@ -6434,8 +6434,8 @@
         </p:nvCxnSpPr>
         <p:spPr>
           <a:xfrm>
-            <a:off x="11292840" y="3108960"/>
-            <a:ext cx="0" cy="502920"/>
+            <a:off x="7284567" y="3813048"/>
+            <a:ext cx="0" cy="987552"/>
           </a:xfrm>
           <a:prstGeom prst="line">
             <a:avLst/>
@@ -6456,7 +6456,7 @@
         </p:nvSpPr>
         <p:spPr>
           <a:xfrm>
-            <a:off x="6172200" y="3611880"/>
+            <a:off x="3352647" y="4434840"/>
             <a:ext cx="731520" cy="731520"/>
           </a:xfrm>
           <a:prstGeom prst="ellipse">
@@ -6496,7 +6496,7 @@
         </p:nvSpPr>
         <p:spPr>
           <a:xfrm>
-            <a:off x="7360920" y="3611880"/>
+            <a:off x="4541367" y="4434840"/>
             <a:ext cx="731520" cy="731520"/>
           </a:xfrm>
           <a:prstGeom prst="ellipse">
@@ -6536,7 +6536,7 @@
         </p:nvSpPr>
         <p:spPr>
           <a:xfrm>
-            <a:off x="8549640" y="3611880"/>
+            <a:off x="5730087" y="4434840"/>
             <a:ext cx="731520" cy="731520"/>
           </a:xfrm>
           <a:prstGeom prst="ellipse">
@@ -6576,7 +6576,7 @@
         </p:nvSpPr>
         <p:spPr>
           <a:xfrm>
-            <a:off x="9738360" y="3611880"/>
+            <a:off x="6918807" y="4434840"/>
             <a:ext cx="731520" cy="731520"/>
           </a:xfrm>
           <a:prstGeom prst="ellipse">
@@ -6616,7 +6616,7 @@
         </p:nvSpPr>
         <p:spPr>
           <a:xfrm>
-            <a:off x="10927080" y="3611880"/>
+            <a:off x="8107527" y="4434840"/>
             <a:ext cx="731520" cy="731520"/>
           </a:xfrm>
           <a:prstGeom prst="ellipse">
@@ -6656,8 +6656,8 @@
         </p:nvSpPr>
         <p:spPr>
           <a:xfrm>
-            <a:off x="6172200" y="4572000"/>
-            <a:ext cx="5029200" cy="411480"/>
+            <a:off x="3352647" y="5239512"/>
+            <a:ext cx="5486400" cy="320040"/>
           </a:xfrm>
           <a:prstGeom prst="rect">
             <a:avLst/>
@@ -6671,8 +6671,8 @@
           </a:bodyPr>
           <a:lstStyle/>
           <a:p>
-            <a:pPr>
-              <a:defRPr sz="1900">
+            <a:pPr algn="ctr">
+              <a:defRPr sz="1800">
                 <a:solidFill>
                   <a:srgbClr val="64748B"/>
                 </a:solidFill>
@@ -6680,7 +6680,7 @@
               </a:defRPr>
             </a:pPr>
             <a:r>
-              <a:t>1-hop and 2-hop neighbors become adjacent</a:t>
+              <a:t>1-hop and 2-hop neighbours become adjacent</a:t>
             </a:r>
           </a:p>
         </p:txBody>
@@ -6693,8 +6693,8 @@
         </p:nvSpPr>
         <p:spPr>
           <a:xfrm>
-            <a:off x="914400" y="5440680"/>
-            <a:ext cx="10362895" cy="502920"/>
+            <a:off x="914400" y="5760720"/>
+            <a:ext cx="10362895" cy="411480"/>
           </a:xfrm>
           <a:prstGeom prst="rect">
             <a:avLst/>

</xml_diff>